<commit_message>
Deck v3: fix cost-slide numbering (x of 3), tighten recommendation panel
Co-Authored-By: Claude Fable 5.1 <noreply@anthropic.com>
Claude-Session: https://claude.ai/code/session_01LkE2ZRYs3PLyj8XHTsU3i4
</commit_message>
<xml_diff>
--- a/PVA second supplier initiative/PVA_Second_Supplier_Leadership_Deck.pptx
+++ b/PVA second supplier initiative/PVA_Second_Supplier_Leadership_Deck.pptx
@@ -5382,7 +5382,7 @@
                 </a:solidFill>
                 <a:latin typeface="Calibri"/>
               </a:rPr>
-              <a:t>Cost (1 of 2): where every price on the table comes from</a:t>
+              <a:t>Cost (1 of 3): where every price on the table comes from</a:t>
             </a:r>
           </a:p>
         </p:txBody>
@@ -6288,7 +6288,7 @@
                 </a:solidFill>
                 <a:latin typeface="Calibri"/>
               </a:rPr>
-              <a:t>Cost (2 of 2): what each option costs us, per year and over five</a:t>
+              <a:t>Cost (2 of 3): what each option costs us, per year and over five</a:t>
             </a:r>
           </a:p>
         </p:txBody>
@@ -10361,13 +10361,13 @@
               </a:spcAft>
             </a:pPr>
             <a:r>
-              <a:rPr sz="1050" b="0" i="0">
+              <a:rPr sz="1000" b="0" i="0">
                 <a:solidFill>
                   <a:srgbClr val="595959"/>
                 </a:solidFill>
                 <a:latin typeface="Calibri"/>
               </a:rPr>
-              <a:t>•  1. Price discovery first: RFQ to PCI Manufacturing on the agreed spec — ~2 weeks, no cost. ≤ ~$1.50/lb → A. ≥ ~$2.50 → B unless the outage cost is large. In between → the outage number decides.</a:t>
+              <a:t>•  1. Price discovery first: RFQ to PCI Manufacturing on the agreed spec (~2 weeks, no cost). ≤ $1.50/lb → A; ≥ $2.50 → B unless the outage cost is large; between → the outage number decides.</a:t>
             </a:r>
           </a:p>
           <a:p>
@@ -10377,13 +10377,13 @@
               </a:spcAft>
             </a:pPr>
             <a:r>
-              <a:rPr sz="1050" b="0" i="0">
+              <a:rPr sz="1000" b="0" i="0">
                 <a:solidFill>
                   <a:srgbClr val="595959"/>
                 </a:solidFill>
                 <a:latin typeface="Calibri"/>
               </a:rPr>
-              <a:t>•  2. Either way, strengthen SNP Inc. now: forecast, hydrogel program, continuity terms, 8–12 weeks of shelf-stable RESIN on consignment, annual financial check.</a:t>
+              <a:t>•  2. Either way, strengthen SNP Inc. now: forecast, hydrogel program, continuity terms, shelf-stable RESIN on consignment, annual financial check.</a:t>
             </a:r>
           </a:p>
           <a:p>
@@ -10393,7 +10393,7 @@
               </a:spcAft>
             </a:pPr>
             <a:r>
-              <a:rPr sz="1050" b="0" i="0">
+              <a:rPr sz="1000" b="0" i="0">
                 <a:solidFill>
                   <a:srgbClr val="595959"/>
                 </a:solidFill>

</xml_diff>

<commit_message>
Deck v3.1: fold fact-checked memo into deck
- Appendix: verified attributions (Kraljic verbatim, Gelderman & van Weele,
  Simchi-Levi/Ford, Sheffi & Rice, Tomlin, Chopra & Sodhi, Pulles/Schiele,
  Deloitte 2025, McKinsey 2024 as secondary, QMSR/ISO 13485/GHTF) + make-in-house line
- Logistics: real time-to-survive ~1-1.5 wk; two-stream quality/CAPA load;
  sub-tier resin convergence; 30-45 day shelf-life study as cheapest lever
- Decision: Option B bundle priced ($3-12k/yr); SNP capacity-headroom trigger;
  transparency line; growth widens supplier set; Finance ask as 3-column table
- Speaker notes: three likely leadership questions with answers

Co-Authored-By: Claude Fable 5.1 <noreply@anthropic.com>
Claude-Session: https://claude.ai/code/session_01LkE2ZRYs3PLyj8XHTsU3i4
</commit_message>
<xml_diff>
--- a/PVA second supplier initiative/PVA_Second_Supplier_Leadership_Deck.pptx
+++ b/PVA second supplier initiative/PVA_Second_Supplier_Leadership_Deck.pptx
@@ -860,7 +860,7 @@
           <a:lstStyle/>
           <a:p>
             <a:r>
-              <a:t>Logistics. With an 18 to 30 day shelf life nothing is stockpiled - every drum is made to order from both suppliers. That means one harmonized spec and one viscometer method, an incoming test on every lot from both, lot traceability so we can see hydrogel performance by source, two cleaning procedures, two quality agreements. It is manageable, but it is a permanent discipline. And one thing it needs that we do not yet have: a written ramp plan for PCI. Without that, the second source cannot actually cover an outage - two-thirds of our volume still stops.</a:t>
+              <a:t>Logistics. With an 18 to 30 day shelf life nothing is stockpiled - every drum is made to order from both suppliers, and because drums arrive already aged, our real time-to-survive is one to one-and-a-half weeks, not two and a half. One check we have not done: whether SNP and PCI cook the same producer's resin - if so, a second cooker hedges cooking, not resin, and the resin buffer is the hedge either way. And the cheapest lever of all under either option is a validated 30-to-45-day shelf-life study. That means one harmonized spec and one viscometer method, an incoming test on every lot from both, lot traceability so we can see hydrogel performance by source, two cleaning procedures, two quality agreements. It is manageable, but it is a permanent discipline. And one thing it needs that we do not yet have: a written ramp plan for PCI. Without that, the second source cannot actually cover an outage - two-thirds of our volume still stops.</a:t>
             </a:r>
           </a:p>
         </p:txBody>
@@ -1000,7 +1000,7 @@
           <a:lstStyle/>
           <a:p>
             <a:r>
-              <a:t>The decision. A costs about 70 thousand a year at the mid price and buys recovery in weeks - if the ramp plan is real. B costs almost nothing and leaves us exposed for months if SNP fails. A pays off only if a six-month outage would cost us more than about 700 thousand at a 10 percent annual risk, or 1.4 million at 5 percent. My recommendation, in order: first, price discovery - get PCI's real number, it is free and it decides this; at or below a dollar fifty we go to A, at two-fifty and above we stay B unless the outage cost is large, and in between the outage number decides. Second, either way, strengthen SNP now. Third, if it is B, settle with PCI honestly. Three asks: the outage-cost number from Finance and Ops; the go-ahead to get PCI's price now; and approval to formalize SNP.</a:t>
+              <a:t>The decision. A costs about 70 thousand a year at the mid price and buys recovery in weeks - if the ramp plan is real. B costs almost nothing and leaves us exposed for months if SNP fails. A pays off only if a six-month outage would cost us more than about 700 thousand at a 10 percent annual risk, or 1.4 million at 5 percent. My recommendation, in order: first, price discovery - get PCI's real number, it is free and it decides this; at or below a dollar fifty we go to A, at two-fifty and above we stay B unless the outage cost is large, and in between the outage number decides. Second, either way, strengthen SNP now. Third, if it is B, settle with PCI honestly. Three asks: the outage-cost number from Finance and Ops - per hydrogel SKU, trailing revenue, contribution margin, and how much demand would be deferred versus lost; if they will not commit, two yes-or-no answers place us on the table: is a six-month stop more or less than a million dollars, more or less than three; the go-ahead to get PCI's price now; and approval to formalize SNP. LIKELY QUESTIONS. One: 'In July you said six to twelve thousand; now it is seventy.' Both were honest: July assumed a dollar to a dollar twenty-five and a share no supplier will accept; this is the same plan at real prices - and if PCI comes in at a dollar fifty, July's number is back. Two: 'If SNP burns down tomorrow, what actually happens?' Today, production stops for six to twelve months. Under A with a signed ramp, a gap of two to six weeks. Under B with the resin buffer and the cold-start kit, months rather than a year. No option closes the gap without PCI's written capacity commitment - which is why getting it is step one. Three: 'Why not just pay the seventy thousand - it is a rounding error against the device line?' Because at that price it covers a third of supply, not all of it; it drops us below one percent of SNP's revenue at the moment we want first call on their capacity and innovation; and standing risk lines are the first thing cut in a budget cycle - nearly half of companies in McKinsey's 2024 survey were cutting risk buffers. If the outage cost clears the break-even, we pay it; the triggers make that automatic.</a:t>
             </a:r>
           </a:p>
         </p:txBody>
@@ -8584,13 +8584,13 @@
               </a:spcAft>
             </a:pPr>
             <a:r>
-              <a:rPr sz="1150" b="0" i="0">
+              <a:rPr sz="1100" b="0" i="0">
                 <a:solidFill>
                   <a:srgbClr val="595959"/>
                 </a:solidFill>
                 <a:latin typeface="Calibri"/>
               </a:rPr>
-              <a:t>•  Every drum is made to order — an 18–30 day shelf life means no safety stock, from either supplier</a:t>
+              <a:t>•  Every drum is made to order — an 18–30 day shelf life means no safety stock from either supplier. Drums arrive already aged, so real time-to-survive is ~1–1.5 weeks, not 2½</a:t>
             </a:r>
           </a:p>
           <a:p>
@@ -8600,7 +8600,7 @@
               </a:spcAft>
             </a:pPr>
             <a:r>
-              <a:rPr sz="1150" b="0" i="0">
+              <a:rPr sz="1100" b="0" i="0">
                 <a:solidFill>
                   <a:srgbClr val="595959"/>
                 </a:solidFill>
@@ -8616,7 +8616,7 @@
               </a:spcAft>
             </a:pPr>
             <a:r>
-              <a:rPr sz="1150" b="0" i="0">
+              <a:rPr sz="1100" b="0" i="0">
                 <a:solidFill>
                   <a:srgbClr val="595959"/>
                 </a:solidFill>
@@ -8846,13 +8846,13 @@
               </a:spcAft>
             </a:pPr>
             <a:r>
-              <a:rPr sz="1150" b="0" i="0">
+              <a:rPr sz="1050" b="0" i="0">
                 <a:solidFill>
                   <a:srgbClr val="595959"/>
                 </a:solidFill>
                 <a:latin typeface="Calibri"/>
               </a:rPr>
-              <a:t>•  A standing overhead: ~1 extra incoming-QC lot per week, dual documentation, two relationships, annual re-check of each</a:t>
+              <a:t>•  A standing overhead: ~1 extra incoming-QC lot per week, dual documentation, two relationships — plus R&amp;D and Quality time for hydrogel equivalence by source and CAPA across two streams. Two suppliers also means two chances of a quality escape</a:t>
             </a:r>
           </a:p>
           <a:p>
@@ -8862,7 +8862,7 @@
               </a:spcAft>
             </a:pPr>
             <a:r>
-              <a:rPr sz="1150" b="0" i="0">
+              <a:rPr sz="1050" b="0" i="0">
                 <a:solidFill>
                   <a:srgbClr val="595959"/>
                 </a:solidFill>
@@ -8878,13 +8878,13 @@
               </a:spcAft>
             </a:pPr>
             <a:r>
-              <a:rPr sz="1150" b="0" i="0">
+              <a:rPr sz="1050" b="0" i="0">
                 <a:solidFill>
                   <a:srgbClr val="595959"/>
                 </a:solidFill>
                 <a:latin typeface="Calibri"/>
               </a:rPr>
-              <a:t>•  If PCI's shelf-life study shows 30 days rather than 18, cadence loosens slightly; it does not create a buffer</a:t>
+              <a:t>•  Sub-tier check: if both cook the same producer's resin, a second cooker hedges cooking, not resin — the shelf-stable resin buffer is the hedge either way</a:t>
             </a:r>
           </a:p>
         </p:txBody>
@@ -8967,7 +8967,7 @@
                 </a:solidFill>
                 <a:latin typeface="Calibri"/>
               </a:rPr>
-              <a:t>What it buys</a:t>
+              <a:t>What it buys — and the cheapest lever of all</a:t>
             </a:r>
           </a:p>
           <a:p>
@@ -8977,13 +8977,13 @@
               </a:spcAft>
             </a:pPr>
             <a:r>
-              <a:rPr sz="1150" b="0" i="0">
+              <a:rPr sz="1050" b="0" i="0">
                 <a:solidFill>
                   <a:srgbClr val="595959"/>
                 </a:solidFill>
                 <a:latin typeface="Calibri"/>
               </a:rPr>
-              <a:t>•  Recovery in weeks, not months, if SNP Inc. fails — provided the ramp plan is real</a:t>
+              <a:t>•  Recovery in weeks, not months, if SNP Inc. fails — provided the ramp plan is real; a live price reference; a second set of process knowledge</a:t>
             </a:r>
           </a:p>
           <a:p>
@@ -8993,13 +8993,13 @@
               </a:spcAft>
             </a:pPr>
             <a:r>
-              <a:rPr sz="1150" b="0" i="0">
+              <a:rPr sz="1050" b="0" i="0">
                 <a:solidFill>
                   <a:srgbClr val="595959"/>
                 </a:solidFill>
                 <a:latin typeface="Calibri"/>
               </a:rPr>
-              <a:t>•  A live price reference and a second set of process knowledge</a:t>
+              <a:t>•  It does NOT remove the exposure: ~2/3 of volume still stops until the ramp completes</a:t>
             </a:r>
           </a:p>
           <a:p>
@@ -9009,13 +9009,13 @@
               </a:spcAft>
             </a:pPr>
             <a:r>
-              <a:rPr sz="1150" b="0" i="0">
+              <a:rPr sz="1050" b="0" i="0">
                 <a:solidFill>
                   <a:srgbClr val="595959"/>
                 </a:solidFill>
                 <a:latin typeface="Calibri"/>
               </a:rPr>
-              <a:t>•  It does NOT remove the exposure: ~2/3 of volume still stops until the ramp completes</a:t>
+              <a:t>•  Under either option, a validated 30–45-day shelf-life study (biocide / refrigeration) lengthens time-to-survive for a lab study's cost — worth doing first</a:t>
             </a:r>
           </a:p>
         </p:txBody>
@@ -9759,7 +9759,7 @@
         </p:nvGraphicFramePr>
         <p:xfrm>
           <a:off x="548640" y="1097280"/>
-          <a:ext cx="11064240" cy="2926080"/>
+          <a:ext cx="11064240" cy="2606040"/>
         </p:xfrm>
         <a:graphic>
           <a:graphicData uri="http://schemas.openxmlformats.org/drawingml/2006/table">
@@ -9772,7 +9772,7 @@
                 <a:gridCol w="4480560"/>
                 <a:gridCol w="4480560"/>
               </a:tblGrid>
-              <a:tr h="418011">
+              <a:tr h="372291">
                 <a:tc>
                   <a:txBody>
                     <a:bodyPr/>
@@ -9780,7 +9780,7 @@
                     <a:p>
                       <a:pPr algn="l"/>
                       <a:r>
-                        <a:rPr sz="1100" b="1">
+                        <a:rPr sz="1050" b="1">
                           <a:solidFill>
                             <a:srgbClr val="FFFFFF"/>
                           </a:solidFill>
@@ -9803,7 +9803,7 @@
                     <a:p>
                       <a:pPr algn="ctr"/>
                       <a:r>
-                        <a:rPr sz="1100" b="1">
+                        <a:rPr sz="1050" b="1">
                           <a:solidFill>
                             <a:srgbClr val="FFFFFF"/>
                           </a:solidFill>
@@ -9826,7 +9826,7 @@
                     <a:p>
                       <a:pPr algn="ctr"/>
                       <a:r>
-                        <a:rPr sz="1100" b="1">
+                        <a:rPr sz="1050" b="1">
                           <a:solidFill>
                             <a:srgbClr val="FFFFFF"/>
                           </a:solidFill>
@@ -9843,7 +9843,7 @@
                   </a:tcPr>
                 </a:tc>
               </a:tr>
-              <a:tr h="418011">
+              <a:tr h="372291">
                 <a:tc>
                   <a:txBody>
                     <a:bodyPr/>
@@ -9851,7 +9851,7 @@
                     <a:p>
                       <a:pPr algn="l"/>
                       <a:r>
-                        <a:rPr sz="1100" b="1">
+                        <a:rPr sz="1050" b="1">
                           <a:solidFill>
                             <a:srgbClr val="1F3864"/>
                           </a:solidFill>
@@ -9874,7 +9874,7 @@
                     <a:p>
                       <a:pPr algn="ctr"/>
                       <a:r>
-                        <a:rPr sz="1100">
+                        <a:rPr sz="1050">
                           <a:solidFill>
                             <a:srgbClr val="1F3864"/>
                           </a:solidFill>
@@ -9897,13 +9897,13 @@
                     <a:p>
                       <a:pPr algn="ctr"/>
                       <a:r>
-                        <a:rPr sz="1100">
+                        <a:rPr sz="1050">
                           <a:solidFill>
                             <a:srgbClr val="1F3864"/>
                           </a:solidFill>
                           <a:latin typeface="Calibri"/>
                         </a:rPr>
-                        <a:t>~$0 + a few $k continuity spend</a:t>
+                        <a:t>~$3–12k/yr continuity bundle</a:t>
                       </a:r>
                     </a:p>
                   </a:txBody>
@@ -9914,7 +9914,7 @@
                   </a:tcPr>
                 </a:tc>
               </a:tr>
-              <a:tr h="418011">
+              <a:tr h="372291">
                 <a:tc>
                   <a:txBody>
                     <a:bodyPr/>
@@ -9922,7 +9922,7 @@
                     <a:p>
                       <a:pPr algn="l"/>
                       <a:r>
-                        <a:rPr sz="1100" b="1">
+                        <a:rPr sz="1050" b="1">
                           <a:solidFill>
                             <a:srgbClr val="1F3864"/>
                           </a:solidFill>
@@ -9945,7 +9945,7 @@
                     <a:p>
                       <a:pPr algn="ctr"/>
                       <a:r>
-                        <a:rPr sz="1100">
+                        <a:rPr sz="1050">
                           <a:solidFill>
                             <a:srgbClr val="1F3864"/>
                           </a:solidFill>
@@ -9968,13 +9968,13 @@
                     <a:p>
                       <a:pPr algn="ctr"/>
                       <a:r>
-                        <a:rPr sz="1100">
+                        <a:rPr sz="1050">
                           <a:solidFill>
                             <a:srgbClr val="1F3864"/>
                           </a:solidFill>
                           <a:latin typeface="Calibri"/>
                         </a:rPr>
-                        <a:t>~$0</a:t>
+                        <a:t>~$15–60k, plus ~$5–10k one-time</a:t>
                       </a:r>
                     </a:p>
                   </a:txBody>
@@ -9985,7 +9985,7 @@
                   </a:tcPr>
                 </a:tc>
               </a:tr>
-              <a:tr h="418011">
+              <a:tr h="372291">
                 <a:tc>
                   <a:txBody>
                     <a:bodyPr/>
@@ -9993,7 +9993,7 @@
                     <a:p>
                       <a:pPr algn="l"/>
                       <a:r>
-                        <a:rPr sz="1100" b="1">
+                        <a:rPr sz="1050" b="1">
                           <a:solidFill>
                             <a:srgbClr val="1F3864"/>
                           </a:solidFill>
@@ -10016,7 +10016,7 @@
                     <a:p>
                       <a:pPr algn="ctr"/>
                       <a:r>
-                        <a:rPr sz="1100">
+                        <a:rPr sz="1050">
                           <a:solidFill>
                             <a:srgbClr val="1F3864"/>
                           </a:solidFill>
@@ -10039,7 +10039,7 @@
                     <a:p>
                       <a:pPr algn="ctr"/>
                       <a:r>
-                        <a:rPr sz="1100">
+                        <a:rPr sz="1050">
                           <a:solidFill>
                             <a:srgbClr val="1F3864"/>
                           </a:solidFill>
@@ -10056,7 +10056,7 @@
                   </a:tcPr>
                 </a:tc>
               </a:tr>
-              <a:tr h="418011">
+              <a:tr h="372291">
                 <a:tc>
                   <a:txBody>
                     <a:bodyPr/>
@@ -10064,7 +10064,7 @@
                     <a:p>
                       <a:pPr algn="l"/>
                       <a:r>
-                        <a:rPr sz="1100" b="1">
+                        <a:rPr sz="1050" b="1">
                           <a:solidFill>
                             <a:srgbClr val="1F3864"/>
                           </a:solidFill>
@@ -10087,7 +10087,7 @@
                     <a:p>
                       <a:pPr algn="ctr"/>
                       <a:r>
-                        <a:rPr sz="1100">
+                        <a:rPr sz="1050">
                           <a:solidFill>
                             <a:srgbClr val="1F3864"/>
                           </a:solidFill>
@@ -10110,7 +10110,7 @@
                     <a:p>
                       <a:pPr algn="ctr"/>
                       <a:r>
-                        <a:rPr sz="1100">
+                        <a:rPr sz="1050">
                           <a:solidFill>
                             <a:srgbClr val="1F3864"/>
                           </a:solidFill>
@@ -10127,7 +10127,7 @@
                   </a:tcPr>
                 </a:tc>
               </a:tr>
-              <a:tr h="418011">
+              <a:tr h="372291">
                 <a:tc>
                   <a:txBody>
                     <a:bodyPr/>
@@ -10135,7 +10135,7 @@
                     <a:p>
                       <a:pPr algn="l"/>
                       <a:r>
-                        <a:rPr sz="1100" b="1">
+                        <a:rPr sz="1050" b="1">
                           <a:solidFill>
                             <a:srgbClr val="1F3864"/>
                           </a:solidFill>
@@ -10158,7 +10158,7 @@
                     <a:p>
                       <a:pPr algn="ctr"/>
                       <a:r>
-                        <a:rPr sz="1100">
+                        <a:rPr sz="1050">
                           <a:solidFill>
                             <a:srgbClr val="1F3864"/>
                           </a:solidFill>
@@ -10181,7 +10181,7 @@
                     <a:p>
                       <a:pPr algn="ctr"/>
                       <a:r>
-                        <a:rPr sz="1100">
+                        <a:rPr sz="1050">
                           <a:solidFill>
                             <a:srgbClr val="1F3864"/>
                           </a:solidFill>
@@ -10198,7 +10198,7 @@
                   </a:tcPr>
                 </a:tc>
               </a:tr>
-              <a:tr h="418014">
+              <a:tr h="372294">
                 <a:tc>
                   <a:txBody>
                     <a:bodyPr/>
@@ -10206,7 +10206,7 @@
                     <a:p>
                       <a:pPr algn="l"/>
                       <a:r>
-                        <a:rPr sz="1100" b="1">
+                        <a:rPr sz="1050" b="1">
                           <a:solidFill>
                             <a:srgbClr val="1F3864"/>
                           </a:solidFill>
@@ -10229,7 +10229,7 @@
                     <a:p>
                       <a:pPr algn="ctr"/>
                       <a:r>
-                        <a:rPr sz="1100">
+                        <a:rPr sz="1050">
                           <a:solidFill>
                             <a:srgbClr val="1F3864"/>
                           </a:solidFill>
@@ -10252,7 +10252,7 @@
                     <a:p>
                       <a:pPr algn="ctr"/>
                       <a:r>
-                        <a:rPr sz="1100">
+                        <a:rPr sz="1050">
                           <a:solidFill>
                             <a:srgbClr val="1F3864"/>
                           </a:solidFill>
@@ -10281,8 +10281,8 @@
         </p:nvSpPr>
         <p:spPr>
           <a:xfrm>
-            <a:off x="548640" y="4160520"/>
-            <a:ext cx="5440680" cy="1691640"/>
+            <a:off x="548640" y="3840480"/>
+            <a:ext cx="5440680" cy="2057400"/>
           </a:xfrm>
           <a:prstGeom prst="rect">
             <a:avLst/>
@@ -10325,8 +10325,8 @@
         </p:nvSpPr>
         <p:spPr>
           <a:xfrm>
-            <a:off x="731520" y="4297680"/>
-            <a:ext cx="5074920" cy="1417320"/>
+            <a:off x="731520" y="3977640"/>
+            <a:ext cx="5074920" cy="1783080"/>
           </a:xfrm>
           <a:prstGeom prst="rect">
             <a:avLst/>
@@ -10361,7 +10361,7 @@
               </a:spcAft>
             </a:pPr>
             <a:r>
-              <a:rPr sz="1000" b="0" i="0">
+              <a:rPr sz="950" b="0" i="0">
                 <a:solidFill>
                   <a:srgbClr val="595959"/>
                 </a:solidFill>
@@ -10377,13 +10377,13 @@
               </a:spcAft>
             </a:pPr>
             <a:r>
-              <a:rPr sz="1000" b="0" i="0">
+              <a:rPr sz="950" b="0" i="0">
                 <a:solidFill>
                   <a:srgbClr val="595959"/>
                 </a:solidFill>
                 <a:latin typeface="Calibri"/>
               </a:rPr>
-              <a:t>•  2. Either way, strengthen SNP Inc. now: forecast, hydrogel program, continuity terms, shelf-stable RESIN on consignment, annual financial check.</a:t>
+              <a:t>•  2. Either way, strengthen SNP Inc. now: forecast, hydrogel program, continuity terms, shelf-stable RESIN on consignment, annual financial check — and confirm their capacity headroom for +10%/yr. Say plainly that continuity planning is a quality-system requirement, not a loss of confidence.</a:t>
             </a:r>
           </a:p>
           <a:p>
@@ -10393,13 +10393,13 @@
               </a:spcAft>
             </a:pPr>
             <a:r>
-              <a:rPr sz="1000" b="0" i="0">
+              <a:rPr sz="950" b="0" i="0">
                 <a:solidFill>
                   <a:srgbClr val="595959"/>
                 </a:solidFill>
                 <a:latin typeface="Calibri"/>
               </a:rPr>
-              <a:t>•  3. If B: settle with PCI Manufacturing honestly — pay for the work, state the triggers.</a:t>
+              <a:t>•  3. If B: settle with PCI Manufacturing honestly — pay for the work, state the triggers. Waiting is not passive: growth widens the feasible supplier set and shrinks the minimum share (35% → 24% by year 5).</a:t>
             </a:r>
           </a:p>
         </p:txBody>
@@ -10412,8 +10412,8 @@
         </p:nvSpPr>
         <p:spPr>
           <a:xfrm>
-            <a:off x="6172200" y="4160520"/>
-            <a:ext cx="5440680" cy="1691640"/>
+            <a:off x="6172200" y="3840480"/>
+            <a:ext cx="5440680" cy="2057400"/>
           </a:xfrm>
           <a:prstGeom prst="rect">
             <a:avLst/>
@@ -10456,8 +10456,8 @@
         </p:nvSpPr>
         <p:spPr>
           <a:xfrm>
-            <a:off x="6355080" y="4297680"/>
-            <a:ext cx="5074920" cy="1417320"/>
+            <a:off x="6355080" y="3977640"/>
+            <a:ext cx="5074920" cy="1783080"/>
           </a:xfrm>
           <a:prstGeom prst="rect">
             <a:avLst/>
@@ -10492,7 +10492,7 @@
               </a:spcAft>
             </a:pPr>
             <a:r>
-              <a:rPr sz="1050" b="0" i="0">
+              <a:rPr sz="950" b="0" i="0">
                 <a:solidFill>
                   <a:srgbClr val="595959"/>
                 </a:solidFill>
@@ -10508,13 +10508,29 @@
               </a:spcAft>
             </a:pPr>
             <a:r>
-              <a:rPr sz="1050" b="0" i="0">
+              <a:rPr sz="950" b="0" i="0">
                 <a:solidFill>
                   <a:srgbClr val="595959"/>
                 </a:solidFill>
                 <a:latin typeface="Calibri"/>
               </a:rPr>
               <a:t>•  PCI Manufacturing quotes ≤ ~$1.50/lb (premium falls to ~$18k)  ·  a new hydrogel line makes PVA strategic  ·  SNP Inc. declines the partnership</a:t>
+            </a:r>
+          </a:p>
+          <a:p>
+            <a:pPr algn="l">
+              <a:spcAft>
+                <a:spcPts val="600"/>
+              </a:spcAft>
+            </a:pPr>
+            <a:r>
+              <a:rPr sz="950" b="0" i="0">
+                <a:solidFill>
+                  <a:srgbClr val="595959"/>
+                </a:solidFill>
+                <a:latin typeface="Calibri"/>
+              </a:rPr>
+              <a:t>•  SNP Inc.'s capacity headroom falls short of year-5 volume (~99k lb) — then this is a capacity question, not an insurance one</a:t>
             </a:r>
           </a:p>
         </p:txBody>
@@ -10591,13 +10607,13 @@
               </a:spcAft>
             </a:pPr>
             <a:r>
-              <a:rPr sz="1400" b="1" i="0">
+              <a:rPr sz="1200" b="1" i="0">
                 <a:solidFill>
                   <a:srgbClr val="FFFFFF"/>
                 </a:solidFill>
                 <a:latin typeface="Calibri"/>
               </a:rPr>
-              <a:t>The ask: (1) the cost of a 6-month PVA outage, from Finance/Ops; (2) go-ahead to get PCI's real price now; (3) approval to formalize SNP Inc. — then A or B by the table.</a:t>
+              <a:t>Asks: (1) the outage cost — per hydrogel SKU: revenue, contribution margin, deferrable vs lost demand (fallback: more or less than $1M? $3M?); (2) get PCI's price now; (3) formalize SNP Inc.</a:t>
             </a:r>
           </a:p>
         </p:txBody>
@@ -11484,13 +11500,13 @@
               </a:spcAft>
             </a:pPr>
             <a:r>
-              <a:rPr sz="950" b="0" i="0">
+              <a:rPr sz="850" b="0" i="0">
                 <a:solidFill>
                   <a:srgbClr val="595959"/>
                 </a:solidFill>
                 <a:latin typeface="Calibri"/>
               </a:rPr>
-              <a:t>Kraljic portfolio model (HBR 1983): low-spend/high-risk 'bottleneck' items → secure supply. Simchi-Levi, Time-to-Recover vs Time-to-Survive (HBR 2014): exposure = recovery time beyond survival time. Tomlin (Management Science 2006): for rare, long disruptions a prepared contingency can beat continuous dual-sourcing. FDA QMSR / ISO 13485 §7.4 and GHTF/SG3/N17: supplier controls proportionate to risk — a documented sole-source risk assessment and contingency plan, not a mandated second supplier.</a:t>
+              <a:t>Kraljic (HBR 1983) — bottleneck items: 'Volume insurance (at cost premium if necessary). Control of vendors. Security of inventories. Backup plans.' — pay for a backup when the premium is proportionate; decide at leadership level. Gelderman &amp; van Weele (2003): 'hold' (accept dependence, reduce consequences) vs 'move' (new supplier) — move only when economically worthwhile. Simchi-Levi et al. (Interfaces 2015, Ford): disruption impact is not correlated with spend; low-spend/high-impact suppliers are the hardest to dual-source. Sheffi &amp; Rice (MIT SMR 2005): single sourcing is legitimate only with a deep, actively managed relationship. Tomlin (Mgmt Sci 2006); Chopra &amp; Sodhi (MIT SMR 2014): assuming zero disruption probability is the expensive mistake. Pulles, Schiele et al. (2016, n=91 suppliers): preferential treatment follows customer attractiveness, not volume. Deloitte CPO Survey 2025: 'maintaining active alternative sources' rated most effective (74%); McKinsey 2024 (secondary coverage): 73% progressing on dual sourcing while 46% were cutting risk buffers. FDA QMSR / ISO 13485 §7.4 / GHTF SG3/N17: controls proportionate to risk — no regulation requires a second source. Make in-house: a ~$30–60k bench cook is a days-to-weeks bridge only; full in-house production is uneconomic at $50k/yr of spend. Research: six lenses, independently fact-checked; four refuted claims excluded; full memo in the repo.</a:t>
             </a:r>
           </a:p>
         </p:txBody>

</xml_diff>

<commit_message>
Deck v3.1: fix appendix and recommendation-panel overflow
Co-Authored-By: Claude Fable 5.1 <noreply@anthropic.com>
Claude-Session: https://claude.ai/code/session_01LkE2ZRYs3PLyj8XHTsU3i4
</commit_message>
<xml_diff>
--- a/PVA second supplier initiative/PVA_Second_Supplier_Leadership_Deck.pptx
+++ b/PVA second supplier initiative/PVA_Second_Supplier_Leadership_Deck.pptx
@@ -10361,7 +10361,7 @@
               </a:spcAft>
             </a:pPr>
             <a:r>
-              <a:rPr sz="950" b="0" i="0">
+              <a:rPr sz="919" b="0" i="0">
                 <a:solidFill>
                   <a:srgbClr val="595959"/>
                 </a:solidFill>
@@ -10377,13 +10377,13 @@
               </a:spcAft>
             </a:pPr>
             <a:r>
-              <a:rPr sz="950" b="0" i="0">
+              <a:rPr sz="919" b="0" i="0">
                 <a:solidFill>
                   <a:srgbClr val="595959"/>
                 </a:solidFill>
                 <a:latin typeface="Calibri"/>
               </a:rPr>
-              <a:t>•  2. Either way, strengthen SNP Inc. now: forecast, hydrogel program, continuity terms, shelf-stable RESIN on consignment, annual financial check — and confirm their capacity headroom for +10%/yr. Say plainly that continuity planning is a quality-system requirement, not a loss of confidence.</a:t>
+              <a:t>•  2. Either way, strengthen SNP Inc. now: forecast, hydrogel program, continuity terms, shelf-stable RESIN on consignment, annual financial check; confirm their capacity headroom for +10%/yr; say plainly that continuity planning is a quality-system requirement, not a loss of confidence.</a:t>
             </a:r>
           </a:p>
           <a:p>
@@ -10393,13 +10393,13 @@
               </a:spcAft>
             </a:pPr>
             <a:r>
-              <a:rPr sz="950" b="0" i="0">
+              <a:rPr sz="919" b="0" i="0">
                 <a:solidFill>
                   <a:srgbClr val="595959"/>
                 </a:solidFill>
                 <a:latin typeface="Calibri"/>
               </a:rPr>
-              <a:t>•  3. If B: settle with PCI Manufacturing honestly — pay for the work, state the triggers. Waiting is not passive: growth widens the feasible supplier set and shrinks the minimum share (35% → 24% by year 5).</a:t>
+              <a:t>•  3. If B: settle with PCI Manufacturing honestly — pay for the work, state the triggers. Waiting is not passive: growth widens the feasible supplier set (minimum share 35% → 24% by year 5).</a:t>
             </a:r>
           </a:p>
         </p:txBody>
@@ -10729,7 +10729,7 @@
         </p:nvGraphicFramePr>
         <p:xfrm>
           <a:off x="548640" y="1051560"/>
-          <a:ext cx="6309360" cy="3566160"/>
+          <a:ext cx="6309360" cy="3017520"/>
         </p:xfrm>
         <a:graphic>
           <a:graphicData uri="http://schemas.openxmlformats.org/drawingml/2006/table">
@@ -10742,7 +10742,7 @@
                 <a:gridCol w="2468880"/>
                 <a:gridCol w="2011680"/>
               </a:tblGrid>
-              <a:tr h="356616">
+              <a:tr h="301752">
                 <a:tc>
                   <a:txBody>
                     <a:bodyPr/>
@@ -10750,7 +10750,7 @@
                     <a:p>
                       <a:pPr algn="l"/>
                       <a:r>
-                        <a:rPr sz="950" b="1">
+                        <a:rPr sz="900" b="1">
                           <a:solidFill>
                             <a:srgbClr val="FFFFFF"/>
                           </a:solidFill>
@@ -10773,7 +10773,7 @@
                     <a:p>
                       <a:pPr algn="ctr"/>
                       <a:r>
-                        <a:rPr sz="950" b="1">
+                        <a:rPr sz="900" b="1">
                           <a:solidFill>
                             <a:srgbClr val="FFFFFF"/>
                           </a:solidFill>
@@ -10796,7 +10796,7 @@
                     <a:p>
                       <a:pPr algn="ctr"/>
                       <a:r>
-                        <a:rPr sz="950" b="1">
+                        <a:rPr sz="900" b="1">
                           <a:solidFill>
                             <a:srgbClr val="FFFFFF"/>
                           </a:solidFill>
@@ -10813,7 +10813,7 @@
                   </a:tcPr>
                 </a:tc>
               </a:tr>
-              <a:tr h="356616">
+              <a:tr h="301752">
                 <a:tc>
                   <a:txBody>
                     <a:bodyPr/>
@@ -10821,7 +10821,7 @@
                     <a:p>
                       <a:pPr algn="l"/>
                       <a:r>
-                        <a:rPr sz="950" b="1">
+                        <a:rPr sz="900" b="1">
                           <a:solidFill>
                             <a:srgbClr val="1F3864"/>
                           </a:solidFill>
@@ -10844,7 +10844,7 @@
                     <a:p>
                       <a:pPr algn="ctr"/>
                       <a:r>
-                        <a:rPr sz="950">
+                        <a:rPr sz="900">
                           <a:solidFill>
                             <a:srgbClr val="1F3864"/>
                           </a:solidFill>
@@ -10867,7 +10867,7 @@
                     <a:p>
                       <a:pPr algn="ctr"/>
                       <a:r>
-                        <a:rPr sz="950">
+                        <a:rPr sz="900">
                           <a:solidFill>
                             <a:srgbClr val="1F3864"/>
                           </a:solidFill>
@@ -10884,7 +10884,7 @@
                   </a:tcPr>
                 </a:tc>
               </a:tr>
-              <a:tr h="356616">
+              <a:tr h="301752">
                 <a:tc>
                   <a:txBody>
                     <a:bodyPr/>
@@ -10892,7 +10892,7 @@
                     <a:p>
                       <a:pPr algn="l"/>
                       <a:r>
-                        <a:rPr sz="950" b="1">
+                        <a:rPr sz="900" b="1">
                           <a:solidFill>
                             <a:srgbClr val="1F3864"/>
                           </a:solidFill>
@@ -10915,7 +10915,7 @@
                     <a:p>
                       <a:pPr algn="ctr"/>
                       <a:r>
-                        <a:rPr sz="950">
+                        <a:rPr sz="900">
                           <a:solidFill>
                             <a:srgbClr val="1F3864"/>
                           </a:solidFill>
@@ -10938,7 +10938,7 @@
                     <a:p>
                       <a:pPr algn="ctr"/>
                       <a:r>
-                        <a:rPr sz="950">
+                        <a:rPr sz="900">
                           <a:solidFill>
                             <a:srgbClr val="1F3864"/>
                           </a:solidFill>
@@ -10955,7 +10955,7 @@
                   </a:tcPr>
                 </a:tc>
               </a:tr>
-              <a:tr h="356616">
+              <a:tr h="301752">
                 <a:tc>
                   <a:txBody>
                     <a:bodyPr/>
@@ -10963,7 +10963,7 @@
                     <a:p>
                       <a:pPr algn="l"/>
                       <a:r>
-                        <a:rPr sz="950" b="1">
+                        <a:rPr sz="900" b="1">
                           <a:solidFill>
                             <a:srgbClr val="1F3864"/>
                           </a:solidFill>
@@ -10986,7 +10986,7 @@
                     <a:p>
                       <a:pPr algn="ctr"/>
                       <a:r>
-                        <a:rPr sz="950">
+                        <a:rPr sz="900">
                           <a:solidFill>
                             <a:srgbClr val="1F3864"/>
                           </a:solidFill>
@@ -11009,7 +11009,7 @@
                     <a:p>
                       <a:pPr algn="ctr"/>
                       <a:r>
-                        <a:rPr sz="950">
+                        <a:rPr sz="900">
                           <a:solidFill>
                             <a:srgbClr val="1F3864"/>
                           </a:solidFill>
@@ -11026,7 +11026,7 @@
                   </a:tcPr>
                 </a:tc>
               </a:tr>
-              <a:tr h="356616">
+              <a:tr h="301752">
                 <a:tc>
                   <a:txBody>
                     <a:bodyPr/>
@@ -11034,7 +11034,7 @@
                     <a:p>
                       <a:pPr algn="l"/>
                       <a:r>
-                        <a:rPr sz="950" b="1">
+                        <a:rPr sz="900" b="1">
                           <a:solidFill>
                             <a:srgbClr val="1F3864"/>
                           </a:solidFill>
@@ -11057,7 +11057,7 @@
                     <a:p>
                       <a:pPr algn="ctr"/>
                       <a:r>
-                        <a:rPr sz="950">
+                        <a:rPr sz="900">
                           <a:solidFill>
                             <a:srgbClr val="1F3864"/>
                           </a:solidFill>
@@ -11080,7 +11080,7 @@
                     <a:p>
                       <a:pPr algn="ctr"/>
                       <a:r>
-                        <a:rPr sz="950">
+                        <a:rPr sz="900">
                           <a:solidFill>
                             <a:srgbClr val="1F3864"/>
                           </a:solidFill>
@@ -11097,7 +11097,7 @@
                   </a:tcPr>
                 </a:tc>
               </a:tr>
-              <a:tr h="356616">
+              <a:tr h="301752">
                 <a:tc>
                   <a:txBody>
                     <a:bodyPr/>
@@ -11105,7 +11105,7 @@
                     <a:p>
                       <a:pPr algn="l"/>
                       <a:r>
-                        <a:rPr sz="950" b="1">
+                        <a:rPr sz="900" b="1">
                           <a:solidFill>
                             <a:srgbClr val="1F3864"/>
                           </a:solidFill>
@@ -11128,7 +11128,7 @@
                     <a:p>
                       <a:pPr algn="ctr"/>
                       <a:r>
-                        <a:rPr sz="950">
+                        <a:rPr sz="900">
                           <a:solidFill>
                             <a:srgbClr val="1F3864"/>
                           </a:solidFill>
@@ -11151,7 +11151,7 @@
                     <a:p>
                       <a:pPr algn="ctr"/>
                       <a:r>
-                        <a:rPr sz="950">
+                        <a:rPr sz="900">
                           <a:solidFill>
                             <a:srgbClr val="1F3864"/>
                           </a:solidFill>
@@ -11168,7 +11168,7 @@
                   </a:tcPr>
                 </a:tc>
               </a:tr>
-              <a:tr h="356616">
+              <a:tr h="301752">
                 <a:tc>
                   <a:txBody>
                     <a:bodyPr/>
@@ -11176,7 +11176,7 @@
                     <a:p>
                       <a:pPr algn="l"/>
                       <a:r>
-                        <a:rPr sz="950" b="1">
+                        <a:rPr sz="900" b="1">
                           <a:solidFill>
                             <a:srgbClr val="1F3864"/>
                           </a:solidFill>
@@ -11199,7 +11199,7 @@
                     <a:p>
                       <a:pPr algn="ctr"/>
                       <a:r>
-                        <a:rPr sz="950">
+                        <a:rPr sz="900">
                           <a:solidFill>
                             <a:srgbClr val="1F3864"/>
                           </a:solidFill>
@@ -11222,7 +11222,7 @@
                     <a:p>
                       <a:pPr algn="ctr"/>
                       <a:r>
-                        <a:rPr sz="950">
+                        <a:rPr sz="900">
                           <a:solidFill>
                             <a:srgbClr val="1F3864"/>
                           </a:solidFill>
@@ -11239,7 +11239,7 @@
                   </a:tcPr>
                 </a:tc>
               </a:tr>
-              <a:tr h="356616">
+              <a:tr h="301752">
                 <a:tc>
                   <a:txBody>
                     <a:bodyPr/>
@@ -11247,7 +11247,7 @@
                     <a:p>
                       <a:pPr algn="l"/>
                       <a:r>
-                        <a:rPr sz="950" b="1">
+                        <a:rPr sz="900" b="1">
                           <a:solidFill>
                             <a:srgbClr val="1F3864"/>
                           </a:solidFill>
@@ -11270,7 +11270,7 @@
                     <a:p>
                       <a:pPr algn="ctr"/>
                       <a:r>
-                        <a:rPr sz="950">
+                        <a:rPr sz="900">
                           <a:solidFill>
                             <a:srgbClr val="1F3864"/>
                           </a:solidFill>
@@ -11293,7 +11293,7 @@
                     <a:p>
                       <a:pPr algn="ctr"/>
                       <a:r>
-                        <a:rPr sz="950">
+                        <a:rPr sz="900">
                           <a:solidFill>
                             <a:srgbClr val="1F3864"/>
                           </a:solidFill>
@@ -11310,7 +11310,7 @@
                   </a:tcPr>
                 </a:tc>
               </a:tr>
-              <a:tr h="356616">
+              <a:tr h="301752">
                 <a:tc>
                   <a:txBody>
                     <a:bodyPr/>
@@ -11318,7 +11318,7 @@
                     <a:p>
                       <a:pPr algn="l"/>
                       <a:r>
-                        <a:rPr sz="950" b="1">
+                        <a:rPr sz="900" b="1">
                           <a:solidFill>
                             <a:srgbClr val="1F3864"/>
                           </a:solidFill>
@@ -11341,7 +11341,7 @@
                     <a:p>
                       <a:pPr algn="ctr"/>
                       <a:r>
-                        <a:rPr sz="950">
+                        <a:rPr sz="900">
                           <a:solidFill>
                             <a:srgbClr val="1F3864"/>
                           </a:solidFill>
@@ -11364,7 +11364,7 @@
                     <a:p>
                       <a:pPr algn="ctr"/>
                       <a:r>
-                        <a:rPr sz="950">
+                        <a:rPr sz="900">
                           <a:solidFill>
                             <a:srgbClr val="1F3864"/>
                           </a:solidFill>
@@ -11381,7 +11381,7 @@
                   </a:tcPr>
                 </a:tc>
               </a:tr>
-              <a:tr h="356616">
+              <a:tr h="301752">
                 <a:tc>
                   <a:txBody>
                     <a:bodyPr/>
@@ -11389,7 +11389,7 @@
                     <a:p>
                       <a:pPr algn="l"/>
                       <a:r>
-                        <a:rPr sz="950" b="1">
+                        <a:rPr sz="900" b="1">
                           <a:solidFill>
                             <a:srgbClr val="1F3864"/>
                           </a:solidFill>
@@ -11412,7 +11412,7 @@
                     <a:p>
                       <a:pPr algn="ctr"/>
                       <a:r>
-                        <a:rPr sz="950">
+                        <a:rPr sz="900">
                           <a:solidFill>
                             <a:srgbClr val="1F3864"/>
                           </a:solidFill>
@@ -11435,7 +11435,7 @@
                     <a:p>
                       <a:pPr algn="ctr"/>
                       <a:r>
-                        <a:rPr sz="950">
+                        <a:rPr sz="900">
                           <a:solidFill>
                             <a:srgbClr val="1F3864"/>
                           </a:solidFill>
@@ -11464,8 +11464,8 @@
         </p:nvSpPr>
         <p:spPr>
           <a:xfrm>
-            <a:off x="548640" y="4709160"/>
-            <a:ext cx="6309360" cy="1280160"/>
+            <a:off x="548640" y="4160520"/>
+            <a:ext cx="6309360" cy="1874519"/>
           </a:xfrm>
           <a:prstGeom prst="rect">
             <a:avLst/>
@@ -11490,7 +11490,7 @@
                 </a:solidFill>
                 <a:latin typeface="Calibri"/>
               </a:rPr>
-              <a:t>Frameworks behind the analysis</a:t>
+              <a:t>Frameworks behind the analysis (independently fact-checked)</a:t>
             </a:r>
           </a:p>
           <a:p>
@@ -11506,7 +11506,7 @@
                 </a:solidFill>
                 <a:latin typeface="Calibri"/>
               </a:rPr>
-              <a:t>Kraljic (HBR 1983) — bottleneck items: 'Volume insurance (at cost premium if necessary). Control of vendors. Security of inventories. Backup plans.' — pay for a backup when the premium is proportionate; decide at leadership level. Gelderman &amp; van Weele (2003): 'hold' (accept dependence, reduce consequences) vs 'move' (new supplier) — move only when economically worthwhile. Simchi-Levi et al. (Interfaces 2015, Ford): disruption impact is not correlated with spend; low-spend/high-impact suppliers are the hardest to dual-source. Sheffi &amp; Rice (MIT SMR 2005): single sourcing is legitimate only with a deep, actively managed relationship. Tomlin (Mgmt Sci 2006); Chopra &amp; Sodhi (MIT SMR 2014): assuming zero disruption probability is the expensive mistake. Pulles, Schiele et al. (2016, n=91 suppliers): preferential treatment follows customer attractiveness, not volume. Deloitte CPO Survey 2025: 'maintaining active alternative sources' rated most effective (74%); McKinsey 2024 (secondary coverage): 73% progressing on dual sourcing while 46% were cutting risk buffers. FDA QMSR / ISO 13485 §7.4 / GHTF SG3/N17: controls proportionate to risk — no regulation requires a second source. Make in-house: a ~$30–60k bench cook is a days-to-weeks bridge only; full in-house production is uneconomic at $50k/yr of spend. Research: six lenses, independently fact-checked; four refuted claims excluded; full memo in the repo.</a:t>
+              <a:t>Kraljic (HBR 1983), bottleneck items: 'Volume insurance (at cost premium if necessary). Control of vendors. Security of inventories. Backup plans' — pay for a backup when the premium is proportionate. Gelderman &amp; van Weele (2003): 'hold' vs 'move' — move only when economically worthwhile. Simchi-Levi et al. (Interfaces 2015, Ford): disruption impact is uncorrelated with spend. Sheffi &amp; Rice (MIT SMR 2005): single sourcing is legitimate only with a deep, managed relationship. Tomlin (2006); Chopra &amp; Sodhi (2014): assuming zero disruption probability is the expensive mistake. Pulles, Schiele et al. (2016): preferential treatment follows attractiveness, not volume. Deloitte CPO 2025: 'active alternative sources' rated most effective (74%); McKinsey 2024 (secondary): 46% cutting risk buffers. QMSR / ISO 13485 §7.4 / GHTF N17: controls proportionate to risk — no second source required. In-house make: a ~$30–60k bench cook is a bridge only. Six research lenses; four refuted claims excluded; memo in the repo.</a:t>
             </a:r>
           </a:p>
         </p:txBody>

</xml_diff>

<commit_message>
Deck v3.1: relax appendix and recommendation-panel fit
Co-Authored-By: Claude Fable 5.1 <noreply@anthropic.com>
Claude-Session: https://claude.ai/code/session_01LkE2ZRYs3PLyj8XHTsU3i4
</commit_message>
<xml_diff>
--- a/PVA second supplier initiative/PVA_Second_Supplier_Leadership_Deck.pptx
+++ b/PVA second supplier initiative/PVA_Second_Supplier_Leadership_Deck.pptx
@@ -9759,7 +9759,7 @@
         </p:nvGraphicFramePr>
         <p:xfrm>
           <a:off x="548640" y="1097280"/>
-          <a:ext cx="11064240" cy="2606040"/>
+          <a:ext cx="11064240" cy="2514600"/>
         </p:xfrm>
         <a:graphic>
           <a:graphicData uri="http://schemas.openxmlformats.org/drawingml/2006/table">
@@ -9772,7 +9772,7 @@
                 <a:gridCol w="4480560"/>
                 <a:gridCol w="4480560"/>
               </a:tblGrid>
-              <a:tr h="372291">
+              <a:tr h="359228">
                 <a:tc>
                   <a:txBody>
                     <a:bodyPr/>
@@ -9843,7 +9843,7 @@
                   </a:tcPr>
                 </a:tc>
               </a:tr>
-              <a:tr h="372291">
+              <a:tr h="359228">
                 <a:tc>
                   <a:txBody>
                     <a:bodyPr/>
@@ -9914,7 +9914,7 @@
                   </a:tcPr>
                 </a:tc>
               </a:tr>
-              <a:tr h="372291">
+              <a:tr h="359228">
                 <a:tc>
                   <a:txBody>
                     <a:bodyPr/>
@@ -9985,7 +9985,7 @@
                   </a:tcPr>
                 </a:tc>
               </a:tr>
-              <a:tr h="372291">
+              <a:tr h="359228">
                 <a:tc>
                   <a:txBody>
                     <a:bodyPr/>
@@ -10056,7 +10056,7 @@
                   </a:tcPr>
                 </a:tc>
               </a:tr>
-              <a:tr h="372291">
+              <a:tr h="359228">
                 <a:tc>
                   <a:txBody>
                     <a:bodyPr/>
@@ -10127,7 +10127,7 @@
                   </a:tcPr>
                 </a:tc>
               </a:tr>
-              <a:tr h="372291">
+              <a:tr h="359228">
                 <a:tc>
                   <a:txBody>
                     <a:bodyPr/>
@@ -10198,7 +10198,7 @@
                   </a:tcPr>
                 </a:tc>
               </a:tr>
-              <a:tr h="372294">
+              <a:tr h="359232">
                 <a:tc>
                   <a:txBody>
                     <a:bodyPr/>
@@ -10281,8 +10281,8 @@
         </p:nvSpPr>
         <p:spPr>
           <a:xfrm>
-            <a:off x="548640" y="3840480"/>
-            <a:ext cx="5440680" cy="2057400"/>
+            <a:off x="548640" y="3703320"/>
+            <a:ext cx="5440680" cy="2194560"/>
           </a:xfrm>
           <a:prstGeom prst="rect">
             <a:avLst/>
@@ -10325,8 +10325,8 @@
         </p:nvSpPr>
         <p:spPr>
           <a:xfrm>
-            <a:off x="731520" y="3977640"/>
-            <a:ext cx="5074920" cy="1783080"/>
+            <a:off x="731520" y="3840480"/>
+            <a:ext cx="5074920" cy="1920240"/>
           </a:xfrm>
           <a:prstGeom prst="rect">
             <a:avLst/>
@@ -10412,8 +10412,8 @@
         </p:nvSpPr>
         <p:spPr>
           <a:xfrm>
-            <a:off x="6172200" y="3840480"/>
-            <a:ext cx="5440680" cy="2057400"/>
+            <a:off x="6172200" y="3703320"/>
+            <a:ext cx="5440680" cy="2194560"/>
           </a:xfrm>
           <a:prstGeom prst="rect">
             <a:avLst/>
@@ -10456,8 +10456,8 @@
         </p:nvSpPr>
         <p:spPr>
           <a:xfrm>
-            <a:off x="6355080" y="3977640"/>
-            <a:ext cx="5074920" cy="1783080"/>
+            <a:off x="6355080" y="3840480"/>
+            <a:ext cx="5074920" cy="1920240"/>
           </a:xfrm>
           <a:prstGeom prst="rect">
             <a:avLst/>
@@ -11464,8 +11464,8 @@
         </p:nvSpPr>
         <p:spPr>
           <a:xfrm>
-            <a:off x="548640" y="4160520"/>
-            <a:ext cx="6309360" cy="1874519"/>
+            <a:off x="548640" y="4114800"/>
+            <a:ext cx="6309360" cy="2103120"/>
           </a:xfrm>
           <a:prstGeom prst="rect">
             <a:avLst/>
@@ -12023,8 +12023,8 @@
         </p:nvSpPr>
         <p:spPr>
           <a:xfrm>
-            <a:off x="548640" y="6035040"/>
-            <a:ext cx="11064240" cy="457200"/>
+            <a:off x="548640" y="6263640"/>
+            <a:ext cx="11064240" cy="411480"/>
           </a:xfrm>
           <a:prstGeom prst="rect">
             <a:avLst/>
@@ -12043,7 +12043,7 @@
               </a:spcAft>
             </a:pPr>
             <a:r>
-              <a:rPr sz="950" b="0" i="1">
+              <a:rPr sz="900" b="0" i="1">
                 <a:solidFill>
                   <a:srgbClr val="595959"/>
                 </a:solidFill>

</xml_diff>

<commit_message>
Deck v4: add 'Keeping a qualified supplier you don't use' slide; outline renumbered
Co-Authored-By: Claude Fable 5.1 <noreply@anthropic.com>
Claude-Session: https://claude.ai/code/session_01LkE2ZRYs3PLyj8XHTsU3i4
</commit_message>
<xml_diff>
--- a/PVA second supplier initiative/PVA_Second_Supplier_Leadership_Deck.pptx
+++ b/PVA second supplier initiative/PVA_Second_Supplier_Leadership_Deck.pptx
@@ -16,6 +16,7 @@
     <p:sldId id="264" r:id="rId15"/>
     <p:sldId id="265" r:id="rId16"/>
     <p:sldId id="266" r:id="rId17"/>
+    <p:sldId id="267" r:id="rId18"/>
   </p:sldIdLst>
   <p:sldSz cx="12191695" cy="6858000" type="screen4x3"/>
   <p:notesSz cx="6858000" cy="9144000"/>
@@ -582,7 +583,7 @@
           <a:lstStyle/>
           <a:p>
             <a:r>
-              <a:t>Recommendation: B-plus with the existing triggers. Order one production batch from PCI now; go into the SNP conversation as a partner and settle the six items on the previous slide; tell PCI the triggers candidly. Switch to A if Finance's outage number clears the break-even, if SNP shows a risk signal - capacity, succession, finances, a missed lot - if PCI's price falls toward a dollar fifty, or if SNP declines the terms. Three asks: the outage-cost number, per hydrogel SKU; the strategy call before the SNP conversation; and approval to formalize SNP plus about 8 thousand for one PCI batch.</a:t>
+              <a:t>Why decide now. Our next face-to-face with SNP is where the strategy becomes real - continuity terms, forecast sharing, resin consignment, capacity headroom, succession. The posture has to match the decision: we cannot deepen the partnership while quietly planning to move a third of their core line, and telling them after a warm visit reads as bait-and-switch. If the answer is A, the volume conversation belongs in that meeting, face to face, with a steady-cadence proposal. If it is B or B-plus, that is the partnership meeting: continuity planning framed as a quality-system requirement, PCI not named, the quote not waved. Decide first; use the meeting to execute, not to discover.</a:t>
             </a:r>
           </a:p>
         </p:txBody>
@@ -652,6 +653,76 @@
           <a:lstStyle/>
           <a:p>
             <a:r>
+              <a:t>Recommendation: B-plus with the existing triggers. Order one production batch from PCI now; go into the SNP conversation as a partner and settle the six items on the previous slide; tell PCI the triggers candidly. Switch to A if Finance's outage number clears the break-even, if SNP shows a risk signal - capacity, succession, finances, a missed lot - if PCI's price falls toward a dollar fifty, or if SNP declines the terms. Three asks: the outage-cost number, per hydrogel SKU; the strategy call before the SNP conversation; and approval to formalize SNP plus about 8 thousand for one PCI batch.</a:t>
+            </a:r>
+          </a:p>
+        </p:txBody>
+      </p:sp>
+      <p:sp>
+        <p:nvSpPr>
+          <p:cNvPr id="4" name="Slide Number Placeholder 3"/>
+          <p:cNvSpPr>
+            <a:spLocks noGrp="1"/>
+          </p:cNvSpPr>
+          <p:nvPr>
+            <p:ph type="sldNum" idx="5" sz="quarter"/>
+          </p:nvPr>
+        </p:nvSpPr>
+        <p:spPr/>
+      </p:sp>
+    </p:spTree>
+  </p:cSld>
+  <p:clrMapOvr>
+    <a:masterClrMapping/>
+  </p:clrMapOvr>
+</p:notes>
+</file>
+
+<file path=ppt/notesSlides/notesSlide12.xml><?xml version="1.0" encoding="utf-8"?>
+<p:notes xmlns:a="http://schemas.openxmlformats.org/drawingml/2006/main" xmlns:p="http://schemas.openxmlformats.org/presentationml/2006/main" xmlns:r="http://schemas.openxmlformats.org/officeDocument/2006/relationships">
+  <p:cSld>
+    <p:spTree>
+      <p:nvGrpSpPr>
+        <p:cNvPr id="1" name=""/>
+        <p:cNvGrpSpPr/>
+        <p:nvPr/>
+      </p:nvGrpSpPr>
+      <p:grpSpPr>
+        <a:xfrm>
+          <a:off x="0" y="0"/>
+          <a:ext cx="0" cy="0"/>
+          <a:chOff x="0" y="0"/>
+          <a:chExt cx="0" cy="0"/>
+        </a:xfrm>
+      </p:grpSpPr>
+      <p:sp>
+        <p:nvSpPr>
+          <p:cNvPr id="2" name="Slide Image Placeholder 1"/>
+          <p:cNvSpPr>
+            <a:spLocks noGrp="1"/>
+          </p:cNvSpPr>
+          <p:nvPr>
+            <p:ph type="sldImg" idx="2"/>
+          </p:nvPr>
+        </p:nvSpPr>
+        <p:spPr/>
+      </p:sp>
+      <p:sp>
+        <p:nvSpPr>
+          <p:cNvPr id="3" name="Notes Placeholder 2"/>
+          <p:cNvSpPr>
+            <a:spLocks noGrp="1"/>
+          </p:cNvSpPr>
+          <p:nvPr>
+            <p:ph type="body" idx="3" sz="quarter"/>
+          </p:nvPr>
+        </p:nvSpPr>
+        <p:spPr/>
+        <p:txBody>
+          <a:bodyPr/>
+          <a:lstStyle/>
+          <a:p>
+            <a:r>
               <a:t>Assumptions, suppliers by full name, acronyms, and the fact-checked frameworks. The workbook holds every number: the Supplier Quotes tab, PCI Quote Scenarios, and the PCI Experiment record.</a:t>
             </a:r>
           </a:p>
@@ -1212,7 +1283,7 @@
           <a:lstStyle/>
           <a:p>
             <a:r>
-              <a:t>Why decide now. Our next face-to-face with SNP is where the strategy becomes real - continuity terms, forecast sharing, resin consignment, capacity headroom, succession. The posture has to match the decision: we cannot deepen the partnership while quietly planning to move a third of their core line, and telling them after a warm visit reads as bait-and-switch. If the answer is A, the volume conversation belongs in that meeting, face to face, with a steady-cadence proposal. If it is B or B-plus, that is the partnership meeting: continuity planning framed as a quality-system requirement, PCI not named, the quote not waved. Decide first; use the meeting to execute, not to discover.</a:t>
+              <a:t>How companies keep a qualified supplier they do not use - because you will be asked whether B-plus is realistic. It is routine in medical devices, pharma and aerospace. What spoils the relationship is silence and unpaid work, not the 'no'. The instruments, in rising order of commitment: pay for the qualification work already done; sign a master agreement with price, spec and terms but no volume commitment; place one production-scale order; a readiness fee, which is rare at our scale; and a planned re-check, because an idle supplier goes stale after about a year. And the conduct: tell PCI the triggers, pay promptly, share results, keep a quarterly touchpoint. The research is clear that suppliers allocate goodwill on trust and growth prospects, not current volume.</a:t>
             </a:r>
           </a:p>
         </p:txBody>
@@ -4512,6 +4583,533 @@
                 </a:solidFill>
                 <a:latin typeface="Calibri"/>
               </a:rPr>
+              <a:t>Why decide now</a:t>
+            </a:r>
+          </a:p>
+        </p:txBody>
+      </p:sp>
+      <p:sp>
+        <p:nvSpPr>
+          <p:cNvPr id="4" name="TextBox 3"/>
+          <p:cNvSpPr txBox="1"/>
+          <p:nvPr/>
+        </p:nvSpPr>
+        <p:spPr>
+          <a:xfrm>
+            <a:off x="9966960" y="274320"/>
+            <a:ext cx="2011680" cy="457200"/>
+          </a:xfrm>
+          <a:prstGeom prst="rect">
+            <a:avLst/>
+          </a:prstGeom>
+          <a:noFill/>
+        </p:spPr>
+        <p:txBody>
+          <a:bodyPr wrap="square">
+            <a:spAutoFit/>
+          </a:bodyPr>
+          <a:lstStyle/>
+          <a:p>
+            <a:pPr algn="r">
+              <a:spcAft>
+                <a:spcPts val="400"/>
+              </a:spcAft>
+            </a:pPr>
+            <a:r>
+              <a:rPr sz="1100" b="0" i="0">
+                <a:solidFill>
+                  <a:srgbClr val="BDD7EE"/>
+                </a:solidFill>
+                <a:latin typeface="Calibri"/>
+              </a:rPr>
+              <a:t>6 · TIMING</a:t>
+            </a:r>
+          </a:p>
+        </p:txBody>
+      </p:sp>
+      <p:sp>
+        <p:nvSpPr>
+          <p:cNvPr id="5" name="TextBox 4"/>
+          <p:cNvSpPr txBox="1"/>
+          <p:nvPr/>
+        </p:nvSpPr>
+        <p:spPr>
+          <a:xfrm>
+            <a:off x="548640" y="1097280"/>
+            <a:ext cx="6035040" cy="4663440"/>
+          </a:xfrm>
+          <a:prstGeom prst="rect">
+            <a:avLst/>
+          </a:prstGeom>
+          <a:noFill/>
+        </p:spPr>
+        <p:txBody>
+          <a:bodyPr wrap="square">
+            <a:spAutoFit/>
+          </a:bodyPr>
+          <a:lstStyle/>
+          <a:p>
+            <a:pPr>
+              <a:spcAft>
+                <a:spcPts val="900"/>
+              </a:spcAft>
+            </a:pPr>
+            <a:r>
+              <a:rPr b="1" sz="1250">
+                <a:solidFill>
+                  <a:srgbClr val="1F3864"/>
+                </a:solidFill>
+                <a:latin typeface="Calibri"/>
+              </a:rPr>
+              <a:t>•  The next face-to-face with SNP Inc. is where the strategy becomes real. </a:t>
+            </a:r>
+            <a:r>
+              <a:rPr sz="1250">
+                <a:solidFill>
+                  <a:srgbClr val="595959"/>
+                </a:solidFill>
+                <a:latin typeface="Calibri"/>
+              </a:rPr>
+              <a:t>Continuity terms, forecast sharing, resin consignment, a resin-indexed price formula, capacity headroom for +10%/yr, succession and financial health — these get settled in a room, not by email.</a:t>
+            </a:r>
+          </a:p>
+          <a:p>
+            <a:pPr>
+              <a:spcAft>
+                <a:spcPts val="900"/>
+              </a:spcAft>
+            </a:pPr>
+            <a:r>
+              <a:rPr b="1" sz="1250">
+                <a:solidFill>
+                  <a:srgbClr val="1F3864"/>
+                </a:solidFill>
+                <a:latin typeface="Calibri"/>
+              </a:rPr>
+              <a:t>•  The posture has to match the decision. </a:t>
+            </a:r>
+            <a:r>
+              <a:rPr sz="1250">
+                <a:solidFill>
+                  <a:srgbClr val="595959"/>
+                </a:solidFill>
+                <a:latin typeface="Calibri"/>
+              </a:rPr>
+              <a:t>We cannot deepen the partnership and quietly plan to move a third of their core line at the same time. And telling them after a warm visit reads as bait-and-switch.</a:t>
+            </a:r>
+          </a:p>
+          <a:p>
+            <a:pPr>
+              <a:spcAft>
+                <a:spcPts val="900"/>
+              </a:spcAft>
+            </a:pPr>
+            <a:r>
+              <a:rPr b="1" sz="1250">
+                <a:solidFill>
+                  <a:srgbClr val="1F3864"/>
+                </a:solidFill>
+                <a:latin typeface="Calibri"/>
+              </a:rPr>
+              <a:t>•  If the answer is A: </a:t>
+            </a:r>
+            <a:r>
+              <a:rPr sz="1250">
+                <a:solidFill>
+                  <a:srgbClr val="595959"/>
+                </a:solidFill>
+                <a:latin typeface="Calibri"/>
+              </a:rPr>
+              <a:t>the volume conversation belongs in that meeting, face-to-face, with a steady-cadence proposal — not discovered later from the order pattern.</a:t>
+            </a:r>
+          </a:p>
+          <a:p>
+            <a:pPr>
+              <a:spcAft>
+                <a:spcPts val="900"/>
+              </a:spcAft>
+            </a:pPr>
+            <a:r>
+              <a:rPr b="1" sz="1250">
+                <a:solidFill>
+                  <a:srgbClr val="1F3864"/>
+                </a:solidFill>
+                <a:latin typeface="Calibri"/>
+              </a:rPr>
+              <a:t>•  If the answer is B or B-plus: </a:t>
+            </a:r>
+            <a:r>
+              <a:rPr sz="1250">
+                <a:solidFill>
+                  <a:srgbClr val="595959"/>
+                </a:solidFill>
+                <a:latin typeface="Calibri"/>
+              </a:rPr>
+              <a:t>the meeting is the partnership meeting. Continuity planning is presented as a quality-system requirement, not a loss of confidence. PCI is not named; the quote is not waved. 'We have benchmarked the market' is fair context.</a:t>
+            </a:r>
+          </a:p>
+        </p:txBody>
+      </p:sp>
+      <p:sp>
+        <p:nvSpPr>
+          <p:cNvPr id="6" name="Rectangle 5"/>
+          <p:cNvSpPr/>
+          <p:nvPr/>
+        </p:nvSpPr>
+        <p:spPr>
+          <a:xfrm>
+            <a:off x="6858000" y="1097280"/>
+            <a:ext cx="4754880" cy="4663440"/>
+          </a:xfrm>
+          <a:prstGeom prst="rect">
+            <a:avLst/>
+          </a:prstGeom>
+          <a:solidFill>
+            <a:srgbClr val="F6F8FB"/>
+          </a:solidFill>
+          <a:ln w="9525">
+            <a:solidFill>
+              <a:srgbClr val="4E79A7"/>
+            </a:solidFill>
+          </a:ln>
+          <a:effectLst/>
+        </p:spPr>
+        <p:style>
+          <a:lnRef idx="1">
+            <a:schemeClr val="accent1"/>
+          </a:lnRef>
+          <a:fillRef idx="3">
+            <a:schemeClr val="accent1"/>
+          </a:fillRef>
+          <a:effectRef idx="2">
+            <a:schemeClr val="accent1"/>
+          </a:effectRef>
+          <a:fontRef idx="minor">
+            <a:schemeClr val="lt1"/>
+          </a:fontRef>
+        </p:style>
+        <p:txBody>
+          <a:bodyPr rtlCol="0" anchor="ctr"/>
+          <a:lstStyle/>
+          <a:p>
+            <a:pPr algn="ctr"/>
+          </a:p>
+        </p:txBody>
+      </p:sp>
+      <p:sp>
+        <p:nvSpPr>
+          <p:cNvPr id="7" name="TextBox 6"/>
+          <p:cNvSpPr txBox="1"/>
+          <p:nvPr/>
+        </p:nvSpPr>
+        <p:spPr>
+          <a:xfrm>
+            <a:off x="7040880" y="1234440"/>
+            <a:ext cx="4389120" cy="4480560"/>
+          </a:xfrm>
+          <a:prstGeom prst="rect">
+            <a:avLst/>
+          </a:prstGeom>
+          <a:noFill/>
+        </p:spPr>
+        <p:txBody>
+          <a:bodyPr wrap="square">
+            <a:spAutoFit/>
+          </a:bodyPr>
+          <a:lstStyle/>
+          <a:p>
+            <a:pPr algn="l">
+              <a:spcAft>
+                <a:spcPts val="600"/>
+              </a:spcAft>
+            </a:pPr>
+            <a:r>
+              <a:rPr sz="1300" b="1" i="0">
+                <a:solidFill>
+                  <a:srgbClr val="1F3864"/>
+                </a:solidFill>
+                <a:latin typeface="Calibri"/>
+              </a:rPr>
+              <a:t>To settle with SNP Inc. under B / B-plus</a:t>
+            </a:r>
+          </a:p>
+          <a:p>
+            <a:pPr algn="l">
+              <a:spcAft>
+                <a:spcPts val="600"/>
+              </a:spcAft>
+            </a:pPr>
+            <a:r>
+              <a:rPr sz="1100" b="0" i="0">
+                <a:solidFill>
+                  <a:srgbClr val="595959"/>
+                </a:solidFill>
+                <a:latin typeface="Calibri"/>
+              </a:rPr>
+              <a:t>•  Rolling 12-month forecast, refreshed monthly; the hydrogel program as a written joint roadmap</a:t>
+            </a:r>
+          </a:p>
+          <a:p>
+            <a:pPr algn="l">
+              <a:spcAft>
+                <a:spcPts val="600"/>
+              </a:spcAft>
+            </a:pPr>
+            <a:r>
+              <a:rPr sz="1100" b="0" i="0">
+                <a:solidFill>
+                  <a:srgbClr val="595959"/>
+                </a:solidFill>
+                <a:latin typeface="Calibri"/>
+              </a:rPr>
+              <a:t>•  Continuity terms in the Supplier Quality Agreement: second line/site plan, key-person cover, advance change notice, right to audit</a:t>
+            </a:r>
+          </a:p>
+          <a:p>
+            <a:pPr algn="l">
+              <a:spcAft>
+                <a:spcPts val="600"/>
+              </a:spcAft>
+            </a:pPr>
+            <a:r>
+              <a:rPr sz="1100" b="0" i="0">
+                <a:solidFill>
+                  <a:srgbClr val="595959"/>
+                </a:solidFill>
+                <a:latin typeface="Calibri"/>
+              </a:rPr>
+              <a:t>•  8–12 weeks of dry PVA resin on consignment (shelf-stable; ~$2.5–6k tied up)</a:t>
+            </a:r>
+          </a:p>
+          <a:p>
+            <a:pPr algn="l">
+              <a:spcAft>
+                <a:spcPts val="600"/>
+              </a:spcAft>
+            </a:pPr>
+            <a:r>
+              <a:rPr sz="1100" b="0" i="0">
+                <a:solidFill>
+                  <a:srgbClr val="595959"/>
+                </a:solidFill>
+                <a:latin typeface="Calibri"/>
+              </a:rPr>
+              <a:t>•  Their capacity headroom at year-5 volume (~99k lb) — the unasked question</a:t>
+            </a:r>
+          </a:p>
+          <a:p>
+            <a:pPr algn="l">
+              <a:spcAft>
+                <a:spcPts val="600"/>
+              </a:spcAft>
+            </a:pPr>
+            <a:r>
+              <a:rPr sz="1100" b="0" i="0">
+                <a:solidFill>
+                  <a:srgbClr val="595959"/>
+                </a:solidFill>
+                <a:latin typeface="Calibri"/>
+              </a:rPr>
+              <a:t>•  Owner/succession and financial health — the risk that gives no warning</a:t>
+            </a:r>
+          </a:p>
+          <a:p>
+            <a:pPr algn="l">
+              <a:spcAft>
+                <a:spcPts val="600"/>
+              </a:spcAft>
+            </a:pPr>
+            <a:r>
+              <a:rPr sz="1100" b="0" i="0">
+                <a:solidFill>
+                  <a:srgbClr val="595959"/>
+                </a:solidFill>
+                <a:latin typeface="Calibri"/>
+              </a:rPr>
+              <a:t>•  A 30–45-day shelf-life study — the cheapest way to lengthen our time-to-survive</a:t>
+            </a:r>
+          </a:p>
+        </p:txBody>
+      </p:sp>
+      <p:sp>
+        <p:nvSpPr>
+          <p:cNvPr id="8" name="Rectangle 7"/>
+          <p:cNvSpPr/>
+          <p:nvPr/>
+        </p:nvSpPr>
+        <p:spPr>
+          <a:xfrm>
+            <a:off x="548640" y="5989320"/>
+            <a:ext cx="11064240" cy="566928"/>
+          </a:xfrm>
+          <a:prstGeom prst="rect">
+            <a:avLst/>
+          </a:prstGeom>
+          <a:solidFill>
+            <a:srgbClr val="9C5A0C"/>
+          </a:solidFill>
+          <a:ln>
+            <a:noFill/>
+          </a:ln>
+          <a:effectLst/>
+        </p:spPr>
+        <p:style>
+          <a:lnRef idx="1">
+            <a:schemeClr val="accent1"/>
+          </a:lnRef>
+          <a:fillRef idx="3">
+            <a:schemeClr val="accent1"/>
+          </a:fillRef>
+          <a:effectRef idx="2">
+            <a:schemeClr val="accent1"/>
+          </a:effectRef>
+          <a:fontRef idx="minor">
+            <a:schemeClr val="lt1"/>
+          </a:fontRef>
+        </p:style>
+        <p:txBody>
+          <a:bodyPr rtlCol="0" anchor="ctr"/>
+          <a:lstStyle/>
+          <a:p>
+            <a:pPr algn="ctr"/>
+          </a:p>
+        </p:txBody>
+      </p:sp>
+      <p:sp>
+        <p:nvSpPr>
+          <p:cNvPr id="9" name="TextBox 8"/>
+          <p:cNvSpPr txBox="1"/>
+          <p:nvPr/>
+        </p:nvSpPr>
+        <p:spPr>
+          <a:xfrm>
+            <a:off x="731520" y="6062472"/>
+            <a:ext cx="10698480" cy="457200"/>
+          </a:xfrm>
+          <a:prstGeom prst="rect">
+            <a:avLst/>
+          </a:prstGeom>
+          <a:noFill/>
+        </p:spPr>
+        <p:txBody>
+          <a:bodyPr wrap="square" anchor="ctr">
+            <a:spAutoFit/>
+          </a:bodyPr>
+          <a:lstStyle/>
+          <a:p>
+            <a:pPr algn="l">
+              <a:spcAft>
+                <a:spcPts val="400"/>
+              </a:spcAft>
+            </a:pPr>
+            <a:r>
+              <a:rPr sz="1350" b="1" i="0">
+                <a:solidFill>
+                  <a:srgbClr val="FFFFFF"/>
+                </a:solidFill>
+                <a:latin typeface="Calibri"/>
+              </a:rPr>
+              <a:t>Decide the strategy first; then use the SNP Inc. conversation to execute it — not to discover it.</a:t>
+            </a:r>
+          </a:p>
+        </p:txBody>
+      </p:sp>
+    </p:spTree>
+  </p:cSld>
+  <p:clrMapOvr>
+    <a:masterClrMapping/>
+  </p:clrMapOvr>
+</p:sld>
+</file>
+
+<file path=ppt/slides/slide11.xml><?xml version="1.0" encoding="utf-8"?>
+<p:sld xmlns:a="http://schemas.openxmlformats.org/drawingml/2006/main" xmlns:p="http://schemas.openxmlformats.org/presentationml/2006/main" xmlns:r="http://schemas.openxmlformats.org/officeDocument/2006/relationships">
+  <p:cSld>
+    <p:spTree>
+      <p:nvGrpSpPr>
+        <p:cNvPr id="1" name=""/>
+        <p:cNvGrpSpPr/>
+        <p:nvPr/>
+      </p:nvGrpSpPr>
+      <p:grpSpPr/>
+      <p:sp>
+        <p:nvSpPr>
+          <p:cNvPr id="2" name="Rectangle 1"/>
+          <p:cNvSpPr/>
+          <p:nvPr/>
+        </p:nvSpPr>
+        <p:spPr>
+          <a:xfrm>
+            <a:off x="0" y="0"/>
+            <a:ext cx="12191695" cy="914400"/>
+          </a:xfrm>
+          <a:prstGeom prst="rect">
+            <a:avLst/>
+          </a:prstGeom>
+          <a:solidFill>
+            <a:srgbClr val="1F3864"/>
+          </a:solidFill>
+          <a:ln>
+            <a:noFill/>
+          </a:ln>
+          <a:effectLst/>
+        </p:spPr>
+        <p:style>
+          <a:lnRef idx="1">
+            <a:schemeClr val="accent1"/>
+          </a:lnRef>
+          <a:fillRef idx="3">
+            <a:schemeClr val="accent1"/>
+          </a:fillRef>
+          <a:effectRef idx="2">
+            <a:schemeClr val="accent1"/>
+          </a:effectRef>
+          <a:fontRef idx="minor">
+            <a:schemeClr val="lt1"/>
+          </a:fontRef>
+        </p:style>
+        <p:txBody>
+          <a:bodyPr rtlCol="0" anchor="ctr"/>
+          <a:lstStyle/>
+          <a:p>
+            <a:pPr algn="ctr"/>
+          </a:p>
+        </p:txBody>
+      </p:sp>
+      <p:sp>
+        <p:nvSpPr>
+          <p:cNvPr id="3" name="TextBox 2"/>
+          <p:cNvSpPr txBox="1"/>
+          <p:nvPr/>
+        </p:nvSpPr>
+        <p:spPr>
+          <a:xfrm>
+            <a:off x="457200" y="128016"/>
+            <a:ext cx="9692640" cy="731520"/>
+          </a:xfrm>
+          <a:prstGeom prst="rect">
+            <a:avLst/>
+          </a:prstGeom>
+          <a:noFill/>
+        </p:spPr>
+        <p:txBody>
+          <a:bodyPr wrap="square">
+            <a:spAutoFit/>
+          </a:bodyPr>
+          <a:lstStyle/>
+          <a:p>
+            <a:pPr algn="l">
+              <a:spcAft>
+                <a:spcPts val="400"/>
+              </a:spcAft>
+            </a:pPr>
+            <a:r>
+              <a:rPr sz="2500" b="1" i="0">
+                <a:solidFill>
+                  <a:srgbClr val="FFFFFF"/>
+                </a:solidFill>
+                <a:latin typeface="Calibri"/>
+              </a:rPr>
               <a:t>Recommendation &amp; asks</a:t>
             </a:r>
           </a:p>
@@ -5040,7 +5638,7 @@
 </p:sld>
 </file>
 
-<file path=ppt/slides/slide11.xml><?xml version="1.0" encoding="utf-8"?>
+<file path=ppt/slides/slide12.xml><?xml version="1.0" encoding="utf-8"?>
 <p:sld xmlns:a="http://schemas.openxmlformats.org/drawingml/2006/main" xmlns:p="http://schemas.openxmlformats.org/presentationml/2006/main" xmlns:r="http://schemas.openxmlformats.org/officeDocument/2006/relationships">
   <p:cSld>
     <p:spTree>
@@ -6572,7 +7170,7 @@
         </p:nvGraphicFramePr>
         <p:xfrm>
           <a:off x="548640" y="1097280"/>
-          <a:ext cx="11064240" cy="4754880"/>
+          <a:ext cx="11064240" cy="4800600"/>
         </p:xfrm>
         <a:graphic>
           <a:graphicData uri="http://schemas.openxmlformats.org/drawingml/2006/table">
@@ -6585,7 +7183,7 @@
                 <a:gridCol w="2743200"/>
                 <a:gridCol w="7863840"/>
               </a:tblGrid>
-              <a:tr h="475488">
+              <a:tr h="436418">
                 <a:tc>
                   <a:txBody>
                     <a:bodyPr/>
@@ -6593,7 +7191,7 @@
                     <a:p>
                       <a:pPr algn="l"/>
                       <a:r>
-                        <a:rPr sz="1050" b="1">
+                        <a:rPr sz="1000" b="1">
                           <a:solidFill>
                             <a:srgbClr val="FFFFFF"/>
                           </a:solidFill>
@@ -6616,7 +7214,7 @@
                     <a:p>
                       <a:pPr algn="ctr"/>
                       <a:r>
-                        <a:rPr sz="1050" b="1">
+                        <a:rPr sz="1000" b="1">
                           <a:solidFill>
                             <a:srgbClr val="FFFFFF"/>
                           </a:solidFill>
@@ -6639,7 +7237,7 @@
                     <a:p>
                       <a:pPr algn="ctr"/>
                       <a:r>
-                        <a:rPr sz="1050" b="1">
+                        <a:rPr sz="1000" b="1">
                           <a:solidFill>
                             <a:srgbClr val="FFFFFF"/>
                           </a:solidFill>
@@ -6656,7 +7254,7 @@
                   </a:tcPr>
                 </a:tc>
               </a:tr>
-              <a:tr h="475488">
+              <a:tr h="436418">
                 <a:tc>
                   <a:txBody>
                     <a:bodyPr/>
@@ -6664,7 +7262,7 @@
                     <a:p>
                       <a:pPr algn="l"/>
                       <a:r>
-                        <a:rPr sz="1050" b="1">
+                        <a:rPr sz="1000" b="1">
                           <a:solidFill>
                             <a:srgbClr val="1F3864"/>
                           </a:solidFill>
@@ -6687,7 +7285,7 @@
                     <a:p>
                       <a:pPr algn="ctr"/>
                       <a:r>
-                        <a:rPr sz="1050">
+                        <a:rPr sz="1000">
                           <a:solidFill>
                             <a:srgbClr val="1F3864"/>
                           </a:solidFill>
@@ -6710,7 +7308,7 @@
                     <a:p>
                       <a:pPr algn="ctr"/>
                       <a:r>
-                        <a:rPr sz="1050">
+                        <a:rPr sz="1000">
                           <a:solidFill>
                             <a:srgbClr val="1F3864"/>
                           </a:solidFill>
@@ -6727,7 +7325,7 @@
                   </a:tcPr>
                 </a:tc>
               </a:tr>
-              <a:tr h="475488">
+              <a:tr h="436418">
                 <a:tc>
                   <a:txBody>
                     <a:bodyPr/>
@@ -6735,7 +7333,7 @@
                     <a:p>
                       <a:pPr algn="l"/>
                       <a:r>
-                        <a:rPr sz="1050" b="1">
+                        <a:rPr sz="1000" b="1">
                           <a:solidFill>
                             <a:srgbClr val="1F3864"/>
                           </a:solidFill>
@@ -6758,7 +7356,7 @@
                     <a:p>
                       <a:pPr algn="ctr"/>
                       <a:r>
-                        <a:rPr sz="1050">
+                        <a:rPr sz="1000">
                           <a:solidFill>
                             <a:srgbClr val="1F3864"/>
                           </a:solidFill>
@@ -6781,7 +7379,7 @@
                     <a:p>
                       <a:pPr algn="ctr"/>
                       <a:r>
-                        <a:rPr sz="1050">
+                        <a:rPr sz="1000">
                           <a:solidFill>
                             <a:srgbClr val="1F3864"/>
                           </a:solidFill>
@@ -6798,7 +7396,7 @@
                   </a:tcPr>
                 </a:tc>
               </a:tr>
-              <a:tr h="475488">
+              <a:tr h="436418">
                 <a:tc>
                   <a:txBody>
                     <a:bodyPr/>
@@ -6806,7 +7404,7 @@
                     <a:p>
                       <a:pPr algn="l"/>
                       <a:r>
-                        <a:rPr sz="1050" b="1">
+                        <a:rPr sz="1000" b="1">
                           <a:solidFill>
                             <a:srgbClr val="1F3864"/>
                           </a:solidFill>
@@ -6829,7 +7427,7 @@
                     <a:p>
                       <a:pPr algn="ctr"/>
                       <a:r>
-                        <a:rPr sz="1050">
+                        <a:rPr sz="1000">
                           <a:solidFill>
                             <a:srgbClr val="1F3864"/>
                           </a:solidFill>
@@ -6852,7 +7450,7 @@
                     <a:p>
                       <a:pPr algn="ctr"/>
                       <a:r>
-                        <a:rPr sz="1050">
+                        <a:rPr sz="1000">
                           <a:solidFill>
                             <a:srgbClr val="1F3864"/>
                           </a:solidFill>
@@ -6869,7 +7467,7 @@
                   </a:tcPr>
                 </a:tc>
               </a:tr>
-              <a:tr h="475488">
+              <a:tr h="436418">
                 <a:tc>
                   <a:txBody>
                     <a:bodyPr/>
@@ -6877,7 +7475,7 @@
                     <a:p>
                       <a:pPr algn="l"/>
                       <a:r>
-                        <a:rPr sz="1050" b="1">
+                        <a:rPr sz="1000" b="1">
                           <a:solidFill>
                             <a:srgbClr val="1F3864"/>
                           </a:solidFill>
@@ -6900,7 +7498,7 @@
                     <a:p>
                       <a:pPr algn="ctr"/>
                       <a:r>
-                        <a:rPr sz="1050">
+                        <a:rPr sz="1000">
                           <a:solidFill>
                             <a:srgbClr val="1F3864"/>
                           </a:solidFill>
@@ -6923,7 +7521,7 @@
                     <a:p>
                       <a:pPr algn="ctr"/>
                       <a:r>
-                        <a:rPr sz="1050">
+                        <a:rPr sz="1000">
                           <a:solidFill>
                             <a:srgbClr val="1F3864"/>
                           </a:solidFill>
@@ -6940,7 +7538,7 @@
                   </a:tcPr>
                 </a:tc>
               </a:tr>
-              <a:tr h="475488">
+              <a:tr h="436418">
                 <a:tc>
                   <a:txBody>
                     <a:bodyPr/>
@@ -6948,7 +7546,7 @@
                     <a:p>
                       <a:pPr algn="l"/>
                       <a:r>
-                        <a:rPr sz="1050" b="1">
+                        <a:rPr sz="1000" b="1">
                           <a:solidFill>
                             <a:srgbClr val="1F3864"/>
                           </a:solidFill>
@@ -6971,7 +7569,7 @@
                     <a:p>
                       <a:pPr algn="ctr"/>
                       <a:r>
-                        <a:rPr sz="1050">
+                        <a:rPr sz="1000">
                           <a:solidFill>
                             <a:srgbClr val="1F3864"/>
                           </a:solidFill>
@@ -6994,7 +7592,7 @@
                     <a:p>
                       <a:pPr algn="ctr"/>
                       <a:r>
-                        <a:rPr sz="1050">
+                        <a:rPr sz="1000">
                           <a:solidFill>
                             <a:srgbClr val="1F3864"/>
                           </a:solidFill>
@@ -7011,7 +7609,7 @@
                   </a:tcPr>
                 </a:tc>
               </a:tr>
-              <a:tr h="475488">
+              <a:tr h="436418">
                 <a:tc>
                   <a:txBody>
                     <a:bodyPr/>
@@ -7019,7 +7617,7 @@
                     <a:p>
                       <a:pPr algn="l"/>
                       <a:r>
-                        <a:rPr sz="1050" b="1">
+                        <a:rPr sz="1000" b="1">
                           <a:solidFill>
                             <a:srgbClr val="1F3864"/>
                           </a:solidFill>
@@ -7042,7 +7640,7 @@
                     <a:p>
                       <a:pPr algn="ctr"/>
                       <a:r>
-                        <a:rPr sz="1050">
+                        <a:rPr sz="1000">
                           <a:solidFill>
                             <a:srgbClr val="1F3864"/>
                           </a:solidFill>
@@ -7065,7 +7663,7 @@
                     <a:p>
                       <a:pPr algn="ctr"/>
                       <a:r>
-                        <a:rPr sz="1050">
+                        <a:rPr sz="1000">
                           <a:solidFill>
                             <a:srgbClr val="1F3864"/>
                           </a:solidFill>
@@ -7082,7 +7680,7 @@
                   </a:tcPr>
                 </a:tc>
               </a:tr>
-              <a:tr h="475488">
+              <a:tr h="436418">
                 <a:tc>
                   <a:txBody>
                     <a:bodyPr/>
@@ -7090,7 +7688,7 @@
                     <a:p>
                       <a:pPr algn="l"/>
                       <a:r>
-                        <a:rPr sz="1050" b="1">
+                        <a:rPr sz="1000" b="1">
                           <a:solidFill>
                             <a:srgbClr val="1F3864"/>
                           </a:solidFill>
@@ -7113,7 +7711,78 @@
                     <a:p>
                       <a:pPr algn="ctr"/>
                       <a:r>
-                        <a:rPr sz="1050">
+                        <a:rPr sz="1000">
+                          <a:solidFill>
+                            <a:srgbClr val="1F3864"/>
+                          </a:solidFill>
+                          <a:latin typeface="Calibri"/>
+                        </a:rPr>
+                        <a:t>Keeping a qualified supplier you don't use</a:t>
+                      </a:r>
+                    </a:p>
+                  </a:txBody>
+                  <a:tcPr>
+                    <a:solidFill>
+                      <a:srgbClr val="FFFFFF"/>
+                    </a:solidFill>
+                  </a:tcPr>
+                </a:tc>
+                <a:tc>
+                  <a:txBody>
+                    <a:bodyPr/>
+                    <a:lstStyle/>
+                    <a:p>
+                      <a:pPr algn="ctr"/>
+                      <a:r>
+                        <a:rPr sz="1000">
+                          <a:solidFill>
+                            <a:srgbClr val="1F3864"/>
+                          </a:solidFill>
+                          <a:latin typeface="Calibri"/>
+                        </a:rPr>
+                        <a:t>How it is done: paid qualification, a no-minimum master agreement, one production batch, a readiness fee, planned re-checks — and the conduct that keeps the relationship intact</a:t>
+                      </a:r>
+                    </a:p>
+                  </a:txBody>
+                  <a:tcPr>
+                    <a:solidFill>
+                      <a:srgbClr val="FFFFFF"/>
+                    </a:solidFill>
+                  </a:tcPr>
+                </a:tc>
+              </a:tr>
+              <a:tr h="436418">
+                <a:tc>
+                  <a:txBody>
+                    <a:bodyPr/>
+                    <a:lstStyle/>
+                    <a:p>
+                      <a:pPr algn="l"/>
+                      <a:r>
+                        <a:rPr sz="1000" b="1">
+                          <a:solidFill>
+                            <a:srgbClr val="1F3864"/>
+                          </a:solidFill>
+                          <a:latin typeface="Calibri"/>
+                        </a:rPr>
+                        <a:t>10</a:t>
+                      </a:r>
+                    </a:p>
+                  </a:txBody>
+                  <a:tcPr>
+                    <a:solidFill>
+                      <a:srgbClr val="FFFFFF"/>
+                    </a:solidFill>
+                  </a:tcPr>
+                </a:tc>
+                <a:tc>
+                  <a:txBody>
+                    <a:bodyPr/>
+                    <a:lstStyle/>
+                    <a:p>
+                      <a:pPr algn="ctr"/>
+                      <a:r>
+                        <a:rPr sz="1000">
                           <a:solidFill>
                             <a:srgbClr val="1F3864"/>
                           </a:solidFill>
@@ -7136,7 +7805,7 @@
                     <a:p>
                       <a:pPr algn="ctr"/>
                       <a:r>
-                        <a:rPr sz="1050">
+                        <a:rPr sz="1000">
                           <a:solidFill>
                             <a:srgbClr val="1F3864"/>
                           </a:solidFill>
@@ -7153,7 +7822,7 @@
                   </a:tcPr>
                 </a:tc>
               </a:tr>
-              <a:tr h="475488">
+              <a:tr h="436418">
                 <a:tc>
                   <a:txBody>
                     <a:bodyPr/>
@@ -7161,13 +7830,13 @@
                     <a:p>
                       <a:pPr algn="l"/>
                       <a:r>
-                        <a:rPr sz="1050" b="1">
+                        <a:rPr sz="1000" b="1">
                           <a:solidFill>
                             <a:srgbClr val="1F3864"/>
                           </a:solidFill>
                           <a:latin typeface="Calibri"/>
                         </a:rPr>
-                        <a:t>10</a:t>
+                        <a:t>11</a:t>
                       </a:r>
                     </a:p>
                   </a:txBody>
@@ -7184,7 +7853,7 @@
                     <a:p>
                       <a:pPr algn="ctr"/>
                       <a:r>
-                        <a:rPr sz="1050">
+                        <a:rPr sz="1000">
                           <a:solidFill>
                             <a:srgbClr val="1F3864"/>
                           </a:solidFill>
@@ -7207,7 +7876,7 @@
                     <a:p>
                       <a:pPr algn="ctr"/>
                       <a:r>
-                        <a:rPr sz="1050">
+                        <a:rPr sz="1000">
                           <a:solidFill>
                             <a:srgbClr val="1F3864"/>
                           </a:solidFill>
@@ -7224,7 +7893,7 @@
                   </a:tcPr>
                 </a:tc>
               </a:tr>
-              <a:tr h="475488">
+              <a:tr h="436420">
                 <a:tc>
                   <a:txBody>
                     <a:bodyPr/>
@@ -7232,13 +7901,13 @@
                     <a:p>
                       <a:pPr algn="l"/>
                       <a:r>
-                        <a:rPr sz="1050" b="1">
+                        <a:rPr sz="1000" b="1">
                           <a:solidFill>
                             <a:srgbClr val="1F3864"/>
                           </a:solidFill>
                           <a:latin typeface="Calibri"/>
                         </a:rPr>
-                        <a:t>11</a:t>
+                        <a:t>12</a:t>
                       </a:r>
                     </a:p>
                   </a:txBody>
@@ -7255,7 +7924,7 @@
                     <a:p>
                       <a:pPr algn="ctr"/>
                       <a:r>
-                        <a:rPr sz="1050">
+                        <a:rPr sz="1000">
                           <a:solidFill>
                             <a:srgbClr val="1F3864"/>
                           </a:solidFill>
@@ -7278,7 +7947,7 @@
                     <a:p>
                       <a:pPr algn="ctr"/>
                       <a:r>
-                        <a:rPr sz="1050">
+                        <a:rPr sz="1000">
                           <a:solidFill>
                             <a:srgbClr val="1F3864"/>
                           </a:solidFill>
@@ -11491,7 +12160,7 @@
                 </a:solidFill>
                 <a:latin typeface="Calibri"/>
               </a:rPr>
-              <a:t>Why decide now</a:t>
+              <a:t>Keeping a qualified supplier you don't use — how it is done</a:t>
             </a:r>
           </a:p>
         </p:txBody>
@@ -11530,7 +12199,7 @@
                 </a:solidFill>
                 <a:latin typeface="Calibri"/>
               </a:rPr>
-              <a:t>6 · TIMING</a:t>
+              <a:t>5 · STRATEGY</a:t>
             </a:r>
           </a:p>
         </p:txBody>
@@ -11543,8 +12212,8 @@
         </p:nvSpPr>
         <p:spPr>
           <a:xfrm>
-            <a:off x="548640" y="1097280"/>
-            <a:ext cx="6035040" cy="4663440"/>
+            <a:off x="548640" y="1051560"/>
+            <a:ext cx="11064240" cy="548640"/>
           </a:xfrm>
           <a:prstGeom prst="rect">
             <a:avLst/>
@@ -11557,304 +12226,631 @@
           </a:bodyPr>
           <a:lstStyle/>
           <a:p>
-            <a:pPr>
-              <a:spcAft>
-                <a:spcPts val="900"/>
-              </a:spcAft>
-            </a:pPr>
-            <a:r>
-              <a:rPr b="1" sz="1250">
+            <a:pPr algn="l">
+              <a:spcAft>
+                <a:spcPts val="400"/>
+              </a:spcAft>
+            </a:pPr>
+            <a:r>
+              <a:rPr sz="1250" b="1" i="0">
                 <a:solidFill>
                   <a:srgbClr val="1F3864"/>
                 </a:solidFill>
                 <a:latin typeface="Calibri"/>
               </a:rPr>
-              <a:t>•  The next face-to-face with SNP Inc. is where the strategy becomes real. </a:t>
-            </a:r>
-            <a:r>
-              <a:rPr sz="1250">
-                <a:solidFill>
-                  <a:srgbClr val="595959"/>
-                </a:solidFill>
-                <a:latin typeface="Calibri"/>
-              </a:rPr>
-              <a:t>Continuity terms, forecast sharing, resin consignment, a resin-indexed price formula, capacity headroom for +10%/yr, succession and financial health — these get settled in a room, not by email.</a:t>
-            </a:r>
-          </a:p>
-          <a:p>
-            <a:pPr>
-              <a:spcAft>
-                <a:spcPts val="900"/>
-              </a:spcAft>
-            </a:pPr>
-            <a:r>
-              <a:rPr b="1" sz="1250">
-                <a:solidFill>
-                  <a:srgbClr val="1F3864"/>
-                </a:solidFill>
-                <a:latin typeface="Calibri"/>
-              </a:rPr>
-              <a:t>•  The posture has to match the decision. </a:t>
-            </a:r>
-            <a:r>
-              <a:rPr sz="1250">
-                <a:solidFill>
-                  <a:srgbClr val="595959"/>
-                </a:solidFill>
-                <a:latin typeface="Calibri"/>
-              </a:rPr>
-              <a:t>We cannot deepen the partnership and quietly plan to move a third of their core line at the same time. And telling them after a warm visit reads as bait-and-switch.</a:t>
-            </a:r>
-          </a:p>
-          <a:p>
-            <a:pPr>
-              <a:spcAft>
-                <a:spcPts val="900"/>
-              </a:spcAft>
-            </a:pPr>
-            <a:r>
-              <a:rPr b="1" sz="1250">
-                <a:solidFill>
-                  <a:srgbClr val="1F3864"/>
-                </a:solidFill>
-                <a:latin typeface="Calibri"/>
-              </a:rPr>
-              <a:t>•  If the answer is A: </a:t>
-            </a:r>
-            <a:r>
-              <a:rPr sz="1250">
-                <a:solidFill>
-                  <a:srgbClr val="595959"/>
-                </a:solidFill>
-                <a:latin typeface="Calibri"/>
-              </a:rPr>
-              <a:t>the volume conversation belongs in that meeting, face-to-face, with a steady-cadence proposal — not discovered later from the order pattern.</a:t>
-            </a:r>
-          </a:p>
-          <a:p>
-            <a:pPr>
-              <a:spcAft>
-                <a:spcPts val="900"/>
-              </a:spcAft>
-            </a:pPr>
-            <a:r>
-              <a:rPr b="1" sz="1250">
-                <a:solidFill>
-                  <a:srgbClr val="1F3864"/>
-                </a:solidFill>
-                <a:latin typeface="Calibri"/>
-              </a:rPr>
-              <a:t>•  If the answer is B or B-plus: </a:t>
-            </a:r>
-            <a:r>
-              <a:rPr sz="1250">
-                <a:solidFill>
-                  <a:srgbClr val="595959"/>
-                </a:solidFill>
-                <a:latin typeface="Calibri"/>
-              </a:rPr>
-              <a:t>the meeting is the partnership meeting. Continuity planning is presented as a quality-system requirement, not a loss of confidence. PCI is not named; the quote is not waved. 'We have benchmarked the market' is fair context.</a:t>
-            </a:r>
-          </a:p>
-        </p:txBody>
-      </p:sp>
-      <p:sp>
-        <p:nvSpPr>
-          <p:cNvPr id="6" name="Rectangle 5"/>
+              <a:t>Medical-device, pharma and aerospace buyers do this routinely. What spoils the relationship is not the 'no' — it is silence and unpaid work. Five instruments, in rising order of commitment:</a:t>
+            </a:r>
+          </a:p>
+        </p:txBody>
+      </p:sp>
+      <p:graphicFrame>
+        <p:nvGraphicFramePr>
+          <p:cNvPr id="6" name="Table 5"/>
+          <p:cNvGraphicFramePr>
+            <a:graphicFrameLocks noGrp="1"/>
+          </p:cNvGraphicFramePr>
+          <p:nvPr/>
+        </p:nvGraphicFramePr>
+        <p:xfrm>
+          <a:off x="548640" y="1691640"/>
+          <a:ext cx="11064240" cy="3246120"/>
+        </p:xfrm>
+        <a:graphic>
+          <a:graphicData uri="http://schemas.openxmlformats.org/drawingml/2006/table">
+            <a:tbl>
+              <a:tblPr firstRow="1" bandRow="1">
+                <a:tableStyleId>{5C22544A-7EE6-4342-B048-85BDC9FD1C3A}</a:tableStyleId>
+              </a:tblPr>
+              <a:tblGrid>
+                <a:gridCol w="2651760"/>
+                <a:gridCol w="3566160"/>
+                <a:gridCol w="1920240"/>
+                <a:gridCol w="2926080"/>
+              </a:tblGrid>
+              <a:tr h="541020">
+                <a:tc>
+                  <a:txBody>
+                    <a:bodyPr/>
+                    <a:lstStyle/>
+                    <a:p>
+                      <a:pPr algn="l"/>
+                      <a:r>
+                        <a:rPr sz="960" b="1">
+                          <a:solidFill>
+                            <a:srgbClr val="FFFFFF"/>
+                          </a:solidFill>
+                          <a:latin typeface="Calibri"/>
+                        </a:rPr>
+                        <a:t>Instrument</a:t>
+                      </a:r>
+                    </a:p>
+                  </a:txBody>
+                  <a:tcPr>
+                    <a:solidFill>
+                      <a:srgbClr val="1F3864"/>
+                    </a:solidFill>
+                  </a:tcPr>
+                </a:tc>
+                <a:tc>
+                  <a:txBody>
+                    <a:bodyPr/>
+                    <a:lstStyle/>
+                    <a:p>
+                      <a:pPr algn="ctr"/>
+                      <a:r>
+                        <a:rPr sz="960" b="1">
+                          <a:solidFill>
+                            <a:srgbClr val="FFFFFF"/>
+                          </a:solidFill>
+                          <a:latin typeface="Calibri"/>
+                        </a:rPr>
+                        <a:t>What it is</a:t>
+                      </a:r>
+                    </a:p>
+                  </a:txBody>
+                  <a:tcPr>
+                    <a:solidFill>
+                      <a:srgbClr val="1F3864"/>
+                    </a:solidFill>
+                  </a:tcPr>
+                </a:tc>
+                <a:tc>
+                  <a:txBody>
+                    <a:bodyPr/>
+                    <a:lstStyle/>
+                    <a:p>
+                      <a:pPr algn="ctr"/>
+                      <a:r>
+                        <a:rPr sz="960" b="1">
+                          <a:solidFill>
+                            <a:srgbClr val="FFFFFF"/>
+                          </a:solidFill>
+                          <a:latin typeface="Calibri"/>
+                        </a:rPr>
+                        <a:t>Cost here</a:t>
+                      </a:r>
+                    </a:p>
+                  </a:txBody>
+                  <a:tcPr>
+                    <a:solidFill>
+                      <a:srgbClr val="1F3864"/>
+                    </a:solidFill>
+                  </a:tcPr>
+                </a:tc>
+                <a:tc>
+                  <a:txBody>
+                    <a:bodyPr/>
+                    <a:lstStyle/>
+                    <a:p>
+                      <a:pPr algn="l"/>
+                      <a:r>
+                        <a:rPr sz="960" b="1">
+                          <a:solidFill>
+                            <a:srgbClr val="FFFFFF"/>
+                          </a:solidFill>
+                          <a:latin typeface="Calibri"/>
+                        </a:rPr>
+                        <a:t>What it does for the relationship</a:t>
+                      </a:r>
+                    </a:p>
+                  </a:txBody>
+                  <a:tcPr>
+                    <a:solidFill>
+                      <a:srgbClr val="1F3864"/>
+                    </a:solidFill>
+                  </a:tcPr>
+                </a:tc>
+              </a:tr>
+              <a:tr h="541020">
+                <a:tc>
+                  <a:txBody>
+                    <a:bodyPr/>
+                    <a:lstStyle/>
+                    <a:p>
+                      <a:pPr algn="l"/>
+                      <a:r>
+                        <a:rPr sz="960" b="1">
+                          <a:solidFill>
+                            <a:srgbClr val="1F3864"/>
+                          </a:solidFill>
+                          <a:latin typeface="Calibri"/>
+                        </a:rPr>
+                        <a:t>1 · Pay for the qualification (NRE — non-recurring engineering)</a:t>
+                      </a:r>
+                    </a:p>
+                  </a:txBody>
+                  <a:tcPr>
+                    <a:solidFill>
+                      <a:srgbClr val="FFFFFF"/>
+                    </a:solidFill>
+                  </a:tcPr>
+                </a:tc>
+                <a:tc>
+                  <a:txBody>
+                    <a:bodyPr/>
+                    <a:lstStyle/>
+                    <a:p>
+                      <a:pPr algn="ctr"/>
+                      <a:r>
+                        <a:rPr sz="960">
+                          <a:solidFill>
+                            <a:srgbClr val="1F3864"/>
+                          </a:solidFill>
+                          <a:latin typeface="Calibri"/>
+                        </a:rPr>
+                        <a:t>We fund the qualification lots, testing and documentation already done</a:t>
+                      </a:r>
+                    </a:p>
+                  </a:txBody>
+                  <a:tcPr>
+                    <a:solidFill>
+                      <a:srgbClr val="FFFFFF"/>
+                    </a:solidFill>
+                  </a:tcPr>
+                </a:tc>
+                <a:tc>
+                  <a:txBody>
+                    <a:bodyPr/>
+                    <a:lstStyle/>
+                    <a:p>
+                      <a:pPr algn="ctr"/>
+                      <a:r>
+                        <a:rPr sz="960">
+                          <a:solidFill>
+                            <a:srgbClr val="1F3864"/>
+                          </a:solidFill>
+                          <a:latin typeface="Calibri"/>
+                        </a:rPr>
+                        <a:t>~$15k (the value of PCI's work)</a:t>
+                      </a:r>
+                    </a:p>
+                  </a:txBody>
+                  <a:tcPr>
+                    <a:solidFill>
+                      <a:srgbClr val="FFFFFF"/>
+                    </a:solidFill>
+                  </a:tcPr>
+                </a:tc>
+                <a:tc>
+                  <a:txBody>
+                    <a:bodyPr/>
+                    <a:lstStyle/>
+                    <a:p>
+                      <a:pPr algn="l"/>
+                      <a:r>
+                        <a:rPr sz="960">
+                          <a:solidFill>
+                            <a:srgbClr val="1F3864"/>
+                          </a:solidFill>
+                          <a:latin typeface="Calibri"/>
+                        </a:rPr>
+                        <a:t>Turns free experiments into a paid development engagement they can justify internally; leaves an approved-source file</a:t>
+                      </a:r>
+                    </a:p>
+                  </a:txBody>
+                  <a:tcPr>
+                    <a:solidFill>
+                      <a:srgbClr val="FFFFFF"/>
+                    </a:solidFill>
+                  </a:tcPr>
+                </a:tc>
+              </a:tr>
+              <a:tr h="541020">
+                <a:tc>
+                  <a:txBody>
+                    <a:bodyPr/>
+                    <a:lstStyle/>
+                    <a:p>
+                      <a:pPr algn="l"/>
+                      <a:r>
+                        <a:rPr sz="960" b="1">
+                          <a:solidFill>
+                            <a:srgbClr val="1F3864"/>
+                          </a:solidFill>
+                          <a:latin typeface="Calibri"/>
+                        </a:rPr>
+                        <a:t>2 · Master supply agreement, no volume commitment</a:t>
+                      </a:r>
+                    </a:p>
+                  </a:txBody>
+                  <a:tcPr>
+                    <a:solidFill>
+                      <a:srgbClr val="FFFFFF"/>
+                    </a:solidFill>
+                  </a:tcPr>
+                </a:tc>
+                <a:tc>
+                  <a:txBody>
+                    <a:bodyPr/>
+                    <a:lstStyle/>
+                    <a:p>
+                      <a:pPr algn="ctr"/>
+                      <a:r>
+                        <a:rPr sz="960">
+                          <a:solidFill>
+                            <a:srgbClr val="1F3864"/>
+                          </a:solidFill>
+                          <a:latin typeface="Calibri"/>
+                        </a:rPr>
+                        <a:t>Price ($3.50, resin-indexed), spec, lead time, quality and change-notification terms; valid 12–24 months; zero minimum</a:t>
+                      </a:r>
+                    </a:p>
+                  </a:txBody>
+                  <a:tcPr>
+                    <a:solidFill>
+                      <a:srgbClr val="FFFFFF"/>
+                    </a:solidFill>
+                  </a:tcPr>
+                </a:tc>
+                <a:tc>
+                  <a:txBody>
+                    <a:bodyPr/>
+                    <a:lstStyle/>
+                    <a:p>
+                      <a:pPr algn="ctr"/>
+                      <a:r>
+                        <a:rPr sz="960">
+                          <a:solidFill>
+                            <a:srgbClr val="1F3864"/>
+                          </a:solidFill>
+                          <a:latin typeface="Calibri"/>
+                        </a:rPr>
+                        <a:t>Legal time</a:t>
+                      </a:r>
+                    </a:p>
+                  </a:txBody>
+                  <a:tcPr>
+                    <a:solidFill>
+                      <a:srgbClr val="FFFFFF"/>
+                    </a:solidFill>
+                  </a:tcPr>
+                </a:tc>
+                <a:tc>
+                  <a:txBody>
+                    <a:bodyPr/>
+                    <a:lstStyle/>
+                    <a:p>
+                      <a:pPr algn="l"/>
+                      <a:r>
+                        <a:rPr sz="960">
+                          <a:solidFill>
+                            <a:srgbClr val="1F3864"/>
+                          </a:solidFill>
+                          <a:latin typeface="Calibri"/>
+                        </a:rPr>
+                        <a:t>Formal 'approved second source' status for them; a callable option at a known price for us</a:t>
+                      </a:r>
+                    </a:p>
+                  </a:txBody>
+                  <a:tcPr>
+                    <a:solidFill>
+                      <a:srgbClr val="FFFFFF"/>
+                    </a:solidFill>
+                  </a:tcPr>
+                </a:tc>
+              </a:tr>
+              <a:tr h="541020">
+                <a:tc>
+                  <a:txBody>
+                    <a:bodyPr/>
+                    <a:lstStyle/>
+                    <a:p>
+                      <a:pPr algn="l"/>
+                      <a:r>
+                        <a:rPr sz="960" b="1">
+                          <a:solidFill>
+                            <a:srgbClr val="1F3864"/>
+                          </a:solidFill>
+                          <a:latin typeface="Calibri"/>
+                        </a:rPr>
+                        <a:t>3 · One production-scale order (B-plus)</a:t>
+                      </a:r>
+                    </a:p>
+                  </a:txBody>
+                  <a:tcPr>
+                    <a:solidFill>
+                      <a:srgbClr val="FFFFFF"/>
+                    </a:solidFill>
+                  </a:tcPr>
+                </a:tc>
+                <a:tc>
+                  <a:txBody>
+                    <a:bodyPr/>
+                    <a:lstStyle/>
+                    <a:p>
+                      <a:pPr algn="ctr"/>
+                      <a:r>
+                        <a:rPr sz="960">
+                          <a:solidFill>
+                            <a:srgbClr val="1F3864"/>
+                          </a:solidFill>
+                          <a:latin typeface="Calibri"/>
+                        </a:rPr>
+                        <a:t>A single paid 5-drum batch: proves rate and hydrogel performance, completes the file</a:t>
+                      </a:r>
+                    </a:p>
+                  </a:txBody>
+                  <a:tcPr>
+                    <a:solidFill>
+                      <a:srgbClr val="E2EFDA"/>
+                    </a:solidFill>
+                  </a:tcPr>
+                </a:tc>
+                <a:tc>
+                  <a:txBody>
+                    <a:bodyPr/>
+                    <a:lstStyle/>
+                    <a:p>
+                      <a:pPr algn="ctr"/>
+                      <a:r>
+                        <a:rPr sz="960">
+                          <a:solidFill>
+                            <a:srgbClr val="1F3864"/>
+                          </a:solidFill>
+                          <a:latin typeface="Calibri"/>
+                        </a:rPr>
+                        <a:t>~$7.9k (+$6.2k over SNP)</a:t>
+                      </a:r>
+                    </a:p>
+                  </a:txBody>
+                  <a:tcPr>
+                    <a:solidFill>
+                      <a:srgbClr val="E2EFDA"/>
+                    </a:solidFill>
+                  </a:tcPr>
+                </a:tc>
+                <a:tc>
+                  <a:txBody>
+                    <a:bodyPr/>
+                    <a:lstStyle/>
+                    <a:p>
+                      <a:pPr algn="l"/>
+                      <a:r>
+                        <a:rPr sz="960">
+                          <a:solidFill>
+                            <a:srgbClr val="1F3864"/>
+                          </a:solidFill>
+                          <a:latin typeface="Calibri"/>
+                        </a:rPr>
+                        <a:t>Strongest form — they have shipped to us; revenue for their work</a:t>
+                      </a:r>
+                    </a:p>
+                  </a:txBody>
+                  <a:tcPr>
+                    <a:solidFill>
+                      <a:srgbClr val="E2EFDA"/>
+                    </a:solidFill>
+                  </a:tcPr>
+                </a:tc>
+              </a:tr>
+              <a:tr h="541020">
+                <a:tc>
+                  <a:txBody>
+                    <a:bodyPr/>
+                    <a:lstStyle/>
+                    <a:p>
+                      <a:pPr algn="l"/>
+                      <a:r>
+                        <a:rPr sz="960" b="1">
+                          <a:solidFill>
+                            <a:srgbClr val="1F3864"/>
+                          </a:solidFill>
+                          <a:latin typeface="Calibri"/>
+                        </a:rPr>
+                        <a:t>4 · Readiness / capacity-reservation fee</a:t>
+                      </a:r>
+                    </a:p>
+                  </a:txBody>
+                  <a:tcPr>
+                    <a:solidFill>
+                      <a:srgbClr val="FFFFFF"/>
+                    </a:solidFill>
+                  </a:tcPr>
+                </a:tc>
+                <a:tc>
+                  <a:txBody>
+                    <a:bodyPr/>
+                    <a:lstStyle/>
+                    <a:p>
+                      <a:pPr algn="ctr"/>
+                      <a:r>
+                        <a:rPr sz="960">
+                          <a:solidFill>
+                            <a:srgbClr val="1F3864"/>
+                          </a:solidFill>
+                          <a:latin typeface="Calibri"/>
+                        </a:rPr>
+                        <a:t>An option contract: a fee for the right to call volume at a set price with a committed ramp (pharma: ~20% of forecast batch value; multi-million minimums)</a:t>
+                      </a:r>
+                    </a:p>
+                  </a:txBody>
+                  <a:tcPr>
+                    <a:solidFill>
+                      <a:srgbClr val="FFFFFF"/>
+                    </a:solidFill>
+                  </a:tcPr>
+                </a:tc>
+                <a:tc>
+                  <a:txBody>
+                    <a:bodyPr/>
+                    <a:lstStyle/>
+                    <a:p>
+                      <a:pPr algn="ctr"/>
+                      <a:r>
+                        <a:rPr sz="960">
+                          <a:solidFill>
+                            <a:srgbClr val="1F3864"/>
+                          </a:solidFill>
+                          <a:latin typeface="Calibri"/>
+                        </a:rPr>
+                        <a:t>Token retainer at most</a:t>
+                      </a:r>
+                    </a:p>
+                  </a:txBody>
+                  <a:tcPr>
+                    <a:solidFill>
+                      <a:srgbClr val="FFFFFF"/>
+                    </a:solidFill>
+                  </a:tcPr>
+                </a:tc>
+                <a:tc>
+                  <a:txBody>
+                    <a:bodyPr/>
+                    <a:lstStyle/>
+                    <a:p>
+                      <a:pPr algn="l"/>
+                      <a:r>
+                        <a:rPr sz="960">
+                          <a:solidFill>
+                            <a:srgbClr val="1F3864"/>
+                          </a:solidFill>
+                          <a:latin typeface="Calibri"/>
+                        </a:rPr>
+                        <a:t>Rarely worth it at our scale; mention only if PCI raises it</a:t>
+                      </a:r>
+                    </a:p>
+                  </a:txBody>
+                  <a:tcPr>
+                    <a:solidFill>
+                      <a:srgbClr val="FFFFFF"/>
+                    </a:solidFill>
+                  </a:tcPr>
+                </a:tc>
+              </a:tr>
+              <a:tr h="541020">
+                <a:tc>
+                  <a:txBody>
+                    <a:bodyPr/>
+                    <a:lstStyle/>
+                    <a:p>
+                      <a:pPr algn="l"/>
+                      <a:r>
+                        <a:rPr sz="960" b="1">
+                          <a:solidFill>
+                            <a:srgbClr val="1F3864"/>
+                          </a:solidFill>
+                          <a:latin typeface="Calibri"/>
+                        </a:rPr>
+                        <a:t>5 · Planned re-check (decay is real)</a:t>
+                      </a:r>
+                    </a:p>
+                  </a:txBody>
+                  <a:tcPr>
+                    <a:solidFill>
+                      <a:srgbClr val="FFFFFF"/>
+                    </a:solidFill>
+                  </a:tcPr>
+                </a:tc>
+                <a:tc>
+                  <a:txBody>
+                    <a:bodyPr/>
+                    <a:lstStyle/>
+                    <a:p>
+                      <a:pPr algn="ctr"/>
+                      <a:r>
+                        <a:rPr sz="960">
+                          <a:solidFill>
+                            <a:srgbClr val="1F3864"/>
+                          </a:solidFill>
+                          <a:latin typeface="Calibri"/>
+                        </a:rPr>
+                        <a:t>Idle suppliers go stale: PPAP re-approval after 12 months idle; ~18 months idle = 'new supplier again'; ISO 13485 §7.4.1 periodic re-evaluation</a:t>
+                      </a:r>
+                    </a:p>
+                  </a:txBody>
+                  <a:tcPr>
+                    <a:solidFill>
+                      <a:srgbClr val="FFFFFF"/>
+                    </a:solidFill>
+                  </a:tcPr>
+                </a:tc>
+                <a:tc>
+                  <a:txBody>
+                    <a:bodyPr/>
+                    <a:lstStyle/>
+                    <a:p>
+                      <a:pPr algn="ctr"/>
+                      <a:r>
+                        <a:rPr sz="960">
+                          <a:solidFill>
+                            <a:srgbClr val="1F3864"/>
+                          </a:solidFill>
+                          <a:latin typeface="Calibri"/>
+                        </a:rPr>
+                        <a:t>One 5-drum re-check batch/yr ≈ $7.9k, or a short requalification lot on restart</a:t>
+                      </a:r>
+                    </a:p>
+                  </a:txBody>
+                  <a:tcPr>
+                    <a:solidFill>
+                      <a:srgbClr val="FFFFFF"/>
+                    </a:solidFill>
+                  </a:tcPr>
+                </a:tc>
+                <a:tc>
+                  <a:txBody>
+                    <a:bodyPr/>
+                    <a:lstStyle/>
+                    <a:p>
+                      <a:pPr algn="l"/>
+                      <a:r>
+                        <a:rPr sz="960">
+                          <a:solidFill>
+                            <a:srgbClr val="1F3864"/>
+                          </a:solidFill>
+                          <a:latin typeface="Calibri"/>
+                        </a:rPr>
+                        <a:t>Keeps the option honest; restart in weeks, not months</a:t>
+                      </a:r>
+                    </a:p>
+                  </a:txBody>
+                  <a:tcPr>
+                    <a:solidFill>
+                      <a:srgbClr val="FFFFFF"/>
+                    </a:solidFill>
+                  </a:tcPr>
+                </a:tc>
+              </a:tr>
+            </a:tbl>
+          </a:graphicData>
+        </a:graphic>
+      </p:graphicFrame>
+      <p:sp>
+        <p:nvSpPr>
+          <p:cNvPr id="7" name="Rectangle 6"/>
           <p:cNvSpPr/>
           <p:nvPr/>
         </p:nvSpPr>
         <p:spPr>
           <a:xfrm>
-            <a:off x="6858000" y="1097280"/>
-            <a:ext cx="4754880" cy="4663440"/>
+            <a:off x="548640" y="5074920"/>
+            <a:ext cx="11064240" cy="868680"/>
           </a:xfrm>
           <a:prstGeom prst="rect">
             <a:avLst/>
           </a:prstGeom>
           <a:solidFill>
-            <a:srgbClr val="F6F8FB"/>
-          </a:solidFill>
-          <a:ln w="9525">
-            <a:solidFill>
-              <a:srgbClr val="4E79A7"/>
-            </a:solidFill>
-          </a:ln>
-          <a:effectLst/>
-        </p:spPr>
-        <p:style>
-          <a:lnRef idx="1">
-            <a:schemeClr val="accent1"/>
-          </a:lnRef>
-          <a:fillRef idx="3">
-            <a:schemeClr val="accent1"/>
-          </a:fillRef>
-          <a:effectRef idx="2">
-            <a:schemeClr val="accent1"/>
-          </a:effectRef>
-          <a:fontRef idx="minor">
-            <a:schemeClr val="lt1"/>
-          </a:fontRef>
-        </p:style>
-        <p:txBody>
-          <a:bodyPr rtlCol="0" anchor="ctr"/>
-          <a:lstStyle/>
-          <a:p>
-            <a:pPr algn="ctr"/>
-          </a:p>
-        </p:txBody>
-      </p:sp>
-      <p:sp>
-        <p:nvSpPr>
-          <p:cNvPr id="7" name="TextBox 6"/>
-          <p:cNvSpPr txBox="1"/>
-          <p:nvPr/>
-        </p:nvSpPr>
-        <p:spPr>
-          <a:xfrm>
-            <a:off x="7040880" y="1234440"/>
-            <a:ext cx="4389120" cy="4480560"/>
-          </a:xfrm>
-          <a:prstGeom prst="rect">
-            <a:avLst/>
-          </a:prstGeom>
-          <a:noFill/>
-        </p:spPr>
-        <p:txBody>
-          <a:bodyPr wrap="square">
-            <a:spAutoFit/>
-          </a:bodyPr>
-          <a:lstStyle/>
-          <a:p>
-            <a:pPr algn="l">
-              <a:spcAft>
-                <a:spcPts val="600"/>
-              </a:spcAft>
-            </a:pPr>
-            <a:r>
-              <a:rPr sz="1300" b="1" i="0">
-                <a:solidFill>
-                  <a:srgbClr val="1F3864"/>
-                </a:solidFill>
-                <a:latin typeface="Calibri"/>
-              </a:rPr>
-              <a:t>To settle with SNP Inc. under B / B-plus</a:t>
-            </a:r>
-          </a:p>
-          <a:p>
-            <a:pPr algn="l">
-              <a:spcAft>
-                <a:spcPts val="600"/>
-              </a:spcAft>
-            </a:pPr>
-            <a:r>
-              <a:rPr sz="1100" b="0" i="0">
-                <a:solidFill>
-                  <a:srgbClr val="595959"/>
-                </a:solidFill>
-                <a:latin typeface="Calibri"/>
-              </a:rPr>
-              <a:t>•  Rolling 12-month forecast, refreshed monthly; the hydrogel program as a written joint roadmap</a:t>
-            </a:r>
-          </a:p>
-          <a:p>
-            <a:pPr algn="l">
-              <a:spcAft>
-                <a:spcPts val="600"/>
-              </a:spcAft>
-            </a:pPr>
-            <a:r>
-              <a:rPr sz="1100" b="0" i="0">
-                <a:solidFill>
-                  <a:srgbClr val="595959"/>
-                </a:solidFill>
-                <a:latin typeface="Calibri"/>
-              </a:rPr>
-              <a:t>•  Continuity terms in the Supplier Quality Agreement: second line/site plan, key-person cover, advance change notice, right to audit</a:t>
-            </a:r>
-          </a:p>
-          <a:p>
-            <a:pPr algn="l">
-              <a:spcAft>
-                <a:spcPts val="600"/>
-              </a:spcAft>
-            </a:pPr>
-            <a:r>
-              <a:rPr sz="1100" b="0" i="0">
-                <a:solidFill>
-                  <a:srgbClr val="595959"/>
-                </a:solidFill>
-                <a:latin typeface="Calibri"/>
-              </a:rPr>
-              <a:t>•  8–12 weeks of dry PVA resin on consignment (shelf-stable; ~$2.5–6k tied up)</a:t>
-            </a:r>
-          </a:p>
-          <a:p>
-            <a:pPr algn="l">
-              <a:spcAft>
-                <a:spcPts val="600"/>
-              </a:spcAft>
-            </a:pPr>
-            <a:r>
-              <a:rPr sz="1100" b="0" i="0">
-                <a:solidFill>
-                  <a:srgbClr val="595959"/>
-                </a:solidFill>
-                <a:latin typeface="Calibri"/>
-              </a:rPr>
-              <a:t>•  Their capacity headroom at year-5 volume (~99k lb) — the unasked question</a:t>
-            </a:r>
-          </a:p>
-          <a:p>
-            <a:pPr algn="l">
-              <a:spcAft>
-                <a:spcPts val="600"/>
-              </a:spcAft>
-            </a:pPr>
-            <a:r>
-              <a:rPr sz="1100" b="0" i="0">
-                <a:solidFill>
-                  <a:srgbClr val="595959"/>
-                </a:solidFill>
-                <a:latin typeface="Calibri"/>
-              </a:rPr>
-              <a:t>•  Owner/succession and financial health — the risk that gives no warning</a:t>
-            </a:r>
-          </a:p>
-          <a:p>
-            <a:pPr algn="l">
-              <a:spcAft>
-                <a:spcPts val="600"/>
-              </a:spcAft>
-            </a:pPr>
-            <a:r>
-              <a:rPr sz="1100" b="0" i="0">
-                <a:solidFill>
-                  <a:srgbClr val="595959"/>
-                </a:solidFill>
-                <a:latin typeface="Calibri"/>
-              </a:rPr>
-              <a:t>•  A 30–45-day shelf-life study — the cheapest way to lengthen our time-to-survive</a:t>
-            </a:r>
-          </a:p>
-        </p:txBody>
-      </p:sp>
-      <p:sp>
-        <p:nvSpPr>
-          <p:cNvPr id="8" name="Rectangle 7"/>
-          <p:cNvSpPr/>
-          <p:nvPr/>
-        </p:nvSpPr>
-        <p:spPr>
-          <a:xfrm>
-            <a:off x="548640" y="5989320"/>
-            <a:ext cx="11064240" cy="566928"/>
-          </a:xfrm>
-          <a:prstGeom prst="rect">
-            <a:avLst/>
-          </a:prstGeom>
-          <a:solidFill>
-            <a:srgbClr val="9C5A0C"/>
+            <a:srgbClr val="EEF2F7"/>
           </a:solidFill>
           <a:ln>
             <a:noFill/>
@@ -11885,7 +12881,106 @@
       </p:sp>
       <p:sp>
         <p:nvSpPr>
-          <p:cNvPr id="9" name="TextBox 8"/>
+          <p:cNvPr id="8" name="TextBox 7"/>
+          <p:cNvSpPr txBox="1"/>
+          <p:nvPr/>
+        </p:nvSpPr>
+        <p:spPr>
+          <a:xfrm>
+            <a:off x="731520" y="5193792"/>
+            <a:ext cx="10698480" cy="630936"/>
+          </a:xfrm>
+          <a:prstGeom prst="rect">
+            <a:avLst/>
+          </a:prstGeom>
+          <a:noFill/>
+        </p:spPr>
+        <p:txBody>
+          <a:bodyPr wrap="square">
+            <a:spAutoFit/>
+          </a:bodyPr>
+          <a:lstStyle/>
+          <a:p>
+            <a:pPr algn="l">
+              <a:spcAft>
+                <a:spcPts val="600"/>
+              </a:spcAft>
+            </a:pPr>
+            <a:r>
+              <a:rPr sz="1350" b="1" i="0">
+                <a:solidFill>
+                  <a:srgbClr val="1F3864"/>
+                </a:solidFill>
+                <a:latin typeface="Calibri"/>
+              </a:rPr>
+              <a:t>Conduct that keeps it intact</a:t>
+            </a:r>
+          </a:p>
+          <a:p>
+            <a:pPr algn="l">
+              <a:spcAft>
+                <a:spcPts val="500"/>
+              </a:spcAft>
+            </a:pPr>
+            <a:r>
+              <a:rPr sz="1050" b="0" i="0">
+                <a:solidFill>
+                  <a:srgbClr val="595959"/>
+                </a:solidFill>
+                <a:latin typeface="Calibri"/>
+              </a:rPr>
+              <a:t>•  Tell PCI Manufacturing the volume reality and the exact triggers · pay promptly for value received · share the test results (they learn too) · a quarterly touchpoint · a reference. Suppliers allocate goodwill on trust, long-term orientation and growth prospects — not on current volume (Pulles, Schiele et al. 2016).</a:t>
+            </a:r>
+          </a:p>
+        </p:txBody>
+      </p:sp>
+      <p:sp>
+        <p:nvSpPr>
+          <p:cNvPr id="9" name="Rectangle 8"/>
+          <p:cNvSpPr/>
+          <p:nvPr/>
+        </p:nvSpPr>
+        <p:spPr>
+          <a:xfrm>
+            <a:off x="548640" y="5989320"/>
+            <a:ext cx="11064240" cy="566928"/>
+          </a:xfrm>
+          <a:prstGeom prst="rect">
+            <a:avLst/>
+          </a:prstGeom>
+          <a:solidFill>
+            <a:srgbClr val="2E7D46"/>
+          </a:solidFill>
+          <a:ln>
+            <a:noFill/>
+          </a:ln>
+          <a:effectLst/>
+        </p:spPr>
+        <p:style>
+          <a:lnRef idx="1">
+            <a:schemeClr val="accent1"/>
+          </a:lnRef>
+          <a:fillRef idx="3">
+            <a:schemeClr val="accent1"/>
+          </a:fillRef>
+          <a:effectRef idx="2">
+            <a:schemeClr val="accent1"/>
+          </a:effectRef>
+          <a:fontRef idx="minor">
+            <a:schemeClr val="lt1"/>
+          </a:fontRef>
+        </p:style>
+        <p:txBody>
+          <a:bodyPr rtlCol="0" anchor="ctr"/>
+          <a:lstStyle/>
+          <a:p>
+            <a:pPr algn="ctr"/>
+          </a:p>
+        </p:txBody>
+      </p:sp>
+      <p:sp>
+        <p:nvSpPr>
+          <p:cNvPr id="10" name="TextBox 9"/>
           <p:cNvSpPr txBox="1"/>
           <p:nvPr/>
         </p:nvSpPr>
@@ -11917,7 +13012,7 @@
                 </a:solidFill>
                 <a:latin typeface="Calibri"/>
               </a:rPr>
-              <a:t>Decide the strategy first; then use the SNP Inc. conversation to execute it — not to discover it.</a:t>
+              <a:t>Not using a qualified supplier is normal. Pay for the work, sign the terms, state the triggers, re-check yearly — and the door stays open.</a:t>
             </a:r>
           </a:p>
         </p:txBody>

</xml_diff>

<commit_message>
Annual-cost chart: Option 3 bars at 1/2/3 batches a year (blues); $6.00 bar as one drum a week (52 drums, ~1/3); reading-the-chart updated
Co-Authored-By: Claude Fable 5.1 <noreply@anthropic.com>
Claude-Session: https://claude.ai/code/session_01LkE2ZRYs3PLyj8XHTsU3i4
</commit_message>
<xml_diff>
--- a/PVA second supplier initiative/PVA_Second_Supplier_Leadership_Deck.pptx
+++ b/PVA second supplier initiative/PVA_Second_Supplier_Leadership_Deck.pptx
@@ -721,7 +721,7 @@
           <a:lstStyle/>
           <a:p>
             <a:r>
-              <a:t>Annual cost side by side, apples to apples. The same 67,600 pounds a year in every bar - 150 drums - and the second source takes exactly one third in every option: 22,500 pounds, 50 drums, ten batches of five. SNP's part is identical everywhere: 45,100 pounds at 75 cents, 33.8 thousand. Only the second source's price changes. At PCI's 3.50 batch price: 78.8 thousand for that third, 112.6 total, plus 61.9 thousand a year - 122 percent of today's bill. At the 6-dollar below-batch price: 168.8 total, plus 118. CJB, for scale: 223 total. Option 3 is not a bar because it is a different quantity - one or two batches a year, plus 6 to 12 thousand - it is on the options slide with the one-time costs.</a:t>
+              <a:t>Annual cost side by side. The same 67,600 pounds a year in every bar - 150 drums; SNP at 75 cents keeps whatever the second source does not take. Green alone is today: 50.7 thousand. The three blues are Option 3: one, two or three five-drum batches a year at 3.50 - plus 6, 12 or 19 thousand. Dark amber is a one-third second source at PCI's batch price: 22,500 pounds, 50 drums, 112.6 thousand total, plus 61.9 - 122 percent of today's bill. Light amber is one drum a week at the 6-dollar below-batch price: 52 drums, 23,400 pounds, almost a third - 173.6 thousand, plus 122.9; the small-order version is the expensive one. Red is CJB at one third, for scale: 223 thousand. Internal hours and one-time costs are on the options slide.</a:t>
             </a:r>
           </a:p>
         </p:txBody>
@@ -6589,7 +6589,7 @@
         <p:spPr>
           <a:xfrm>
             <a:off x="548640" y="1051560"/>
-            <a:ext cx="7406640" cy="3635987"/>
+            <a:ext cx="7406640" cy="3477901"/>
           </a:xfrm>
           <a:prstGeom prst="rect">
             <a:avLst/>
@@ -6701,7 +6701,7 @@
                 </a:solidFill>
                 <a:latin typeface="Calibri"/>
               </a:rPr>
-              <a:t>— 67,600 lb = 150 drums — identical in every bar</a:t>
+              <a:t>— 67,600 lb = 150 drums in every bar; SNP Inc. at $0.75 keeps whatever the second source does not take</a:t>
             </a:r>
           </a:p>
           <a:p>
@@ -6717,7 +6717,7 @@
                 </a:solidFill>
                 <a:latin typeface="Calibri"/>
               </a:rPr>
-              <a:t>Split  </a:t>
+              <a:t>All-SNP  </a:t>
             </a:r>
             <a:r>
               <a:rPr sz="1000">
@@ -6726,7 +6726,7 @@
                 </a:solidFill>
                 <a:latin typeface="Calibri"/>
               </a:rPr>
-              <a:t>— second source takes one-third = 22,500 lb (50 drums, 10 batches); SNP Inc. keeps 45,100 lb × $0.75 = $33.8k in every option</a:t>
+              <a:t>— 67,600 × $0.75 = $50.7k</a:t>
             </a:r>
           </a:p>
           <a:p>
@@ -6742,7 +6742,7 @@
                 </a:solidFill>
                 <a:latin typeface="Calibri"/>
               </a:rPr>
-              <a:t>All-SNP  </a:t>
+              <a:t>Option 3, blues  </a:t>
             </a:r>
             <a:r>
               <a:rPr sz="1000">
@@ -6751,7 +6751,7 @@
                 </a:solidFill>
                 <a:latin typeface="Calibri"/>
               </a:rPr>
-              <a:t>— 67,600 × $0.75 = $50.7k</a:t>
+              <a:t>— 1 / 2 / 3 batches of 5 drums a year at $3.50 (2,250 / 4,500 / 6,750 lb): +$6.2k / +$12.4k / +$18.6k</a:t>
             </a:r>
           </a:p>
           <a:p>
@@ -6776,7 +6776,7 @@
                 </a:solidFill>
                 <a:latin typeface="Calibri"/>
               </a:rPr>
-              <a:t>— 22,500 × $3.50 = $78.8k → $112.6k; +$61.9k (122%)</a:t>
+              <a:t>— one-third = 22,500 lb (50 drums, 10 batches) × $3.50 = $78.8k → $112.6k; +$61.9k (122%)</a:t>
             </a:r>
           </a:p>
           <a:p>
@@ -6801,7 +6801,7 @@
                 </a:solidFill>
                 <a:latin typeface="Calibri"/>
               </a:rPr>
-              <a:t>— same third, ordered below batch size → $168.8k; +$118.1k (233%)</a:t>
+              <a:t>— one drum a week = 52 drums = 23,400 lb, almost one-third, ordered below batch size → $173.6k; +$122.9k (242%)</a:t>
             </a:r>
           </a:p>
           <a:p>
@@ -6826,7 +6826,7 @@
                 </a:solidFill>
                 <a:latin typeface="Calibri"/>
               </a:rPr>
-              <a:t>— same third, for scale → $223.3k; +$172.6k (340%)</a:t>
+              <a:t>— one-third, for scale → $223.3k; +$172.6k (340%)</a:t>
             </a:r>
           </a:p>
           <a:p>
@@ -6851,7 +6851,7 @@
                 </a:solidFill>
                 <a:latin typeface="Calibri"/>
               </a:rPr>
-              <a:t>— SNP Inc.'s part never changes; only the second source's price does</a:t>
+              <a:t>— only the second source's quantity and price change</a:t>
             </a:r>
           </a:p>
           <a:p>
@@ -6876,7 +6876,7 @@
                 </a:solidFill>
                 <a:latin typeface="Calibri"/>
               </a:rPr>
-              <a:t>— Option 3 (1–2 batches/yr, +$6–12k) is a different quantity — the options slide; internal hours and one-time costs — the options slide</a:t>
+              <a:t>— internal hours and one-time costs — the options slide</a:t>
             </a:r>
           </a:p>
         </p:txBody>
@@ -6959,7 +6959,7 @@
                 </a:solidFill>
                 <a:latin typeface="Calibri"/>
               </a:rPr>
-              <a:t>Same demand, same one-third split in every option — only the second source's price changes. At PCI's $3.50 the PVA bill more than doubles (2.2×), every year.</a:t>
+              <a:t>Option 3 adds $6–19k a year. A one-third second source at PCI's $3.50 more than doubles the bill (2.2×); one drum a week at $6.00 costs more still.</a:t>
             </a:r>
           </a:p>
         </p:txBody>

</xml_diff>

<commit_message>
Chronology: Columbus Chemical never quoted; drop the July price assumption from its event
Co-Authored-By: Claude Fable 5.1 <noreply@anthropic.com>
Claude-Session: https://claude.ai/code/session_01LkE2ZRYs3PLyj8XHTsU3i4
</commit_message>
<xml_diff>
--- a/PVA second supplier initiative/PVA_Second_Supplier_Leadership_Deck.pptx
+++ b/PVA second supplier initiative/PVA_Second_Supplier_Leadership_Deck.pptx
@@ -791,7 +791,7 @@
           <a:lstStyle/>
           <a:p>
             <a:r>
-              <a:t>How we got here, as a series of events. November last year: Brenntag, a distributor, tried our formula - the viscosity came out above range, unreadable on their viscometer; they stalled and we never received a quote; in March they sent us a resin sample instead. March to April: we screened about 94 US suppliers and reached out to ArroChem, Piedmont and ILC Dover with one hard gate - hold 90 to 95 degrees. May: ArroChem and ILC Dover failed that gate. June 26: CJB cleared it and became the front-runner; APV confirmed heat; we confirmed demand at 1,300 pounds a week. July: Columbus Chemical told us they cannot hold the temperature. August 4: CJB's quote came in at 8 to 8.50 a pound for toll processing alone - eleven times SNP - and their trial would have cost 6,400 dollars; we declined, so we never corroborated whether they could actually make it. August to September: PCI Manufacturing ran two-plus lab batches and a dilution study, unpaid. September 22: the viscosity root cause - elevated solids - and a locked spec. September 28: spec met, and a real quote of 3.50 a pound per five-drum batch. What it is worth: a cold start is now months, not a year. What it cost: PCI's unpaid engineering, and about 15 thousand of our own hours, sunk. Using it costs 62 thousand a year plus a permanent discipline; walking away costs goodwill; the middle is one or two batches a year.</a:t>
+              <a:t>How we got here, as a series of events. November last year: Brenntag, a distributor, tried our formula - the viscosity came out above range, unreadable on their viscometer; they stalled and we never received a quote; in March they sent us a resin sample instead. March to April: we screened about 94 US suppliers and reached out to ArroChem, Piedmont and ILC Dover with one hard gate - hold 90 to 95 degrees. May: ArroChem and ILC Dover failed that gate. June 26: CJB cleared it and became the front-runner; APV confirmed heat; we confirmed demand at 1,300 pounds a week. July: Columbus Chemical reached out to us, then told us directly they cannot hold the temperature - eliminated, never quoted. August 4: CJB's quote came in at 8 to 8.50 a pound for toll processing alone - eleven times SNP - and their trial would have cost 6,400 dollars; we declined, so we never corroborated whether they could actually make it. August to September: PCI Manufacturing ran two-plus lab batches and a dilution study, unpaid. September 22: the viscosity root cause - elevated solids - and a locked spec. September 28: spec met, and a real quote of 3.50 a pound per five-drum batch. What it is worth: a cold start is now months, not a year. What it cost: PCI's unpaid engineering, and about 15 thousand of our own hours, sunk. Using it costs 62 thousand a year plus a permanent discipline; walking away costs goodwill; the middle is one or two batches a year.</a:t>
             </a:r>
           </a:p>
         </p:txBody>
@@ -7843,7 +7843,7 @@
                 </a:solidFill>
                 <a:latin typeface="Calibri"/>
               </a:rPr>
-              <a:t>Eliminated. July review assumed $1.00–1.25/lb</a:t>
+              <a:t>Reached out to us, then told us directly they cannot hold 90–95 °C. Eliminated; never quoted</a:t>
             </a:r>
           </a:p>
         </p:txBody>

</xml_diff>

<commit_message>
Deck v4.4: merge logistics + options into a year-at-a-glance slide; add cost-against-protection slide; validated palette
Co-Authored-By: Claude Fable 5.1 <noreply@anthropic.com>
Claude-Session: https://claude.ai/code/session_01LkE2ZRYs3PLyj8XHTsU3i4
</commit_message>
<xml_diff>
--- a/PVA second supplier initiative/PVA_Second_Supplier_Leadership_Deck.pptx
+++ b/PVA second supplier initiative/PVA_Second_Supplier_Leadership_Deck.pptx
@@ -861,7 +861,7 @@
           <a:lstStyle/>
           <a:p>
             <a:r>
-              <a:t>Logistics. The shelf-life clock starts at manufacture. PCI cooks on day zero, the five drums land around day four, we run on them at full rate through about day sixteen, and they expire on day eighteen - about two days of slack. Then three and a half weeks on SNP, repeat every five weeks; ten batches in year one, about fifteen by year five. We cannot run PCI alongside SNP at a third of rate: a batch would last thirty-six days; even at two-thirds it takes eighteen. A validated twenty-one-day life gives block rotation real margin; a thirty-day life still needs PCI at about half of rate. For SNP: a third less volume, and a choice of cadence - a twelve-day pause every cycle, or a steady two drums a week if we carry about three drums of rolling stock and use them first; the shelf-life study decides. What SNP reads is the signal, not the dollars. For us: one spec, one viscometer method, freeze-protected freight, five drums on site, a written failover with SNP's lead time, PCI's residual-film issue closed before any production batch, two quality agreements. What it buys - recovery in weeks - only if PCI confirms in writing that they can ramp.</a:t>
+              <a:t>Three options on one page: what each costs, how the year runs, what each supplier sees. The strips are the year, week by week: green is SNP material, colored blocks are PCI batches - each five-drum batch is about twelve days at full rate, because the drums land about four days old and the eighteen-day life is counted from manufacture, so a batch is used in one block. Option 1: ten blocks a year, one every five weeks - SNP sees ten pauses, or a level cadence if we carry about three drums of rolling stock; 80 to 110 thousand in the first twelve months, 65 to 70 a year after; recovery in weeks only if PCI confirms the ramp in writing. Option 3: one or two blocks a year, when we choose - 31 to 78 thousand in year one, 9 to 24 after; SNP sees one or two pre-announced pauses or none; restart in weeks to a few months. Option 2: the whole year on SNP, PCI a quoted option - 13 to 32 thousand in year one, 3 to 12 after; if SNP fails, three to six months, and a cold start decays after a year idle. Why not run PCI alongside SNP at a third of rate instead of blocks? A batch would last thirty-six days - twice the life; even at two-thirds it takes eighteen. A validated twenty-one-day life gives margin; a thirty-day life still needs PCI at about half of rate. For us, two suppliers means one spec and one viscometer method, freeze-protected freight, a written failover with SNP's lead time, PCI's residual-film issue closed before any production batch, and two quality agreements. Costs exclude the fifteen thousand of internal hours already spent.</a:t>
             </a:r>
           </a:p>
         </p:txBody>
@@ -931,7 +931,7 @@
           <a:lstStyle/>
           <a:p>
             <a:r>
-              <a:t>Three options. The chart shows the first twelve months all-in and each year after, as ranges; the table says what each buys and what each supplier sees. Option 1, a second supplier at a third of volume: 62 thousand a year of premium plus a few thousand of quality overhead, plus 15 to 40 thousand of internal hours to reach production release - about 80 to 110 thousand in year one; a practiced second source, but strain with SNP at the wrong moment. Option 2, strengthen SNP only, no volume moved: a development fee to PCI, a few thousand to formalize SNP, 3 to 12 thousand a year - 13 to 32 thousand in year one; deeper partnership, but SNP failure still means months. Option 3, keep-alive: Option 2's partnership plus one or two five-drum batches a year from PCI, 7,900 dollars each gross, 6,200 of premium each - 31 to 70 thousand in year one at one batch, 39 to 78 at two, of which 13 to 26 thousand is cash to suppliers. Everything Option 2 buys plus production scale proven and a qualification that never goes stale; SNP sees one or two pre-announced twelve-day pauses, or none if we carry a small rolling stock. The economic advantage of Option 3: the 3.50 batch price has no volume string attached - nothing in the quote or any contract ties it to a yearly volume - so we can order a batch when we choose; we should get that in writing, and if PCI ever attaches a minimum, Option 3 collapses to Option 2. Internal hours already spent - about 15 thousand - are sunk and excluded everywhere. Option 3 at one batch a year is my recommendation.</a:t>
+              <a:t>Cost against protection. Left to right is what each option costs in its first twelve months, all-in; bottom to top is how long we would be without PVA if SNP stopped tomorrow. Each box is the range of one option. Green, Option 2, is the cheapest and the least protected: a cold start of three to six months, and longer as the file goes stale. Blue, Option 3, sits in the middle: a practiced supplier restarts in weeks to a few months for a third of Option 1's cost. Amber, Option 1, is the most protected - weeks, if PCI confirms the ramp in writing - and the most expensive, every year. The chart does not show what SNP experiences: ten pauses a year under Option 1, one or two under Option 3, none under Option 2. The question for Finance is whether the extra weeks of speed under Option 1 are worth about 62 thousand a year.</a:t>
             </a:r>
           </a:p>
         </p:txBody>
@@ -8980,7 +8980,7 @@
                 </a:solidFill>
                 <a:latin typeface="Calibri"/>
               </a:rPr>
-              <a:t>What 5-drum batches mean operationally</a:t>
+              <a:t>Three options — what each costs, how the year runs, what each supplier sees</a:t>
             </a:r>
           </a:p>
         </p:txBody>
@@ -9019,7 +9019,7 @@
                 </a:solidFill>
                 <a:latin typeface="Calibri"/>
               </a:rPr>
-              <a:t>3 · LOGISTICS</a:t>
+              <a:t>3 · OPTIONS</a:t>
             </a:r>
           </a:p>
         </p:txBody>
@@ -9032,8 +9032,8 @@
         </p:nvSpPr>
         <p:spPr>
           <a:xfrm>
-            <a:off x="548640" y="987552"/>
-            <a:ext cx="11064240" cy="365760"/>
+            <a:off x="3017520" y="987552"/>
+            <a:ext cx="6035040" cy="274320"/>
           </a:xfrm>
           <a:prstGeom prst="rect">
             <a:avLst/>
@@ -9048,17 +9048,17 @@
           <a:p>
             <a:pPr algn="l">
               <a:spcAft>
-                <a:spcPts val="400"/>
-              </a:spcAft>
-            </a:pPr>
-            <a:r>
-              <a:rPr sz="1250" b="1" i="0">
+                <a:spcPts val="0"/>
+              </a:spcAft>
+            </a:pPr>
+            <a:r>
+              <a:rPr sz="1000" b="1" i="0">
                 <a:solidFill>
                   <a:srgbClr val="1F3864"/>
                 </a:solidFill>
                 <a:latin typeface="Calibri"/>
               </a:rPr>
-              <a:t>Block rotation at one-third: one 5-drum batch every ~5 weeks. The 18-day shelf life is counted from manufacture.</a:t>
+              <a:t>The year, week by week — green: SNP Inc. material · colored blocks: PCI batches (5 drums = ~12 days)</a:t>
             </a:r>
           </a:p>
         </p:txBody>
@@ -9071,8 +9071,8 @@
         </p:nvSpPr>
         <p:spPr>
           <a:xfrm>
-            <a:off x="548640" y="1389888"/>
-            <a:ext cx="1737360" cy="420624"/>
+            <a:off x="548640" y="1325880"/>
+            <a:ext cx="2377440" cy="1280160"/>
           </a:xfrm>
           <a:prstGeom prst="rect">
             <a:avLst/>
@@ -9080,24 +9080,56 @@
           <a:noFill/>
         </p:spPr>
         <p:txBody>
-          <a:bodyPr wrap="square" anchor="ctr">
+          <a:bodyPr wrap="square">
             <a:spAutoFit/>
           </a:bodyPr>
           <a:lstStyle/>
           <a:p>
             <a:pPr algn="l">
               <a:spcAft>
+                <a:spcPts val="200"/>
+              </a:spcAft>
+            </a:pPr>
+            <a:r>
+              <a:rPr sz="1500" b="1" i="0">
+                <a:solidFill>
+                  <a:srgbClr val="C9741A"/>
+                </a:solidFill>
+                <a:latin typeface="Calibri"/>
+              </a:rPr>
+              <a:t>Option 1</a:t>
+            </a:r>
+          </a:p>
+          <a:p>
+            <a:pPr algn="l">
+              <a:spcAft>
+                <a:spcPts val="200"/>
+              </a:spcAft>
+            </a:pPr>
+            <a:r>
+              <a:rPr sz="1100" b="1" i="0">
+                <a:solidFill>
+                  <a:srgbClr val="1F3864"/>
+                </a:solidFill>
+                <a:latin typeface="Calibri"/>
+              </a:rPr>
+              <a:t>Second supplier at one-third</a:t>
+            </a:r>
+          </a:p>
+          <a:p>
+            <a:pPr algn="l">
+              <a:spcAft>
                 <a:spcPts val="0"/>
               </a:spcAft>
             </a:pPr>
             <a:r>
-              <a:rPr sz="950" b="1" i="0">
-                <a:solidFill>
-                  <a:srgbClr val="1F3864"/>
-                </a:solidFill>
-                <a:latin typeface="Calibri"/>
-              </a:rPr>
-              <a:t>PCI batch clock</a:t>
+              <a:rPr sz="900" b="0" i="0">
+                <a:solidFill>
+                  <a:srgbClr val="595959"/>
+                </a:solidFill>
+                <a:latin typeface="Calibri"/>
+              </a:rPr>
+              <a:t>10 PCI batches a year: ~12 days on PCI material every ~5 weeks</a:t>
             </a:r>
           </a:p>
         </p:txBody>
@@ -9110,19 +9142,17 @@
         </p:nvSpPr>
         <p:spPr>
           <a:xfrm>
-            <a:off x="2331720" y="1417320"/>
-            <a:ext cx="1031240" cy="365760"/>
+            <a:off x="3017520" y="1490472"/>
+            <a:ext cx="6035040" cy="566928"/>
           </a:xfrm>
           <a:prstGeom prst="rect">
             <a:avLst/>
           </a:prstGeom>
           <a:solidFill>
-            <a:srgbClr val="D6DCE5"/>
+            <a:srgbClr val="2E7D46"/>
           </a:solidFill>
-          <a:ln w="9525">
-            <a:solidFill>
-              <a:srgbClr val="FFFFFF"/>
-            </a:solidFill>
+          <a:ln>
+            <a:noFill/>
           </a:ln>
           <a:effectLst/>
         </p:spPr>
@@ -9150,64 +9180,23 @@
       </p:sp>
       <p:sp>
         <p:nvSpPr>
-          <p:cNvPr id="8" name="TextBox 7"/>
-          <p:cNvSpPr txBox="1"/>
-          <p:nvPr/>
-        </p:nvSpPr>
-        <p:spPr>
-          <a:xfrm>
-            <a:off x="2331720" y="1417320"/>
-            <a:ext cx="1031240" cy="365760"/>
-          </a:xfrm>
-          <a:prstGeom prst="rect">
-            <a:avLst/>
-          </a:prstGeom>
-          <a:noFill/>
-        </p:spPr>
-        <p:txBody>
-          <a:bodyPr wrap="square" anchor="ctr">
-            <a:spAutoFit/>
-          </a:bodyPr>
-          <a:lstStyle/>
-          <a:p>
-            <a:pPr algn="ctr">
-              <a:spcAft>
-                <a:spcPts val="0"/>
-              </a:spcAft>
-            </a:pPr>
-            <a:r>
-              <a:rPr sz="850" b="1" i="0">
-                <a:solidFill>
-                  <a:srgbClr val="1F3864"/>
-                </a:solidFill>
-                <a:latin typeface="Calibri"/>
-              </a:rPr>
-              <a:t>cook → ship ~4 d</a:t>
-            </a:r>
-          </a:p>
-        </p:txBody>
-      </p:sp>
-      <p:sp>
-        <p:nvSpPr>
-          <p:cNvPr id="9" name="Rectangle 8"/>
+          <p:cNvPr id="8" name="Rectangle 7"/>
           <p:cNvSpPr/>
           <p:nvPr/>
         </p:nvSpPr>
         <p:spPr>
           <a:xfrm>
-            <a:off x="3362960" y="1417320"/>
-            <a:ext cx="3119501" cy="365760"/>
+            <a:off x="3017520" y="1490472"/>
+            <a:ext cx="200065" cy="566928"/>
           </a:xfrm>
           <a:prstGeom prst="rect">
             <a:avLst/>
           </a:prstGeom>
           <a:solidFill>
-            <a:srgbClr val="1F3864"/>
+            <a:srgbClr val="C9741A"/>
           </a:solidFill>
-          <a:ln w="9525">
-            <a:solidFill>
-              <a:srgbClr val="FFFFFF"/>
-            </a:solidFill>
+          <a:ln>
+            <a:noFill/>
           </a:ln>
           <a:effectLst/>
         </p:spPr>
@@ -9235,64 +9224,23 @@
       </p:sp>
       <p:sp>
         <p:nvSpPr>
-          <p:cNvPr id="10" name="TextBox 9"/>
-          <p:cNvSpPr txBox="1"/>
-          <p:nvPr/>
-        </p:nvSpPr>
-        <p:spPr>
-          <a:xfrm>
-            <a:off x="3362960" y="1417320"/>
-            <a:ext cx="3119501" cy="365760"/>
-          </a:xfrm>
-          <a:prstGeom prst="rect">
-            <a:avLst/>
-          </a:prstGeom>
-          <a:noFill/>
-        </p:spPr>
-        <p:txBody>
-          <a:bodyPr wrap="square" anchor="ctr">
-            <a:spAutoFit/>
-          </a:bodyPr>
-          <a:lstStyle/>
-          <a:p>
-            <a:pPr algn="ctr">
-              <a:spcAft>
-                <a:spcPts val="0"/>
-              </a:spcAft>
-            </a:pPr>
-            <a:r>
-              <a:rPr sz="850" b="1" i="0">
-                <a:solidFill>
-                  <a:srgbClr val="FFFFFF"/>
-                </a:solidFill>
-                <a:latin typeface="Calibri"/>
-              </a:rPr>
-              <a:t>12.1 days used at full rate</a:t>
-            </a:r>
-          </a:p>
-        </p:txBody>
-      </p:sp>
-      <p:sp>
-        <p:nvSpPr>
-          <p:cNvPr id="11" name="Rectangle 10"/>
+          <p:cNvPr id="9" name="Rectangle 8"/>
           <p:cNvSpPr/>
           <p:nvPr/>
         </p:nvSpPr>
         <p:spPr>
           <a:xfrm>
-            <a:off x="6482461" y="1417320"/>
-            <a:ext cx="489838" cy="365760"/>
+            <a:off x="2999232" y="1490472"/>
+            <a:ext cx="18288" cy="566928"/>
           </a:xfrm>
           <a:prstGeom prst="rect">
             <a:avLst/>
           </a:prstGeom>
           <a:solidFill>
-            <a:srgbClr val="FFF2CC"/>
+            <a:srgbClr val="FFFFFF"/>
           </a:solidFill>
-          <a:ln w="9525">
-            <a:solidFill>
-              <a:srgbClr val="FFFFFF"/>
-            </a:solidFill>
+          <a:ln>
+            <a:noFill/>
           </a:ln>
           <a:effectLst/>
         </p:spPr>
@@ -9320,64 +9268,23 @@
       </p:sp>
       <p:sp>
         <p:nvSpPr>
-          <p:cNvPr id="12" name="TextBox 11"/>
-          <p:cNvSpPr txBox="1"/>
-          <p:nvPr/>
-        </p:nvSpPr>
-        <p:spPr>
-          <a:xfrm>
-            <a:off x="6482461" y="1417320"/>
-            <a:ext cx="489838" cy="365760"/>
-          </a:xfrm>
-          <a:prstGeom prst="rect">
-            <a:avLst/>
-          </a:prstGeom>
-          <a:noFill/>
-        </p:spPr>
-        <p:txBody>
-          <a:bodyPr wrap="square" anchor="ctr">
-            <a:spAutoFit/>
-          </a:bodyPr>
-          <a:lstStyle/>
-          <a:p>
-            <a:pPr algn="ctr">
-              <a:spcAft>
-                <a:spcPts val="0"/>
-              </a:spcAft>
-            </a:pPr>
-            <a:r>
-              <a:rPr sz="850" b="1" i="0">
-                <a:solidFill>
-                  <a:srgbClr val="9C5A0C"/>
-                </a:solidFill>
-                <a:latin typeface="Calibri"/>
-              </a:rPr>
-              <a:t>slack ~2 d</a:t>
-            </a:r>
-          </a:p>
-        </p:txBody>
-      </p:sp>
-      <p:sp>
-        <p:nvSpPr>
-          <p:cNvPr id="13" name="Rectangle 12"/>
+          <p:cNvPr id="10" name="Rectangle 9"/>
           <p:cNvSpPr/>
           <p:nvPr/>
         </p:nvSpPr>
         <p:spPr>
           <a:xfrm>
-            <a:off x="6972300" y="1417320"/>
-            <a:ext cx="4640580" cy="365760"/>
+            <a:off x="3217585" y="1490472"/>
+            <a:ext cx="18288" cy="566928"/>
           </a:xfrm>
           <a:prstGeom prst="rect">
             <a:avLst/>
           </a:prstGeom>
           <a:solidFill>
-            <a:srgbClr val="F6F8FB"/>
+            <a:srgbClr val="FFFFFF"/>
           </a:solidFill>
-          <a:ln w="9525">
-            <a:solidFill>
-              <a:srgbClr val="FFFFFF"/>
-            </a:solidFill>
+          <a:ln>
+            <a:noFill/>
           </a:ln>
           <a:effectLst/>
         </p:spPr>
@@ -9405,20 +9312,20 @@
       </p:sp>
       <p:sp>
         <p:nvSpPr>
-          <p:cNvPr id="14" name="Rectangle 13"/>
+          <p:cNvPr id="11" name="Rectangle 10"/>
           <p:cNvSpPr/>
           <p:nvPr/>
         </p:nvSpPr>
         <p:spPr>
           <a:xfrm>
-            <a:off x="6958584" y="1371600"/>
-            <a:ext cx="27432" cy="457200"/>
+            <a:off x="3618213" y="1490472"/>
+            <a:ext cx="200065" cy="566928"/>
           </a:xfrm>
           <a:prstGeom prst="rect">
             <a:avLst/>
           </a:prstGeom>
           <a:solidFill>
-            <a:srgbClr val="B23A2E"/>
+            <a:srgbClr val="C9741A"/>
           </a:solidFill>
           <a:ln>
             <a:noFill/>
@@ -9449,103 +9356,23 @@
       </p:sp>
       <p:sp>
         <p:nvSpPr>
-          <p:cNvPr id="15" name="TextBox 14"/>
-          <p:cNvSpPr txBox="1"/>
-          <p:nvPr/>
-        </p:nvSpPr>
-        <p:spPr>
-          <a:xfrm>
-            <a:off x="6149340" y="1810512"/>
-            <a:ext cx="1645920" cy="228600"/>
-          </a:xfrm>
-          <a:prstGeom prst="rect">
-            <a:avLst/>
-          </a:prstGeom>
-          <a:noFill/>
-        </p:spPr>
-        <p:txBody>
-          <a:bodyPr wrap="square">
-            <a:spAutoFit/>
-          </a:bodyPr>
-          <a:lstStyle/>
-          <a:p>
-            <a:pPr algn="ctr">
-              <a:spcAft>
-                <a:spcPts val="0"/>
-              </a:spcAft>
-            </a:pPr>
-            <a:r>
-              <a:rPr sz="850" b="1" i="0">
-                <a:solidFill>
-                  <a:srgbClr val="B23A2E"/>
-                </a:solidFill>
-                <a:latin typeface="Calibri"/>
-              </a:rPr>
-              <a:t>expiry — day 18</a:t>
-            </a:r>
-          </a:p>
-        </p:txBody>
-      </p:sp>
-      <p:sp>
-        <p:nvSpPr>
-          <p:cNvPr id="16" name="TextBox 15"/>
-          <p:cNvSpPr txBox="1"/>
-          <p:nvPr/>
-        </p:nvSpPr>
-        <p:spPr>
-          <a:xfrm>
-            <a:off x="548640" y="2075688"/>
-            <a:ext cx="1737360" cy="420624"/>
-          </a:xfrm>
-          <a:prstGeom prst="rect">
-            <a:avLst/>
-          </a:prstGeom>
-          <a:noFill/>
-        </p:spPr>
-        <p:txBody>
-          <a:bodyPr wrap="square" anchor="ctr">
-            <a:spAutoFit/>
-          </a:bodyPr>
-          <a:lstStyle/>
-          <a:p>
-            <a:pPr algn="l">
-              <a:spcAft>
-                <a:spcPts val="0"/>
-              </a:spcAft>
-            </a:pPr>
-            <a:r>
-              <a:rPr sz="950" b="1" i="0">
-                <a:solidFill>
-                  <a:srgbClr val="1F3864"/>
-                </a:solidFill>
-                <a:latin typeface="Calibri"/>
-              </a:rPr>
-              <a:t>What the line runs on</a:t>
-            </a:r>
-          </a:p>
-        </p:txBody>
-      </p:sp>
-      <p:sp>
-        <p:nvSpPr>
-          <p:cNvPr id="17" name="Rectangle 16"/>
+          <p:cNvPr id="12" name="Rectangle 11"/>
           <p:cNvSpPr/>
           <p:nvPr/>
         </p:nvSpPr>
         <p:spPr>
           <a:xfrm>
-            <a:off x="2331720" y="2103120"/>
-            <a:ext cx="1031240" cy="365760"/>
+            <a:off x="3599925" y="1490472"/>
+            <a:ext cx="18288" cy="566928"/>
           </a:xfrm>
           <a:prstGeom prst="rect">
             <a:avLst/>
           </a:prstGeom>
           <a:solidFill>
-            <a:srgbClr val="2E7D46"/>
+            <a:srgbClr val="FFFFFF"/>
           </a:solidFill>
-          <a:ln w="9525">
-            <a:solidFill>
-              <a:srgbClr val="FFFFFF"/>
-            </a:solidFill>
+          <a:ln>
+            <a:noFill/>
           </a:ln>
           <a:effectLst/>
         </p:spPr>
@@ -9573,64 +9400,23 @@
       </p:sp>
       <p:sp>
         <p:nvSpPr>
-          <p:cNvPr id="18" name="TextBox 17"/>
-          <p:cNvSpPr txBox="1"/>
-          <p:nvPr/>
-        </p:nvSpPr>
-        <p:spPr>
-          <a:xfrm>
-            <a:off x="2331720" y="2103120"/>
-            <a:ext cx="1031240" cy="365760"/>
-          </a:xfrm>
-          <a:prstGeom prst="rect">
-            <a:avLst/>
-          </a:prstGeom>
-          <a:noFill/>
-        </p:spPr>
-        <p:txBody>
-          <a:bodyPr wrap="square" anchor="ctr">
-            <a:spAutoFit/>
-          </a:bodyPr>
-          <a:lstStyle/>
-          <a:p>
-            <a:pPr algn="ctr">
-              <a:spcAft>
-                <a:spcPts val="0"/>
-              </a:spcAft>
-            </a:pPr>
-            <a:r>
-              <a:rPr sz="850" b="1" i="0">
-                <a:solidFill>
-                  <a:srgbClr val="FFFFFF"/>
-                </a:solidFill>
-                <a:latin typeface="Calibri"/>
-              </a:rPr>
-              <a:t>SNP Inc.</a:t>
-            </a:r>
-          </a:p>
-        </p:txBody>
-      </p:sp>
-      <p:sp>
-        <p:nvSpPr>
-          <p:cNvPr id="19" name="Rectangle 18"/>
+          <p:cNvPr id="13" name="Rectangle 12"/>
           <p:cNvSpPr/>
           <p:nvPr/>
         </p:nvSpPr>
         <p:spPr>
           <a:xfrm>
-            <a:off x="3362960" y="2103120"/>
-            <a:ext cx="3119501" cy="365760"/>
+            <a:off x="3818278" y="1490472"/>
+            <a:ext cx="18288" cy="566928"/>
           </a:xfrm>
           <a:prstGeom prst="rect">
             <a:avLst/>
           </a:prstGeom>
           <a:solidFill>
-            <a:srgbClr val="1F3864"/>
+            <a:srgbClr val="FFFFFF"/>
           </a:solidFill>
-          <a:ln w="9525">
-            <a:solidFill>
-              <a:srgbClr val="FFFFFF"/>
-            </a:solidFill>
+          <a:ln>
+            <a:noFill/>
           </a:ln>
           <a:effectLst/>
         </p:spPr>
@@ -9658,64 +9444,23 @@
       </p:sp>
       <p:sp>
         <p:nvSpPr>
-          <p:cNvPr id="20" name="TextBox 19"/>
-          <p:cNvSpPr txBox="1"/>
-          <p:nvPr/>
-        </p:nvSpPr>
-        <p:spPr>
-          <a:xfrm>
-            <a:off x="3362960" y="2103120"/>
-            <a:ext cx="3119501" cy="365760"/>
-          </a:xfrm>
-          <a:prstGeom prst="rect">
-            <a:avLst/>
-          </a:prstGeom>
-          <a:noFill/>
-        </p:spPr>
-        <p:txBody>
-          <a:bodyPr wrap="square" anchor="ctr">
-            <a:spAutoFit/>
-          </a:bodyPr>
-          <a:lstStyle/>
-          <a:p>
-            <a:pPr algn="ctr">
-              <a:spcAft>
-                <a:spcPts val="0"/>
-              </a:spcAft>
-            </a:pPr>
-            <a:r>
-              <a:rPr sz="850" b="1" i="0">
-                <a:solidFill>
-                  <a:srgbClr val="FFFFFF"/>
-                </a:solidFill>
-                <a:latin typeface="Calibri"/>
-              </a:rPr>
-              <a:t>PCI material — 5 drums</a:t>
-            </a:r>
-          </a:p>
-        </p:txBody>
-      </p:sp>
-      <p:sp>
-        <p:nvSpPr>
-          <p:cNvPr id="21" name="Rectangle 20"/>
+          <p:cNvPr id="14" name="Rectangle 13"/>
           <p:cNvSpPr/>
           <p:nvPr/>
         </p:nvSpPr>
         <p:spPr>
           <a:xfrm>
-            <a:off x="6482461" y="2103120"/>
-            <a:ext cx="5130419" cy="365760"/>
+            <a:off x="4218906" y="1490472"/>
+            <a:ext cx="200065" cy="566928"/>
           </a:xfrm>
           <a:prstGeom prst="rect">
             <a:avLst/>
           </a:prstGeom>
           <a:solidFill>
-            <a:srgbClr val="2E7D46"/>
+            <a:srgbClr val="C9741A"/>
           </a:solidFill>
-          <a:ln w="9525">
-            <a:solidFill>
-              <a:srgbClr val="FFFFFF"/>
-            </a:solidFill>
+          <a:ln>
+            <a:noFill/>
           </a:ln>
           <a:effectLst/>
         </p:spPr>
@@ -9743,254 +9488,20 @@
       </p:sp>
       <p:sp>
         <p:nvSpPr>
-          <p:cNvPr id="22" name="TextBox 21"/>
-          <p:cNvSpPr txBox="1"/>
-          <p:nvPr/>
-        </p:nvSpPr>
-        <p:spPr>
-          <a:xfrm>
-            <a:off x="6482461" y="2103120"/>
-            <a:ext cx="5130419" cy="365760"/>
-          </a:xfrm>
-          <a:prstGeom prst="rect">
-            <a:avLst/>
-          </a:prstGeom>
-          <a:noFill/>
-        </p:spPr>
-        <p:txBody>
-          <a:bodyPr wrap="square" anchor="ctr">
-            <a:spAutoFit/>
-          </a:bodyPr>
-          <a:lstStyle/>
-          <a:p>
-            <a:pPr algn="ctr">
-              <a:spcAft>
-                <a:spcPts val="0"/>
-              </a:spcAft>
-            </a:pPr>
-            <a:r>
-              <a:rPr sz="850" b="1" i="0">
-                <a:solidFill>
-                  <a:srgbClr val="FFFFFF"/>
-                </a:solidFill>
-                <a:latin typeface="Calibri"/>
-              </a:rPr>
-              <a:t>SNP Inc. material — ~10 drums  →  repeat every ~5 weeks</a:t>
-            </a:r>
-          </a:p>
-        </p:txBody>
-      </p:sp>
-      <p:sp>
-        <p:nvSpPr>
-          <p:cNvPr id="23" name="TextBox 22"/>
-          <p:cNvSpPr txBox="1"/>
-          <p:nvPr/>
-        </p:nvSpPr>
-        <p:spPr>
-          <a:xfrm>
-            <a:off x="1965960" y="2487168"/>
-            <a:ext cx="731520" cy="201168"/>
-          </a:xfrm>
-          <a:prstGeom prst="rect">
-            <a:avLst/>
-          </a:prstGeom>
-          <a:noFill/>
-        </p:spPr>
-        <p:txBody>
-          <a:bodyPr wrap="square">
-            <a:spAutoFit/>
-          </a:bodyPr>
-          <a:lstStyle/>
-          <a:p>
-            <a:pPr algn="ctr">
-              <a:spcAft>
-                <a:spcPts val="0"/>
-              </a:spcAft>
-            </a:pPr>
-            <a:r>
-              <a:rPr sz="800" b="0" i="0">
-                <a:solidFill>
-                  <a:srgbClr val="595959"/>
-                </a:solidFill>
-                <a:latin typeface="Calibri"/>
-              </a:rPr>
-              <a:t>day 0</a:t>
-            </a:r>
-          </a:p>
-        </p:txBody>
-      </p:sp>
-      <p:sp>
-        <p:nvSpPr>
-          <p:cNvPr id="24" name="TextBox 23"/>
-          <p:cNvSpPr txBox="1"/>
-          <p:nvPr/>
-        </p:nvSpPr>
-        <p:spPr>
-          <a:xfrm>
-            <a:off x="2997200" y="2487168"/>
-            <a:ext cx="731520" cy="201168"/>
-          </a:xfrm>
-          <a:prstGeom prst="rect">
-            <a:avLst/>
-          </a:prstGeom>
-          <a:noFill/>
-        </p:spPr>
-        <p:txBody>
-          <a:bodyPr wrap="square">
-            <a:spAutoFit/>
-          </a:bodyPr>
-          <a:lstStyle/>
-          <a:p>
-            <a:pPr algn="ctr">
-              <a:spcAft>
-                <a:spcPts val="0"/>
-              </a:spcAft>
-            </a:pPr>
-            <a:r>
-              <a:rPr sz="800" b="0" i="0">
-                <a:solidFill>
-                  <a:srgbClr val="595959"/>
-                </a:solidFill>
-                <a:latin typeface="Calibri"/>
-              </a:rPr>
-              <a:t>day 4</a:t>
-            </a:r>
-          </a:p>
-        </p:txBody>
-      </p:sp>
-      <p:sp>
-        <p:nvSpPr>
-          <p:cNvPr id="25" name="TextBox 24"/>
-          <p:cNvSpPr txBox="1"/>
-          <p:nvPr/>
-        </p:nvSpPr>
-        <p:spPr>
-          <a:xfrm>
-            <a:off x="6090919" y="2487168"/>
-            <a:ext cx="731520" cy="201168"/>
-          </a:xfrm>
-          <a:prstGeom prst="rect">
-            <a:avLst/>
-          </a:prstGeom>
-          <a:noFill/>
-        </p:spPr>
-        <p:txBody>
-          <a:bodyPr wrap="square">
-            <a:spAutoFit/>
-          </a:bodyPr>
-          <a:lstStyle/>
-          <a:p>
-            <a:pPr algn="ctr">
-              <a:spcAft>
-                <a:spcPts val="0"/>
-              </a:spcAft>
-            </a:pPr>
-            <a:r>
-              <a:rPr sz="800" b="0" i="0">
-                <a:solidFill>
-                  <a:srgbClr val="595959"/>
-                </a:solidFill>
-                <a:latin typeface="Calibri"/>
-              </a:rPr>
-              <a:t>day 16</a:t>
-            </a:r>
-          </a:p>
-        </p:txBody>
-      </p:sp>
-      <p:sp>
-        <p:nvSpPr>
-          <p:cNvPr id="26" name="TextBox 25"/>
-          <p:cNvSpPr txBox="1"/>
-          <p:nvPr/>
-        </p:nvSpPr>
-        <p:spPr>
-          <a:xfrm>
-            <a:off x="11247119" y="2487168"/>
-            <a:ext cx="731520" cy="201168"/>
-          </a:xfrm>
-          <a:prstGeom prst="rect">
-            <a:avLst/>
-          </a:prstGeom>
-          <a:noFill/>
-        </p:spPr>
-        <p:txBody>
-          <a:bodyPr wrap="square">
-            <a:spAutoFit/>
-          </a:bodyPr>
-          <a:lstStyle/>
-          <a:p>
-            <a:pPr algn="ctr">
-              <a:spcAft>
-                <a:spcPts val="0"/>
-              </a:spcAft>
-            </a:pPr>
-            <a:r>
-              <a:rPr sz="800" b="0" i="0">
-                <a:solidFill>
-                  <a:srgbClr val="595959"/>
-                </a:solidFill>
-                <a:latin typeface="Calibri"/>
-              </a:rPr>
-              <a:t>day 36</a:t>
-            </a:r>
-          </a:p>
-        </p:txBody>
-      </p:sp>
-      <p:sp>
-        <p:nvSpPr>
-          <p:cNvPr id="27" name="TextBox 26"/>
-          <p:cNvSpPr txBox="1"/>
-          <p:nvPr/>
-        </p:nvSpPr>
-        <p:spPr>
-          <a:xfrm>
-            <a:off x="548640" y="2743200"/>
-            <a:ext cx="11064240" cy="457200"/>
-          </a:xfrm>
-          <a:prstGeom prst="rect">
-            <a:avLst/>
-          </a:prstGeom>
-          <a:noFill/>
-        </p:spPr>
-        <p:txBody>
-          <a:bodyPr wrap="square">
-            <a:spAutoFit/>
-          </a:bodyPr>
-          <a:lstStyle/>
-          <a:p>
-            <a:pPr algn="l">
-              <a:spcAft>
-                <a:spcPts val="400"/>
-              </a:spcAft>
-            </a:pPr>
-            <a:r>
-              <a:rPr sz="1050" b="1" i="0">
-                <a:solidFill>
-                  <a:srgbClr val="1F3864"/>
-                </a:solidFill>
-                <a:latin typeface="Calibri"/>
-              </a:rPr>
-              <a:t>Why not blend PCI at one-third alongside SNP Inc.? A batch would last 36 days — twice the life. Even at two-thirds: 18.2 days. A validated 21-day life gives block rotation margin; a 30-day life still needs PCI at ~half of rate.</a:t>
-            </a:r>
-          </a:p>
-        </p:txBody>
-      </p:sp>
-      <p:sp>
-        <p:nvSpPr>
-          <p:cNvPr id="28" name="Rectangle 27"/>
+          <p:cNvPr id="15" name="Rectangle 14"/>
           <p:cNvSpPr/>
           <p:nvPr/>
         </p:nvSpPr>
         <p:spPr>
           <a:xfrm>
-            <a:off x="548640" y="3291840"/>
-            <a:ext cx="3611880" cy="2560320"/>
+            <a:off x="4200618" y="1490472"/>
+            <a:ext cx="18288" cy="566928"/>
           </a:xfrm>
           <a:prstGeom prst="rect">
             <a:avLst/>
           </a:prstGeom>
           <a:solidFill>
-            <a:srgbClr val="FCE4D6"/>
+            <a:srgbClr val="FFFFFF"/>
           </a:solidFill>
           <a:ln>
             <a:noFill/>
@@ -10021,107 +9532,20 @@
       </p:sp>
       <p:sp>
         <p:nvSpPr>
-          <p:cNvPr id="29" name="TextBox 28"/>
-          <p:cNvSpPr txBox="1"/>
-          <p:nvPr/>
-        </p:nvSpPr>
-        <p:spPr>
-          <a:xfrm>
-            <a:off x="731520" y="3410712"/>
-            <a:ext cx="3246120" cy="2322576"/>
-          </a:xfrm>
-          <a:prstGeom prst="rect">
-            <a:avLst/>
-          </a:prstGeom>
-          <a:noFill/>
-        </p:spPr>
-        <p:txBody>
-          <a:bodyPr wrap="square">
-            <a:spAutoFit/>
-          </a:bodyPr>
-          <a:lstStyle/>
-          <a:p>
-            <a:pPr algn="l">
-              <a:spcAft>
-                <a:spcPts val="600"/>
-              </a:spcAft>
-            </a:pPr>
-            <a:r>
-              <a:rPr sz="1350" b="1" i="0">
-                <a:solidFill>
-                  <a:srgbClr val="B23A2E"/>
-                </a:solidFill>
-                <a:latin typeface="Calibri"/>
-              </a:rPr>
-              <a:t>What SNP Inc. experiences</a:t>
-            </a:r>
-          </a:p>
-          <a:p>
-            <a:pPr algn="l">
-              <a:spcAft>
-                <a:spcPts val="500"/>
-              </a:spcAft>
-            </a:pPr>
-            <a:r>
-              <a:rPr sz="1000" b="0" i="0">
-                <a:solidFill>
-                  <a:srgbClr val="595959"/>
-                </a:solidFill>
-                <a:latin typeface="Calibri"/>
-              </a:rPr>
-              <a:t>•  A third less volume ($50.7k → $33.8k/yr)</a:t>
-            </a:r>
-          </a:p>
-          <a:p>
-            <a:pPr algn="l">
-              <a:spcAft>
-                <a:spcPts val="500"/>
-              </a:spcAft>
-            </a:pPr>
-            <a:r>
-              <a:rPr sz="1000" b="0" i="0">
-                <a:solidFill>
-                  <a:srgbClr val="595959"/>
-                </a:solidFill>
-                <a:latin typeface="Calibri"/>
-              </a:rPr>
-              <a:t>•  Cadence is a choice: a ~12-day pause every ~5 weeks — or a steady ~2 drums/week if we hold ~3 drums of rolling stock (strict first-in-first-out)</a:t>
-            </a:r>
-          </a:p>
-          <a:p>
-            <a:pPr algn="l">
-              <a:spcAft>
-                <a:spcPts val="500"/>
-              </a:spcAft>
-            </a:pPr>
-            <a:r>
-              <a:rPr sz="1000" b="0" i="0">
-                <a:solidFill>
-                  <a:srgbClr val="595959"/>
-                </a:solidFill>
-                <a:latin typeface="Calibri"/>
-              </a:rPr>
-              <a:t>•  They read the signal, not the dollars: a third of their core line moved right after we asked for partnership</a:t>
-            </a:r>
-          </a:p>
-        </p:txBody>
-      </p:sp>
-      <p:sp>
-        <p:nvSpPr>
-          <p:cNvPr id="30" name="Rectangle 29"/>
+          <p:cNvPr id="16" name="Rectangle 15"/>
           <p:cNvSpPr/>
           <p:nvPr/>
         </p:nvSpPr>
         <p:spPr>
           <a:xfrm>
-            <a:off x="4297680" y="3291840"/>
-            <a:ext cx="3611880" cy="2560320"/>
+            <a:off x="4418972" y="1490472"/>
+            <a:ext cx="18288" cy="566928"/>
           </a:xfrm>
           <a:prstGeom prst="rect">
             <a:avLst/>
           </a:prstGeom>
           <a:solidFill>
-            <a:srgbClr val="FFF2CC"/>
+            <a:srgbClr val="FFFFFF"/>
           </a:solidFill>
           <a:ln>
             <a:noFill/>
@@ -10152,123 +9576,20 @@
       </p:sp>
       <p:sp>
         <p:nvSpPr>
-          <p:cNvPr id="31" name="TextBox 30"/>
-          <p:cNvSpPr txBox="1"/>
-          <p:nvPr/>
-        </p:nvSpPr>
-        <p:spPr>
-          <a:xfrm>
-            <a:off x="4480560" y="3410712"/>
-            <a:ext cx="3246120" cy="2322576"/>
-          </a:xfrm>
-          <a:prstGeom prst="rect">
-            <a:avLst/>
-          </a:prstGeom>
-          <a:noFill/>
-        </p:spPr>
-        <p:txBody>
-          <a:bodyPr wrap="square">
-            <a:spAutoFit/>
-          </a:bodyPr>
-          <a:lstStyle/>
-          <a:p>
-            <a:pPr algn="l">
-              <a:spcAft>
-                <a:spcPts val="600"/>
-              </a:spcAft>
-            </a:pPr>
-            <a:r>
-              <a:rPr sz="1350" b="1" i="0">
-                <a:solidFill>
-                  <a:srgbClr val="9C5A0C"/>
-                </a:solidFill>
-                <a:latin typeface="Calibri"/>
-              </a:rPr>
-              <a:t>What we would run</a:t>
-            </a:r>
-          </a:p>
-          <a:p>
-            <a:pPr algn="l">
-              <a:spcAft>
-                <a:spcPts val="500"/>
-              </a:spcAft>
-            </a:pPr>
-            <a:r>
-              <a:rPr sz="1000" b="0" i="0">
-                <a:solidFill>
-                  <a:srgbClr val="595959"/>
-                </a:solidFill>
-                <a:latin typeface="Calibri"/>
-              </a:rPr>
-              <a:t>•  One spec, one viscometer method; incoming test on every lot; traceability by source</a:t>
-            </a:r>
-          </a:p>
-          <a:p>
-            <a:pPr algn="l">
-              <a:spcAft>
-                <a:spcPts val="500"/>
-              </a:spcAft>
-            </a:pPr>
-            <a:r>
-              <a:rPr sz="1000" b="0" i="0">
-                <a:solidFill>
-                  <a:srgbClr val="595959"/>
-                </a:solidFill>
-                <a:latin typeface="Calibri"/>
-              </a:rPr>
-              <a:t>•  Freeze-protected freight; five drums on site; strict first-in-first-out</a:t>
-            </a:r>
-          </a:p>
-          <a:p>
-            <a:pPr algn="l">
-              <a:spcAft>
-                <a:spcPts val="500"/>
-              </a:spcAft>
-            </a:pPr>
-            <a:r>
-              <a:rPr sz="1000" b="0" i="0">
-                <a:solidFill>
-                  <a:srgbClr val="595959"/>
-                </a:solidFill>
-                <a:latin typeface="Calibri"/>
-              </a:rPr>
-              <a:t>•  Failover in writing: SNP Inc. lead time + a standing cover order — a rejected PCI lot is line-down for that lead time</a:t>
-            </a:r>
-          </a:p>
-          <a:p>
-            <a:pPr algn="l">
-              <a:spcAft>
-                <a:spcPts val="500"/>
-              </a:spcAft>
-            </a:pPr>
-            <a:r>
-              <a:rPr sz="1000" b="0" i="0">
-                <a:solidFill>
-                  <a:srgbClr val="595959"/>
-                </a:solidFill>
-                <a:latin typeface="Calibri"/>
-              </a:rPr>
-              <a:t>•  PCI's residual-film issue closed before any production batch; two Supplier Quality Agreements (SQA)</a:t>
-            </a:r>
-          </a:p>
-        </p:txBody>
-      </p:sp>
-      <p:sp>
-        <p:nvSpPr>
-          <p:cNvPr id="32" name="Rectangle 31"/>
+          <p:cNvPr id="17" name="Rectangle 16"/>
           <p:cNvSpPr/>
           <p:nvPr/>
         </p:nvSpPr>
         <p:spPr>
           <a:xfrm>
-            <a:off x="8046720" y="3291840"/>
-            <a:ext cx="3566160" cy="2560320"/>
+            <a:off x="4819599" y="1490472"/>
+            <a:ext cx="200065" cy="566928"/>
           </a:xfrm>
           <a:prstGeom prst="rect">
             <a:avLst/>
           </a:prstGeom>
           <a:solidFill>
-            <a:srgbClr val="E2EFDA"/>
+            <a:srgbClr val="C9741A"/>
           </a:solidFill>
           <a:ln>
             <a:noFill/>
@@ -10299,107 +9620,20 @@
       </p:sp>
       <p:sp>
         <p:nvSpPr>
-          <p:cNvPr id="33" name="TextBox 32"/>
-          <p:cNvSpPr txBox="1"/>
-          <p:nvPr/>
-        </p:nvSpPr>
-        <p:spPr>
-          <a:xfrm>
-            <a:off x="8229600" y="3410712"/>
-            <a:ext cx="3200400" cy="2322576"/>
-          </a:xfrm>
-          <a:prstGeom prst="rect">
-            <a:avLst/>
-          </a:prstGeom>
-          <a:noFill/>
-        </p:spPr>
-        <p:txBody>
-          <a:bodyPr wrap="square">
-            <a:spAutoFit/>
-          </a:bodyPr>
-          <a:lstStyle/>
-          <a:p>
-            <a:pPr algn="l">
-              <a:spcAft>
-                <a:spcPts val="600"/>
-              </a:spcAft>
-            </a:pPr>
-            <a:r>
-              <a:rPr sz="1350" b="1" i="0">
-                <a:solidFill>
-                  <a:srgbClr val="2E7D46"/>
-                </a:solidFill>
-                <a:latin typeface="Calibri"/>
-              </a:rPr>
-              <a:t>What it buys</a:t>
-            </a:r>
-          </a:p>
-          <a:p>
-            <a:pPr algn="l">
-              <a:spcAft>
-                <a:spcPts val="500"/>
-              </a:spcAft>
-            </a:pPr>
-            <a:r>
-              <a:rPr sz="1000" b="0" i="0">
-                <a:solidFill>
-                  <a:srgbClr val="595959"/>
-                </a:solidFill>
-                <a:latin typeface="Calibri"/>
-              </a:rPr>
-              <a:t>•  Recovery in weeks — only if PCI confirms in writing a ramp to ~3 batches a month</a:t>
-            </a:r>
-          </a:p>
-          <a:p>
-            <a:pPr algn="l">
-              <a:spcAft>
-                <a:spcPts val="500"/>
-              </a:spcAft>
-            </a:pPr>
-            <a:r>
-              <a:rPr sz="1000" b="0" i="0">
-                <a:solidFill>
-                  <a:srgbClr val="595959"/>
-                </a:solidFill>
-                <a:latin typeface="Calibri"/>
-              </a:rPr>
-              <a:t>•  Until then, ~2/3 of volume still stops in an outage</a:t>
-            </a:r>
-          </a:p>
-          <a:p>
-            <a:pPr algn="l">
-              <a:spcAft>
-                <a:spcPts val="500"/>
-              </a:spcAft>
-            </a:pPr>
-            <a:r>
-              <a:rPr sz="1000" b="0" i="0">
-                <a:solidFill>
-                  <a:srgbClr val="595959"/>
-                </a:solidFill>
-                <a:latin typeface="Calibri"/>
-              </a:rPr>
-              <a:t>•  If PCI cooks the same producer's resin as SNP: it hedges the cook, not the resin — buffer dry resin either way</a:t>
-            </a:r>
-          </a:p>
-        </p:txBody>
-      </p:sp>
-      <p:sp>
-        <p:nvSpPr>
-          <p:cNvPr id="34" name="Rectangle 33"/>
+          <p:cNvPr id="18" name="Rectangle 17"/>
           <p:cNvSpPr/>
           <p:nvPr/>
         </p:nvSpPr>
         <p:spPr>
           <a:xfrm>
-            <a:off x="548640" y="5989320"/>
-            <a:ext cx="11064240" cy="566928"/>
+            <a:off x="4801311" y="1490472"/>
+            <a:ext cx="18288" cy="566928"/>
           </a:xfrm>
           <a:prstGeom prst="rect">
             <a:avLst/>
           </a:prstGeom>
           <a:solidFill>
-            <a:srgbClr val="1F3864"/>
+            <a:srgbClr val="FFFFFF"/>
           </a:solidFill>
           <a:ln>
             <a:noFill/>
@@ -10430,7 +9664,2059 @@
       </p:sp>
       <p:sp>
         <p:nvSpPr>
-          <p:cNvPr id="35" name="TextBox 34"/>
+          <p:cNvPr id="19" name="Rectangle 18"/>
+          <p:cNvSpPr/>
+          <p:nvPr/>
+        </p:nvSpPr>
+        <p:spPr>
+          <a:xfrm>
+            <a:off x="5019665" y="1490472"/>
+            <a:ext cx="18288" cy="566928"/>
+          </a:xfrm>
+          <a:prstGeom prst="rect">
+            <a:avLst/>
+          </a:prstGeom>
+          <a:solidFill>
+            <a:srgbClr val="FFFFFF"/>
+          </a:solidFill>
+          <a:ln>
+            <a:noFill/>
+          </a:ln>
+          <a:effectLst/>
+        </p:spPr>
+        <p:style>
+          <a:lnRef idx="1">
+            <a:schemeClr val="accent1"/>
+          </a:lnRef>
+          <a:fillRef idx="3">
+            <a:schemeClr val="accent1"/>
+          </a:fillRef>
+          <a:effectRef idx="2">
+            <a:schemeClr val="accent1"/>
+          </a:effectRef>
+          <a:fontRef idx="minor">
+            <a:schemeClr val="lt1"/>
+          </a:fontRef>
+        </p:style>
+        <p:txBody>
+          <a:bodyPr rtlCol="0" anchor="ctr"/>
+          <a:lstStyle/>
+          <a:p>
+            <a:pPr algn="ctr"/>
+          </a:p>
+        </p:txBody>
+      </p:sp>
+      <p:sp>
+        <p:nvSpPr>
+          <p:cNvPr id="20" name="Rectangle 19"/>
+          <p:cNvSpPr/>
+          <p:nvPr/>
+        </p:nvSpPr>
+        <p:spPr>
+          <a:xfrm>
+            <a:off x="5420292" y="1490472"/>
+            <a:ext cx="200065" cy="566928"/>
+          </a:xfrm>
+          <a:prstGeom prst="rect">
+            <a:avLst/>
+          </a:prstGeom>
+          <a:solidFill>
+            <a:srgbClr val="C9741A"/>
+          </a:solidFill>
+          <a:ln>
+            <a:noFill/>
+          </a:ln>
+          <a:effectLst/>
+        </p:spPr>
+        <p:style>
+          <a:lnRef idx="1">
+            <a:schemeClr val="accent1"/>
+          </a:lnRef>
+          <a:fillRef idx="3">
+            <a:schemeClr val="accent1"/>
+          </a:fillRef>
+          <a:effectRef idx="2">
+            <a:schemeClr val="accent1"/>
+          </a:effectRef>
+          <a:fontRef idx="minor">
+            <a:schemeClr val="lt1"/>
+          </a:fontRef>
+        </p:style>
+        <p:txBody>
+          <a:bodyPr rtlCol="0" anchor="ctr"/>
+          <a:lstStyle/>
+          <a:p>
+            <a:pPr algn="ctr"/>
+          </a:p>
+        </p:txBody>
+      </p:sp>
+      <p:sp>
+        <p:nvSpPr>
+          <p:cNvPr id="21" name="Rectangle 20"/>
+          <p:cNvSpPr/>
+          <p:nvPr/>
+        </p:nvSpPr>
+        <p:spPr>
+          <a:xfrm>
+            <a:off x="5402004" y="1490472"/>
+            <a:ext cx="18288" cy="566928"/>
+          </a:xfrm>
+          <a:prstGeom prst="rect">
+            <a:avLst/>
+          </a:prstGeom>
+          <a:solidFill>
+            <a:srgbClr val="FFFFFF"/>
+          </a:solidFill>
+          <a:ln>
+            <a:noFill/>
+          </a:ln>
+          <a:effectLst/>
+        </p:spPr>
+        <p:style>
+          <a:lnRef idx="1">
+            <a:schemeClr val="accent1"/>
+          </a:lnRef>
+          <a:fillRef idx="3">
+            <a:schemeClr val="accent1"/>
+          </a:fillRef>
+          <a:effectRef idx="2">
+            <a:schemeClr val="accent1"/>
+          </a:effectRef>
+          <a:fontRef idx="minor">
+            <a:schemeClr val="lt1"/>
+          </a:fontRef>
+        </p:style>
+        <p:txBody>
+          <a:bodyPr rtlCol="0" anchor="ctr"/>
+          <a:lstStyle/>
+          <a:p>
+            <a:pPr algn="ctr"/>
+          </a:p>
+        </p:txBody>
+      </p:sp>
+      <p:sp>
+        <p:nvSpPr>
+          <p:cNvPr id="22" name="Rectangle 21"/>
+          <p:cNvSpPr/>
+          <p:nvPr/>
+        </p:nvSpPr>
+        <p:spPr>
+          <a:xfrm>
+            <a:off x="5620358" y="1490472"/>
+            <a:ext cx="18288" cy="566928"/>
+          </a:xfrm>
+          <a:prstGeom prst="rect">
+            <a:avLst/>
+          </a:prstGeom>
+          <a:solidFill>
+            <a:srgbClr val="FFFFFF"/>
+          </a:solidFill>
+          <a:ln>
+            <a:noFill/>
+          </a:ln>
+          <a:effectLst/>
+        </p:spPr>
+        <p:style>
+          <a:lnRef idx="1">
+            <a:schemeClr val="accent1"/>
+          </a:lnRef>
+          <a:fillRef idx="3">
+            <a:schemeClr val="accent1"/>
+          </a:fillRef>
+          <a:effectRef idx="2">
+            <a:schemeClr val="accent1"/>
+          </a:effectRef>
+          <a:fontRef idx="minor">
+            <a:schemeClr val="lt1"/>
+          </a:fontRef>
+        </p:style>
+        <p:txBody>
+          <a:bodyPr rtlCol="0" anchor="ctr"/>
+          <a:lstStyle/>
+          <a:p>
+            <a:pPr algn="ctr"/>
+          </a:p>
+        </p:txBody>
+      </p:sp>
+      <p:sp>
+        <p:nvSpPr>
+          <p:cNvPr id="23" name="Rectangle 22"/>
+          <p:cNvSpPr/>
+          <p:nvPr/>
+        </p:nvSpPr>
+        <p:spPr>
+          <a:xfrm>
+            <a:off x="6020985" y="1490472"/>
+            <a:ext cx="200065" cy="566928"/>
+          </a:xfrm>
+          <a:prstGeom prst="rect">
+            <a:avLst/>
+          </a:prstGeom>
+          <a:solidFill>
+            <a:srgbClr val="C9741A"/>
+          </a:solidFill>
+          <a:ln>
+            <a:noFill/>
+          </a:ln>
+          <a:effectLst/>
+        </p:spPr>
+        <p:style>
+          <a:lnRef idx="1">
+            <a:schemeClr val="accent1"/>
+          </a:lnRef>
+          <a:fillRef idx="3">
+            <a:schemeClr val="accent1"/>
+          </a:fillRef>
+          <a:effectRef idx="2">
+            <a:schemeClr val="accent1"/>
+          </a:effectRef>
+          <a:fontRef idx="minor">
+            <a:schemeClr val="lt1"/>
+          </a:fontRef>
+        </p:style>
+        <p:txBody>
+          <a:bodyPr rtlCol="0" anchor="ctr"/>
+          <a:lstStyle/>
+          <a:p>
+            <a:pPr algn="ctr"/>
+          </a:p>
+        </p:txBody>
+      </p:sp>
+      <p:sp>
+        <p:nvSpPr>
+          <p:cNvPr id="24" name="Rectangle 23"/>
+          <p:cNvSpPr/>
+          <p:nvPr/>
+        </p:nvSpPr>
+        <p:spPr>
+          <a:xfrm>
+            <a:off x="6002697" y="1490472"/>
+            <a:ext cx="18288" cy="566928"/>
+          </a:xfrm>
+          <a:prstGeom prst="rect">
+            <a:avLst/>
+          </a:prstGeom>
+          <a:solidFill>
+            <a:srgbClr val="FFFFFF"/>
+          </a:solidFill>
+          <a:ln>
+            <a:noFill/>
+          </a:ln>
+          <a:effectLst/>
+        </p:spPr>
+        <p:style>
+          <a:lnRef idx="1">
+            <a:schemeClr val="accent1"/>
+          </a:lnRef>
+          <a:fillRef idx="3">
+            <a:schemeClr val="accent1"/>
+          </a:fillRef>
+          <a:effectRef idx="2">
+            <a:schemeClr val="accent1"/>
+          </a:effectRef>
+          <a:fontRef idx="minor">
+            <a:schemeClr val="lt1"/>
+          </a:fontRef>
+        </p:style>
+        <p:txBody>
+          <a:bodyPr rtlCol="0" anchor="ctr"/>
+          <a:lstStyle/>
+          <a:p>
+            <a:pPr algn="ctr"/>
+          </a:p>
+        </p:txBody>
+      </p:sp>
+      <p:sp>
+        <p:nvSpPr>
+          <p:cNvPr id="25" name="Rectangle 24"/>
+          <p:cNvSpPr/>
+          <p:nvPr/>
+        </p:nvSpPr>
+        <p:spPr>
+          <a:xfrm>
+            <a:off x="6221051" y="1490472"/>
+            <a:ext cx="18288" cy="566928"/>
+          </a:xfrm>
+          <a:prstGeom prst="rect">
+            <a:avLst/>
+          </a:prstGeom>
+          <a:solidFill>
+            <a:srgbClr val="FFFFFF"/>
+          </a:solidFill>
+          <a:ln>
+            <a:noFill/>
+          </a:ln>
+          <a:effectLst/>
+        </p:spPr>
+        <p:style>
+          <a:lnRef idx="1">
+            <a:schemeClr val="accent1"/>
+          </a:lnRef>
+          <a:fillRef idx="3">
+            <a:schemeClr val="accent1"/>
+          </a:fillRef>
+          <a:effectRef idx="2">
+            <a:schemeClr val="accent1"/>
+          </a:effectRef>
+          <a:fontRef idx="minor">
+            <a:schemeClr val="lt1"/>
+          </a:fontRef>
+        </p:style>
+        <p:txBody>
+          <a:bodyPr rtlCol="0" anchor="ctr"/>
+          <a:lstStyle/>
+          <a:p>
+            <a:pPr algn="ctr"/>
+          </a:p>
+        </p:txBody>
+      </p:sp>
+      <p:sp>
+        <p:nvSpPr>
+          <p:cNvPr id="26" name="Rectangle 25"/>
+          <p:cNvSpPr/>
+          <p:nvPr/>
+        </p:nvSpPr>
+        <p:spPr>
+          <a:xfrm>
+            <a:off x="6621678" y="1490472"/>
+            <a:ext cx="200065" cy="566928"/>
+          </a:xfrm>
+          <a:prstGeom prst="rect">
+            <a:avLst/>
+          </a:prstGeom>
+          <a:solidFill>
+            <a:srgbClr val="C9741A"/>
+          </a:solidFill>
+          <a:ln>
+            <a:noFill/>
+          </a:ln>
+          <a:effectLst/>
+        </p:spPr>
+        <p:style>
+          <a:lnRef idx="1">
+            <a:schemeClr val="accent1"/>
+          </a:lnRef>
+          <a:fillRef idx="3">
+            <a:schemeClr val="accent1"/>
+          </a:fillRef>
+          <a:effectRef idx="2">
+            <a:schemeClr val="accent1"/>
+          </a:effectRef>
+          <a:fontRef idx="minor">
+            <a:schemeClr val="lt1"/>
+          </a:fontRef>
+        </p:style>
+        <p:txBody>
+          <a:bodyPr rtlCol="0" anchor="ctr"/>
+          <a:lstStyle/>
+          <a:p>
+            <a:pPr algn="ctr"/>
+          </a:p>
+        </p:txBody>
+      </p:sp>
+      <p:sp>
+        <p:nvSpPr>
+          <p:cNvPr id="27" name="Rectangle 26"/>
+          <p:cNvSpPr/>
+          <p:nvPr/>
+        </p:nvSpPr>
+        <p:spPr>
+          <a:xfrm>
+            <a:off x="6603390" y="1490472"/>
+            <a:ext cx="18288" cy="566928"/>
+          </a:xfrm>
+          <a:prstGeom prst="rect">
+            <a:avLst/>
+          </a:prstGeom>
+          <a:solidFill>
+            <a:srgbClr val="FFFFFF"/>
+          </a:solidFill>
+          <a:ln>
+            <a:noFill/>
+          </a:ln>
+          <a:effectLst/>
+        </p:spPr>
+        <p:style>
+          <a:lnRef idx="1">
+            <a:schemeClr val="accent1"/>
+          </a:lnRef>
+          <a:fillRef idx="3">
+            <a:schemeClr val="accent1"/>
+          </a:fillRef>
+          <a:effectRef idx="2">
+            <a:schemeClr val="accent1"/>
+          </a:effectRef>
+          <a:fontRef idx="minor">
+            <a:schemeClr val="lt1"/>
+          </a:fontRef>
+        </p:style>
+        <p:txBody>
+          <a:bodyPr rtlCol="0" anchor="ctr"/>
+          <a:lstStyle/>
+          <a:p>
+            <a:pPr algn="ctr"/>
+          </a:p>
+        </p:txBody>
+      </p:sp>
+      <p:sp>
+        <p:nvSpPr>
+          <p:cNvPr id="28" name="Rectangle 27"/>
+          <p:cNvSpPr/>
+          <p:nvPr/>
+        </p:nvSpPr>
+        <p:spPr>
+          <a:xfrm>
+            <a:off x="6821744" y="1490472"/>
+            <a:ext cx="18288" cy="566928"/>
+          </a:xfrm>
+          <a:prstGeom prst="rect">
+            <a:avLst/>
+          </a:prstGeom>
+          <a:solidFill>
+            <a:srgbClr val="FFFFFF"/>
+          </a:solidFill>
+          <a:ln>
+            <a:noFill/>
+          </a:ln>
+          <a:effectLst/>
+        </p:spPr>
+        <p:style>
+          <a:lnRef idx="1">
+            <a:schemeClr val="accent1"/>
+          </a:lnRef>
+          <a:fillRef idx="3">
+            <a:schemeClr val="accent1"/>
+          </a:fillRef>
+          <a:effectRef idx="2">
+            <a:schemeClr val="accent1"/>
+          </a:effectRef>
+          <a:fontRef idx="minor">
+            <a:schemeClr val="lt1"/>
+          </a:fontRef>
+        </p:style>
+        <p:txBody>
+          <a:bodyPr rtlCol="0" anchor="ctr"/>
+          <a:lstStyle/>
+          <a:p>
+            <a:pPr algn="ctr"/>
+          </a:p>
+        </p:txBody>
+      </p:sp>
+      <p:sp>
+        <p:nvSpPr>
+          <p:cNvPr id="29" name="Rectangle 28"/>
+          <p:cNvSpPr/>
+          <p:nvPr/>
+        </p:nvSpPr>
+        <p:spPr>
+          <a:xfrm>
+            <a:off x="7222372" y="1490472"/>
+            <a:ext cx="200065" cy="566928"/>
+          </a:xfrm>
+          <a:prstGeom prst="rect">
+            <a:avLst/>
+          </a:prstGeom>
+          <a:solidFill>
+            <a:srgbClr val="C9741A"/>
+          </a:solidFill>
+          <a:ln>
+            <a:noFill/>
+          </a:ln>
+          <a:effectLst/>
+        </p:spPr>
+        <p:style>
+          <a:lnRef idx="1">
+            <a:schemeClr val="accent1"/>
+          </a:lnRef>
+          <a:fillRef idx="3">
+            <a:schemeClr val="accent1"/>
+          </a:fillRef>
+          <a:effectRef idx="2">
+            <a:schemeClr val="accent1"/>
+          </a:effectRef>
+          <a:fontRef idx="minor">
+            <a:schemeClr val="lt1"/>
+          </a:fontRef>
+        </p:style>
+        <p:txBody>
+          <a:bodyPr rtlCol="0" anchor="ctr"/>
+          <a:lstStyle/>
+          <a:p>
+            <a:pPr algn="ctr"/>
+          </a:p>
+        </p:txBody>
+      </p:sp>
+      <p:sp>
+        <p:nvSpPr>
+          <p:cNvPr id="30" name="Rectangle 29"/>
+          <p:cNvSpPr/>
+          <p:nvPr/>
+        </p:nvSpPr>
+        <p:spPr>
+          <a:xfrm>
+            <a:off x="7204084" y="1490472"/>
+            <a:ext cx="18288" cy="566928"/>
+          </a:xfrm>
+          <a:prstGeom prst="rect">
+            <a:avLst/>
+          </a:prstGeom>
+          <a:solidFill>
+            <a:srgbClr val="FFFFFF"/>
+          </a:solidFill>
+          <a:ln>
+            <a:noFill/>
+          </a:ln>
+          <a:effectLst/>
+        </p:spPr>
+        <p:style>
+          <a:lnRef idx="1">
+            <a:schemeClr val="accent1"/>
+          </a:lnRef>
+          <a:fillRef idx="3">
+            <a:schemeClr val="accent1"/>
+          </a:fillRef>
+          <a:effectRef idx="2">
+            <a:schemeClr val="accent1"/>
+          </a:effectRef>
+          <a:fontRef idx="minor">
+            <a:schemeClr val="lt1"/>
+          </a:fontRef>
+        </p:style>
+        <p:txBody>
+          <a:bodyPr rtlCol="0" anchor="ctr"/>
+          <a:lstStyle/>
+          <a:p>
+            <a:pPr algn="ctr"/>
+          </a:p>
+        </p:txBody>
+      </p:sp>
+      <p:sp>
+        <p:nvSpPr>
+          <p:cNvPr id="31" name="Rectangle 30"/>
+          <p:cNvSpPr/>
+          <p:nvPr/>
+        </p:nvSpPr>
+        <p:spPr>
+          <a:xfrm>
+            <a:off x="7422437" y="1490472"/>
+            <a:ext cx="18288" cy="566928"/>
+          </a:xfrm>
+          <a:prstGeom prst="rect">
+            <a:avLst/>
+          </a:prstGeom>
+          <a:solidFill>
+            <a:srgbClr val="FFFFFF"/>
+          </a:solidFill>
+          <a:ln>
+            <a:noFill/>
+          </a:ln>
+          <a:effectLst/>
+        </p:spPr>
+        <p:style>
+          <a:lnRef idx="1">
+            <a:schemeClr val="accent1"/>
+          </a:lnRef>
+          <a:fillRef idx="3">
+            <a:schemeClr val="accent1"/>
+          </a:fillRef>
+          <a:effectRef idx="2">
+            <a:schemeClr val="accent1"/>
+          </a:effectRef>
+          <a:fontRef idx="minor">
+            <a:schemeClr val="lt1"/>
+          </a:fontRef>
+        </p:style>
+        <p:txBody>
+          <a:bodyPr rtlCol="0" anchor="ctr"/>
+          <a:lstStyle/>
+          <a:p>
+            <a:pPr algn="ctr"/>
+          </a:p>
+        </p:txBody>
+      </p:sp>
+      <p:sp>
+        <p:nvSpPr>
+          <p:cNvPr id="32" name="Rectangle 31"/>
+          <p:cNvSpPr/>
+          <p:nvPr/>
+        </p:nvSpPr>
+        <p:spPr>
+          <a:xfrm>
+            <a:off x="7823065" y="1490472"/>
+            <a:ext cx="200065" cy="566928"/>
+          </a:xfrm>
+          <a:prstGeom prst="rect">
+            <a:avLst/>
+          </a:prstGeom>
+          <a:solidFill>
+            <a:srgbClr val="C9741A"/>
+          </a:solidFill>
+          <a:ln>
+            <a:noFill/>
+          </a:ln>
+          <a:effectLst/>
+        </p:spPr>
+        <p:style>
+          <a:lnRef idx="1">
+            <a:schemeClr val="accent1"/>
+          </a:lnRef>
+          <a:fillRef idx="3">
+            <a:schemeClr val="accent1"/>
+          </a:fillRef>
+          <a:effectRef idx="2">
+            <a:schemeClr val="accent1"/>
+          </a:effectRef>
+          <a:fontRef idx="minor">
+            <a:schemeClr val="lt1"/>
+          </a:fontRef>
+        </p:style>
+        <p:txBody>
+          <a:bodyPr rtlCol="0" anchor="ctr"/>
+          <a:lstStyle/>
+          <a:p>
+            <a:pPr algn="ctr"/>
+          </a:p>
+        </p:txBody>
+      </p:sp>
+      <p:sp>
+        <p:nvSpPr>
+          <p:cNvPr id="33" name="Rectangle 32"/>
+          <p:cNvSpPr/>
+          <p:nvPr/>
+        </p:nvSpPr>
+        <p:spPr>
+          <a:xfrm>
+            <a:off x="7804777" y="1490472"/>
+            <a:ext cx="18288" cy="566928"/>
+          </a:xfrm>
+          <a:prstGeom prst="rect">
+            <a:avLst/>
+          </a:prstGeom>
+          <a:solidFill>
+            <a:srgbClr val="FFFFFF"/>
+          </a:solidFill>
+          <a:ln>
+            <a:noFill/>
+          </a:ln>
+          <a:effectLst/>
+        </p:spPr>
+        <p:style>
+          <a:lnRef idx="1">
+            <a:schemeClr val="accent1"/>
+          </a:lnRef>
+          <a:fillRef idx="3">
+            <a:schemeClr val="accent1"/>
+          </a:fillRef>
+          <a:effectRef idx="2">
+            <a:schemeClr val="accent1"/>
+          </a:effectRef>
+          <a:fontRef idx="minor">
+            <a:schemeClr val="lt1"/>
+          </a:fontRef>
+        </p:style>
+        <p:txBody>
+          <a:bodyPr rtlCol="0" anchor="ctr"/>
+          <a:lstStyle/>
+          <a:p>
+            <a:pPr algn="ctr"/>
+          </a:p>
+        </p:txBody>
+      </p:sp>
+      <p:sp>
+        <p:nvSpPr>
+          <p:cNvPr id="34" name="Rectangle 33"/>
+          <p:cNvSpPr/>
+          <p:nvPr/>
+        </p:nvSpPr>
+        <p:spPr>
+          <a:xfrm>
+            <a:off x="8023130" y="1490472"/>
+            <a:ext cx="18288" cy="566928"/>
+          </a:xfrm>
+          <a:prstGeom prst="rect">
+            <a:avLst/>
+          </a:prstGeom>
+          <a:solidFill>
+            <a:srgbClr val="FFFFFF"/>
+          </a:solidFill>
+          <a:ln>
+            <a:noFill/>
+          </a:ln>
+          <a:effectLst/>
+        </p:spPr>
+        <p:style>
+          <a:lnRef idx="1">
+            <a:schemeClr val="accent1"/>
+          </a:lnRef>
+          <a:fillRef idx="3">
+            <a:schemeClr val="accent1"/>
+          </a:fillRef>
+          <a:effectRef idx="2">
+            <a:schemeClr val="accent1"/>
+          </a:effectRef>
+          <a:fontRef idx="minor">
+            <a:schemeClr val="lt1"/>
+          </a:fontRef>
+        </p:style>
+        <p:txBody>
+          <a:bodyPr rtlCol="0" anchor="ctr"/>
+          <a:lstStyle/>
+          <a:p>
+            <a:pPr algn="ctr"/>
+          </a:p>
+        </p:txBody>
+      </p:sp>
+      <p:sp>
+        <p:nvSpPr>
+          <p:cNvPr id="35" name="Rectangle 34"/>
+          <p:cNvSpPr/>
+          <p:nvPr/>
+        </p:nvSpPr>
+        <p:spPr>
+          <a:xfrm>
+            <a:off x="8423758" y="1490472"/>
+            <a:ext cx="200065" cy="566928"/>
+          </a:xfrm>
+          <a:prstGeom prst="rect">
+            <a:avLst/>
+          </a:prstGeom>
+          <a:solidFill>
+            <a:srgbClr val="C9741A"/>
+          </a:solidFill>
+          <a:ln>
+            <a:noFill/>
+          </a:ln>
+          <a:effectLst/>
+        </p:spPr>
+        <p:style>
+          <a:lnRef idx="1">
+            <a:schemeClr val="accent1"/>
+          </a:lnRef>
+          <a:fillRef idx="3">
+            <a:schemeClr val="accent1"/>
+          </a:fillRef>
+          <a:effectRef idx="2">
+            <a:schemeClr val="accent1"/>
+          </a:effectRef>
+          <a:fontRef idx="minor">
+            <a:schemeClr val="lt1"/>
+          </a:fontRef>
+        </p:style>
+        <p:txBody>
+          <a:bodyPr rtlCol="0" anchor="ctr"/>
+          <a:lstStyle/>
+          <a:p>
+            <a:pPr algn="ctr"/>
+          </a:p>
+        </p:txBody>
+      </p:sp>
+      <p:sp>
+        <p:nvSpPr>
+          <p:cNvPr id="36" name="Rectangle 35"/>
+          <p:cNvSpPr/>
+          <p:nvPr/>
+        </p:nvSpPr>
+        <p:spPr>
+          <a:xfrm>
+            <a:off x="8405470" y="1490472"/>
+            <a:ext cx="18288" cy="566928"/>
+          </a:xfrm>
+          <a:prstGeom prst="rect">
+            <a:avLst/>
+          </a:prstGeom>
+          <a:solidFill>
+            <a:srgbClr val="FFFFFF"/>
+          </a:solidFill>
+          <a:ln>
+            <a:noFill/>
+          </a:ln>
+          <a:effectLst/>
+        </p:spPr>
+        <p:style>
+          <a:lnRef idx="1">
+            <a:schemeClr val="accent1"/>
+          </a:lnRef>
+          <a:fillRef idx="3">
+            <a:schemeClr val="accent1"/>
+          </a:fillRef>
+          <a:effectRef idx="2">
+            <a:schemeClr val="accent1"/>
+          </a:effectRef>
+          <a:fontRef idx="minor">
+            <a:schemeClr val="lt1"/>
+          </a:fontRef>
+        </p:style>
+        <p:txBody>
+          <a:bodyPr rtlCol="0" anchor="ctr"/>
+          <a:lstStyle/>
+          <a:p>
+            <a:pPr algn="ctr"/>
+          </a:p>
+        </p:txBody>
+      </p:sp>
+      <p:sp>
+        <p:nvSpPr>
+          <p:cNvPr id="37" name="Rectangle 36"/>
+          <p:cNvSpPr/>
+          <p:nvPr/>
+        </p:nvSpPr>
+        <p:spPr>
+          <a:xfrm>
+            <a:off x="8623824" y="1490472"/>
+            <a:ext cx="18288" cy="566928"/>
+          </a:xfrm>
+          <a:prstGeom prst="rect">
+            <a:avLst/>
+          </a:prstGeom>
+          <a:solidFill>
+            <a:srgbClr val="FFFFFF"/>
+          </a:solidFill>
+          <a:ln>
+            <a:noFill/>
+          </a:ln>
+          <a:effectLst/>
+        </p:spPr>
+        <p:style>
+          <a:lnRef idx="1">
+            <a:schemeClr val="accent1"/>
+          </a:lnRef>
+          <a:fillRef idx="3">
+            <a:schemeClr val="accent1"/>
+          </a:fillRef>
+          <a:effectRef idx="2">
+            <a:schemeClr val="accent1"/>
+          </a:effectRef>
+          <a:fontRef idx="minor">
+            <a:schemeClr val="lt1"/>
+          </a:fontRef>
+        </p:style>
+        <p:txBody>
+          <a:bodyPr rtlCol="0" anchor="ctr"/>
+          <a:lstStyle/>
+          <a:p>
+            <a:pPr algn="ctr"/>
+          </a:p>
+        </p:txBody>
+      </p:sp>
+      <p:sp>
+        <p:nvSpPr>
+          <p:cNvPr id="38" name="TextBox 37"/>
+          <p:cNvSpPr txBox="1"/>
+          <p:nvPr/>
+        </p:nvSpPr>
+        <p:spPr>
+          <a:xfrm>
+            <a:off x="9189720" y="1307592"/>
+            <a:ext cx="2468880" cy="1371600"/>
+          </a:xfrm>
+          <a:prstGeom prst="rect">
+            <a:avLst/>
+          </a:prstGeom>
+          <a:noFill/>
+        </p:spPr>
+        <p:txBody>
+          <a:bodyPr wrap="square">
+            <a:spAutoFit/>
+          </a:bodyPr>
+          <a:lstStyle/>
+          <a:p>
+            <a:pPr>
+              <a:spcAft>
+                <a:spcPts val="200"/>
+              </a:spcAft>
+            </a:pPr>
+            <a:r>
+              <a:rPr sz="850">
+                <a:solidFill>
+                  <a:srgbClr val="595959"/>
+                </a:solidFill>
+                <a:latin typeface="Calibri"/>
+              </a:rPr>
+              <a:t>First 12 months, all-in  </a:t>
+            </a:r>
+            <a:r>
+              <a:rPr sz="900" b="1">
+                <a:solidFill>
+                  <a:srgbClr val="1F3864"/>
+                </a:solidFill>
+                <a:latin typeface="Calibri"/>
+              </a:rPr>
+              <a:t>$80–110k</a:t>
+            </a:r>
+          </a:p>
+          <a:p>
+            <a:pPr>
+              <a:spcAft>
+                <a:spcPts val="200"/>
+              </a:spcAft>
+            </a:pPr>
+            <a:r>
+              <a:rPr sz="850">
+                <a:solidFill>
+                  <a:srgbClr val="595959"/>
+                </a:solidFill>
+                <a:latin typeface="Calibri"/>
+              </a:rPr>
+              <a:t>Each year after  </a:t>
+            </a:r>
+            <a:r>
+              <a:rPr sz="900" b="0">
+                <a:solidFill>
+                  <a:srgbClr val="1F3864"/>
+                </a:solidFill>
+                <a:latin typeface="Calibri"/>
+              </a:rPr>
+              <a:t>$65–70k</a:t>
+            </a:r>
+          </a:p>
+          <a:p>
+            <a:pPr>
+              <a:spcAft>
+                <a:spcPts val="200"/>
+              </a:spcAft>
+            </a:pPr>
+            <a:r>
+              <a:rPr sz="850">
+                <a:solidFill>
+                  <a:srgbClr val="595959"/>
+                </a:solidFill>
+                <a:latin typeface="Calibri"/>
+              </a:rPr>
+              <a:t>Volume to PCI a year  </a:t>
+            </a:r>
+            <a:r>
+              <a:rPr sz="900" b="0">
+                <a:solidFill>
+                  <a:srgbClr val="1F3864"/>
+                </a:solidFill>
+                <a:latin typeface="Calibri"/>
+              </a:rPr>
+              <a:t>22,500 lb · 50 drums (33%)</a:t>
+            </a:r>
+          </a:p>
+          <a:p>
+            <a:pPr>
+              <a:spcAft>
+                <a:spcPts val="200"/>
+              </a:spcAft>
+            </a:pPr>
+            <a:r>
+              <a:rPr sz="850">
+                <a:solidFill>
+                  <a:srgbClr val="595959"/>
+                </a:solidFill>
+                <a:latin typeface="Calibri"/>
+              </a:rPr>
+              <a:t>SNP Inc. sees  </a:t>
+            </a:r>
+            <a:r>
+              <a:rPr sz="900" b="0">
+                <a:solidFill>
+                  <a:srgbClr val="1F3864"/>
+                </a:solidFill>
+                <a:latin typeface="Calibri"/>
+              </a:rPr>
+              <a:t>10 pauses of ~12 days, or a level cadence with a rolling stock</a:t>
+            </a:r>
+          </a:p>
+          <a:p>
+            <a:pPr>
+              <a:spcAft>
+                <a:spcPts val="200"/>
+              </a:spcAft>
+            </a:pPr>
+            <a:r>
+              <a:rPr sz="850">
+                <a:solidFill>
+                  <a:srgbClr val="595959"/>
+                </a:solidFill>
+                <a:latin typeface="Calibri"/>
+              </a:rPr>
+              <a:t>If SNP fails, restart in  </a:t>
+            </a:r>
+            <a:r>
+              <a:rPr sz="900" b="0">
+                <a:solidFill>
+                  <a:srgbClr val="1F3864"/>
+                </a:solidFill>
+                <a:latin typeface="Calibri"/>
+              </a:rPr>
+              <a:t>weeks — if PCI's ramp is confirmed in writing</a:t>
+            </a:r>
+          </a:p>
+        </p:txBody>
+      </p:sp>
+      <p:sp>
+        <p:nvSpPr>
+          <p:cNvPr id="39" name="TextBox 38"/>
+          <p:cNvSpPr txBox="1"/>
+          <p:nvPr/>
+        </p:nvSpPr>
+        <p:spPr>
+          <a:xfrm>
+            <a:off x="548640" y="2788920"/>
+            <a:ext cx="2377440" cy="1280160"/>
+          </a:xfrm>
+          <a:prstGeom prst="rect">
+            <a:avLst/>
+          </a:prstGeom>
+          <a:noFill/>
+        </p:spPr>
+        <p:txBody>
+          <a:bodyPr wrap="square">
+            <a:spAutoFit/>
+          </a:bodyPr>
+          <a:lstStyle/>
+          <a:p>
+            <a:pPr algn="l">
+              <a:spcAft>
+                <a:spcPts val="200"/>
+              </a:spcAft>
+            </a:pPr>
+            <a:r>
+              <a:rPr sz="1500" b="1" i="0">
+                <a:solidFill>
+                  <a:srgbClr val="2F6DB5"/>
+                </a:solidFill>
+                <a:latin typeface="Calibri"/>
+              </a:rPr>
+              <a:t>Option 3</a:t>
+            </a:r>
+          </a:p>
+          <a:p>
+            <a:pPr algn="l">
+              <a:spcAft>
+                <a:spcPts val="200"/>
+              </a:spcAft>
+            </a:pPr>
+            <a:r>
+              <a:rPr sz="1100" b="1" i="0">
+                <a:solidFill>
+                  <a:srgbClr val="1F3864"/>
+                </a:solidFill>
+                <a:latin typeface="Calibri"/>
+              </a:rPr>
+              <a:t>Keep-alive: 1–2 batches a year</a:t>
+            </a:r>
+          </a:p>
+          <a:p>
+            <a:pPr algn="l">
+              <a:spcAft>
+                <a:spcPts val="0"/>
+              </a:spcAft>
+            </a:pPr>
+            <a:r>
+              <a:rPr sz="900" b="0" i="0">
+                <a:solidFill>
+                  <a:srgbClr val="595959"/>
+                </a:solidFill>
+                <a:latin typeface="Calibri"/>
+              </a:rPr>
+              <a:t>one ~12-day block per batch, when we choose</a:t>
+            </a:r>
+          </a:p>
+        </p:txBody>
+      </p:sp>
+      <p:sp>
+        <p:nvSpPr>
+          <p:cNvPr id="40" name="Rectangle 39"/>
+          <p:cNvSpPr/>
+          <p:nvPr/>
+        </p:nvSpPr>
+        <p:spPr>
+          <a:xfrm>
+            <a:off x="3017520" y="2953512"/>
+            <a:ext cx="6035040" cy="566928"/>
+          </a:xfrm>
+          <a:prstGeom prst="rect">
+            <a:avLst/>
+          </a:prstGeom>
+          <a:solidFill>
+            <a:srgbClr val="2E7D46"/>
+          </a:solidFill>
+          <a:ln>
+            <a:noFill/>
+          </a:ln>
+          <a:effectLst/>
+        </p:spPr>
+        <p:style>
+          <a:lnRef idx="1">
+            <a:schemeClr val="accent1"/>
+          </a:lnRef>
+          <a:fillRef idx="3">
+            <a:schemeClr val="accent1"/>
+          </a:fillRef>
+          <a:effectRef idx="2">
+            <a:schemeClr val="accent1"/>
+          </a:effectRef>
+          <a:fontRef idx="minor">
+            <a:schemeClr val="lt1"/>
+          </a:fontRef>
+        </p:style>
+        <p:txBody>
+          <a:bodyPr rtlCol="0" anchor="ctr"/>
+          <a:lstStyle/>
+          <a:p>
+            <a:pPr algn="ctr"/>
+          </a:p>
+        </p:txBody>
+      </p:sp>
+      <p:sp>
+        <p:nvSpPr>
+          <p:cNvPr id="41" name="Rectangle 40"/>
+          <p:cNvSpPr/>
+          <p:nvPr/>
+        </p:nvSpPr>
+        <p:spPr>
+          <a:xfrm>
+            <a:off x="5001642" y="2953512"/>
+            <a:ext cx="200065" cy="566928"/>
+          </a:xfrm>
+          <a:prstGeom prst="rect">
+            <a:avLst/>
+          </a:prstGeom>
+          <a:solidFill>
+            <a:srgbClr val="2F6DB5"/>
+          </a:solidFill>
+          <a:ln>
+            <a:noFill/>
+          </a:ln>
+          <a:effectLst/>
+        </p:spPr>
+        <p:style>
+          <a:lnRef idx="1">
+            <a:schemeClr val="accent1"/>
+          </a:lnRef>
+          <a:fillRef idx="3">
+            <a:schemeClr val="accent1"/>
+          </a:fillRef>
+          <a:effectRef idx="2">
+            <a:schemeClr val="accent1"/>
+          </a:effectRef>
+          <a:fontRef idx="minor">
+            <a:schemeClr val="lt1"/>
+          </a:fontRef>
+        </p:style>
+        <p:txBody>
+          <a:bodyPr rtlCol="0" anchor="ctr"/>
+          <a:lstStyle/>
+          <a:p>
+            <a:pPr algn="ctr"/>
+          </a:p>
+        </p:txBody>
+      </p:sp>
+      <p:sp>
+        <p:nvSpPr>
+          <p:cNvPr id="42" name="Rectangle 41"/>
+          <p:cNvSpPr/>
+          <p:nvPr/>
+        </p:nvSpPr>
+        <p:spPr>
+          <a:xfrm>
+            <a:off x="4983354" y="2953512"/>
+            <a:ext cx="18288" cy="566928"/>
+          </a:xfrm>
+          <a:prstGeom prst="rect">
+            <a:avLst/>
+          </a:prstGeom>
+          <a:solidFill>
+            <a:srgbClr val="FFFFFF"/>
+          </a:solidFill>
+          <a:ln>
+            <a:noFill/>
+          </a:ln>
+          <a:effectLst/>
+        </p:spPr>
+        <p:style>
+          <a:lnRef idx="1">
+            <a:schemeClr val="accent1"/>
+          </a:lnRef>
+          <a:fillRef idx="3">
+            <a:schemeClr val="accent1"/>
+          </a:fillRef>
+          <a:effectRef idx="2">
+            <a:schemeClr val="accent1"/>
+          </a:effectRef>
+          <a:fontRef idx="minor">
+            <a:schemeClr val="lt1"/>
+          </a:fontRef>
+        </p:style>
+        <p:txBody>
+          <a:bodyPr rtlCol="0" anchor="ctr"/>
+          <a:lstStyle/>
+          <a:p>
+            <a:pPr algn="ctr"/>
+          </a:p>
+        </p:txBody>
+      </p:sp>
+      <p:sp>
+        <p:nvSpPr>
+          <p:cNvPr id="43" name="Rectangle 42"/>
+          <p:cNvSpPr/>
+          <p:nvPr/>
+        </p:nvSpPr>
+        <p:spPr>
+          <a:xfrm>
+            <a:off x="5201708" y="2953512"/>
+            <a:ext cx="18288" cy="566928"/>
+          </a:xfrm>
+          <a:prstGeom prst="rect">
+            <a:avLst/>
+          </a:prstGeom>
+          <a:solidFill>
+            <a:srgbClr val="FFFFFF"/>
+          </a:solidFill>
+          <a:ln>
+            <a:noFill/>
+          </a:ln>
+          <a:effectLst/>
+        </p:spPr>
+        <p:style>
+          <a:lnRef idx="1">
+            <a:schemeClr val="accent1"/>
+          </a:lnRef>
+          <a:fillRef idx="3">
+            <a:schemeClr val="accent1"/>
+          </a:fillRef>
+          <a:effectRef idx="2">
+            <a:schemeClr val="accent1"/>
+          </a:effectRef>
+          <a:fontRef idx="minor">
+            <a:schemeClr val="lt1"/>
+          </a:fontRef>
+        </p:style>
+        <p:txBody>
+          <a:bodyPr rtlCol="0" anchor="ctr"/>
+          <a:lstStyle/>
+          <a:p>
+            <a:pPr algn="ctr"/>
+          </a:p>
+        </p:txBody>
+      </p:sp>
+      <p:sp>
+        <p:nvSpPr>
+          <p:cNvPr id="44" name="Rectangle 43"/>
+          <p:cNvSpPr/>
+          <p:nvPr/>
+        </p:nvSpPr>
+        <p:spPr>
+          <a:xfrm>
+            <a:off x="7977826" y="2953512"/>
+            <a:ext cx="200065" cy="566928"/>
+          </a:xfrm>
+          <a:prstGeom prst="rect">
+            <a:avLst/>
+          </a:prstGeom>
+          <a:solidFill>
+            <a:srgbClr val="2F6DB5"/>
+          </a:solidFill>
+          <a:ln>
+            <a:noFill/>
+          </a:ln>
+          <a:effectLst/>
+        </p:spPr>
+        <p:style>
+          <a:lnRef idx="1">
+            <a:schemeClr val="accent1"/>
+          </a:lnRef>
+          <a:fillRef idx="3">
+            <a:schemeClr val="accent1"/>
+          </a:fillRef>
+          <a:effectRef idx="2">
+            <a:schemeClr val="accent1"/>
+          </a:effectRef>
+          <a:fontRef idx="minor">
+            <a:schemeClr val="lt1"/>
+          </a:fontRef>
+        </p:style>
+        <p:txBody>
+          <a:bodyPr rtlCol="0" anchor="ctr"/>
+          <a:lstStyle/>
+          <a:p>
+            <a:pPr algn="ctr"/>
+          </a:p>
+        </p:txBody>
+      </p:sp>
+      <p:sp>
+        <p:nvSpPr>
+          <p:cNvPr id="45" name="Rectangle 44"/>
+          <p:cNvSpPr/>
+          <p:nvPr/>
+        </p:nvSpPr>
+        <p:spPr>
+          <a:xfrm>
+            <a:off x="7959538" y="2953512"/>
+            <a:ext cx="18288" cy="566928"/>
+          </a:xfrm>
+          <a:prstGeom prst="rect">
+            <a:avLst/>
+          </a:prstGeom>
+          <a:solidFill>
+            <a:srgbClr val="FFFFFF"/>
+          </a:solidFill>
+          <a:ln>
+            <a:noFill/>
+          </a:ln>
+          <a:effectLst/>
+        </p:spPr>
+        <p:style>
+          <a:lnRef idx="1">
+            <a:schemeClr val="accent1"/>
+          </a:lnRef>
+          <a:fillRef idx="3">
+            <a:schemeClr val="accent1"/>
+          </a:fillRef>
+          <a:effectRef idx="2">
+            <a:schemeClr val="accent1"/>
+          </a:effectRef>
+          <a:fontRef idx="minor">
+            <a:schemeClr val="lt1"/>
+          </a:fontRef>
+        </p:style>
+        <p:txBody>
+          <a:bodyPr rtlCol="0" anchor="ctr"/>
+          <a:lstStyle/>
+          <a:p>
+            <a:pPr algn="ctr"/>
+          </a:p>
+        </p:txBody>
+      </p:sp>
+      <p:sp>
+        <p:nvSpPr>
+          <p:cNvPr id="46" name="Rectangle 45"/>
+          <p:cNvSpPr/>
+          <p:nvPr/>
+        </p:nvSpPr>
+        <p:spPr>
+          <a:xfrm>
+            <a:off x="8177892" y="2953512"/>
+            <a:ext cx="18288" cy="566928"/>
+          </a:xfrm>
+          <a:prstGeom prst="rect">
+            <a:avLst/>
+          </a:prstGeom>
+          <a:solidFill>
+            <a:srgbClr val="FFFFFF"/>
+          </a:solidFill>
+          <a:ln>
+            <a:noFill/>
+          </a:ln>
+          <a:effectLst/>
+        </p:spPr>
+        <p:style>
+          <a:lnRef idx="1">
+            <a:schemeClr val="accent1"/>
+          </a:lnRef>
+          <a:fillRef idx="3">
+            <a:schemeClr val="accent1"/>
+          </a:fillRef>
+          <a:effectRef idx="2">
+            <a:schemeClr val="accent1"/>
+          </a:effectRef>
+          <a:fontRef idx="minor">
+            <a:schemeClr val="lt1"/>
+          </a:fontRef>
+        </p:style>
+        <p:txBody>
+          <a:bodyPr rtlCol="0" anchor="ctr"/>
+          <a:lstStyle/>
+          <a:p>
+            <a:pPr algn="ctr"/>
+          </a:p>
+        </p:txBody>
+      </p:sp>
+      <p:sp>
+        <p:nvSpPr>
+          <p:cNvPr id="47" name="TextBox 46"/>
+          <p:cNvSpPr txBox="1"/>
+          <p:nvPr/>
+        </p:nvSpPr>
+        <p:spPr>
+          <a:xfrm>
+            <a:off x="9189720" y="2770632"/>
+            <a:ext cx="2468880" cy="1371600"/>
+          </a:xfrm>
+          <a:prstGeom prst="rect">
+            <a:avLst/>
+          </a:prstGeom>
+          <a:noFill/>
+        </p:spPr>
+        <p:txBody>
+          <a:bodyPr wrap="square">
+            <a:spAutoFit/>
+          </a:bodyPr>
+          <a:lstStyle/>
+          <a:p>
+            <a:pPr>
+              <a:spcAft>
+                <a:spcPts val="200"/>
+              </a:spcAft>
+            </a:pPr>
+            <a:r>
+              <a:rPr sz="850">
+                <a:solidFill>
+                  <a:srgbClr val="595959"/>
+                </a:solidFill>
+                <a:latin typeface="Calibri"/>
+              </a:rPr>
+              <a:t>First 12 months, all-in  </a:t>
+            </a:r>
+            <a:r>
+              <a:rPr sz="900" b="1">
+                <a:solidFill>
+                  <a:srgbClr val="1F3864"/>
+                </a:solidFill>
+                <a:latin typeface="Calibri"/>
+              </a:rPr>
+              <a:t>$31–78k</a:t>
+            </a:r>
+          </a:p>
+          <a:p>
+            <a:pPr>
+              <a:spcAft>
+                <a:spcPts val="200"/>
+              </a:spcAft>
+            </a:pPr>
+            <a:r>
+              <a:rPr sz="850">
+                <a:solidFill>
+                  <a:srgbClr val="595959"/>
+                </a:solidFill>
+                <a:latin typeface="Calibri"/>
+              </a:rPr>
+              <a:t>Each year after  </a:t>
+            </a:r>
+            <a:r>
+              <a:rPr sz="900" b="0">
+                <a:solidFill>
+                  <a:srgbClr val="1F3864"/>
+                </a:solidFill>
+                <a:latin typeface="Calibri"/>
+              </a:rPr>
+              <a:t>$9–24k</a:t>
+            </a:r>
+          </a:p>
+          <a:p>
+            <a:pPr>
+              <a:spcAft>
+                <a:spcPts val="200"/>
+              </a:spcAft>
+            </a:pPr>
+            <a:r>
+              <a:rPr sz="850">
+                <a:solidFill>
+                  <a:srgbClr val="595959"/>
+                </a:solidFill>
+                <a:latin typeface="Calibri"/>
+              </a:rPr>
+              <a:t>Volume to PCI a year  </a:t>
+            </a:r>
+            <a:r>
+              <a:rPr sz="900" b="0">
+                <a:solidFill>
+                  <a:srgbClr val="1F3864"/>
+                </a:solidFill>
+                <a:latin typeface="Calibri"/>
+              </a:rPr>
+              <a:t>2,250–4,500 lb · 5–10 drums (3–7%)</a:t>
+            </a:r>
+          </a:p>
+          <a:p>
+            <a:pPr>
+              <a:spcAft>
+                <a:spcPts val="200"/>
+              </a:spcAft>
+            </a:pPr>
+            <a:r>
+              <a:rPr sz="850">
+                <a:solidFill>
+                  <a:srgbClr val="595959"/>
+                </a:solidFill>
+                <a:latin typeface="Calibri"/>
+              </a:rPr>
+              <a:t>SNP Inc. sees  </a:t>
+            </a:r>
+            <a:r>
+              <a:rPr sz="900" b="0">
+                <a:solidFill>
+                  <a:srgbClr val="1F3864"/>
+                </a:solidFill>
+                <a:latin typeface="Calibri"/>
+              </a:rPr>
+              <a:t>1–2 pre-announced pauses, or none</a:t>
+            </a:r>
+          </a:p>
+          <a:p>
+            <a:pPr>
+              <a:spcAft>
+                <a:spcPts val="200"/>
+              </a:spcAft>
+            </a:pPr>
+            <a:r>
+              <a:rPr sz="850">
+                <a:solidFill>
+                  <a:srgbClr val="595959"/>
+                </a:solidFill>
+                <a:latin typeface="Calibri"/>
+              </a:rPr>
+              <a:t>If SNP fails, restart in  </a:t>
+            </a:r>
+            <a:r>
+              <a:rPr sz="900" b="0">
+                <a:solidFill>
+                  <a:srgbClr val="1F3864"/>
+                </a:solidFill>
+                <a:latin typeface="Calibri"/>
+              </a:rPr>
+              <a:t>weeks to a few months</a:t>
+            </a:r>
+          </a:p>
+        </p:txBody>
+      </p:sp>
+      <p:sp>
+        <p:nvSpPr>
+          <p:cNvPr id="48" name="TextBox 47"/>
+          <p:cNvSpPr txBox="1"/>
+          <p:nvPr/>
+        </p:nvSpPr>
+        <p:spPr>
+          <a:xfrm>
+            <a:off x="548640" y="4251960"/>
+            <a:ext cx="2377440" cy="1280160"/>
+          </a:xfrm>
+          <a:prstGeom prst="rect">
+            <a:avLst/>
+          </a:prstGeom>
+          <a:noFill/>
+        </p:spPr>
+        <p:txBody>
+          <a:bodyPr wrap="square">
+            <a:spAutoFit/>
+          </a:bodyPr>
+          <a:lstStyle/>
+          <a:p>
+            <a:pPr algn="l">
+              <a:spcAft>
+                <a:spcPts val="200"/>
+              </a:spcAft>
+            </a:pPr>
+            <a:r>
+              <a:rPr sz="1500" b="1" i="0">
+                <a:solidFill>
+                  <a:srgbClr val="2E7D46"/>
+                </a:solidFill>
+                <a:latin typeface="Calibri"/>
+              </a:rPr>
+              <a:t>Option 2</a:t>
+            </a:r>
+          </a:p>
+          <a:p>
+            <a:pPr algn="l">
+              <a:spcAft>
+                <a:spcPts val="200"/>
+              </a:spcAft>
+            </a:pPr>
+            <a:r>
+              <a:rPr sz="1100" b="1" i="0">
+                <a:solidFill>
+                  <a:srgbClr val="1F3864"/>
+                </a:solidFill>
+                <a:latin typeface="Calibri"/>
+              </a:rPr>
+              <a:t>Strengthen SNP Inc. only</a:t>
+            </a:r>
+          </a:p>
+          <a:p>
+            <a:pPr algn="l">
+              <a:spcAft>
+                <a:spcPts val="0"/>
+              </a:spcAft>
+            </a:pPr>
+            <a:r>
+              <a:rPr sz="900" b="0" i="0">
+                <a:solidFill>
+                  <a:srgbClr val="595959"/>
+                </a:solidFill>
+                <a:latin typeface="Calibri"/>
+              </a:rPr>
+              <a:t>all year on SNP Inc.; PCI kept as a quoted option</a:t>
+            </a:r>
+          </a:p>
+        </p:txBody>
+      </p:sp>
+      <p:sp>
+        <p:nvSpPr>
+          <p:cNvPr id="49" name="Rectangle 48"/>
+          <p:cNvSpPr/>
+          <p:nvPr/>
+        </p:nvSpPr>
+        <p:spPr>
+          <a:xfrm>
+            <a:off x="3017520" y="4416552"/>
+            <a:ext cx="6035040" cy="566928"/>
+          </a:xfrm>
+          <a:prstGeom prst="rect">
+            <a:avLst/>
+          </a:prstGeom>
+          <a:solidFill>
+            <a:srgbClr val="2E7D46"/>
+          </a:solidFill>
+          <a:ln>
+            <a:noFill/>
+          </a:ln>
+          <a:effectLst/>
+        </p:spPr>
+        <p:style>
+          <a:lnRef idx="1">
+            <a:schemeClr val="accent1"/>
+          </a:lnRef>
+          <a:fillRef idx="3">
+            <a:schemeClr val="accent1"/>
+          </a:fillRef>
+          <a:effectRef idx="2">
+            <a:schemeClr val="accent1"/>
+          </a:effectRef>
+          <a:fontRef idx="minor">
+            <a:schemeClr val="lt1"/>
+          </a:fontRef>
+        </p:style>
+        <p:txBody>
+          <a:bodyPr rtlCol="0" anchor="ctr"/>
+          <a:lstStyle/>
+          <a:p>
+            <a:pPr algn="ctr"/>
+          </a:p>
+        </p:txBody>
+      </p:sp>
+      <p:sp>
+        <p:nvSpPr>
+          <p:cNvPr id="50" name="TextBox 49"/>
+          <p:cNvSpPr txBox="1"/>
+          <p:nvPr/>
+        </p:nvSpPr>
+        <p:spPr>
+          <a:xfrm>
+            <a:off x="2743200" y="5001768"/>
+            <a:ext cx="548640" cy="228600"/>
+          </a:xfrm>
+          <a:prstGeom prst="rect">
+            <a:avLst/>
+          </a:prstGeom>
+          <a:noFill/>
+        </p:spPr>
+        <p:txBody>
+          <a:bodyPr wrap="square">
+            <a:spAutoFit/>
+          </a:bodyPr>
+          <a:lstStyle/>
+          <a:p>
+            <a:pPr algn="ctr">
+              <a:spcAft>
+                <a:spcPts val="0"/>
+              </a:spcAft>
+            </a:pPr>
+            <a:r>
+              <a:rPr sz="850" b="0" i="0">
+                <a:solidFill>
+                  <a:srgbClr val="595959"/>
+                </a:solidFill>
+                <a:latin typeface="Calibri"/>
+              </a:rPr>
+              <a:t>Jan</a:t>
+            </a:r>
+          </a:p>
+        </p:txBody>
+      </p:sp>
+      <p:sp>
+        <p:nvSpPr>
+          <p:cNvPr id="51" name="TextBox 50"/>
+          <p:cNvSpPr txBox="1"/>
+          <p:nvPr/>
+        </p:nvSpPr>
+        <p:spPr>
+          <a:xfrm>
+            <a:off x="4247826" y="5001768"/>
+            <a:ext cx="548640" cy="228600"/>
+          </a:xfrm>
+          <a:prstGeom prst="rect">
+            <a:avLst/>
+          </a:prstGeom>
+          <a:noFill/>
+        </p:spPr>
+        <p:txBody>
+          <a:bodyPr wrap="square">
+            <a:spAutoFit/>
+          </a:bodyPr>
+          <a:lstStyle/>
+          <a:p>
+            <a:pPr algn="ctr">
+              <a:spcAft>
+                <a:spcPts val="0"/>
+              </a:spcAft>
+            </a:pPr>
+            <a:r>
+              <a:rPr sz="850" b="0" i="0">
+                <a:solidFill>
+                  <a:srgbClr val="595959"/>
+                </a:solidFill>
+                <a:latin typeface="Calibri"/>
+              </a:rPr>
+              <a:t>Apr</a:t>
+            </a:r>
+          </a:p>
+        </p:txBody>
+      </p:sp>
+      <p:sp>
+        <p:nvSpPr>
+          <p:cNvPr id="52" name="TextBox 51"/>
+          <p:cNvSpPr txBox="1"/>
+          <p:nvPr/>
+        </p:nvSpPr>
+        <p:spPr>
+          <a:xfrm>
+            <a:off x="5752452" y="5001768"/>
+            <a:ext cx="548640" cy="228600"/>
+          </a:xfrm>
+          <a:prstGeom prst="rect">
+            <a:avLst/>
+          </a:prstGeom>
+          <a:noFill/>
+        </p:spPr>
+        <p:txBody>
+          <a:bodyPr wrap="square">
+            <a:spAutoFit/>
+          </a:bodyPr>
+          <a:lstStyle/>
+          <a:p>
+            <a:pPr algn="ctr">
+              <a:spcAft>
+                <a:spcPts val="0"/>
+              </a:spcAft>
+            </a:pPr>
+            <a:r>
+              <a:rPr sz="850" b="0" i="0">
+                <a:solidFill>
+                  <a:srgbClr val="595959"/>
+                </a:solidFill>
+                <a:latin typeface="Calibri"/>
+              </a:rPr>
+              <a:t>Jul</a:t>
+            </a:r>
+          </a:p>
+        </p:txBody>
+      </p:sp>
+      <p:sp>
+        <p:nvSpPr>
+          <p:cNvPr id="53" name="TextBox 52"/>
+          <p:cNvSpPr txBox="1"/>
+          <p:nvPr/>
+        </p:nvSpPr>
+        <p:spPr>
+          <a:xfrm>
+            <a:off x="7273613" y="5001768"/>
+            <a:ext cx="548640" cy="228600"/>
+          </a:xfrm>
+          <a:prstGeom prst="rect">
+            <a:avLst/>
+          </a:prstGeom>
+          <a:noFill/>
+        </p:spPr>
+        <p:txBody>
+          <a:bodyPr wrap="square">
+            <a:spAutoFit/>
+          </a:bodyPr>
+          <a:lstStyle/>
+          <a:p>
+            <a:pPr algn="ctr">
+              <a:spcAft>
+                <a:spcPts val="0"/>
+              </a:spcAft>
+            </a:pPr>
+            <a:r>
+              <a:rPr sz="850" b="0" i="0">
+                <a:solidFill>
+                  <a:srgbClr val="595959"/>
+                </a:solidFill>
+                <a:latin typeface="Calibri"/>
+              </a:rPr>
+              <a:t>Oct</a:t>
+            </a:r>
+          </a:p>
+        </p:txBody>
+      </p:sp>
+      <p:sp>
+        <p:nvSpPr>
+          <p:cNvPr id="54" name="TextBox 53"/>
+          <p:cNvSpPr txBox="1"/>
+          <p:nvPr/>
+        </p:nvSpPr>
+        <p:spPr>
+          <a:xfrm>
+            <a:off x="8778239" y="5001768"/>
+            <a:ext cx="548640" cy="228600"/>
+          </a:xfrm>
+          <a:prstGeom prst="rect">
+            <a:avLst/>
+          </a:prstGeom>
+          <a:noFill/>
+        </p:spPr>
+        <p:txBody>
+          <a:bodyPr wrap="square">
+            <a:spAutoFit/>
+          </a:bodyPr>
+          <a:lstStyle/>
+          <a:p>
+            <a:pPr algn="ctr">
+              <a:spcAft>
+                <a:spcPts val="0"/>
+              </a:spcAft>
+            </a:pPr>
+            <a:r>
+              <a:rPr sz="850" b="0" i="0">
+                <a:solidFill>
+                  <a:srgbClr val="595959"/>
+                </a:solidFill>
+                <a:latin typeface="Calibri"/>
+              </a:rPr>
+              <a:t>Dec</a:t>
+            </a:r>
+          </a:p>
+        </p:txBody>
+      </p:sp>
+      <p:sp>
+        <p:nvSpPr>
+          <p:cNvPr id="55" name="TextBox 54"/>
+          <p:cNvSpPr txBox="1"/>
+          <p:nvPr/>
+        </p:nvSpPr>
+        <p:spPr>
+          <a:xfrm>
+            <a:off x="9189720" y="4233672"/>
+            <a:ext cx="2468880" cy="1371600"/>
+          </a:xfrm>
+          <a:prstGeom prst="rect">
+            <a:avLst/>
+          </a:prstGeom>
+          <a:noFill/>
+        </p:spPr>
+        <p:txBody>
+          <a:bodyPr wrap="square">
+            <a:spAutoFit/>
+          </a:bodyPr>
+          <a:lstStyle/>
+          <a:p>
+            <a:pPr>
+              <a:spcAft>
+                <a:spcPts val="200"/>
+              </a:spcAft>
+            </a:pPr>
+            <a:r>
+              <a:rPr sz="850">
+                <a:solidFill>
+                  <a:srgbClr val="595959"/>
+                </a:solidFill>
+                <a:latin typeface="Calibri"/>
+              </a:rPr>
+              <a:t>First 12 months, all-in  </a:t>
+            </a:r>
+            <a:r>
+              <a:rPr sz="900" b="1">
+                <a:solidFill>
+                  <a:srgbClr val="1F3864"/>
+                </a:solidFill>
+                <a:latin typeface="Calibri"/>
+              </a:rPr>
+              <a:t>$13–32k</a:t>
+            </a:r>
+          </a:p>
+          <a:p>
+            <a:pPr>
+              <a:spcAft>
+                <a:spcPts val="200"/>
+              </a:spcAft>
+            </a:pPr>
+            <a:r>
+              <a:rPr sz="850">
+                <a:solidFill>
+                  <a:srgbClr val="595959"/>
+                </a:solidFill>
+                <a:latin typeface="Calibri"/>
+              </a:rPr>
+              <a:t>Each year after  </a:t>
+            </a:r>
+            <a:r>
+              <a:rPr sz="900" b="0">
+                <a:solidFill>
+                  <a:srgbClr val="1F3864"/>
+                </a:solidFill>
+                <a:latin typeface="Calibri"/>
+              </a:rPr>
+              <a:t>$3–12k</a:t>
+            </a:r>
+          </a:p>
+          <a:p>
+            <a:pPr>
+              <a:spcAft>
+                <a:spcPts val="200"/>
+              </a:spcAft>
+            </a:pPr>
+            <a:r>
+              <a:rPr sz="850">
+                <a:solidFill>
+                  <a:srgbClr val="595959"/>
+                </a:solidFill>
+                <a:latin typeface="Calibri"/>
+              </a:rPr>
+              <a:t>Volume to PCI a year  </a:t>
+            </a:r>
+            <a:r>
+              <a:rPr sz="900" b="0">
+                <a:solidFill>
+                  <a:srgbClr val="1F3864"/>
+                </a:solidFill>
+                <a:latin typeface="Calibri"/>
+              </a:rPr>
+              <a:t>none</a:t>
+            </a:r>
+          </a:p>
+          <a:p>
+            <a:pPr>
+              <a:spcAft>
+                <a:spcPts val="200"/>
+              </a:spcAft>
+            </a:pPr>
+            <a:r>
+              <a:rPr sz="850">
+                <a:solidFill>
+                  <a:srgbClr val="595959"/>
+                </a:solidFill>
+                <a:latin typeface="Calibri"/>
+              </a:rPr>
+              <a:t>SNP Inc. sees  </a:t>
+            </a:r>
+            <a:r>
+              <a:rPr sz="900" b="0">
+                <a:solidFill>
+                  <a:srgbClr val="1F3864"/>
+                </a:solidFill>
+                <a:latin typeface="Calibri"/>
+              </a:rPr>
+              <a:t>a strengthened partner</a:t>
+            </a:r>
+          </a:p>
+          <a:p>
+            <a:pPr>
+              <a:spcAft>
+                <a:spcPts val="200"/>
+              </a:spcAft>
+            </a:pPr>
+            <a:r>
+              <a:rPr sz="850">
+                <a:solidFill>
+                  <a:srgbClr val="595959"/>
+                </a:solidFill>
+                <a:latin typeface="Calibri"/>
+              </a:rPr>
+              <a:t>If SNP fails, restart in  </a:t>
+            </a:r>
+            <a:r>
+              <a:rPr sz="900" b="0">
+                <a:solidFill>
+                  <a:srgbClr val="1F3864"/>
+                </a:solidFill>
+                <a:latin typeface="Calibri"/>
+              </a:rPr>
+              <a:t>~3–6 months; a cold start decays after ~12 idle</a:t>
+            </a:r>
+          </a:p>
+        </p:txBody>
+      </p:sp>
+      <p:sp>
+        <p:nvSpPr>
+          <p:cNvPr id="56" name="TextBox 55"/>
+          <p:cNvSpPr txBox="1"/>
+          <p:nvPr/>
+        </p:nvSpPr>
+        <p:spPr>
+          <a:xfrm>
+            <a:off x="548640" y="5623560"/>
+            <a:ext cx="11064240" cy="320040"/>
+          </a:xfrm>
+          <a:prstGeom prst="rect">
+            <a:avLst/>
+          </a:prstGeom>
+          <a:noFill/>
+        </p:spPr>
+        <p:txBody>
+          <a:bodyPr wrap="square">
+            <a:spAutoFit/>
+          </a:bodyPr>
+          <a:lstStyle/>
+          <a:p>
+            <a:pPr algn="l">
+              <a:spcAft>
+                <a:spcPts val="0"/>
+              </a:spcAft>
+            </a:pPr>
+            <a:r>
+              <a:rPr sz="900" b="0" i="0">
+                <a:solidFill>
+                  <a:srgbClr val="595959"/>
+                </a:solidFill>
+                <a:latin typeface="Calibri"/>
+              </a:rPr>
+              <a:t>Block rotation: PCI drums land ~4 days old and expire on day 18, so a 5-drum batch is used at full rate in one ~12-day block. Costs exclude ~$15k of internal hours already spent; ranges cover internal hours, supplier payments and material premium.</a:t>
+            </a:r>
+          </a:p>
+        </p:txBody>
+      </p:sp>
+      <p:sp>
+        <p:nvSpPr>
+          <p:cNvPr id="57" name="Rectangle 56"/>
+          <p:cNvSpPr/>
+          <p:nvPr/>
+        </p:nvSpPr>
+        <p:spPr>
+          <a:xfrm>
+            <a:off x="548640" y="5989320"/>
+            <a:ext cx="11064240" cy="566928"/>
+          </a:xfrm>
+          <a:prstGeom prst="rect">
+            <a:avLst/>
+          </a:prstGeom>
+          <a:solidFill>
+            <a:srgbClr val="2E7D46"/>
+          </a:solidFill>
+          <a:ln>
+            <a:noFill/>
+          </a:ln>
+          <a:effectLst/>
+        </p:spPr>
+        <p:style>
+          <a:lnRef idx="1">
+            <a:schemeClr val="accent1"/>
+          </a:lnRef>
+          <a:fillRef idx="3">
+            <a:schemeClr val="accent1"/>
+          </a:fillRef>
+          <a:effectRef idx="2">
+            <a:schemeClr val="accent1"/>
+          </a:effectRef>
+          <a:fontRef idx="minor">
+            <a:schemeClr val="lt1"/>
+          </a:fontRef>
+        </p:style>
+        <p:txBody>
+          <a:bodyPr rtlCol="0" anchor="ctr"/>
+          <a:lstStyle/>
+          <a:p>
+            <a:pPr algn="ctr"/>
+          </a:p>
+        </p:txBody>
+      </p:sp>
+      <p:sp>
+        <p:nvSpPr>
+          <p:cNvPr id="58" name="TextBox 57"/>
           <p:cNvSpPr txBox="1"/>
           <p:nvPr/>
         </p:nvSpPr>
@@ -10462,7 +11748,7 @@
                 </a:solidFill>
                 <a:latin typeface="Calibri"/>
               </a:rPr>
-              <a:t>Two suppliers is workable as a permanent discipline; SNP Inc.'s cadence can stay level if we carry a few drums of margin — the shelf-life study decides.</a:t>
+              <a:t>Option 3 keeps a paid, practiced supplier for ~$8–16k a year gross, with one or two pre-announced pauses for SNP Inc. — Option 1 costs ~$62k a year more and changes SNP's year.</a:t>
             </a:r>
           </a:p>
         </p:txBody>
@@ -10563,7 +11849,7 @@
                 </a:solidFill>
                 <a:latin typeface="Calibri"/>
               </a:rPr>
-              <a:t>Three options</a:t>
+              <a:t>Cost against protection — where each option sits</a:t>
             </a:r>
           </a:p>
         </p:txBody>
@@ -10602,14 +11888,14 @@
                 </a:solidFill>
                 <a:latin typeface="Calibri"/>
               </a:rPr>
-              <a:t>4 · STRATEGY</a:t>
+              <a:t>3 · OPTIONS</a:t>
             </a:r>
           </a:p>
         </p:txBody>
       </p:sp>
       <p:pic>
         <p:nvPicPr>
-          <p:cNvPr id="5" name="Picture 4" descr="chart_options_year1.png"/>
+          <p:cNvPr id="5" name="Picture 4" descr="chart_cost_vs_protection.png"/>
           <p:cNvPicPr>
             <a:picLocks noChangeAspect="1"/>
           </p:cNvPicPr>
@@ -10623,797 +11909,277 @@
         </p:blipFill>
         <p:spPr>
           <a:xfrm>
-            <a:off x="548640" y="987552"/>
-            <a:ext cx="11064240" cy="1844040"/>
+            <a:off x="548640" y="1051560"/>
+            <a:ext cx="7406640" cy="4696894"/>
           </a:xfrm>
           <a:prstGeom prst="rect">
             <a:avLst/>
           </a:prstGeom>
         </p:spPr>
       </p:pic>
-      <p:graphicFrame>
-        <p:nvGraphicFramePr>
-          <p:cNvPr id="6" name="Table 5"/>
-          <p:cNvGraphicFramePr>
-            <a:graphicFrameLocks noGrp="1"/>
-          </p:cNvGraphicFramePr>
-          <p:nvPr/>
-        </p:nvGraphicFramePr>
-        <p:xfrm>
-          <a:off x="548640" y="2834640"/>
-          <a:ext cx="11064240" cy="3017520"/>
-        </p:xfrm>
-        <a:graphic>
-          <a:graphicData uri="http://schemas.openxmlformats.org/drawingml/2006/table">
-            <a:tbl>
-              <a:tblPr firstRow="1" bandRow="1">
-                <a:tableStyleId>{5C22544A-7EE6-4342-B048-85BDC9FD1C3A}</a:tableStyleId>
-              </a:tblPr>
-              <a:tblGrid>
-                <a:gridCol w="1234440"/>
-                <a:gridCol w="3063240"/>
-                <a:gridCol w="3246120"/>
-                <a:gridCol w="3520440"/>
-              </a:tblGrid>
-              <a:tr h="377190">
-                <a:tc>
-                  <a:txBody>
-                    <a:bodyPr/>
-                    <a:lstStyle/>
-                    <a:p>
-                      <a:pPr algn="l"/>
-                      <a:r>
-                        <a:rPr sz="900" b="1">
-                          <a:solidFill>
-                            <a:srgbClr val="FFFFFF"/>
-                          </a:solidFill>
-                          <a:latin typeface="Calibri"/>
-                        </a:rPr>
-                        <a:t/>
-                      </a:r>
-                    </a:p>
-                  </a:txBody>
-                  <a:tcPr>
-                    <a:solidFill>
-                      <a:srgbClr val="1F3864"/>
-                    </a:solidFill>
-                  </a:tcPr>
-                </a:tc>
-                <a:tc>
-                  <a:txBody>
-                    <a:bodyPr/>
-                    <a:lstStyle/>
-                    <a:p>
-                      <a:pPr algn="ctr"/>
-                      <a:r>
-                        <a:rPr sz="900" b="1">
-                          <a:solidFill>
-                            <a:srgbClr val="FFFFFF"/>
-                          </a:solidFill>
-                          <a:latin typeface="Calibri"/>
-                        </a:rPr>
-                        <a:t>Option 1 · Second supplier at one-third</a:t>
-                      </a:r>
-                    </a:p>
-                  </a:txBody>
-                  <a:tcPr>
-                    <a:solidFill>
-                      <a:srgbClr val="1F3864"/>
-                    </a:solidFill>
-                  </a:tcPr>
-                </a:tc>
-                <a:tc>
-                  <a:txBody>
-                    <a:bodyPr/>
-                    <a:lstStyle/>
-                    <a:p>
-                      <a:pPr algn="ctr"/>
-                      <a:r>
-                        <a:rPr sz="900" b="1">
-                          <a:solidFill>
-                            <a:srgbClr val="FFFFFF"/>
-                          </a:solidFill>
-                          <a:latin typeface="Calibri"/>
-                        </a:rPr>
-                        <a:t>Option 2 · Strengthen SNP Inc. only — no volume moved</a:t>
-                      </a:r>
-                    </a:p>
-                  </a:txBody>
-                  <a:tcPr>
-                    <a:solidFill>
-                      <a:srgbClr val="1F3864"/>
-                    </a:solidFill>
-                  </a:tcPr>
-                </a:tc>
-                <a:tc>
-                  <a:txBody>
-                    <a:bodyPr/>
-                    <a:lstStyle/>
-                    <a:p>
-                      <a:pPr algn="l"/>
-                      <a:r>
-                        <a:rPr sz="900" b="1">
-                          <a:solidFill>
-                            <a:srgbClr val="FFFFFF"/>
-                          </a:solidFill>
-                          <a:latin typeface="Calibri"/>
-                        </a:rPr>
-                        <a:t>Option 3 · Keep-alive: 1–2 batches of 5 drums a year</a:t>
-                      </a:r>
-                    </a:p>
-                  </a:txBody>
-                  <a:tcPr>
-                    <a:solidFill>
-                      <a:srgbClr val="1F3864"/>
-                    </a:solidFill>
-                  </a:tcPr>
-                </a:tc>
-              </a:tr>
-              <a:tr h="377190">
-                <a:tc>
-                  <a:txBody>
-                    <a:bodyPr/>
-                    <a:lstStyle/>
-                    <a:p>
-                      <a:pPr algn="l"/>
-                      <a:r>
-                        <a:rPr sz="900" b="1">
-                          <a:solidFill>
-                            <a:srgbClr val="1F3864"/>
-                          </a:solidFill>
-                          <a:latin typeface="Calibri"/>
-                        </a:rPr>
-                        <a:t>What it is</a:t>
-                      </a:r>
-                    </a:p>
-                  </a:txBody>
-                  <a:tcPr>
-                    <a:solidFill>
-                      <a:srgbClr val="FFFFFF"/>
-                    </a:solidFill>
-                  </a:tcPr>
-                </a:tc>
-                <a:tc>
-                  <a:txBody>
-                    <a:bodyPr/>
-                    <a:lstStyle/>
-                    <a:p>
-                      <a:pPr algn="ctr"/>
-                      <a:r>
-                        <a:rPr sz="900">
-                          <a:solidFill>
-                            <a:srgbClr val="1F3864"/>
-                          </a:solidFill>
-                          <a:latin typeface="Calibri"/>
-                        </a:rPr>
-                        <a:t>10 PCI batches/yr; SNP Inc. keeps ~2/3</a:t>
-                      </a:r>
-                    </a:p>
-                  </a:txBody>
-                  <a:tcPr>
-                    <a:solidFill>
-                      <a:srgbClr val="FCE4D6"/>
-                    </a:solidFill>
-                  </a:tcPr>
-                </a:tc>
-                <a:tc>
-                  <a:txBody>
-                    <a:bodyPr/>
-                    <a:lstStyle/>
-                    <a:p>
-                      <a:pPr algn="ctr"/>
-                      <a:r>
-                        <a:rPr sz="900">
-                          <a:solidFill>
-                            <a:srgbClr val="1F3864"/>
-                          </a:solidFill>
-                          <a:latin typeface="Calibri"/>
-                        </a:rPr>
-                        <a:t>SNP Inc. sole source with partnership terms; PCI a quoted option; pay a development fee</a:t>
-                      </a:r>
-                    </a:p>
-                  </a:txBody>
-                  <a:tcPr>
-                    <a:solidFill>
-                      <a:srgbClr val="E2EFDA"/>
-                    </a:solidFill>
-                  </a:tcPr>
-                </a:tc>
-                <a:tc>
-                  <a:txBody>
-                    <a:bodyPr/>
-                    <a:lstStyle/>
-                    <a:p>
-                      <a:pPr algn="l"/>
-                      <a:r>
-                        <a:rPr sz="900">
-                          <a:solidFill>
-                            <a:srgbClr val="1F3864"/>
-                          </a:solidFill>
-                          <a:latin typeface="Calibri"/>
-                        </a:rPr>
-                        <a:t>Option 2, plus 1–2 PCI batches a year — the minimum that keeps a qualified supplier alive</a:t>
-                      </a:r>
-                    </a:p>
-                  </a:txBody>
-                  <a:tcPr>
-                    <a:solidFill>
-                      <a:srgbClr val="FFF2CC"/>
-                    </a:solidFill>
-                  </a:tcPr>
-                </a:tc>
-              </a:tr>
-              <a:tr h="377190">
-                <a:tc>
-                  <a:txBody>
-                    <a:bodyPr/>
-                    <a:lstStyle/>
-                    <a:p>
-                      <a:pPr algn="l"/>
-                      <a:r>
-                        <a:rPr sz="900" b="1">
-                          <a:solidFill>
-                            <a:srgbClr val="1F3864"/>
-                          </a:solidFill>
-                          <a:latin typeface="Calibri"/>
-                        </a:rPr>
-                        <a:t>Recurring</a:t>
-                      </a:r>
-                    </a:p>
-                  </a:txBody>
-                  <a:tcPr>
-                    <a:solidFill>
-                      <a:srgbClr val="FFFFFF"/>
-                    </a:solidFill>
-                  </a:tcPr>
-                </a:tc>
-                <a:tc>
-                  <a:txBody>
-                    <a:bodyPr/>
-                    <a:lstStyle/>
-                    <a:p>
-                      <a:pPr algn="ctr"/>
-                      <a:r>
-                        <a:rPr sz="900">
-                          <a:solidFill>
-                            <a:srgbClr val="1F3864"/>
-                          </a:solidFill>
-                          <a:latin typeface="Calibri"/>
-                        </a:rPr>
-                        <a:t>+$62k/yr premium + ~$3–8k quality overhead (~$378k / 5 yrs)</a:t>
-                      </a:r>
-                    </a:p>
-                  </a:txBody>
-                  <a:tcPr>
-                    <a:solidFill>
-                      <a:srgbClr val="FCE4D6"/>
-                    </a:solidFill>
-                  </a:tcPr>
-                </a:tc>
-                <a:tc>
-                  <a:txBody>
-                    <a:bodyPr/>
-                    <a:lstStyle/>
-                    <a:p>
-                      <a:pPr algn="ctr"/>
-                      <a:r>
-                        <a:rPr sz="900">
-                          <a:solidFill>
-                            <a:srgbClr val="1F3864"/>
-                          </a:solidFill>
-                          <a:latin typeface="Calibri"/>
-                        </a:rPr>
-                        <a:t>~$3–12k/yr</a:t>
-                      </a:r>
-                    </a:p>
-                  </a:txBody>
-                  <a:tcPr>
-                    <a:solidFill>
-                      <a:srgbClr val="E2EFDA"/>
-                    </a:solidFill>
-                  </a:tcPr>
-                </a:tc>
-                <a:tc>
-                  <a:txBody>
-                    <a:bodyPr/>
-                    <a:lstStyle/>
-                    <a:p>
-                      <a:pPr algn="l"/>
-                      <a:r>
-                        <a:rPr sz="900">
-                          <a:solidFill>
-                            <a:srgbClr val="1F3864"/>
-                          </a:solidFill>
-                          <a:latin typeface="Calibri"/>
-                        </a:rPr>
-                        <a:t>+$6.2k/yr per batch ($7.9k gross) + Option 2's ~$3–12k</a:t>
-                      </a:r>
-                    </a:p>
-                  </a:txBody>
-                  <a:tcPr>
-                    <a:solidFill>
-                      <a:srgbClr val="FFF2CC"/>
-                    </a:solidFill>
-                  </a:tcPr>
-                </a:tc>
-              </a:tr>
-              <a:tr h="377190">
-                <a:tc>
-                  <a:txBody>
-                    <a:bodyPr/>
-                    <a:lstStyle/>
-                    <a:p>
-                      <a:pPr algn="l"/>
-                      <a:r>
-                        <a:rPr sz="900" b="1">
-                          <a:solidFill>
-                            <a:srgbClr val="1F3864"/>
-                          </a:solidFill>
-                          <a:latin typeface="Calibri"/>
-                        </a:rPr>
-                        <a:t>One-time</a:t>
-                      </a:r>
-                    </a:p>
-                  </a:txBody>
-                  <a:tcPr>
-                    <a:solidFill>
-                      <a:srgbClr val="FFFFFF"/>
-                    </a:solidFill>
-                  </a:tcPr>
-                </a:tc>
-                <a:tc>
-                  <a:txBody>
-                    <a:bodyPr/>
-                    <a:lstStyle/>
-                    <a:p>
-                      <a:pPr algn="ctr"/>
-                      <a:r>
-                        <a:rPr sz="900">
-                          <a:solidFill>
-                            <a:srgbClr val="1F3864"/>
-                          </a:solidFill>
-                          <a:latin typeface="Calibri"/>
-                        </a:rPr>
-                        <a:t>~$15–40k internal hours to production release</a:t>
-                      </a:r>
-                    </a:p>
-                  </a:txBody>
-                  <a:tcPr>
-                    <a:solidFill>
-                      <a:srgbClr val="FCE4D6"/>
-                    </a:solidFill>
-                  </a:tcPr>
-                </a:tc>
-                <a:tc>
-                  <a:txBody>
-                    <a:bodyPr/>
-                    <a:lstStyle/>
-                    <a:p>
-                      <a:pPr algn="ctr"/>
-                      <a:r>
-                        <a:rPr sz="900">
-                          <a:solidFill>
-                            <a:srgbClr val="1F3864"/>
-                          </a:solidFill>
-                          <a:latin typeface="Calibri"/>
-                        </a:rPr>
-                        <a:t>~$5–10k PCI fee + ~$5–10k SNP terms</a:t>
-                      </a:r>
-                    </a:p>
-                  </a:txBody>
-                  <a:tcPr>
-                    <a:solidFill>
-                      <a:srgbClr val="E2EFDA"/>
-                    </a:solidFill>
-                  </a:tcPr>
-                </a:tc>
-                <a:tc>
-                  <a:txBody>
-                    <a:bodyPr/>
-                    <a:lstStyle/>
-                    <a:p>
-                      <a:pPr algn="l"/>
-                      <a:r>
-                        <a:rPr sz="900">
-                          <a:solidFill>
-                            <a:srgbClr val="1F3864"/>
-                          </a:solidFill>
-                          <a:latin typeface="Calibri"/>
-                        </a:rPr>
-                        <a:t>~$15–40k internal hours + ~$5–10k SNP terms (the batches are PCI's payment)</a:t>
-                      </a:r>
-                    </a:p>
-                  </a:txBody>
-                  <a:tcPr>
-                    <a:solidFill>
-                      <a:srgbClr val="FFF2CC"/>
-                    </a:solidFill>
-                  </a:tcPr>
-                </a:tc>
-              </a:tr>
-              <a:tr h="377190">
-                <a:tc>
-                  <a:txBody>
-                    <a:bodyPr/>
-                    <a:lstStyle/>
-                    <a:p>
-                      <a:pPr algn="l"/>
-                      <a:r>
-                        <a:rPr sz="900" b="1">
-                          <a:solidFill>
-                            <a:srgbClr val="1F3864"/>
-                          </a:solidFill>
-                          <a:latin typeface="Calibri"/>
-                        </a:rPr>
-                        <a:t>What it buys</a:t>
-                      </a:r>
-                    </a:p>
-                  </a:txBody>
-                  <a:tcPr>
-                    <a:solidFill>
-                      <a:srgbClr val="FFFFFF"/>
-                    </a:solidFill>
-                  </a:tcPr>
-                </a:tc>
-                <a:tc>
-                  <a:txBody>
-                    <a:bodyPr/>
-                    <a:lstStyle/>
-                    <a:p>
-                      <a:pPr algn="ctr"/>
-                      <a:r>
-                        <a:rPr sz="900">
-                          <a:solidFill>
-                            <a:srgbClr val="1F3864"/>
-                          </a:solidFill>
-                          <a:latin typeface="Calibri"/>
-                        </a:rPr>
-                        <a:t>A practiced second source; weeks to recover if the ramp is confirmed</a:t>
-                      </a:r>
-                    </a:p>
-                  </a:txBody>
-                  <a:tcPr>
-                    <a:solidFill>
-                      <a:srgbClr val="FCE4D6"/>
-                    </a:solidFill>
-                  </a:tcPr>
-                </a:tc>
-                <a:tc>
-                  <a:txBody>
-                    <a:bodyPr/>
-                    <a:lstStyle/>
-                    <a:p>
-                      <a:pPr algn="ctr"/>
-                      <a:r>
-                        <a:rPr sz="900">
-                          <a:solidFill>
-                            <a:srgbClr val="1F3864"/>
-                          </a:solidFill>
-                          <a:latin typeface="Calibri"/>
-                        </a:rPr>
-                        <a:t>Deeper partnership; cold start ~3–6 months (decays after ~12 idle)</a:t>
-                      </a:r>
-                    </a:p>
-                  </a:txBody>
-                  <a:tcPr>
-                    <a:solidFill>
-                      <a:srgbClr val="E2EFDA"/>
-                    </a:solidFill>
-                  </a:tcPr>
-                </a:tc>
-                <a:tc>
-                  <a:txBody>
-                    <a:bodyPr/>
-                    <a:lstStyle/>
-                    <a:p>
-                      <a:pPr algn="l"/>
-                      <a:r>
-                        <a:rPr sz="900">
-                          <a:solidFill>
-                            <a:srgbClr val="1F3864"/>
-                          </a:solidFill>
-                          <a:latin typeface="Calibri"/>
-                        </a:rPr>
-                        <a:t>Option 2 + production scale proven, a qualification that never goes stale, and a batch price with no volume string attached; restart weeks to months</a:t>
-                      </a:r>
-                    </a:p>
-                  </a:txBody>
-                  <a:tcPr>
-                    <a:solidFill>
-                      <a:srgbClr val="FFF2CC"/>
-                    </a:solidFill>
-                  </a:tcPr>
-                </a:tc>
-              </a:tr>
-              <a:tr h="377190">
-                <a:tc>
-                  <a:txBody>
-                    <a:bodyPr/>
-                    <a:lstStyle/>
-                    <a:p>
-                      <a:pPr algn="l"/>
-                      <a:r>
-                        <a:rPr sz="900" b="1">
-                          <a:solidFill>
-                            <a:srgbClr val="1F3864"/>
-                          </a:solidFill>
-                          <a:latin typeface="Calibri"/>
-                        </a:rPr>
-                        <a:t>SNP Inc. sees</a:t>
-                      </a:r>
-                    </a:p>
-                  </a:txBody>
-                  <a:tcPr>
-                    <a:solidFill>
-                      <a:srgbClr val="FFFFFF"/>
-                    </a:solidFill>
-                  </a:tcPr>
-                </a:tc>
-                <a:tc>
-                  <a:txBody>
-                    <a:bodyPr/>
-                    <a:lstStyle/>
-                    <a:p>
-                      <a:pPr algn="ctr"/>
-                      <a:r>
-                        <a:rPr sz="900">
-                          <a:solidFill>
-                            <a:srgbClr val="1F3864"/>
-                          </a:solidFill>
-                          <a:latin typeface="Calibri"/>
-                        </a:rPr>
-                        <a:t>A third less volume; strain at the wrong moment</a:t>
-                      </a:r>
-                    </a:p>
-                  </a:txBody>
-                  <a:tcPr>
-                    <a:solidFill>
-                      <a:srgbClr val="FCE4D6"/>
-                    </a:solidFill>
-                  </a:tcPr>
-                </a:tc>
-                <a:tc>
-                  <a:txBody>
-                    <a:bodyPr/>
-                    <a:lstStyle/>
-                    <a:p>
-                      <a:pPr algn="ctr"/>
-                      <a:r>
-                        <a:rPr sz="900">
-                          <a:solidFill>
-                            <a:srgbClr val="1F3864"/>
-                          </a:solidFill>
-                          <a:latin typeface="Calibri"/>
-                        </a:rPr>
-                        <a:t>A strengthened partner</a:t>
-                      </a:r>
-                    </a:p>
-                  </a:txBody>
-                  <a:tcPr>
-                    <a:solidFill>
-                      <a:srgbClr val="E2EFDA"/>
-                    </a:solidFill>
-                  </a:tcPr>
-                </a:tc>
-                <a:tc>
-                  <a:txBody>
-                    <a:bodyPr/>
-                    <a:lstStyle/>
-                    <a:p>
-                      <a:pPr algn="l"/>
-                      <a:r>
-                        <a:rPr sz="900">
-                          <a:solidFill>
-                            <a:srgbClr val="1F3864"/>
-                          </a:solidFill>
-                          <a:latin typeface="Calibri"/>
-                        </a:rPr>
-                        <a:t>1–2 pre-announced 12-day pauses a year (3–7%) — or none, with a rolling stock</a:t>
-                      </a:r>
-                    </a:p>
-                  </a:txBody>
-                  <a:tcPr>
-                    <a:solidFill>
-                      <a:srgbClr val="FFF2CC"/>
-                    </a:solidFill>
-                  </a:tcPr>
-                </a:tc>
-              </a:tr>
-              <a:tr h="377190">
-                <a:tc>
-                  <a:txBody>
-                    <a:bodyPr/>
-                    <a:lstStyle/>
-                    <a:p>
-                      <a:pPr algn="l"/>
-                      <a:r>
-                        <a:rPr sz="900" b="1">
-                          <a:solidFill>
-                            <a:srgbClr val="1F3864"/>
-                          </a:solidFill>
-                          <a:latin typeface="Calibri"/>
-                        </a:rPr>
-                        <a:t>PCI sees</a:t>
-                      </a:r>
-                    </a:p>
-                  </a:txBody>
-                  <a:tcPr>
-                    <a:solidFill>
-                      <a:srgbClr val="FFFFFF"/>
-                    </a:solidFill>
-                  </a:tcPr>
-                </a:tc>
-                <a:tc>
-                  <a:txBody>
-                    <a:bodyPr/>
-                    <a:lstStyle/>
-                    <a:p>
-                      <a:pPr algn="ctr"/>
-                      <a:r>
-                        <a:rPr sz="900">
-                          <a:solidFill>
-                            <a:srgbClr val="1F3864"/>
-                          </a:solidFill>
-                          <a:latin typeface="Calibri"/>
-                        </a:rPr>
-                        <a:t>A customer</a:t>
-                      </a:r>
-                    </a:p>
-                  </a:txBody>
-                  <a:tcPr>
-                    <a:solidFill>
-                      <a:srgbClr val="FCE4D6"/>
-                    </a:solidFill>
-                  </a:tcPr>
-                </a:tc>
-                <a:tc>
-                  <a:txBody>
-                    <a:bodyPr/>
-                    <a:lstStyle/>
-                    <a:p>
-                      <a:pPr algn="ctr"/>
-                      <a:r>
-                        <a:rPr sz="900">
-                          <a:solidFill>
-                            <a:srgbClr val="1F3864"/>
-                          </a:solidFill>
-                          <a:latin typeface="Calibri"/>
-                        </a:rPr>
-                        <a:t>Goodwill at risk unless settled candidly</a:t>
-                      </a:r>
-                    </a:p>
-                  </a:txBody>
-                  <a:tcPr>
-                    <a:solidFill>
-                      <a:srgbClr val="E2EFDA"/>
-                    </a:solidFill>
-                  </a:tcPr>
-                </a:tc>
-                <a:tc>
-                  <a:txBody>
-                    <a:bodyPr/>
-                    <a:lstStyle/>
-                    <a:p>
-                      <a:pPr algn="l"/>
-                      <a:r>
-                        <a:rPr sz="900">
-                          <a:solidFill>
-                            <a:srgbClr val="1F3864"/>
-                          </a:solidFill>
-                          <a:latin typeface="Calibri"/>
-                        </a:rPr>
-                        <a:t>A customer — small, but real, every year</a:t>
-                      </a:r>
-                    </a:p>
-                  </a:txBody>
-                  <a:tcPr>
-                    <a:solidFill>
-                      <a:srgbClr val="FFF2CC"/>
-                    </a:solidFill>
-                  </a:tcPr>
-                </a:tc>
-              </a:tr>
-              <a:tr h="377190">
-                <a:tc>
-                  <a:txBody>
-                    <a:bodyPr/>
-                    <a:lstStyle/>
-                    <a:p>
-                      <a:pPr algn="l"/>
-                      <a:r>
-                        <a:rPr sz="900" b="1">
-                          <a:solidFill>
-                            <a:srgbClr val="1F3864"/>
-                          </a:solidFill>
-                          <a:latin typeface="Calibri"/>
-                        </a:rPr>
-                        <a:t>Residual risk</a:t>
-                      </a:r>
-                    </a:p>
-                  </a:txBody>
-                  <a:tcPr>
-                    <a:solidFill>
-                      <a:srgbClr val="FFFFFF"/>
-                    </a:solidFill>
-                  </a:tcPr>
-                </a:tc>
-                <a:tc>
-                  <a:txBody>
-                    <a:bodyPr/>
-                    <a:lstStyle/>
-                    <a:p>
-                      <a:pPr algn="ctr"/>
-                      <a:r>
-                        <a:rPr sz="900">
-                          <a:solidFill>
-                            <a:srgbClr val="1F3864"/>
-                          </a:solidFill>
-                          <a:latin typeface="Calibri"/>
-                        </a:rPr>
-                        <a:t>~2/3 exposed until ramp; SNP re-price; two-stream quality load</a:t>
-                      </a:r>
-                    </a:p>
-                  </a:txBody>
-                  <a:tcPr>
-                    <a:solidFill>
-                      <a:srgbClr val="FCE4D6"/>
-                    </a:solidFill>
-                  </a:tcPr>
-                </a:tc>
-                <a:tc>
-                  <a:txBody>
-                    <a:bodyPr/>
-                    <a:lstStyle/>
-                    <a:p>
-                      <a:pPr algn="ctr"/>
-                      <a:r>
-                        <a:rPr sz="900">
-                          <a:solidFill>
-                            <a:srgbClr val="1F3864"/>
-                          </a:solidFill>
-                          <a:latin typeface="Calibri"/>
-                        </a:rPr>
-                        <a:t>SNP failure = months</a:t>
-                      </a:r>
-                    </a:p>
-                  </a:txBody>
-                  <a:tcPr>
-                    <a:solidFill>
-                      <a:srgbClr val="E2EFDA"/>
-                    </a:solidFill>
-                  </a:tcPr>
-                </a:tc>
-                <a:tc>
-                  <a:txBody>
-                    <a:bodyPr/>
-                    <a:lstStyle/>
-                    <a:p>
-                      <a:pPr algn="l"/>
-                      <a:r>
-                        <a:rPr sz="900">
-                          <a:solidFill>
-                            <a:srgbClr val="1F3864"/>
-                          </a:solidFill>
-                          <a:latin typeface="Calibri"/>
-                        </a:rPr>
-                        <a:t>No volume term on the $3.50 price so far — get it in writing; ~93–97% exposed until PCI ramps</a:t>
-                      </a:r>
-                    </a:p>
-                  </a:txBody>
-                  <a:tcPr>
-                    <a:solidFill>
-                      <a:srgbClr val="FFF2CC"/>
-                    </a:solidFill>
-                  </a:tcPr>
-                </a:tc>
-              </a:tr>
-            </a:tbl>
-          </a:graphicData>
-        </a:graphic>
-      </p:graphicFrame>
-      <p:sp>
-        <p:nvSpPr>
-          <p:cNvPr id="7" name="Rectangle 6"/>
+      <p:sp>
+        <p:nvSpPr>
+          <p:cNvPr id="6" name="Rectangle 5"/>
+          <p:cNvSpPr/>
+          <p:nvPr/>
+        </p:nvSpPr>
+        <p:spPr>
+          <a:xfrm>
+            <a:off x="8183879" y="1051560"/>
+            <a:ext cx="3429000" cy="4754880"/>
+          </a:xfrm>
+          <a:prstGeom prst="rect">
+            <a:avLst/>
+          </a:prstGeom>
+          <a:solidFill>
+            <a:srgbClr val="F6F8FB"/>
+          </a:solidFill>
+          <a:ln w="9525">
+            <a:solidFill>
+              <a:srgbClr val="4E79A7"/>
+            </a:solidFill>
+          </a:ln>
+          <a:effectLst/>
+        </p:spPr>
+        <p:style>
+          <a:lnRef idx="1">
+            <a:schemeClr val="accent1"/>
+          </a:lnRef>
+          <a:fillRef idx="3">
+            <a:schemeClr val="accent1"/>
+          </a:fillRef>
+          <a:effectRef idx="2">
+            <a:schemeClr val="accent1"/>
+          </a:effectRef>
+          <a:fontRef idx="minor">
+            <a:schemeClr val="lt1"/>
+          </a:fontRef>
+        </p:style>
+        <p:txBody>
+          <a:bodyPr rtlCol="0" anchor="ctr"/>
+          <a:lstStyle/>
+          <a:p>
+            <a:pPr algn="ctr"/>
+          </a:p>
+        </p:txBody>
+      </p:sp>
+      <p:sp>
+        <p:nvSpPr>
+          <p:cNvPr id="7" name="TextBox 6"/>
+          <p:cNvSpPr txBox="1"/>
+          <p:nvPr/>
+        </p:nvSpPr>
+        <p:spPr>
+          <a:xfrm>
+            <a:off x="8321040" y="1143000"/>
+            <a:ext cx="3200400" cy="4617720"/>
+          </a:xfrm>
+          <a:prstGeom prst="rect">
+            <a:avLst/>
+          </a:prstGeom>
+          <a:noFill/>
+        </p:spPr>
+        <p:txBody>
+          <a:bodyPr wrap="square">
+            <a:spAutoFit/>
+          </a:bodyPr>
+          <a:lstStyle/>
+          <a:p>
+            <a:pPr algn="l">
+              <a:spcAft>
+                <a:spcPts val="500"/>
+              </a:spcAft>
+            </a:pPr>
+            <a:r>
+              <a:rPr sz="1300" b="1" i="0">
+                <a:solidFill>
+                  <a:srgbClr val="1F3864"/>
+                </a:solidFill>
+                <a:latin typeface="Calibri"/>
+              </a:rPr>
+              <a:t>Reading the chart</a:t>
+            </a:r>
+          </a:p>
+          <a:p>
+            <a:pPr>
+              <a:spcAft>
+                <a:spcPts val="600"/>
+              </a:spcAft>
+            </a:pPr>
+            <a:r>
+              <a:rPr b="1" sz="1050">
+                <a:solidFill>
+                  <a:srgbClr val="1F3864"/>
+                </a:solidFill>
+                <a:latin typeface="Calibri"/>
+              </a:rPr>
+              <a:t>Left to right  </a:t>
+            </a:r>
+            <a:r>
+              <a:rPr sz="1000">
+                <a:solidFill>
+                  <a:srgbClr val="595959"/>
+                </a:solidFill>
+                <a:latin typeface="Calibri"/>
+              </a:rPr>
+              <a:t>— what the option costs in its first 12 months, all-in: internal hours to finish qualification, payments to suppliers, and the material premium (excludes ~$15k already spent)</a:t>
+            </a:r>
+          </a:p>
+          <a:p>
+            <a:pPr>
+              <a:spcAft>
+                <a:spcPts val="600"/>
+              </a:spcAft>
+            </a:pPr>
+            <a:r>
+              <a:rPr b="1" sz="1050">
+                <a:solidFill>
+                  <a:srgbClr val="1F3864"/>
+                </a:solidFill>
+                <a:latin typeface="Calibri"/>
+              </a:rPr>
+              <a:t>Bottom to top  </a:t>
+            </a:r>
+            <a:r>
+              <a:rPr sz="1000">
+                <a:solidFill>
+                  <a:srgbClr val="595959"/>
+                </a:solidFill>
+                <a:latin typeface="Calibri"/>
+              </a:rPr>
+              <a:t>— how long we would be without PVA if SNP Inc. stopped tomorrow — the time to restart supply elsewhere</a:t>
+            </a:r>
+          </a:p>
+          <a:p>
+            <a:pPr>
+              <a:spcAft>
+                <a:spcPts val="600"/>
+              </a:spcAft>
+            </a:pPr>
+            <a:r>
+              <a:rPr b="1" sz="1050">
+                <a:solidFill>
+                  <a:srgbClr val="1F3864"/>
+                </a:solidFill>
+                <a:latin typeface="Calibri"/>
+              </a:rPr>
+              <a:t>Each box  </a:t>
+            </a:r>
+            <a:r>
+              <a:rPr sz="1000">
+                <a:solidFill>
+                  <a:srgbClr val="595959"/>
+                </a:solidFill>
+                <a:latin typeface="Calibri"/>
+              </a:rPr>
+              <a:t>— the range of one option on both measures; a box lower and further left is better</a:t>
+            </a:r>
+          </a:p>
+          <a:p>
+            <a:pPr>
+              <a:spcAft>
+                <a:spcPts val="600"/>
+              </a:spcAft>
+            </a:pPr>
+            <a:r>
+              <a:rPr b="1" sz="1050">
+                <a:solidFill>
+                  <a:srgbClr val="1F3864"/>
+                </a:solidFill>
+                <a:latin typeface="Calibri"/>
+              </a:rPr>
+              <a:t>Option 2, green  </a:t>
+            </a:r>
+            <a:r>
+              <a:rPr sz="1000">
+                <a:solidFill>
+                  <a:srgbClr val="595959"/>
+                </a:solidFill>
+                <a:latin typeface="Calibri"/>
+              </a:rPr>
+              <a:t>— cheapest; least protected — a cold start of ~3–6 months, longer as the file goes stale</a:t>
+            </a:r>
+          </a:p>
+          <a:p>
+            <a:pPr>
+              <a:spcAft>
+                <a:spcPts val="600"/>
+              </a:spcAft>
+            </a:pPr>
+            <a:r>
+              <a:rPr b="1" sz="1050">
+                <a:solidFill>
+                  <a:srgbClr val="1F3864"/>
+                </a:solidFill>
+                <a:latin typeface="Calibri"/>
+              </a:rPr>
+              <a:t>Option 3, blue  </a:t>
+            </a:r>
+            <a:r>
+              <a:rPr sz="1000">
+                <a:solidFill>
+                  <a:srgbClr val="595959"/>
+                </a:solidFill>
+                <a:latin typeface="Calibri"/>
+              </a:rPr>
+              <a:t>— the middle: a practiced supplier restarts in weeks to a few months, for a fraction of Option 1's cost</a:t>
+            </a:r>
+          </a:p>
+          <a:p>
+            <a:pPr>
+              <a:spcAft>
+                <a:spcPts val="600"/>
+              </a:spcAft>
+            </a:pPr>
+            <a:r>
+              <a:rPr b="1" sz="1050">
+                <a:solidFill>
+                  <a:srgbClr val="1F3864"/>
+                </a:solidFill>
+                <a:latin typeface="Calibri"/>
+              </a:rPr>
+              <a:t>Option 1, amber  </a:t>
+            </a:r>
+            <a:r>
+              <a:rPr sz="1000">
+                <a:solidFill>
+                  <a:srgbClr val="595959"/>
+                </a:solidFill>
+                <a:latin typeface="Calibri"/>
+              </a:rPr>
+              <a:t>— most protected — weeks, if PCI's ramp is confirmed in writing — and most expensive, every year</a:t>
+            </a:r>
+          </a:p>
+          <a:p>
+            <a:pPr>
+              <a:spcAft>
+                <a:spcPts val="600"/>
+              </a:spcAft>
+            </a:pPr>
+            <a:r>
+              <a:rPr b="1" sz="1050">
+                <a:solidFill>
+                  <a:srgbClr val="1F3864"/>
+                </a:solidFill>
+                <a:latin typeface="Calibri"/>
+              </a:rPr>
+              <a:t>Not shown  </a:t>
+            </a:r>
+            <a:r>
+              <a:rPr sz="1000">
+                <a:solidFill>
+                  <a:srgbClr val="595959"/>
+                </a:solidFill>
+                <a:latin typeface="Calibri"/>
+              </a:rPr>
+              <a:t>— what SNP Inc. experiences: 10 pauses a year under Option 1, 1–2 under Option 3, none under Option 2</a:t>
+            </a:r>
+          </a:p>
+        </p:txBody>
+      </p:sp>
+      <p:sp>
+        <p:nvSpPr>
+          <p:cNvPr id="8" name="Rectangle 7"/>
           <p:cNvSpPr/>
           <p:nvPr/>
         </p:nvSpPr>
@@ -11426,7 +12192,7 @@
             <a:avLst/>
           </a:prstGeom>
           <a:solidFill>
-            <a:srgbClr val="2E7D46"/>
+            <a:srgbClr val="1F3864"/>
           </a:solidFill>
           <a:ln>
             <a:noFill/>
@@ -11457,7 +12223,7 @@
       </p:sp>
       <p:sp>
         <p:nvSpPr>
-          <p:cNvPr id="8" name="TextBox 7"/>
+          <p:cNvPr id="9" name="TextBox 8"/>
           <p:cNvSpPr txBox="1"/>
           <p:nvPr/>
         </p:nvSpPr>
@@ -11489,7 +12255,7 @@
                 </a:solidFill>
                 <a:latin typeface="Calibri"/>
               </a:rPr>
-              <a:t>Option 3 keeps a paid, practiced supplier for ~$8–16k a year gross — with one or two pre-announced 12-day pauses for SNP Inc., or none with a small rolling stock.</a:t>
+              <a:t>Option 3 buys most of Option 1's protection for a third of its cost. Option 1 pays every year for weeks of extra speed — worth it only if the outage would cost far more.</a:t>
             </a:r>
           </a:p>
         </p:txBody>

</xml_diff>

<commit_message>
Slides: volumes in drums and percent of demand; 1 drum = 450 lb stated on title, annual chart and options slide
Co-Authored-By: Claude Fable 5.1 <noreply@anthropic.com>
Claude-Session: https://claude.ai/code/session_01LkE2ZRYs3PLyj8XHTsU3i4
</commit_message>
<xml_diff>
--- a/PVA second supplier initiative/PVA_Second_Supplier_Leadership_Deck.pptx
+++ b/PVA second supplier initiative/PVA_Second_Supplier_Leadership_Deck.pptx
@@ -721,7 +721,7 @@
           <a:lstStyle/>
           <a:p>
             <a:r>
-              <a:t>Annual cost side by side. The same 67,600 pounds a year in every bar - 150 drums; SNP at 75 cents keeps whatever the second source does not take. Green alone is today: 50.7 thousand. The three blues are Option 3: one, two or three five-drum batches a year at 3.50 - plus 6, 12 or 19 thousand. Dark amber is a one-third second source at PCI's batch price: 22,500 pounds, 50 drums, 112.6 thousand total, plus 61.9 - 122 percent of today's bill. Light amber is one drum a week at the 6-dollar below-batch price: 52 drums, 23,400 pounds, almost a third - 173.6 thousand, plus 122.9; the small-order version is the expensive one. Red is CJB at one third, for scale: 223 thousand. Internal hours and one-time costs are on the options slide.</a:t>
+              <a:t>Annual cost side by side. The same 150 drums a year in every bar - a drum is 450 pounds of PVA; SNP at 75 cents a pound keeps whatever the second source does not take. Green alone is today: 50.7 thousand. The three blues are Option 3: one, two or three five-drum batches a year at 3.50 - plus 6, 12 or 19 thousand. Dark amber is a one-third second source at PCI's batch price: 50 drums, ten batches, 112.6 thousand total, plus 61.9 - 122 percent of today's bill. Light amber is one drum a week at the 6-dollar below-batch price: 52 drums, 35 percent, almost a third - 173.6 thousand, plus 122.9; the small-order version is the expensive one. Red is CJB at one third, for scale: 223 thousand. Internal hours and one-time costs are on the options slide.</a:t>
             </a:r>
           </a:p>
         </p:txBody>
@@ -791,7 +791,7 @@
           <a:lstStyle/>
           <a:p>
             <a:r>
-              <a:t>How we got here, as a series of events. November last year: Brenntag, a distributor, tried our formula - the viscosity came out above range, unreadable on their viscometer; they stalled and we never received a quote; in March they sent us a resin sample instead. March to April: we screened about 94 US suppliers and reached out to ArroChem, Piedmont and ILC Dover with one hard gate - hold 90 to 95 degrees. May: ArroChem and ILC Dover failed that gate. June 26: CJB cleared it and became the front-runner; APV confirmed heat; we confirmed demand at 1,300 pounds a week. July: Columbus Chemical reached out to us, then told us directly they cannot hold the temperature - eliminated, never quoted. August 4: CJB's quote came in at 8 to 8.50 a pound for toll processing alone - eleven times SNP - and their trial would have cost 6,400 dollars; we declined, so we never corroborated whether they could actually make it. August to September: PCI Manufacturing ran two-plus lab batches and a dilution study, unpaid. September 22: the viscosity root cause - elevated solids - and a locked spec. September 28: spec met, and a real quote of 3.50 a pound per five-drum batch. What it is worth: a cold start is now months, not a year. What it cost: PCI's unpaid engineering, and about 15 thousand of our own hours, sunk. Using it costs 62 thousand a year plus a permanent discipline; walking away costs goodwill; the middle is one or two batches a year.</a:t>
+              <a:t>How we got here, as a series of events. November last year: Brenntag, a distributor, tried our formula - the viscosity came out above range, unreadable on their viscometer; they stalled and we never received a quote; in March they sent us a resin sample instead. March to April: we screened about 94 US suppliers and reached out to ArroChem, Piedmont and ILC Dover with one hard gate - hold 90 to 95 degrees. May: ArroChem and ILC Dover failed that gate. June 26: CJB cleared it and became the front-runner; APV confirmed heat; we confirmed demand at about three drums a week - 150 a year. July: Columbus Chemical reached out to us, then told us directly they cannot hold the temperature - eliminated, never quoted. August 4: CJB's quote came in at 8 to 8.50 a pound for toll processing alone - eleven times SNP - and their trial would have cost 6,400 dollars; we declined, so we never corroborated whether they could actually make it. August to September: PCI Manufacturing ran two-plus lab batches and a dilution study, unpaid. September 22: the viscosity root cause - elevated solids - and a locked spec. September 28: spec met, and a real quote of 3.50 a pound per five-drum batch. What it is worth: a cold start is now months, not a year. What it cost: PCI's unpaid engineering, and about 15 thousand of our own hours, sunk. Using it costs 62 thousand a year plus a permanent discipline; walking away costs goodwill; the middle is one or two batches a year.</a:t>
             </a:r>
           </a:p>
         </p:txBody>
@@ -4324,7 +4324,7 @@
                 </a:solidFill>
                 <a:latin typeface="Calibri"/>
               </a:rPr>
-              <a:t>PVA = polyvinyl alcohol — the liquid we buy in 55-gallon drums from SNP Inc. (Durham, NC) to make our hydrogels. Sole-sourced today.</a:t>
+              <a:t>PVA = polyvinyl alcohol — the liquid we buy in 55-gallon drums (450 lb of PVA each) from SNP Inc. (Durham, NC) to make our hydrogels. Sole-sourced today. Volumes on these slides are in drums and percent of demand.</a:t>
             </a:r>
           </a:p>
           <a:p>
@@ -4577,7 +4577,7 @@
                           </a:solidFill>
                           <a:latin typeface="Calibri"/>
                         </a:rPr>
-                        <a:t>1,300 lb/wk = 67,600 lb ≈ 150 drums/yr; +10%/yr</a:t>
+                        <a:t>150 drums/yr (1 drum = 450 lb) = 1,300 lb/wk = 67,600 lb/yr; +10%/yr</a:t>
                       </a:r>
                     </a:p>
                   </a:txBody>
@@ -4790,7 +4790,7 @@
                           </a:solidFill>
                           <a:latin typeface="Calibri"/>
                         </a:rPr>
-                        <a:t>1/3 = 50 drums/yr = 10 batches = 22,500 lb</a:t>
+                        <a:t>1/3 = 50 drums/yr = 10 batches (22,500 lb)</a:t>
                       </a:r>
                     </a:p>
                   </a:txBody>
@@ -4861,7 +4861,7 @@
                           </a:solidFill>
                           <a:latin typeface="Calibri"/>
                         </a:rPr>
-                        <a:t>1–2 batches/yr = 5–10 drums = 3.3–6.7%; +$6.2–12.4k/yr</a:t>
+                        <a:t>1–2 batches/yr = 5–10 drums = 3–7% of demand; +$6.2–12.4k/yr</a:t>
                       </a:r>
                     </a:p>
                   </a:txBody>
@@ -4884,7 +4884,7 @@
                           </a:solidFill>
                           <a:latin typeface="Calibri"/>
                         </a:rPr>
-                        <a:t>$7.9k gross per batch</a:t>
+                        <a:t>$7.9k gross per batch ($3.50/lb × 2,250 lb)</a:t>
                       </a:r>
                     </a:p>
                   </a:txBody>
@@ -6701,7 +6701,7 @@
                 </a:solidFill>
                 <a:latin typeface="Calibri"/>
               </a:rPr>
-              <a:t>— 67,600 lb = 150 drums in every bar; SNP Inc. at $0.75 keeps whatever the second source does not take</a:t>
+              <a:t>— 150 drums a year in every bar (1 drum = 450 lb of PVA); SNP Inc. at $0.75/lb keeps whatever the second source does not take</a:t>
             </a:r>
           </a:p>
           <a:p>
@@ -6726,7 +6726,7 @@
                 </a:solidFill>
                 <a:latin typeface="Calibri"/>
               </a:rPr>
-              <a:t>— 67,600 × $0.75 = $50.7k</a:t>
+              <a:t>— 150 drums × $337.50 = $50.7k</a:t>
             </a:r>
           </a:p>
           <a:p>
@@ -6751,7 +6751,7 @@
                 </a:solidFill>
                 <a:latin typeface="Calibri"/>
               </a:rPr>
-              <a:t>— 1 / 2 / 3 batches of 5 drums a year at $3.50 (2,250 / 4,500 / 6,750 lb): +$6.2k / +$12.4k / +$18.6k</a:t>
+              <a:t>— 1 / 2 / 3 batches of 5 drums a year (3% / 7% / 10% of demand) at $3.50/lb: +$6.2k / +$12.4k / +$18.6k</a:t>
             </a:r>
           </a:p>
           <a:p>
@@ -6776,7 +6776,7 @@
                 </a:solidFill>
                 <a:latin typeface="Calibri"/>
               </a:rPr>
-              <a:t>— one-third = 22,500 lb (50 drums, 10 batches) × $3.50 = $78.8k → $112.6k; +$61.9k (122%)</a:t>
+              <a:t>— one-third = 50 drums (10 batches, 33%) at $3.50/lb = $78.8k → $112.6k; +$61.9k (122%)</a:t>
             </a:r>
           </a:p>
           <a:p>
@@ -6801,7 +6801,7 @@
                 </a:solidFill>
                 <a:latin typeface="Calibri"/>
               </a:rPr>
-              <a:t>— one drum a week = 52 drums = 23,400 lb, almost one-third, ordered below batch size → $173.6k; +$122.9k (242%)</a:t>
+              <a:t>— one drum a week = 52 drums (35%, almost one-third), ordered below batch size → $173.6k; +$122.9k (242%)</a:t>
             </a:r>
           </a:p>
           <a:p>
@@ -6826,7 +6826,7 @@
                 </a:solidFill>
                 <a:latin typeface="Calibri"/>
               </a:rPr>
-              <a:t>— one-third, for scale → $223.3k; +$172.6k (340%)</a:t>
+              <a:t>— one-third = 50 drums, for scale → $223.3k; +$172.6k (340%)</a:t>
             </a:r>
           </a:p>
           <a:p>
@@ -7703,7 +7703,7 @@
                 </a:solidFill>
                 <a:latin typeface="Calibri"/>
               </a:rPr>
-              <a:t>Front-runner. APV Engineered Coatings confirms heat. Demand confirmed: 1,300 lb/week</a:t>
+              <a:t>Front-runner. APV Engineered Coatings confirms heat. Demand confirmed: ~3 drums a week</a:t>
             </a:r>
           </a:p>
         </p:txBody>
@@ -10591,7 +10591,7 @@
                 </a:solidFill>
                 <a:latin typeface="Calibri"/>
               </a:rPr>
-              <a:t>22,500 lb · 50 drums (33%)</a:t>
+              <a:t>50 drums (33% of demand)</a:t>
             </a:r>
           </a:p>
           <a:p>
@@ -11118,7 +11118,7 @@
                 </a:solidFill>
                 <a:latin typeface="Calibri"/>
               </a:rPr>
-              <a:t>2,250–4,500 lb · 5–10 drums (3–7%)</a:t>
+              <a:t>5–10 drums (3–7% of demand)</a:t>
             </a:r>
           </a:p>
           <a:p>
@@ -11665,7 +11665,7 @@
                 </a:solidFill>
                 <a:latin typeface="Calibri"/>
               </a:rPr>
-              <a:t>Block rotation: PCI drums land ~4 days old and expire on day 18, so a 5-drum batch is used at full rate in one ~12-day block. Costs exclude ~$15k of internal hours already spent; ranges cover internal hours, supplier payments and material premium.</a:t>
+              <a:t>Demand: 150 drums a year (1 drum = 450 lb of PVA), ~3 drums a week. Block rotation: PCI drums land ~4 days old and expire on day 18, so a 5-drum batch is used at full rate in one ~12-day block. Costs exclude ~$15k of internal hours already spent.</a:t>
             </a:r>
           </a:p>
         </p:txBody>

</xml_diff>

<commit_message>
Cost against protection + year at a glance: total yearly PVA cost (material at both suppliers + internal hours + supplier payments), not the increment
Co-Authored-By: Claude Fable 5.1 <noreply@anthropic.com>
Claude-Session: https://claude.ai/code/session_01LkE2ZRYs3PLyj8XHTsU3i4
</commit_message>
<xml_diff>
--- a/PVA second supplier initiative/PVA_Second_Supplier_Leadership_Deck.pptx
+++ b/PVA second supplier initiative/PVA_Second_Supplier_Leadership_Deck.pptx
@@ -861,7 +861,7 @@
           <a:lstStyle/>
           <a:p>
             <a:r>
-              <a:t>Three options on one page: what each costs, how the year runs, what each supplier sees. The strips are the year, week by week: green is SNP material, colored blocks are PCI batches - each five-drum batch is about twelve days at full rate, because the drums land about four days old and the eighteen-day life is counted from manufacture, so a batch is used in one block. Option 1: ten blocks a year, one every five weeks - SNP sees ten pauses, or a level cadence if we carry about three drums of rolling stock; 80 to 110 thousand in the first twelve months, 65 to 70 a year after; recovery in weeks only if PCI confirms the ramp in writing. Option 3: one or two blocks a year, when we choose - 31 to 78 thousand in year one, 9 to 24 after; SNP sees one or two pre-announced pauses or none; restart in weeks to a few months. Option 2: the whole year on SNP, PCI a quoted option - 13 to 32 thousand in year one, 3 to 12 after; if SNP fails, three to six months, and a cold start decays after a year idle. Why not run PCI alongside SNP at a third of rate instead of blocks? A batch would last thirty-six days - twice the life; even at two-thirds it takes eighteen. A validated twenty-one-day life gives margin; a thirty-day life still needs PCI at about half of rate. For us, two suppliers means one spec and one viscometer method, freeze-protected freight, a written failover with SNP's lead time, PCI's residual-film issue closed before any production batch, and two quality agreements. Costs exclude the fifteen thousand of internal hours already spent.</a:t>
+              <a:t>Three options on one page: what each costs, how the year runs, what each supplier sees. The strips are the year, week by week: green is SNP material, colored blocks are PCI batches - each five-drum batch is about twelve days at full rate, because the drums land about four days old and the eighteen-day life is counted from manufacture, so a batch is used in one block. Option 1: ten blocks a year, one every five weeks - SNP sees ten pauses, or a level cadence if we carry about three drums of rolling stock; a total PVA bill of 131 to 161 thousand in the first twelve months, 116 to 121 a year after; recovery in weeks only if PCI confirms the ramp in writing. Option 3: one or two blocks a year, when we choose - 80 to 125 thousand total in year one, 60 to 75 after; SNP sees one or two pre-announced pauses or none; restart in weeks to a few months. Option 2: the whole year on SNP, PCI a quoted option - 64 to 83 thousand total in year one, 54 to 63 after; today's material bill alone is 50.7; if SNP fails, three to six months, and a cold start decays after a year idle. Why not run PCI alongside SNP at a third of rate instead of blocks? A batch would last thirty-six days - twice the life; even at two-thirds it takes eighteen. A validated twenty-one-day life gives margin; a thirty-day life still needs PCI at about half of rate. For us, two suppliers means one spec and one viscometer method, freeze-protected freight, a written failover with SNP's lead time, PCI's residual-film issue closed before any production batch, and two quality agreements. Costs exclude the fifteen thousand of internal hours already spent.</a:t>
             </a:r>
           </a:p>
         </p:txBody>
@@ -931,7 +931,7 @@
           <a:lstStyle/>
           <a:p>
             <a:r>
-              <a:t>Cost against protection. Left to right is what each option costs in its first twelve months, all-in; bottom to top is how long we would be without PVA if SNP stopped tomorrow. Each box is the range of one option. Green, Option 2, is the cheapest and the least protected: a cold start of three to six months, and longer as the file goes stale. Blue, Option 3, sits in the middle: a practiced supplier restarts in weeks to a few months for a third of Option 1's cost. Amber, Option 1, is the most protected - weeks, if PCI confirms the ramp in writing - and the most expensive, every year. The chart does not show what SNP experiences: ten pauses a year under Option 1, one or two under Option 3, none under Option 2. The question for Finance is whether the extra weeks of speed under Option 1 are worth about 62 thousand a year.</a:t>
+              <a:t>Cost against protection. Left to right is the total PVA bill for each option in its first twelve months - material at both suppliers, internal hours and supplier payments; today's material-only bill of 50.7 thousand is the grey line; bottom to top is how long we would be without PVA if SNP stopped tomorrow. Each box is the range of one option. Green, Option 2, 64 to 83 thousand, is the cheapest and the least protected: a cold start of three to six months, and longer as the file goes stale. Blue, Option 3, 80 to 125 thousand, sits in the middle: a practiced supplier restarts in weeks to a few months, about fifty thousand a year less than Option 1. Amber, Option 1, 131 to 161 thousand, is the most protected - weeks, if PCI confirms the ramp in writing - and the most expensive, every year. The chart does not show what SNP experiences: ten pauses a year under Option 1, one or two under Option 3, none under Option 2. The question for Finance is whether the extra weeks of speed under Option 1 are worth about 62 thousand a year.</a:t>
             </a:r>
           </a:p>
         </p:txBody>
@@ -10532,7 +10532,7 @@
                 </a:solidFill>
                 <a:latin typeface="Calibri"/>
               </a:rPr>
-              <a:t>First 12 months, all-in  </a:t>
+              <a:t>Total PVA cost, first 12 months  </a:t>
             </a:r>
             <a:r>
               <a:rPr sz="900" b="1">
@@ -10541,7 +10541,7 @@
                 </a:solidFill>
                 <a:latin typeface="Calibri"/>
               </a:rPr>
-              <a:t>$80–110k</a:t>
+              <a:t>$131–161k</a:t>
             </a:r>
           </a:p>
           <a:p>
@@ -10566,7 +10566,7 @@
                 </a:solidFill>
                 <a:latin typeface="Calibri"/>
               </a:rPr>
-              <a:t>$65–70k</a:t>
+              <a:t>$116–121k</a:t>
             </a:r>
           </a:p>
           <a:p>
@@ -11059,7 +11059,7 @@
                 </a:solidFill>
                 <a:latin typeface="Calibri"/>
               </a:rPr>
-              <a:t>First 12 months, all-in  </a:t>
+              <a:t>Total PVA cost, first 12 months  </a:t>
             </a:r>
             <a:r>
               <a:rPr sz="900" b="1">
@@ -11068,7 +11068,7 @@
                 </a:solidFill>
                 <a:latin typeface="Calibri"/>
               </a:rPr>
-              <a:t>$31–78k</a:t>
+              <a:t>$80–125k</a:t>
             </a:r>
           </a:p>
           <a:p>
@@ -11093,7 +11093,7 @@
                 </a:solidFill>
                 <a:latin typeface="Calibri"/>
               </a:rPr>
-              <a:t>$9–24k</a:t>
+              <a:t>$60–75k</a:t>
             </a:r>
           </a:p>
           <a:p>
@@ -11517,7 +11517,7 @@
                 </a:solidFill>
                 <a:latin typeface="Calibri"/>
               </a:rPr>
-              <a:t>First 12 months, all-in  </a:t>
+              <a:t>Total PVA cost, first 12 months  </a:t>
             </a:r>
             <a:r>
               <a:rPr sz="900" b="1">
@@ -11526,7 +11526,7 @@
                 </a:solidFill>
                 <a:latin typeface="Calibri"/>
               </a:rPr>
-              <a:t>$13–32k</a:t>
+              <a:t>$64–83k</a:t>
             </a:r>
           </a:p>
           <a:p>
@@ -11551,7 +11551,7 @@
                 </a:solidFill>
                 <a:latin typeface="Calibri"/>
               </a:rPr>
-              <a:t>$3–12k</a:t>
+              <a:t>$54–63k</a:t>
             </a:r>
           </a:p>
           <a:p>
@@ -11665,7 +11665,7 @@
                 </a:solidFill>
                 <a:latin typeface="Calibri"/>
               </a:rPr>
-              <a:t>Demand: 150 drums a year (1 drum = 450 lb of PVA), ~3 drums a week. Block rotation: PCI drums land ~4 days old and expire on day 18, so a 5-drum batch is used at full rate in one ~12-day block. Costs exclude ~$15k of internal hours already spent.</a:t>
+              <a:t>Demand: 150 drums a year (1 drum = 450 lb of PVA), ~3 drums a week. Block rotation: PCI drums land ~4 days old and expire on day 18, so a 5-drum batch is used at full rate in one ~12-day block. Totals = material at both suppliers + internal hours + supplier payments (today's material bill alone is $50.7k; ~$15k already spent is excluded).</a:t>
             </a:r>
           </a:p>
         </p:txBody>
@@ -11748,7 +11748,7 @@
                 </a:solidFill>
                 <a:latin typeface="Calibri"/>
               </a:rPr>
-              <a:t>Option 3 keeps a paid, practiced supplier for ~$8–16k a year gross, with one or two pre-announced pauses for SNP Inc. — Option 1 costs ~$62k a year more and changes SNP's year.</a:t>
+              <a:t>Option 3 keeps a paid, practiced supplier for a total PVA bill of ~$60–75k a year, with one or two pre-announced pauses for SNP Inc. — Option 1 runs ~$116–121k a year and changes SNP's year.</a:t>
             </a:r>
           </a:p>
         </p:txBody>
@@ -12022,7 +12022,7 @@
                 </a:solidFill>
                 <a:latin typeface="Calibri"/>
               </a:rPr>
-              <a:t>— what the option costs in its first 12 months, all-in: internal hours to finish qualification, payments to suppliers, and the material premium (excludes ~$15k already spent)</a:t>
+              <a:t>— the total PVA cost in the first 12 months: material at both suppliers, internal hours to finish qualification, payments to suppliers. Today's material bill alone is $50.7k (grey line); ~$15k already spent is excluded</a:t>
             </a:r>
           </a:p>
           <a:p>
@@ -12097,7 +12097,7 @@
                 </a:solidFill>
                 <a:latin typeface="Calibri"/>
               </a:rPr>
-              <a:t>— cheapest; least protected — a cold start of ~3–6 months, longer as the file goes stale</a:t>
+              <a:t>— $64–83k; least protected — a cold start of ~3–6 months, longer as the file goes stale</a:t>
             </a:r>
           </a:p>
           <a:p>
@@ -12122,7 +12122,7 @@
                 </a:solidFill>
                 <a:latin typeface="Calibri"/>
               </a:rPr>
-              <a:t>— the middle: a practiced supplier restarts in weeks to a few months, for a fraction of Option 1's cost</a:t>
+              <a:t>— $80–125k; a practiced supplier restarts in weeks to a few months — about $50k a year less than Option 1</a:t>
             </a:r>
           </a:p>
           <a:p>
@@ -12147,7 +12147,7 @@
                 </a:solidFill>
                 <a:latin typeface="Calibri"/>
               </a:rPr>
-              <a:t>— most protected — weeks, if PCI's ramp is confirmed in writing — and most expensive, every year</a:t>
+              <a:t>— $131–161k; most protected — weeks, if PCI's ramp is confirmed in writing — and ~$116–121k every year after</a:t>
             </a:r>
           </a:p>
           <a:p>
@@ -12255,7 +12255,7 @@
                 </a:solidFill>
                 <a:latin typeface="Calibri"/>
               </a:rPr>
-              <a:t>Option 3 buys most of Option 1's protection for a third of its cost. Option 1 pays every year for weeks of extra speed — worth it only if the outage would cost far more.</a:t>
+              <a:t>Option 3 buys most of Option 1's protection for ~$50k a year less. Option 1 pays every year for weeks of extra speed — worth it only if the outage would cost far more.</a:t>
             </a:r>
           </a:p>
         </p:txBody>

</xml_diff>

<commit_message>
Options slides: shorter labels so titles and totals do not clip
Co-Authored-By: Claude Fable 5.1 <noreply@anthropic.com>
Claude-Session: https://claude.ai/code/session_01LkE2ZRYs3PLyj8XHTsU3i4
</commit_message>
<xml_diff>
--- a/PVA second supplier initiative/PVA_Second_Supplier_Leadership_Deck.pptx
+++ b/PVA second supplier initiative/PVA_Second_Supplier_Leadership_Deck.pptx
@@ -10532,7 +10532,7 @@
                 </a:solidFill>
                 <a:latin typeface="Calibri"/>
               </a:rPr>
-              <a:t>Total PVA cost, first 12 months  </a:t>
+              <a:t>Total, first 12 months  </a:t>
             </a:r>
             <a:r>
               <a:rPr sz="900" b="1">
@@ -11059,7 +11059,7 @@
                 </a:solidFill>
                 <a:latin typeface="Calibri"/>
               </a:rPr>
-              <a:t>Total PVA cost, first 12 months  </a:t>
+              <a:t>Total, first 12 months  </a:t>
             </a:r>
             <a:r>
               <a:rPr sz="900" b="1">
@@ -11517,7 +11517,7 @@
                 </a:solidFill>
                 <a:latin typeface="Calibri"/>
               </a:rPr>
-              <a:t>Total PVA cost, first 12 months  </a:t>
+              <a:t>Total, first 12 months  </a:t>
             </a:r>
             <a:r>
               <a:rPr sz="900" b="1">

</xml_diff>

<commit_message>
Chronology corrections: ArroChem and Columbus right kind of company but no heating capacity; APV estimated >= $3/lb (unconfirmed); 22 Sep = test results, not a root-cause finding
Co-Authored-By: Claude Fable 5.1 <noreply@anthropic.com>
Claude-Session: https://claude.ai/code/session_01LkE2ZRYs3PLyj8XHTsU3i4
</commit_message>
<xml_diff>
--- a/PVA second supplier initiative/PVA_Second_Supplier_Leadership_Deck.pptx
+++ b/PVA second supplier initiative/PVA_Second_Supplier_Leadership_Deck.pptx
@@ -791,7 +791,7 @@
           <a:lstStyle/>
           <a:p>
             <a:r>
-              <a:t>How we got here, as a series of events. November last year: Brenntag, a distributor, tried our formula - the viscosity came out above range, unreadable on their viscometer; they stalled and we never received a quote; in March they sent us a resin sample instead. March to April: we screened about 94 US suppliers and reached out to ArroChem, Piedmont and ILC Dover with one hard gate - hold 90 to 95 degrees. May: ArroChem and ILC Dover failed that gate. June 26: CJB cleared it and became the front-runner; APV confirmed heat; we confirmed demand at about three drums a week - 150 a year. July: Columbus Chemical reached out to us, then told us directly they cannot hold the temperature - eliminated, never quoted. August 4: CJB's quote came in at 8 to 8.50 a pound for toll processing alone - eleven times SNP - and their trial would have cost 6,400 dollars; we declined, so we never corroborated whether they could actually make it. August to September: PCI Manufacturing ran two-plus lab batches and a dilution study, unpaid. September 22: the viscosity root cause - elevated solids - and a locked spec. September 28: spec met, and a real quote of 3.50 a pound per five-drum batch. What it is worth: a cold start is now months, not a year. What it cost: PCI's unpaid engineering, and about 15 thousand of our own hours, sunk. Using it costs 62 thousand a year plus a permanent discipline; walking away costs goodwill; the middle is one or two batches a year.</a:t>
+              <a:t>How we got here, as a series of events. November last year: Brenntag, a distributor, tried our formula - the viscosity came out above range, unreadable on their viscometer; they stalled and we never received a quote; in March they sent us a resin sample instead. March to April: we screened about 94 US suppliers and reached out to ArroChem, Piedmont and ILC Dover with one hard gate - hold 90 to 95 degrees. May: ArroChem - the right kind of company - could not get past 90 degrees, and ILC Dover could not reach it either. June 26: CJB cleared it and became the front-runner; APV confirmed heat but, on our call, called a dollar fifty a pound too cheap for our volume - so we estimate APV at three dollars or more, never confirmed; we confirmed demand at about three drums a week - 150 a year. July: Columbus Chemical, also the right kind of company, reached out to us and then told us directly they cannot hold the temperature - eliminated, never quoted. August 4: CJB's quote came in at 8 to 8.50 a pound for toll processing alone - eleven times SNP - and their trial would have cost 6,400 dollars; we declined, so we never corroborated whether they could actually make it. August to September: PCI Manufacturing ran two-plus lab batches and a dilution study, unpaid. September 22: PCI's test results - the viscosity was brought on target within the test by adjusting solids and water - and the spec was agreed. September 28: spec met, and a real quote of 3.50 a pound per five-drum batch. What it is worth: a cold start is now months, not a year. What it cost: PCI's unpaid engineering, and about 15 thousand of our own hours, sunk. Using it costs 62 thousand a year plus a permanent discipline; walking away costs goodwill; the middle is one or two batches a year.</a:t>
             </a:r>
           </a:p>
         </p:txBody>
@@ -5418,7 +5418,7 @@
                 </a:solidFill>
                 <a:latin typeface="Calibri"/>
               </a:rPr>
-              <a:t>— Mount Holly, NC — 85 °C ceiling</a:t>
+              <a:t>— Mount Holly, NC — right kind of company; could not get past 90 °C</a:t>
             </a:r>
           </a:p>
           <a:p>
@@ -5468,7 +5468,7 @@
                 </a:solidFill>
                 <a:latin typeface="Calibri"/>
               </a:rPr>
-              <a:t>— Columbus, WI — could not hold temperature</a:t>
+              <a:t>— Columbus, WI — right kind of company; could not hold 90–95 °C; never quoted</a:t>
             </a:r>
           </a:p>
           <a:p>
@@ -5543,7 +5543,7 @@
                 </a:solidFill>
                 <a:latin typeface="Calibri"/>
               </a:rPr>
-              <a:t>— Akron, OH — reserve</a:t>
+              <a:t>— Akron, OH — heat confirmed; called $1.50/lb too cheap, likely ≥$3/lb (unconfirmed)</a:t>
             </a:r>
           </a:p>
           <a:p>
@@ -7563,7 +7563,7 @@
                 </a:solidFill>
                 <a:latin typeface="Calibri"/>
               </a:rPr>
-              <a:t>85 °C ceiling; ILC Dover also the wrong kind of company</a:t>
+              <a:t>ArroChem: the right kind of company, but could not get past 90 °C. ILC Dover could not reach it either</a:t>
             </a:r>
           </a:p>
         </p:txBody>
@@ -7703,7 +7703,7 @@
                 </a:solidFill>
                 <a:latin typeface="Calibri"/>
               </a:rPr>
-              <a:t>Front-runner. APV Engineered Coatings confirms heat. Demand confirmed: ~3 drums a week</a:t>
+              <a:t>Front-runner. APV Engineered Coatings confirms heat, but on our call called $1.50/lb too cheap for the volume — likely $3/lb or more, never confirmed. Demand: ~3 drums a week</a:t>
             </a:r>
           </a:p>
         </p:txBody>
@@ -7843,7 +7843,7 @@
                 </a:solidFill>
                 <a:latin typeface="Calibri"/>
               </a:rPr>
-              <a:t>Reached out to us, then told us directly they cannot hold 90–95 °C. Eliminated; never quoted</a:t>
+              <a:t>The right kind of company; reached out to us, then told us directly they cannot hold 90–95 °C. Eliminated; never quoted</a:t>
             </a:r>
           </a:p>
         </p:txBody>
@@ -8224,7 +8224,7 @@
                 </a:solidFill>
                 <a:latin typeface="Calibri"/>
               </a:rPr>
-              <a:t>Viscosity root cause found</a:t>
+              <a:t>PCI test results</a:t>
             </a:r>
           </a:p>
         </p:txBody>
@@ -8263,7 +8263,7 @@
                 </a:solidFill>
                 <a:latin typeface="Calibri"/>
               </a:rPr>
-              <a:t>Elevated solids from water loss. Spec locked: 11% / 900–1,100 cP</a:t>
+              <a:t>Viscosity brought on target within the test (solids / water adjustment). Spec agreed: 11% / 900–1,100 cP</a:t>
             </a:r>
           </a:p>
         </p:txBody>
@@ -8502,7 +8502,7 @@
                 </a:solidFill>
                 <a:latin typeface="Calibri"/>
               </a:rPr>
-              <a:t>•  The cook, the viscosity control, the spec — met on PCI's instrument</a:t>
+              <a:t>•  The cook, the viscosity brought on target within the test, the spec — met on PCI's instrument</a:t>
             </a:r>
           </a:p>
           <a:p>

</xml_diff>

<commit_message>
Chronology slide: shorter event text so nothing spills into the panels
Co-Authored-By: Claude Fable 5.1 <noreply@anthropic.com>
Claude-Session: https://claude.ai/code/session_01LkE2ZRYs3PLyj8XHTsU3i4
</commit_message>
<xml_diff>
--- a/PVA second supplier initiative/PVA_Second_Supplier_Leadership_Deck.pptx
+++ b/PVA second supplier initiative/PVA_Second_Supplier_Leadership_Deck.pptx
@@ -7563,7 +7563,7 @@
                 </a:solidFill>
                 <a:latin typeface="Calibri"/>
               </a:rPr>
-              <a:t>ArroChem: the right kind of company, but could not get past 90 °C. ILC Dover could not reach it either</a:t>
+              <a:t>ArroChem: right kind of company, could not get past 90 °C. ILC Dover could not reach it either</a:t>
             </a:r>
           </a:p>
         </p:txBody>
@@ -7703,7 +7703,7 @@
                 </a:solidFill>
                 <a:latin typeface="Calibri"/>
               </a:rPr>
-              <a:t>Front-runner. APV Engineered Coatings confirms heat, but on our call called $1.50/lb too cheap for the volume — likely $3/lb or more, never confirmed. Demand: ~3 drums a week</a:t>
+              <a:t>Front-runner. APV Engineered Coatings confirms heat but calls $1.50/lb too cheap — likely ≥$3/lb, unconfirmed. Demand: ~3 drums/week</a:t>
             </a:r>
           </a:p>
         </p:txBody>
@@ -7843,7 +7843,7 @@
                 </a:solidFill>
                 <a:latin typeface="Calibri"/>
               </a:rPr>
-              <a:t>The right kind of company; reached out to us, then told us directly they cannot hold 90–95 °C. Eliminated; never quoted</a:t>
+              <a:t>Right kind of company; reached out to us, then said they cannot hold 90–95 °C. Eliminated; never quoted</a:t>
             </a:r>
           </a:p>
         </p:txBody>

</xml_diff>

<commit_message>
Option slides: PVA purchases only (no soft-cost ranges); drums and money per supplier per option; Option 3 at 1-3 batches
Co-Authored-By: Claude Fable 5.1 <noreply@anthropic.com>
Claude-Session: https://claude.ai/code/session_01LkE2ZRYs3PLyj8XHTsU3i4
</commit_message>
<xml_diff>
--- a/PVA second supplier initiative/PVA_Second_Supplier_Leadership_Deck.pptx
+++ b/PVA second supplier initiative/PVA_Second_Supplier_Leadership_Deck.pptx
@@ -861,7 +861,7 @@
           <a:lstStyle/>
           <a:p>
             <a:r>
-              <a:t>Three options on one page: what each costs, how the year runs, what each supplier sees. The strips are the year, week by week: green is SNP material, colored blocks are PCI batches - each five-drum batch is about twelve days at full rate, because the drums land about four days old and the eighteen-day life is counted from manufacture, so a batch is used in one block. Option 1: ten blocks a year, one every five weeks - SNP sees ten pauses, or a level cadence if we carry about three drums of rolling stock; a total PVA bill of 131 to 161 thousand in the first twelve months, 116 to 121 a year after; recovery in weeks only if PCI confirms the ramp in writing. Option 3: one or two blocks a year, when we choose - 80 to 125 thousand total in year one, 60 to 75 after; SNP sees one or two pre-announced pauses or none; restart in weeks to a few months. Option 2: the whole year on SNP, PCI a quoted option - 64 to 83 thousand total in year one, 54 to 63 after; today's material bill alone is 50.7; if SNP fails, three to six months, and a cold start decays after a year idle. Why not run PCI alongside SNP at a third of rate instead of blocks? A batch would last thirty-six days - twice the life; even at two-thirds it takes eighteen. A validated twenty-one-day life gives margin; a thirty-day life still needs PCI at about half of rate. For us, two suppliers means one spec and one viscometer method, freeze-protected freight, a written failover with SNP's lead time, PCI's residual-film issue closed before any production batch, and two quality agreements. Costs exclude the fifteen thousand of internal hours already spent.</a:t>
+              <a:t>Three options on one page: what each costs, how the year runs, what each supplier sees. The strips are the year, week by week: green is SNP material, colored blocks are PCI batches - each five-drum batch is about twelve days at full rate, because the drums land about four days old and the eighteen-day life is counted from manufacture, so a batch is used in one block. Option 1: ten blocks a year, one every five weeks - SNP sees ten pauses, or a level cadence if we carry about three drums of rolling stock; PVA purchases of 112.6 thousand a year, growing with volume; recovery in weeks only if PCI confirms the ramp in writing. Option 3: one or two blocks a year, when we choose - 56.9 thousand with one batch, 63.1 with two, 69.3 with three - SNP keeps 145, 140 or 135 drums; SNP sees one or two pre-announced pauses or none; restart in weeks to a few months. Option 2: the whole year on SNP, PCI a quoted option - 50.7 thousand, what we pay today; if SNP fails, three to six months, and a cold start decays after a year idle. Why not run PCI alongside SNP at a third of rate instead of blocks? A batch would last thirty-six days - twice the life; even at two-thirds it takes eighteen. A validated twenty-one-day life gives margin; a thirty-day life still needs PCI at about half of rate. For us, two suppliers means one spec and one viscometer method, freeze-protected freight, a written failover with SNP's lead time, PCI's residual-film issue closed before any production batch, and two quality agreements. Purchases only: internal hours to finish PCI's qualification - fifteen to forty thousand once, under Options 1 and 3 - are not in these numbers.</a:t>
             </a:r>
           </a:p>
         </p:txBody>
@@ -931,7 +931,7 @@
           <a:lstStyle/>
           <a:p>
             <a:r>
-              <a:t>Cost against protection. Left to right is the total PVA bill for each option in its first twelve months - material at both suppliers, internal hours and supplier payments; today's material-only bill of 50.7 thousand is the grey line; bottom to top is how long we would be without PVA if SNP stopped tomorrow. Each box is the range of one option. Green, Option 2, 64 to 83 thousand, is the cheapest and the least protected: a cold start of three to six months, and longer as the file goes stale. Blue, Option 3, 80 to 125 thousand, sits in the middle: a practiced supplier restarts in weeks to a few months, about fifty thousand a year less than Option 1. Amber, Option 1, 131 to 161 thousand, is the most protected - weeks, if PCI confirms the ramp in writing - and the most expensive, every year. The chart does not show what SNP experiences: ten pauses a year under Option 1, one or two under Option 3, none under Option 2. The question for Finance is whether the extra weeks of speed under Option 1 are worth about 62 thousand a year.</a:t>
+              <a:t>Cost against protection. Left to right is what each option means in PVA purchases for a year - SNP at 75 cents plus PCI at 3.50; today's 50.7 thousand is the grey line; bottom to top is how long we would be without PVA if SNP stopped tomorrow. Each box is the range of one option. Green, Option 2, 50.7 thousand, is the cheapest and the least protected: a cold start of three to six months, and longer as the file goes stale. Blue, Option 3, 57 to 69 thousand for one to three batches, sits in the middle: a practiced supplier restarts in weeks to a few months, about fifty thousand a year less than Option 1. Amber, Option 1, 112.6 thousand, is the most protected - weeks, if PCI confirms the ramp in writing - and the most expensive, every year. The chart does not show what SNP experiences: ten pauses a year under Option 1, one or two under Option 3, none under Option 2. The question for Finance is whether the extra weeks of speed under Option 1 are worth about 62 thousand a year.</a:t>
             </a:r>
           </a:p>
         </p:txBody>
@@ -8796,7 +8796,7 @@
                 </a:solidFill>
                 <a:latin typeface="Calibri"/>
               </a:rPr>
-              <a:t>•  The middle (Option 3): 1–2 batches of 5 drums a year, $7.9k each — a paid, practiced supplier</a:t>
+              <a:t>•  The middle (Option 3): 1–3 batches of 5 drums a year, $7.9k each — a paid, practiced supplier</a:t>
             </a:r>
           </a:p>
         </p:txBody>
@@ -10532,7 +10532,7 @@
                 </a:solidFill>
                 <a:latin typeface="Calibri"/>
               </a:rPr>
-              <a:t>Total, first 12 months  </a:t>
+              <a:t>Drums a year  </a:t>
             </a:r>
             <a:r>
               <a:rPr sz="900" b="1">
@@ -10541,7 +10541,7 @@
                 </a:solidFill>
                 <a:latin typeface="Calibri"/>
               </a:rPr>
-              <a:t>$131–161k</a:t>
+              <a:t>150 = SNP Inc. 100 + PCI 50 (33%)</a:t>
             </a:r>
           </a:p>
           <a:p>
@@ -10557,7 +10557,7 @@
                 </a:solidFill>
                 <a:latin typeface="Calibri"/>
               </a:rPr>
-              <a:t>Each year after  </a:t>
+              <a:t>Money a year  </a:t>
             </a:r>
             <a:r>
               <a:rPr sz="900" b="0">
@@ -10566,32 +10566,7 @@
                 </a:solidFill>
                 <a:latin typeface="Calibri"/>
               </a:rPr>
-              <a:t>$116–121k</a:t>
-            </a:r>
-          </a:p>
-          <a:p>
-            <a:pPr>
-              <a:spcAft>
-                <a:spcPts val="200"/>
-              </a:spcAft>
-            </a:pPr>
-            <a:r>
-              <a:rPr sz="850">
-                <a:solidFill>
-                  <a:srgbClr val="595959"/>
-                </a:solidFill>
-                <a:latin typeface="Calibri"/>
-              </a:rPr>
-              <a:t>Volume to PCI a year  </a:t>
-            </a:r>
-            <a:r>
-              <a:rPr sz="900" b="0">
-                <a:solidFill>
-                  <a:srgbClr val="1F3864"/>
-                </a:solidFill>
-                <a:latin typeface="Calibri"/>
-              </a:rPr>
-              <a:t>50 drums (33% of demand)</a:t>
+              <a:t>$112.6k = SNP Inc. $33.8k + PCI $78.8k</a:t>
             </a:r>
           </a:p>
           <a:p>
@@ -10696,7 +10671,7 @@
                 </a:solidFill>
                 <a:latin typeface="Calibri"/>
               </a:rPr>
-              <a:t>Keep-alive: 1–2 batches a year</a:t>
+              <a:t>Keep-alive: 1–3 batches a year</a:t>
             </a:r>
           </a:p>
           <a:p>
@@ -10769,7 +10744,7 @@
         </p:nvSpPr>
         <p:spPr>
           <a:xfrm>
-            <a:off x="5001642" y="2953512"/>
+            <a:off x="4257596" y="2953512"/>
             <a:ext cx="200065" cy="566928"/>
           </a:xfrm>
           <a:prstGeom prst="rect">
@@ -10813,7 +10788,7 @@
         </p:nvSpPr>
         <p:spPr>
           <a:xfrm>
-            <a:off x="4983354" y="2953512"/>
+            <a:off x="4239308" y="2953512"/>
             <a:ext cx="18288" cy="566928"/>
           </a:xfrm>
           <a:prstGeom prst="rect">
@@ -10857,7 +10832,7 @@
         </p:nvSpPr>
         <p:spPr>
           <a:xfrm>
-            <a:off x="5201708" y="2953512"/>
+            <a:off x="4457662" y="2953512"/>
             <a:ext cx="18288" cy="566928"/>
           </a:xfrm>
           <a:prstGeom prst="rect">
@@ -10901,7 +10876,7 @@
         </p:nvSpPr>
         <p:spPr>
           <a:xfrm>
-            <a:off x="7977826" y="2953512"/>
+            <a:off x="6159047" y="2953512"/>
             <a:ext cx="200065" cy="566928"/>
           </a:xfrm>
           <a:prstGeom prst="rect">
@@ -10945,7 +10920,7 @@
         </p:nvSpPr>
         <p:spPr>
           <a:xfrm>
-            <a:off x="7959538" y="2953512"/>
+            <a:off x="6140759" y="2953512"/>
             <a:ext cx="18288" cy="566928"/>
           </a:xfrm>
           <a:prstGeom prst="rect">
@@ -10989,7 +10964,7 @@
         </p:nvSpPr>
         <p:spPr>
           <a:xfrm>
-            <a:off x="8177892" y="2953512"/>
+            <a:off x="6359113" y="2953512"/>
             <a:ext cx="18288" cy="566928"/>
           </a:xfrm>
           <a:prstGeom prst="rect">
@@ -11027,7 +11002,139 @@
       </p:sp>
       <p:sp>
         <p:nvSpPr>
-          <p:cNvPr id="47" name="TextBox 46"/>
+          <p:cNvPr id="47" name="Rectangle 46"/>
+          <p:cNvSpPr/>
+          <p:nvPr/>
+        </p:nvSpPr>
+        <p:spPr>
+          <a:xfrm>
+            <a:off x="8060498" y="2953512"/>
+            <a:ext cx="200065" cy="566928"/>
+          </a:xfrm>
+          <a:prstGeom prst="rect">
+            <a:avLst/>
+          </a:prstGeom>
+          <a:solidFill>
+            <a:srgbClr val="2F6DB5"/>
+          </a:solidFill>
+          <a:ln>
+            <a:noFill/>
+          </a:ln>
+          <a:effectLst/>
+        </p:spPr>
+        <p:style>
+          <a:lnRef idx="1">
+            <a:schemeClr val="accent1"/>
+          </a:lnRef>
+          <a:fillRef idx="3">
+            <a:schemeClr val="accent1"/>
+          </a:fillRef>
+          <a:effectRef idx="2">
+            <a:schemeClr val="accent1"/>
+          </a:effectRef>
+          <a:fontRef idx="minor">
+            <a:schemeClr val="lt1"/>
+          </a:fontRef>
+        </p:style>
+        <p:txBody>
+          <a:bodyPr rtlCol="0" anchor="ctr"/>
+          <a:lstStyle/>
+          <a:p>
+            <a:pPr algn="ctr"/>
+          </a:p>
+        </p:txBody>
+      </p:sp>
+      <p:sp>
+        <p:nvSpPr>
+          <p:cNvPr id="48" name="Rectangle 47"/>
+          <p:cNvSpPr/>
+          <p:nvPr/>
+        </p:nvSpPr>
+        <p:spPr>
+          <a:xfrm>
+            <a:off x="8042210" y="2953512"/>
+            <a:ext cx="18288" cy="566928"/>
+          </a:xfrm>
+          <a:prstGeom prst="rect">
+            <a:avLst/>
+          </a:prstGeom>
+          <a:solidFill>
+            <a:srgbClr val="FFFFFF"/>
+          </a:solidFill>
+          <a:ln>
+            <a:noFill/>
+          </a:ln>
+          <a:effectLst/>
+        </p:spPr>
+        <p:style>
+          <a:lnRef idx="1">
+            <a:schemeClr val="accent1"/>
+          </a:lnRef>
+          <a:fillRef idx="3">
+            <a:schemeClr val="accent1"/>
+          </a:fillRef>
+          <a:effectRef idx="2">
+            <a:schemeClr val="accent1"/>
+          </a:effectRef>
+          <a:fontRef idx="minor">
+            <a:schemeClr val="lt1"/>
+          </a:fontRef>
+        </p:style>
+        <p:txBody>
+          <a:bodyPr rtlCol="0" anchor="ctr"/>
+          <a:lstStyle/>
+          <a:p>
+            <a:pPr algn="ctr"/>
+          </a:p>
+        </p:txBody>
+      </p:sp>
+      <p:sp>
+        <p:nvSpPr>
+          <p:cNvPr id="49" name="Rectangle 48"/>
+          <p:cNvSpPr/>
+          <p:nvPr/>
+        </p:nvSpPr>
+        <p:spPr>
+          <a:xfrm>
+            <a:off x="8260564" y="2953512"/>
+            <a:ext cx="18288" cy="566928"/>
+          </a:xfrm>
+          <a:prstGeom prst="rect">
+            <a:avLst/>
+          </a:prstGeom>
+          <a:solidFill>
+            <a:srgbClr val="FFFFFF"/>
+          </a:solidFill>
+          <a:ln>
+            <a:noFill/>
+          </a:ln>
+          <a:effectLst/>
+        </p:spPr>
+        <p:style>
+          <a:lnRef idx="1">
+            <a:schemeClr val="accent1"/>
+          </a:lnRef>
+          <a:fillRef idx="3">
+            <a:schemeClr val="accent1"/>
+          </a:fillRef>
+          <a:effectRef idx="2">
+            <a:schemeClr val="accent1"/>
+          </a:effectRef>
+          <a:fontRef idx="minor">
+            <a:schemeClr val="lt1"/>
+          </a:fontRef>
+        </p:style>
+        <p:txBody>
+          <a:bodyPr rtlCol="0" anchor="ctr"/>
+          <a:lstStyle/>
+          <a:p>
+            <a:pPr algn="ctr"/>
+          </a:p>
+        </p:txBody>
+      </p:sp>
+      <p:sp>
+        <p:nvSpPr>
+          <p:cNvPr id="50" name="TextBox 49"/>
           <p:cNvSpPr txBox="1"/>
           <p:nvPr/>
         </p:nvSpPr>
@@ -11059,7 +11166,7 @@
                 </a:solidFill>
                 <a:latin typeface="Calibri"/>
               </a:rPr>
-              <a:t>Total, first 12 months  </a:t>
+              <a:t>Drums a year  </a:t>
             </a:r>
             <a:r>
               <a:rPr sz="900" b="1">
@@ -11068,7 +11175,7 @@
                 </a:solidFill>
                 <a:latin typeface="Calibri"/>
               </a:rPr>
-              <a:t>$80–125k</a:t>
+              <a:t>150 = SNP Inc. 145 / 140 / 135 + PCI 5 / 10 / 15 (1, 2 or 3 batches)</a:t>
             </a:r>
           </a:p>
           <a:p>
@@ -11084,7 +11191,7 @@
                 </a:solidFill>
                 <a:latin typeface="Calibri"/>
               </a:rPr>
-              <a:t>Each year after  </a:t>
+              <a:t>Money a year  </a:t>
             </a:r>
             <a:r>
               <a:rPr sz="900" b="0">
@@ -11093,7 +11200,7 @@
                 </a:solidFill>
                 <a:latin typeface="Calibri"/>
               </a:rPr>
-              <a:t>$60–75k</a:t>
+              <a:t>$56.9k / $63.1k / $69.3k = SNP Inc. $49.0k / $47.3k / $45.6k + PCI $7.9k / $15.8k / $23.6k</a:t>
             </a:r>
           </a:p>
           <a:p>
@@ -11109,7 +11216,7 @@
                 </a:solidFill>
                 <a:latin typeface="Calibri"/>
               </a:rPr>
-              <a:t>Volume to PCI a year  </a:t>
+              <a:t>SNP Inc. sees  </a:t>
             </a:r>
             <a:r>
               <a:rPr sz="900" b="0">
@@ -11118,7 +11225,7 @@
                 </a:solidFill>
                 <a:latin typeface="Calibri"/>
               </a:rPr>
-              <a:t>5–10 drums (3–7% of demand)</a:t>
+              <a:t>1–3 pre-announced pauses, or none</a:t>
             </a:r>
           </a:p>
           <a:p>
@@ -11134,7 +11241,7 @@
                 </a:solidFill>
                 <a:latin typeface="Calibri"/>
               </a:rPr>
-              <a:t>SNP Inc. sees  </a:t>
+              <a:t>If SNP fails, restart in  </a:t>
             </a:r>
             <a:r>
               <a:rPr sz="900" b="0">
@@ -11143,31 +11250,6 @@
                 </a:solidFill>
                 <a:latin typeface="Calibri"/>
               </a:rPr>
-              <a:t>1–2 pre-announced pauses, or none</a:t>
-            </a:r>
-          </a:p>
-          <a:p>
-            <a:pPr>
-              <a:spcAft>
-                <a:spcPts val="200"/>
-              </a:spcAft>
-            </a:pPr>
-            <a:r>
-              <a:rPr sz="850">
-                <a:solidFill>
-                  <a:srgbClr val="595959"/>
-                </a:solidFill>
-                <a:latin typeface="Calibri"/>
-              </a:rPr>
-              <a:t>If SNP fails, restart in  </a:t>
-            </a:r>
-            <a:r>
-              <a:rPr sz="900" b="0">
-                <a:solidFill>
-                  <a:srgbClr val="1F3864"/>
-                </a:solidFill>
-                <a:latin typeface="Calibri"/>
-              </a:rPr>
               <a:t>weeks to a few months</a:t>
             </a:r>
           </a:p>
@@ -11175,7 +11257,7 @@
       </p:sp>
       <p:sp>
         <p:nvSpPr>
-          <p:cNvPr id="48" name="TextBox 47"/>
+          <p:cNvPr id="51" name="TextBox 50"/>
           <p:cNvSpPr txBox="1"/>
           <p:nvPr/>
         </p:nvSpPr>
@@ -11246,7 +11328,7 @@
       </p:sp>
       <p:sp>
         <p:nvSpPr>
-          <p:cNvPr id="49" name="Rectangle 48"/>
+          <p:cNvPr id="52" name="Rectangle 51"/>
           <p:cNvSpPr/>
           <p:nvPr/>
         </p:nvSpPr>
@@ -11290,7 +11372,7 @@
       </p:sp>
       <p:sp>
         <p:nvSpPr>
-          <p:cNvPr id="50" name="TextBox 49"/>
+          <p:cNvPr id="53" name="TextBox 52"/>
           <p:cNvSpPr txBox="1"/>
           <p:nvPr/>
         </p:nvSpPr>
@@ -11329,7 +11411,7 @@
       </p:sp>
       <p:sp>
         <p:nvSpPr>
-          <p:cNvPr id="51" name="TextBox 50"/>
+          <p:cNvPr id="54" name="TextBox 53"/>
           <p:cNvSpPr txBox="1"/>
           <p:nvPr/>
         </p:nvSpPr>
@@ -11368,7 +11450,7 @@
       </p:sp>
       <p:sp>
         <p:nvSpPr>
-          <p:cNvPr id="52" name="TextBox 51"/>
+          <p:cNvPr id="55" name="TextBox 54"/>
           <p:cNvSpPr txBox="1"/>
           <p:nvPr/>
         </p:nvSpPr>
@@ -11407,7 +11489,7 @@
       </p:sp>
       <p:sp>
         <p:nvSpPr>
-          <p:cNvPr id="53" name="TextBox 52"/>
+          <p:cNvPr id="56" name="TextBox 55"/>
           <p:cNvSpPr txBox="1"/>
           <p:nvPr/>
         </p:nvSpPr>
@@ -11446,7 +11528,7 @@
       </p:sp>
       <p:sp>
         <p:nvSpPr>
-          <p:cNvPr id="54" name="TextBox 53"/>
+          <p:cNvPr id="57" name="TextBox 56"/>
           <p:cNvSpPr txBox="1"/>
           <p:nvPr/>
         </p:nvSpPr>
@@ -11485,7 +11567,7 @@
       </p:sp>
       <p:sp>
         <p:nvSpPr>
-          <p:cNvPr id="55" name="TextBox 54"/>
+          <p:cNvPr id="58" name="TextBox 57"/>
           <p:cNvSpPr txBox="1"/>
           <p:nvPr/>
         </p:nvSpPr>
@@ -11517,7 +11599,7 @@
                 </a:solidFill>
                 <a:latin typeface="Calibri"/>
               </a:rPr>
-              <a:t>Total, first 12 months  </a:t>
+              <a:t>Drums a year  </a:t>
             </a:r>
             <a:r>
               <a:rPr sz="900" b="1">
@@ -11526,7 +11608,7 @@
                 </a:solidFill>
                 <a:latin typeface="Calibri"/>
               </a:rPr>
-              <a:t>$64–83k</a:t>
+              <a:t>150 = SNP Inc. 150</a:t>
             </a:r>
           </a:p>
           <a:p>
@@ -11542,7 +11624,7 @@
                 </a:solidFill>
                 <a:latin typeface="Calibri"/>
               </a:rPr>
-              <a:t>Each year after  </a:t>
+              <a:t>Money a year  </a:t>
             </a:r>
             <a:r>
               <a:rPr sz="900" b="0">
@@ -11551,7 +11633,7 @@
                 </a:solidFill>
                 <a:latin typeface="Calibri"/>
               </a:rPr>
-              <a:t>$54–63k</a:t>
+              <a:t>$50.7k = SNP Inc. $50.7k — what we pay today</a:t>
             </a:r>
           </a:p>
           <a:p>
@@ -11567,7 +11649,7 @@
                 </a:solidFill>
                 <a:latin typeface="Calibri"/>
               </a:rPr>
-              <a:t>Volume to PCI a year  </a:t>
+              <a:t>SNP Inc. sees  </a:t>
             </a:r>
             <a:r>
               <a:rPr sz="900" b="0">
@@ -11576,7 +11658,7 @@
                 </a:solidFill>
                 <a:latin typeface="Calibri"/>
               </a:rPr>
-              <a:t>none</a:t>
+              <a:t>a strengthened partner</a:t>
             </a:r>
           </a:p>
           <a:p>
@@ -11592,7 +11674,7 @@
                 </a:solidFill>
                 <a:latin typeface="Calibri"/>
               </a:rPr>
-              <a:t>SNP Inc. sees  </a:t>
+              <a:t>If SNP fails, restart in  </a:t>
             </a:r>
             <a:r>
               <a:rPr sz="900" b="0">
@@ -11601,31 +11683,6 @@
                 </a:solidFill>
                 <a:latin typeface="Calibri"/>
               </a:rPr>
-              <a:t>a strengthened partner</a:t>
-            </a:r>
-          </a:p>
-          <a:p>
-            <a:pPr>
-              <a:spcAft>
-                <a:spcPts val="200"/>
-              </a:spcAft>
-            </a:pPr>
-            <a:r>
-              <a:rPr sz="850">
-                <a:solidFill>
-                  <a:srgbClr val="595959"/>
-                </a:solidFill>
-                <a:latin typeface="Calibri"/>
-              </a:rPr>
-              <a:t>If SNP fails, restart in  </a:t>
-            </a:r>
-            <a:r>
-              <a:rPr sz="900" b="0">
-                <a:solidFill>
-                  <a:srgbClr val="1F3864"/>
-                </a:solidFill>
-                <a:latin typeface="Calibri"/>
-              </a:rPr>
               <a:t>~3–6 months; a cold start decays after ~12 idle</a:t>
             </a:r>
           </a:p>
@@ -11633,7 +11690,7 @@
       </p:sp>
       <p:sp>
         <p:nvSpPr>
-          <p:cNvPr id="56" name="TextBox 55"/>
+          <p:cNvPr id="59" name="TextBox 58"/>
           <p:cNvSpPr txBox="1"/>
           <p:nvPr/>
         </p:nvSpPr>
@@ -11665,14 +11722,14 @@
                 </a:solidFill>
                 <a:latin typeface="Calibri"/>
               </a:rPr>
-              <a:t>Demand: 150 drums a year (1 drum = 450 lb of PVA), ~3 drums a week. Block rotation: PCI drums land ~4 days old and expire on day 18, so a 5-drum batch is used at full rate in one ~12-day block. Totals = material at both suppliers + internal hours + supplier payments (today's material bill alone is $50.7k; ~$15k already spent is excluded).</a:t>
-            </a:r>
-          </a:p>
-        </p:txBody>
-      </p:sp>
-      <p:sp>
-        <p:nvSpPr>
-          <p:cNvPr id="57" name="Rectangle 56"/>
+              <a:t>Demand: 150 drums a year (1 drum = 450 lb of PVA), ~3 drums a week. Block rotation: PCI drums land ~4 days old and expire on day 18, so a 5-drum batch is used at full rate in one ~12-day block. Purchases at today's volume: SNP Inc. $0.75/lb ($337.50 a drum), PCI $3.50/lb ($1,575 a drum); all grow ~10%/yr with volume. Not included: internal hours to finish PCI's qualification (Options 1 and 3, ~$15–40k once).</a:t>
+            </a:r>
+          </a:p>
+        </p:txBody>
+      </p:sp>
+      <p:sp>
+        <p:nvSpPr>
+          <p:cNvPr id="60" name="Rectangle 59"/>
           <p:cNvSpPr/>
           <p:nvPr/>
         </p:nvSpPr>
@@ -11716,7 +11773,7 @@
       </p:sp>
       <p:sp>
         <p:nvSpPr>
-          <p:cNvPr id="58" name="TextBox 57"/>
+          <p:cNvPr id="61" name="TextBox 60"/>
           <p:cNvSpPr txBox="1"/>
           <p:nvPr/>
         </p:nvSpPr>
@@ -11748,7 +11805,7 @@
                 </a:solidFill>
                 <a:latin typeface="Calibri"/>
               </a:rPr>
-              <a:t>Option 3 keeps a paid, practiced supplier for a total PVA bill of ~$60–75k a year, with one or two pre-announced pauses for SNP Inc. — Option 1 runs ~$116–121k a year and changes SNP's year.</a:t>
+              <a:t>Option 3 keeps a paid, practiced supplier for $6–19k a year on top of today's $50.7k, with one to three pre-announced pauses for SNP Inc. — Option 1 more than doubles the bill and changes SNP's year.</a:t>
             </a:r>
           </a:p>
         </p:txBody>
@@ -12022,7 +12079,7 @@
                 </a:solidFill>
                 <a:latin typeface="Calibri"/>
               </a:rPr>
-              <a:t>— the total PVA cost in the first 12 months: material at both suppliers, internal hours to finish qualification, payments to suppliers. Today's material bill alone is $50.7k (grey line); ~$15k already spent is excluded</a:t>
+              <a:t>— PVA purchases in a year: SNP Inc. at $0.75/lb plus PCI at $3.50/lb. Today is $50.7k (grey line). Internal hours to finish PCI's qualification are not included</a:t>
             </a:r>
           </a:p>
           <a:p>
@@ -12097,7 +12154,7 @@
                 </a:solidFill>
                 <a:latin typeface="Calibri"/>
               </a:rPr>
-              <a:t>— $64–83k; least protected — a cold start of ~3–6 months, longer as the file goes stale</a:t>
+              <a:t>— $50.7k, what we pay today; least protected — a cold start of ~3–6 months, longer as the file goes stale</a:t>
             </a:r>
           </a:p>
           <a:p>
@@ -12122,7 +12179,7 @@
                 </a:solidFill>
                 <a:latin typeface="Calibri"/>
               </a:rPr>
-              <a:t>— $80–125k; a practiced supplier restarts in weeks to a few months — about $50k a year less than Option 1</a:t>
+              <a:t>— $56.9–69.3k (1–3 batches); a practiced supplier restarts in weeks to a few months — $43–56k a year less than Option 1</a:t>
             </a:r>
           </a:p>
           <a:p>
@@ -12147,7 +12204,7 @@
                 </a:solidFill>
                 <a:latin typeface="Calibri"/>
               </a:rPr>
-              <a:t>— $131–161k; most protected — weeks, if PCI's ramp is confirmed in writing — and ~$116–121k every year after</a:t>
+              <a:t>— $112.6k; most protected — weeks, if PCI's ramp is confirmed in writing — and the same every year, growing with volume</a:t>
             </a:r>
           </a:p>
           <a:p>

</xml_diff>

<commit_message>
Option slides: Option 3 at 1-3 batches, Option 2 = today's $50.7k; drums and money per supplier; labels beside chart boxes; footer fits
Co-Authored-By: Claude Fable 5.1 <noreply@anthropic.com>
Claude-Session: https://claude.ai/code/session_01LkE2ZRYs3PLyj8XHTsU3i4
</commit_message>
<xml_diff>
--- a/PVA second supplier initiative/PVA_Second_Supplier_Leadership_Deck.pptx
+++ b/PVA second supplier initiative/PVA_Second_Supplier_Leadership_Deck.pptx
@@ -9032,8 +9032,8 @@
         </p:nvSpPr>
         <p:spPr>
           <a:xfrm>
-            <a:off x="3017520" y="987552"/>
-            <a:ext cx="6035040" cy="274320"/>
+            <a:off x="2926080" y="987552"/>
+            <a:ext cx="5760720" cy="274320"/>
           </a:xfrm>
           <a:prstGeom prst="rect">
             <a:avLst/>
@@ -9052,7 +9052,7 @@
               </a:spcAft>
             </a:pPr>
             <a:r>
-              <a:rPr sz="1000" b="1" i="0">
+              <a:rPr sz="950" b="1" i="0">
                 <a:solidFill>
                   <a:srgbClr val="1F3864"/>
                 </a:solidFill>
@@ -9142,8 +9142,8 @@
         </p:nvSpPr>
         <p:spPr>
           <a:xfrm>
-            <a:off x="3017520" y="1490472"/>
-            <a:ext cx="6035040" cy="566928"/>
+            <a:off x="2926080" y="1490472"/>
+            <a:ext cx="5577840" cy="566928"/>
           </a:xfrm>
           <a:prstGeom prst="rect">
             <a:avLst/>
@@ -9186,8 +9186,8 @@
         </p:nvSpPr>
         <p:spPr>
           <a:xfrm>
-            <a:off x="3017520" y="1490472"/>
-            <a:ext cx="200065" cy="566928"/>
+            <a:off x="2926080" y="1490472"/>
+            <a:ext cx="184909" cy="566928"/>
           </a:xfrm>
           <a:prstGeom prst="rect">
             <a:avLst/>
@@ -9230,7 +9230,7 @@
         </p:nvSpPr>
         <p:spPr>
           <a:xfrm>
-            <a:off x="2999232" y="1490472"/>
+            <a:off x="2907792" y="1490472"/>
             <a:ext cx="18288" cy="566928"/>
           </a:xfrm>
           <a:prstGeom prst="rect">
@@ -9274,7 +9274,7 @@
         </p:nvSpPr>
         <p:spPr>
           <a:xfrm>
-            <a:off x="3217585" y="1490472"/>
+            <a:off x="3110989" y="1490472"/>
             <a:ext cx="18288" cy="566928"/>
           </a:xfrm>
           <a:prstGeom prst="rect">
@@ -9318,8 +9318,8 @@
         </p:nvSpPr>
         <p:spPr>
           <a:xfrm>
-            <a:off x="3618213" y="1490472"/>
-            <a:ext cx="200065" cy="566928"/>
+            <a:off x="3481266" y="1490472"/>
+            <a:ext cx="184909" cy="566928"/>
           </a:xfrm>
           <a:prstGeom prst="rect">
             <a:avLst/>
@@ -9362,7 +9362,7 @@
         </p:nvSpPr>
         <p:spPr>
           <a:xfrm>
-            <a:off x="3599925" y="1490472"/>
+            <a:off x="3462978" y="1490472"/>
             <a:ext cx="18288" cy="566928"/>
           </a:xfrm>
           <a:prstGeom prst="rect">
@@ -9406,7 +9406,7 @@
         </p:nvSpPr>
         <p:spPr>
           <a:xfrm>
-            <a:off x="3818278" y="1490472"/>
+            <a:off x="3666175" y="1490472"/>
             <a:ext cx="18288" cy="566928"/>
           </a:xfrm>
           <a:prstGeom prst="rect">
@@ -9450,8 +9450,8 @@
         </p:nvSpPr>
         <p:spPr>
           <a:xfrm>
-            <a:off x="4218906" y="1490472"/>
-            <a:ext cx="200065" cy="566928"/>
+            <a:off x="4036452" y="1490472"/>
+            <a:ext cx="184909" cy="566928"/>
           </a:xfrm>
           <a:prstGeom prst="rect">
             <a:avLst/>
@@ -9494,7 +9494,7 @@
         </p:nvSpPr>
         <p:spPr>
           <a:xfrm>
-            <a:off x="4200618" y="1490472"/>
+            <a:off x="4018164" y="1490472"/>
             <a:ext cx="18288" cy="566928"/>
           </a:xfrm>
           <a:prstGeom prst="rect">
@@ -9538,7 +9538,7 @@
         </p:nvSpPr>
         <p:spPr>
           <a:xfrm>
-            <a:off x="4418972" y="1490472"/>
+            <a:off x="4221361" y="1490472"/>
             <a:ext cx="18288" cy="566928"/>
           </a:xfrm>
           <a:prstGeom prst="rect">
@@ -9582,8 +9582,8 @@
         </p:nvSpPr>
         <p:spPr>
           <a:xfrm>
-            <a:off x="4819599" y="1490472"/>
-            <a:ext cx="200065" cy="566928"/>
+            <a:off x="4591638" y="1490472"/>
+            <a:ext cx="184909" cy="566928"/>
           </a:xfrm>
           <a:prstGeom prst="rect">
             <a:avLst/>
@@ -9626,7 +9626,7 @@
         </p:nvSpPr>
         <p:spPr>
           <a:xfrm>
-            <a:off x="4801311" y="1490472"/>
+            <a:off x="4573350" y="1490472"/>
             <a:ext cx="18288" cy="566928"/>
           </a:xfrm>
           <a:prstGeom prst="rect">
@@ -9670,7 +9670,7 @@
         </p:nvSpPr>
         <p:spPr>
           <a:xfrm>
-            <a:off x="5019665" y="1490472"/>
+            <a:off x="4776547" y="1490472"/>
             <a:ext cx="18288" cy="566928"/>
           </a:xfrm>
           <a:prstGeom prst="rect">
@@ -9714,8 +9714,8 @@
         </p:nvSpPr>
         <p:spPr>
           <a:xfrm>
-            <a:off x="5420292" y="1490472"/>
-            <a:ext cx="200065" cy="566928"/>
+            <a:off x="5146824" y="1490472"/>
+            <a:ext cx="184909" cy="566928"/>
           </a:xfrm>
           <a:prstGeom prst="rect">
             <a:avLst/>
@@ -9758,7 +9758,7 @@
         </p:nvSpPr>
         <p:spPr>
           <a:xfrm>
-            <a:off x="5402004" y="1490472"/>
+            <a:off x="5128536" y="1490472"/>
             <a:ext cx="18288" cy="566928"/>
           </a:xfrm>
           <a:prstGeom prst="rect">
@@ -9802,7 +9802,7 @@
         </p:nvSpPr>
         <p:spPr>
           <a:xfrm>
-            <a:off x="5620358" y="1490472"/>
+            <a:off x="5331733" y="1490472"/>
             <a:ext cx="18288" cy="566928"/>
           </a:xfrm>
           <a:prstGeom prst="rect">
@@ -9846,8 +9846,8 @@
         </p:nvSpPr>
         <p:spPr>
           <a:xfrm>
-            <a:off x="6020985" y="1490472"/>
-            <a:ext cx="200065" cy="566928"/>
+            <a:off x="5702010" y="1490472"/>
+            <a:ext cx="184909" cy="566928"/>
           </a:xfrm>
           <a:prstGeom prst="rect">
             <a:avLst/>
@@ -9890,7 +9890,7 @@
         </p:nvSpPr>
         <p:spPr>
           <a:xfrm>
-            <a:off x="6002697" y="1490472"/>
+            <a:off x="5683722" y="1490472"/>
             <a:ext cx="18288" cy="566928"/>
           </a:xfrm>
           <a:prstGeom prst="rect">
@@ -9934,7 +9934,7 @@
         </p:nvSpPr>
         <p:spPr>
           <a:xfrm>
-            <a:off x="6221051" y="1490472"/>
+            <a:off x="5886919" y="1490472"/>
             <a:ext cx="18288" cy="566928"/>
           </a:xfrm>
           <a:prstGeom prst="rect">
@@ -9978,8 +9978,8 @@
         </p:nvSpPr>
         <p:spPr>
           <a:xfrm>
-            <a:off x="6621678" y="1490472"/>
-            <a:ext cx="200065" cy="566928"/>
+            <a:off x="6257196" y="1490472"/>
+            <a:ext cx="184909" cy="566928"/>
           </a:xfrm>
           <a:prstGeom prst="rect">
             <a:avLst/>
@@ -10022,7 +10022,7 @@
         </p:nvSpPr>
         <p:spPr>
           <a:xfrm>
-            <a:off x="6603390" y="1490472"/>
+            <a:off x="6238908" y="1490472"/>
             <a:ext cx="18288" cy="566928"/>
           </a:xfrm>
           <a:prstGeom prst="rect">
@@ -10066,7 +10066,7 @@
         </p:nvSpPr>
         <p:spPr>
           <a:xfrm>
-            <a:off x="6821744" y="1490472"/>
+            <a:off x="6442105" y="1490472"/>
             <a:ext cx="18288" cy="566928"/>
           </a:xfrm>
           <a:prstGeom prst="rect">
@@ -10110,8 +10110,8 @@
         </p:nvSpPr>
         <p:spPr>
           <a:xfrm>
-            <a:off x="7222372" y="1490472"/>
-            <a:ext cx="200065" cy="566928"/>
+            <a:off x="6812382" y="1490472"/>
+            <a:ext cx="184909" cy="566928"/>
           </a:xfrm>
           <a:prstGeom prst="rect">
             <a:avLst/>
@@ -10154,7 +10154,7 @@
         </p:nvSpPr>
         <p:spPr>
           <a:xfrm>
-            <a:off x="7204084" y="1490472"/>
+            <a:off x="6794094" y="1490472"/>
             <a:ext cx="18288" cy="566928"/>
           </a:xfrm>
           <a:prstGeom prst="rect">
@@ -10198,7 +10198,7 @@
         </p:nvSpPr>
         <p:spPr>
           <a:xfrm>
-            <a:off x="7422437" y="1490472"/>
+            <a:off x="6997291" y="1490472"/>
             <a:ext cx="18288" cy="566928"/>
           </a:xfrm>
           <a:prstGeom prst="rect">
@@ -10242,8 +10242,8 @@
         </p:nvSpPr>
         <p:spPr>
           <a:xfrm>
-            <a:off x="7823065" y="1490472"/>
-            <a:ext cx="200065" cy="566928"/>
+            <a:off x="7367568" y="1490472"/>
+            <a:ext cx="184909" cy="566928"/>
           </a:xfrm>
           <a:prstGeom prst="rect">
             <a:avLst/>
@@ -10286,7 +10286,7 @@
         </p:nvSpPr>
         <p:spPr>
           <a:xfrm>
-            <a:off x="7804777" y="1490472"/>
+            <a:off x="7349280" y="1490472"/>
             <a:ext cx="18288" cy="566928"/>
           </a:xfrm>
           <a:prstGeom prst="rect">
@@ -10330,7 +10330,7 @@
         </p:nvSpPr>
         <p:spPr>
           <a:xfrm>
-            <a:off x="8023130" y="1490472"/>
+            <a:off x="7552478" y="1490472"/>
             <a:ext cx="18288" cy="566928"/>
           </a:xfrm>
           <a:prstGeom prst="rect">
@@ -10374,8 +10374,8 @@
         </p:nvSpPr>
         <p:spPr>
           <a:xfrm>
-            <a:off x="8423758" y="1490472"/>
-            <a:ext cx="200065" cy="566928"/>
+            <a:off x="7922754" y="1490472"/>
+            <a:ext cx="184909" cy="566928"/>
           </a:xfrm>
           <a:prstGeom prst="rect">
             <a:avLst/>
@@ -10418,7 +10418,7 @@
         </p:nvSpPr>
         <p:spPr>
           <a:xfrm>
-            <a:off x="8405470" y="1490472"/>
+            <a:off x="7904466" y="1490472"/>
             <a:ext cx="18288" cy="566928"/>
           </a:xfrm>
           <a:prstGeom prst="rect">
@@ -10462,7 +10462,7 @@
         </p:nvSpPr>
         <p:spPr>
           <a:xfrm>
-            <a:off x="8623824" y="1490472"/>
+            <a:off x="8107664" y="1490472"/>
             <a:ext cx="18288" cy="566928"/>
           </a:xfrm>
           <a:prstGeom prst="rect">
@@ -10506,8 +10506,8 @@
         </p:nvSpPr>
         <p:spPr>
           <a:xfrm>
-            <a:off x="9189720" y="1307592"/>
-            <a:ext cx="2468880" cy="1371600"/>
+            <a:off x="8641080" y="1280160"/>
+            <a:ext cx="3017520" cy="1417320"/>
           </a:xfrm>
           <a:prstGeom prst="rect">
             <a:avLst/>
@@ -10522,11 +10522,11 @@
           <a:p>
             <a:pPr>
               <a:spcAft>
-                <a:spcPts val="200"/>
-              </a:spcAft>
-            </a:pPr>
-            <a:r>
-              <a:rPr sz="850">
+                <a:spcPts val="100"/>
+              </a:spcAft>
+            </a:pPr>
+            <a:r>
+              <a:rPr sz="800">
                 <a:solidFill>
                   <a:srgbClr val="595959"/>
                 </a:solidFill>
@@ -10535,23 +10535,23 @@
               <a:t>Drums a year  </a:t>
             </a:r>
             <a:r>
-              <a:rPr sz="900" b="1">
+              <a:rPr sz="850" b="1">
                 <a:solidFill>
                   <a:srgbClr val="1F3864"/>
                 </a:solidFill>
                 <a:latin typeface="Calibri"/>
               </a:rPr>
-              <a:t>150 = SNP Inc. 100 + PCI 50 (33%)</a:t>
+              <a:t>150 = SNP 100 + PCI 50 (33%)</a:t>
             </a:r>
           </a:p>
           <a:p>
             <a:pPr>
               <a:spcAft>
-                <a:spcPts val="200"/>
-              </a:spcAft>
-            </a:pPr>
-            <a:r>
-              <a:rPr sz="850">
+                <a:spcPts val="100"/>
+              </a:spcAft>
+            </a:pPr>
+            <a:r>
+              <a:rPr sz="800">
                 <a:solidFill>
                   <a:srgbClr val="595959"/>
                 </a:solidFill>
@@ -10560,23 +10560,23 @@
               <a:t>Money a year  </a:t>
             </a:r>
             <a:r>
-              <a:rPr sz="900" b="0">
+              <a:rPr sz="850" b="1">
                 <a:solidFill>
                   <a:srgbClr val="1F3864"/>
                 </a:solidFill>
                 <a:latin typeface="Calibri"/>
               </a:rPr>
-              <a:t>$112.6k = SNP Inc. $33.8k + PCI $78.8k</a:t>
+              <a:t>$112.6k = SNP $33.8k + PCI $78.8k</a:t>
             </a:r>
           </a:p>
           <a:p>
             <a:pPr>
               <a:spcAft>
-                <a:spcPts val="200"/>
-              </a:spcAft>
-            </a:pPr>
-            <a:r>
-              <a:rPr sz="850">
+                <a:spcPts val="100"/>
+              </a:spcAft>
+            </a:pPr>
+            <a:r>
+              <a:rPr sz="800">
                 <a:solidFill>
                   <a:srgbClr val="595959"/>
                 </a:solidFill>
@@ -10585,23 +10585,23 @@
               <a:t>SNP Inc. sees  </a:t>
             </a:r>
             <a:r>
-              <a:rPr sz="900" b="0">
+              <a:rPr sz="850" b="0">
                 <a:solidFill>
                   <a:srgbClr val="1F3864"/>
                 </a:solidFill>
                 <a:latin typeface="Calibri"/>
               </a:rPr>
-              <a:t>10 pauses of ~12 days, or a level cadence with a rolling stock</a:t>
+              <a:t>10 pauses of ~12 days, or level with a rolling stock</a:t>
             </a:r>
           </a:p>
           <a:p>
             <a:pPr>
               <a:spcAft>
-                <a:spcPts val="200"/>
-              </a:spcAft>
-            </a:pPr>
-            <a:r>
-              <a:rPr sz="850">
+                <a:spcPts val="100"/>
+              </a:spcAft>
+            </a:pPr>
+            <a:r>
+              <a:rPr sz="800">
                 <a:solidFill>
                   <a:srgbClr val="595959"/>
                 </a:solidFill>
@@ -10610,13 +10610,13 @@
               <a:t>If SNP fails, restart in  </a:t>
             </a:r>
             <a:r>
-              <a:rPr sz="900" b="0">
+              <a:rPr sz="850" b="0">
                 <a:solidFill>
                   <a:srgbClr val="1F3864"/>
                 </a:solidFill>
                 <a:latin typeface="Calibri"/>
               </a:rPr>
-              <a:t>weeks — if PCI's ramp is confirmed in writing</a:t>
+              <a:t>weeks, if PCI's ramp is confirmed in writing</a:t>
             </a:r>
           </a:p>
         </p:txBody>
@@ -10700,8 +10700,8 @@
         </p:nvSpPr>
         <p:spPr>
           <a:xfrm>
-            <a:off x="3017520" y="2953512"/>
-            <a:ext cx="6035040" cy="566928"/>
+            <a:off x="2926080" y="2953512"/>
+            <a:ext cx="5577840" cy="566928"/>
           </a:xfrm>
           <a:prstGeom prst="rect">
             <a:avLst/>
@@ -10744,8 +10744,8 @@
         </p:nvSpPr>
         <p:spPr>
           <a:xfrm>
-            <a:off x="4257596" y="2953512"/>
-            <a:ext cx="200065" cy="566928"/>
+            <a:off x="4072211" y="2953512"/>
+            <a:ext cx="184909" cy="566928"/>
           </a:xfrm>
           <a:prstGeom prst="rect">
             <a:avLst/>
@@ -10788,7 +10788,7 @@
         </p:nvSpPr>
         <p:spPr>
           <a:xfrm>
-            <a:off x="4239308" y="2953512"/>
+            <a:off x="4053923" y="2953512"/>
             <a:ext cx="18288" cy="566928"/>
           </a:xfrm>
           <a:prstGeom prst="rect">
@@ -10832,7 +10832,7 @@
         </p:nvSpPr>
         <p:spPr>
           <a:xfrm>
-            <a:off x="4457662" y="2953512"/>
+            <a:off x="4257120" y="2953512"/>
             <a:ext cx="18288" cy="566928"/>
           </a:xfrm>
           <a:prstGeom prst="rect">
@@ -10876,8 +10876,8 @@
         </p:nvSpPr>
         <p:spPr>
           <a:xfrm>
-            <a:off x="6159047" y="2953512"/>
-            <a:ext cx="200065" cy="566928"/>
+            <a:off x="5829613" y="2953512"/>
+            <a:ext cx="184909" cy="566928"/>
           </a:xfrm>
           <a:prstGeom prst="rect">
             <a:avLst/>
@@ -10920,7 +10920,7 @@
         </p:nvSpPr>
         <p:spPr>
           <a:xfrm>
-            <a:off x="6140759" y="2953512"/>
+            <a:off x="5811325" y="2953512"/>
             <a:ext cx="18288" cy="566928"/>
           </a:xfrm>
           <a:prstGeom prst="rect">
@@ -10964,7 +10964,7 @@
         </p:nvSpPr>
         <p:spPr>
           <a:xfrm>
-            <a:off x="6359113" y="2953512"/>
+            <a:off x="6014522" y="2953512"/>
             <a:ext cx="18288" cy="566928"/>
           </a:xfrm>
           <a:prstGeom prst="rect">
@@ -11008,8 +11008,8 @@
         </p:nvSpPr>
         <p:spPr>
           <a:xfrm>
-            <a:off x="8060498" y="2953512"/>
-            <a:ext cx="200065" cy="566928"/>
+            <a:off x="7587014" y="2953512"/>
+            <a:ext cx="184909" cy="566928"/>
           </a:xfrm>
           <a:prstGeom prst="rect">
             <a:avLst/>
@@ -11052,7 +11052,7 @@
         </p:nvSpPr>
         <p:spPr>
           <a:xfrm>
-            <a:off x="8042210" y="2953512"/>
+            <a:off x="7568726" y="2953512"/>
             <a:ext cx="18288" cy="566928"/>
           </a:xfrm>
           <a:prstGeom prst="rect">
@@ -11096,7 +11096,7 @@
         </p:nvSpPr>
         <p:spPr>
           <a:xfrm>
-            <a:off x="8260564" y="2953512"/>
+            <a:off x="7771924" y="2953512"/>
             <a:ext cx="18288" cy="566928"/>
           </a:xfrm>
           <a:prstGeom prst="rect">
@@ -11140,8 +11140,8 @@
         </p:nvSpPr>
         <p:spPr>
           <a:xfrm>
-            <a:off x="9189720" y="2770632"/>
-            <a:ext cx="2468880" cy="1371600"/>
+            <a:off x="8641080" y="2743200"/>
+            <a:ext cx="3017520" cy="1417320"/>
           </a:xfrm>
           <a:prstGeom prst="rect">
             <a:avLst/>
@@ -11156,11 +11156,11 @@
           <a:p>
             <a:pPr>
               <a:spcAft>
-                <a:spcPts val="200"/>
-              </a:spcAft>
-            </a:pPr>
-            <a:r>
-              <a:rPr sz="850">
+                <a:spcPts val="100"/>
+              </a:spcAft>
+            </a:pPr>
+            <a:r>
+              <a:rPr sz="800">
                 <a:solidFill>
                   <a:srgbClr val="595959"/>
                 </a:solidFill>
@@ -11169,23 +11169,23 @@
               <a:t>Drums a year  </a:t>
             </a:r>
             <a:r>
-              <a:rPr sz="900" b="1">
+              <a:rPr sz="850" b="1">
                 <a:solidFill>
                   <a:srgbClr val="1F3864"/>
                 </a:solidFill>
                 <a:latin typeface="Calibri"/>
               </a:rPr>
-              <a:t>150 = SNP Inc. 145 / 140 / 135 + PCI 5 / 10 / 15 (1, 2 or 3 batches)</a:t>
+              <a:t>150 = SNP 145/140/135 + PCI 5/10/15 (1/2/3 batches)</a:t>
             </a:r>
           </a:p>
           <a:p>
             <a:pPr>
               <a:spcAft>
-                <a:spcPts val="200"/>
-              </a:spcAft>
-            </a:pPr>
-            <a:r>
-              <a:rPr sz="850">
+                <a:spcPts val="100"/>
+              </a:spcAft>
+            </a:pPr>
+            <a:r>
+              <a:rPr sz="800">
                 <a:solidFill>
                   <a:srgbClr val="595959"/>
                 </a:solidFill>
@@ -11194,23 +11194,23 @@
               <a:t>Money a year  </a:t>
             </a:r>
             <a:r>
-              <a:rPr sz="900" b="0">
+              <a:rPr sz="850" b="1">
                 <a:solidFill>
                   <a:srgbClr val="1F3864"/>
                 </a:solidFill>
                 <a:latin typeface="Calibri"/>
               </a:rPr>
-              <a:t>$56.9k / $63.1k / $69.3k = SNP Inc. $49.0k / $47.3k / $45.6k + PCI $7.9k / $15.8k / $23.6k</a:t>
+              <a:t>$56.9k / $63.1k / $69.3k = SNP $49.0k/$47.3k/$45.6k + PCI $7.9k/$15.8k/$23.6k</a:t>
             </a:r>
           </a:p>
           <a:p>
             <a:pPr>
               <a:spcAft>
-                <a:spcPts val="200"/>
-              </a:spcAft>
-            </a:pPr>
-            <a:r>
-              <a:rPr sz="850">
+                <a:spcPts val="100"/>
+              </a:spcAft>
+            </a:pPr>
+            <a:r>
+              <a:rPr sz="800">
                 <a:solidFill>
                   <a:srgbClr val="595959"/>
                 </a:solidFill>
@@ -11219,7 +11219,7 @@
               <a:t>SNP Inc. sees  </a:t>
             </a:r>
             <a:r>
-              <a:rPr sz="900" b="0">
+              <a:rPr sz="850" b="0">
                 <a:solidFill>
                   <a:srgbClr val="1F3864"/>
                 </a:solidFill>
@@ -11231,11 +11231,11 @@
           <a:p>
             <a:pPr>
               <a:spcAft>
-                <a:spcPts val="200"/>
-              </a:spcAft>
-            </a:pPr>
-            <a:r>
-              <a:rPr sz="850">
+                <a:spcPts val="100"/>
+              </a:spcAft>
+            </a:pPr>
+            <a:r>
+              <a:rPr sz="800">
                 <a:solidFill>
                   <a:srgbClr val="595959"/>
                 </a:solidFill>
@@ -11244,7 +11244,7 @@
               <a:t>If SNP fails, restart in  </a:t>
             </a:r>
             <a:r>
-              <a:rPr sz="900" b="0">
+              <a:rPr sz="850" b="0">
                 <a:solidFill>
                   <a:srgbClr val="1F3864"/>
                 </a:solidFill>
@@ -11334,8 +11334,8 @@
         </p:nvSpPr>
         <p:spPr>
           <a:xfrm>
-            <a:off x="3017520" y="4416552"/>
-            <a:ext cx="6035040" cy="566928"/>
+            <a:off x="2926080" y="4416552"/>
+            <a:ext cx="5577840" cy="566928"/>
           </a:xfrm>
           <a:prstGeom prst="rect">
             <a:avLst/>
@@ -11378,7 +11378,7 @@
         </p:nvSpPr>
         <p:spPr>
           <a:xfrm>
-            <a:off x="2743200" y="5001768"/>
+            <a:off x="2651760" y="5001768"/>
             <a:ext cx="548640" cy="228600"/>
           </a:xfrm>
           <a:prstGeom prst="rect">
@@ -11417,7 +11417,7 @@
         </p:nvSpPr>
         <p:spPr>
           <a:xfrm>
-            <a:off x="4247826" y="5001768"/>
+            <a:off x="4042399" y="5001768"/>
             <a:ext cx="548640" cy="228600"/>
           </a:xfrm>
           <a:prstGeom prst="rect">
@@ -11456,7 +11456,7 @@
         </p:nvSpPr>
         <p:spPr>
           <a:xfrm>
-            <a:off x="5752452" y="5001768"/>
+            <a:off x="5433039" y="5001768"/>
             <a:ext cx="548640" cy="228600"/>
           </a:xfrm>
           <a:prstGeom prst="rect">
@@ -11495,7 +11495,7 @@
         </p:nvSpPr>
         <p:spPr>
           <a:xfrm>
-            <a:off x="7273613" y="5001768"/>
+            <a:off x="6838960" y="5001768"/>
             <a:ext cx="548640" cy="228600"/>
           </a:xfrm>
           <a:prstGeom prst="rect">
@@ -11534,7 +11534,7 @@
         </p:nvSpPr>
         <p:spPr>
           <a:xfrm>
-            <a:off x="8778239" y="5001768"/>
+            <a:off x="8229600" y="5001768"/>
             <a:ext cx="548640" cy="228600"/>
           </a:xfrm>
           <a:prstGeom prst="rect">
@@ -11573,8 +11573,8 @@
         </p:nvSpPr>
         <p:spPr>
           <a:xfrm>
-            <a:off x="9189720" y="4233672"/>
-            <a:ext cx="2468880" cy="1371600"/>
+            <a:off x="8641080" y="4206240"/>
+            <a:ext cx="3017520" cy="1417320"/>
           </a:xfrm>
           <a:prstGeom prst="rect">
             <a:avLst/>
@@ -11589,11 +11589,11 @@
           <a:p>
             <a:pPr>
               <a:spcAft>
-                <a:spcPts val="200"/>
-              </a:spcAft>
-            </a:pPr>
-            <a:r>
-              <a:rPr sz="850">
+                <a:spcPts val="100"/>
+              </a:spcAft>
+            </a:pPr>
+            <a:r>
+              <a:rPr sz="800">
                 <a:solidFill>
                   <a:srgbClr val="595959"/>
                 </a:solidFill>
@@ -11602,23 +11602,23 @@
               <a:t>Drums a year  </a:t>
             </a:r>
             <a:r>
-              <a:rPr sz="900" b="1">
+              <a:rPr sz="850" b="1">
                 <a:solidFill>
                   <a:srgbClr val="1F3864"/>
                 </a:solidFill>
                 <a:latin typeface="Calibri"/>
               </a:rPr>
-              <a:t>150 = SNP Inc. 150</a:t>
+              <a:t>150 = SNP 150</a:t>
             </a:r>
           </a:p>
           <a:p>
             <a:pPr>
               <a:spcAft>
-                <a:spcPts val="200"/>
-              </a:spcAft>
-            </a:pPr>
-            <a:r>
-              <a:rPr sz="850">
+                <a:spcPts val="100"/>
+              </a:spcAft>
+            </a:pPr>
+            <a:r>
+              <a:rPr sz="800">
                 <a:solidFill>
                   <a:srgbClr val="595959"/>
                 </a:solidFill>
@@ -11627,23 +11627,23 @@
               <a:t>Money a year  </a:t>
             </a:r>
             <a:r>
-              <a:rPr sz="900" b="0">
+              <a:rPr sz="850" b="1">
                 <a:solidFill>
                   <a:srgbClr val="1F3864"/>
                 </a:solidFill>
                 <a:latin typeface="Calibri"/>
               </a:rPr>
-              <a:t>$50.7k = SNP Inc. $50.7k — what we pay today</a:t>
+              <a:t>$50.7k = SNP $50.7k — what we pay today</a:t>
             </a:r>
           </a:p>
           <a:p>
             <a:pPr>
               <a:spcAft>
-                <a:spcPts val="200"/>
-              </a:spcAft>
-            </a:pPr>
-            <a:r>
-              <a:rPr sz="850">
+                <a:spcPts val="100"/>
+              </a:spcAft>
+            </a:pPr>
+            <a:r>
+              <a:rPr sz="800">
                 <a:solidFill>
                   <a:srgbClr val="595959"/>
                 </a:solidFill>
@@ -11652,7 +11652,7 @@
               <a:t>SNP Inc. sees  </a:t>
             </a:r>
             <a:r>
-              <a:rPr sz="900" b="0">
+              <a:rPr sz="850" b="0">
                 <a:solidFill>
                   <a:srgbClr val="1F3864"/>
                 </a:solidFill>
@@ -11664,11 +11664,11 @@
           <a:p>
             <a:pPr>
               <a:spcAft>
-                <a:spcPts val="200"/>
-              </a:spcAft>
-            </a:pPr>
-            <a:r>
-              <a:rPr sz="850">
+                <a:spcPts val="100"/>
+              </a:spcAft>
+            </a:pPr>
+            <a:r>
+              <a:rPr sz="800">
                 <a:solidFill>
                   <a:srgbClr val="595959"/>
                 </a:solidFill>
@@ -11677,13 +11677,13 @@
               <a:t>If SNP fails, restart in  </a:t>
             </a:r>
             <a:r>
-              <a:rPr sz="900" b="0">
+              <a:rPr sz="850" b="0">
                 <a:solidFill>
                   <a:srgbClr val="1F3864"/>
                 </a:solidFill>
                 <a:latin typeface="Calibri"/>
               </a:rPr>
-              <a:t>~3–6 months; a cold start decays after ~12 idle</a:t>
+              <a:t>~3–6 months; decays after ~12 months idle</a:t>
             </a:r>
           </a:p>
         </p:txBody>
@@ -11696,8 +11696,8 @@
         </p:nvSpPr>
         <p:spPr>
           <a:xfrm>
-            <a:off x="548640" y="5623560"/>
-            <a:ext cx="11064240" cy="320040"/>
+            <a:off x="548640" y="5486400"/>
+            <a:ext cx="11064240" cy="457200"/>
           </a:xfrm>
           <a:prstGeom prst="rect">
             <a:avLst/>
@@ -11716,13 +11716,13 @@
               </a:spcAft>
             </a:pPr>
             <a:r>
-              <a:rPr sz="900" b="0" i="0">
+              <a:rPr sz="850" b="0" i="0">
                 <a:solidFill>
                   <a:srgbClr val="595959"/>
                 </a:solidFill>
                 <a:latin typeface="Calibri"/>
               </a:rPr>
-              <a:t>Demand: 150 drums a year (1 drum = 450 lb of PVA), ~3 drums a week. Block rotation: PCI drums land ~4 days old and expire on day 18, so a 5-drum batch is used at full rate in one ~12-day block. Purchases at today's volume: SNP Inc. $0.75/lb ($337.50 a drum), PCI $3.50/lb ($1,575 a drum); all grow ~10%/yr with volume. Not included: internal hours to finish PCI's qualification (Options 1 and 3, ~$15–40k once).</a:t>
+              <a:t>Demand: 150 drums a year (1 drum = 450 lb of PVA), ~3 a week. A 5-drum PCI batch is used in one ~12-day block (drums land ~4 days old, expire on day 18). Purchases at today's volume: SNP $337.50 a drum, PCI $1,575 a drum; all grow ~10%/yr. Internal hours to finish PCI's qualification (~$15–40k once) are not included.</a:t>
             </a:r>
           </a:p>
         </p:txBody>
@@ -12229,7 +12229,7 @@
                 </a:solidFill>
                 <a:latin typeface="Calibri"/>
               </a:rPr>
-              <a:t>— what SNP Inc. experiences: 10 pauses a year under Option 1, 1–2 under Option 3, none under Option 2</a:t>
+              <a:t>— what SNP Inc. experiences: 10 pauses a year under Option 1, 1–3 under Option 3, none under Option 2</a:t>
             </a:r>
           </a:p>
         </p:txBody>

</xml_diff>

<commit_message>
Qualified-supplier slide: three weighted instruments (real order, signed terms, fee for work done); readiness fee and PPAP re-check dropped
Co-Authored-By: Claude Fable 5.1 <noreply@anthropic.com>
Claude-Session: https://claude.ai/code/session_01LkE2ZRYs3PLyj8XHTsU3i4
</commit_message>
<xml_diff>
--- a/PVA second supplier initiative/PVA_Second_Supplier_Leadership_Deck.pptx
+++ b/PVA second supplier initiative/PVA_Second_Supplier_Leadership_Deck.pptx
@@ -1001,7 +1001,7 @@
           <a:lstStyle/>
           <a:p>
             <a:r>
-              <a:t>How companies keep a qualified supplier they barely use - because you will be asked whether Option 3 is realistic. It is routine in medical devices, pharma and aerospace. What spoils the relationship is silence and unpaid work, not the 'no'. The instruments, in rising order of commitment: pay a development fee for the qualification work already done; sign a master agreement with price, spec and terms but no volume commitment, if PCI accepts one; place one production-scale order; a readiness fee, which is rare at our scale; and a planned re-check, because an idle supplier goes stale after about a year - the Production Part Approval Process rule of thumb is twelve months. Option 3 is the last two made routine. And the conduct: tell PCI the triggers, pay promptly, share results, keep a quarterly touchpoint. The research is clear that suppliers allocate goodwill on trust and growth prospects, not current volume.</a:t>
+              <a:t>How companies keep a qualified supplier they barely use - because you will be asked whether Option 3 is realistic. It is routine in medical devices, pharma and aerospace. What spoils the relationship is silence and unpaid work, not the 'no'. Three instruments, weighted. First and essential: place a real order - one five-drum batch, one to three times a year; it is the only thing that pays PCI with revenue and proves production scale, and it is Option 3. Second and essential: sign terms with no volume commitment - the 3.50 batch price, spec, lead time, change notification, twelve to twenty-four months, zero minimum; it locks the economic core of Option 3 in writing and costs only legal time. Third, only under Option 2: pay a development fee for the work already done, to repair the goodwill if we order nothing; under Option 3 the first batch is the payment. Capacity-reservation fees and formal re-approval programs are pharma-scale practices that do not apply to us. And the conduct: tell PCI the triggers, pay promptly, share results, keep a quarterly touchpoint. The research is clear that suppliers allocate goodwill on trust and growth prospects, not current volume.</a:t>
             </a:r>
           </a:p>
         </p:txBody>
@@ -12413,7 +12413,7 @@
                 </a:solidFill>
                 <a:latin typeface="Calibri"/>
               </a:rPr>
-              <a:t>Keeping a qualified supplier you barely use — how it is done</a:t>
+              <a:t>Keeping a qualified supplier you barely use — three instruments, weighted</a:t>
             </a:r>
           </a:p>
         </p:txBody>
@@ -12466,7 +12466,7 @@
         <p:spPr>
           <a:xfrm>
             <a:off x="548640" y="1024128"/>
-            <a:ext cx="11064240" cy="502920"/>
+            <a:ext cx="11064240" cy="640080"/>
           </a:xfrm>
           <a:prstGeom prst="rect">
             <a:avLst/>
@@ -12481,613 +12481,65 @@
           <a:p>
             <a:pPr algn="l">
               <a:spcAft>
-                <a:spcPts val="400"/>
-              </a:spcAft>
-            </a:pPr>
-            <a:r>
-              <a:rPr sz="1200" b="1" i="0">
+                <a:spcPts val="0"/>
+              </a:spcAft>
+            </a:pPr>
+            <a:r>
+              <a:rPr sz="1250" b="1" i="0">
                 <a:solidFill>
                   <a:srgbClr val="1F3864"/>
                 </a:solidFill>
                 <a:latin typeface="Calibri"/>
               </a:rPr>
-              <a:t>Routine in medical devices, pharma and aerospace. What spoils the relationship is not the 'no' — it is silence and unpaid work. Five instruments, rising commitment; Option 3 is instruments 3 and 5 made routine.</a:t>
-            </a:r>
-          </a:p>
-        </p:txBody>
-      </p:sp>
-      <p:graphicFrame>
-        <p:nvGraphicFramePr>
-          <p:cNvPr id="6" name="Table 5"/>
-          <p:cNvGraphicFramePr>
-            <a:graphicFrameLocks noGrp="1"/>
-          </p:cNvGraphicFramePr>
-          <p:nvPr/>
-        </p:nvGraphicFramePr>
-        <p:xfrm>
-          <a:off x="548640" y="1600200"/>
-          <a:ext cx="11064240" cy="3246120"/>
-        </p:xfrm>
-        <a:graphic>
-          <a:graphicData uri="http://schemas.openxmlformats.org/drawingml/2006/table">
-            <a:tbl>
-              <a:tblPr firstRow="1" bandRow="1">
-                <a:tableStyleId>{5C22544A-7EE6-4342-B048-85BDC9FD1C3A}</a:tableStyleId>
-              </a:tblPr>
-              <a:tblGrid>
-                <a:gridCol w="2651760"/>
-                <a:gridCol w="3657600"/>
-                <a:gridCol w="2011680"/>
-                <a:gridCol w="2743200"/>
-              </a:tblGrid>
-              <a:tr h="541020">
-                <a:tc>
-                  <a:txBody>
-                    <a:bodyPr/>
-                    <a:lstStyle/>
-                    <a:p>
-                      <a:pPr algn="l"/>
-                      <a:r>
-                        <a:rPr sz="960" b="1">
-                          <a:solidFill>
-                            <a:srgbClr val="FFFFFF"/>
-                          </a:solidFill>
-                          <a:latin typeface="Calibri"/>
-                        </a:rPr>
-                        <a:t>Instrument</a:t>
-                      </a:r>
-                    </a:p>
-                  </a:txBody>
-                  <a:tcPr>
-                    <a:solidFill>
-                      <a:srgbClr val="1F3864"/>
-                    </a:solidFill>
-                  </a:tcPr>
-                </a:tc>
-                <a:tc>
-                  <a:txBody>
-                    <a:bodyPr/>
-                    <a:lstStyle/>
-                    <a:p>
-                      <a:pPr algn="ctr"/>
-                      <a:r>
-                        <a:rPr sz="960" b="1">
-                          <a:solidFill>
-                            <a:srgbClr val="FFFFFF"/>
-                          </a:solidFill>
-                          <a:latin typeface="Calibri"/>
-                        </a:rPr>
-                        <a:t>What it is</a:t>
-                      </a:r>
-                    </a:p>
-                  </a:txBody>
-                  <a:tcPr>
-                    <a:solidFill>
-                      <a:srgbClr val="1F3864"/>
-                    </a:solidFill>
-                  </a:tcPr>
-                </a:tc>
-                <a:tc>
-                  <a:txBody>
-                    <a:bodyPr/>
-                    <a:lstStyle/>
-                    <a:p>
-                      <a:pPr algn="ctr"/>
-                      <a:r>
-                        <a:rPr sz="960" b="1">
-                          <a:solidFill>
-                            <a:srgbClr val="FFFFFF"/>
-                          </a:solidFill>
-                          <a:latin typeface="Calibri"/>
-                        </a:rPr>
-                        <a:t>Cost here</a:t>
-                      </a:r>
-                    </a:p>
-                  </a:txBody>
-                  <a:tcPr>
-                    <a:solidFill>
-                      <a:srgbClr val="1F3864"/>
-                    </a:solidFill>
-                  </a:tcPr>
-                </a:tc>
-                <a:tc>
-                  <a:txBody>
-                    <a:bodyPr/>
-                    <a:lstStyle/>
-                    <a:p>
-                      <a:pPr algn="l"/>
-                      <a:r>
-                        <a:rPr sz="960" b="1">
-                          <a:solidFill>
-                            <a:srgbClr val="FFFFFF"/>
-                          </a:solidFill>
-                          <a:latin typeface="Calibri"/>
-                        </a:rPr>
-                        <a:t>What it does for the relationship</a:t>
-                      </a:r>
-                    </a:p>
-                  </a:txBody>
-                  <a:tcPr>
-                    <a:solidFill>
-                      <a:srgbClr val="1F3864"/>
-                    </a:solidFill>
-                  </a:tcPr>
-                </a:tc>
-              </a:tr>
-              <a:tr h="541020">
-                <a:tc>
-                  <a:txBody>
-                    <a:bodyPr/>
-                    <a:lstStyle/>
-                    <a:p>
-                      <a:pPr algn="l"/>
-                      <a:r>
-                        <a:rPr sz="960" b="1">
-                          <a:solidFill>
-                            <a:srgbClr val="1F3864"/>
-                          </a:solidFill>
-                          <a:latin typeface="Calibri"/>
-                        </a:rPr>
-                        <a:t>1 · Pay for the qualification (NRE — non-recurring engineering)</a:t>
-                      </a:r>
-                    </a:p>
-                  </a:txBody>
-                  <a:tcPr>
-                    <a:solidFill>
-                      <a:srgbClr val="FFFFFF"/>
-                    </a:solidFill>
-                  </a:tcPr>
-                </a:tc>
-                <a:tc>
-                  <a:txBody>
-                    <a:bodyPr/>
-                    <a:lstStyle/>
-                    <a:p>
-                      <a:pPr algn="ctr"/>
-                      <a:r>
-                        <a:rPr sz="960">
-                          <a:solidFill>
-                            <a:srgbClr val="1F3864"/>
-                          </a:solidFill>
-                          <a:latin typeface="Calibri"/>
-                        </a:rPr>
-                        <a:t>Fund the lots, testing and documentation already done</a:t>
-                      </a:r>
-                    </a:p>
-                  </a:txBody>
-                  <a:tcPr>
-                    <a:solidFill>
-                      <a:srgbClr val="FFFFFF"/>
-                    </a:solidFill>
-                  </a:tcPr>
-                </a:tc>
-                <a:tc>
-                  <a:txBody>
-                    <a:bodyPr/>
-                    <a:lstStyle/>
-                    <a:p>
-                      <a:pPr algn="ctr"/>
-                      <a:r>
-                        <a:rPr sz="960">
-                          <a:solidFill>
-                            <a:srgbClr val="1F3864"/>
-                          </a:solidFill>
-                          <a:latin typeface="Calibri"/>
-                        </a:rPr>
-                        <a:t>Development fee, ~$5–10k placeholder — PCI to invoice</a:t>
-                      </a:r>
-                    </a:p>
-                  </a:txBody>
-                  <a:tcPr>
-                    <a:solidFill>
-                      <a:srgbClr val="FFFFFF"/>
-                    </a:solidFill>
-                  </a:tcPr>
-                </a:tc>
-                <a:tc>
-                  <a:txBody>
-                    <a:bodyPr/>
-                    <a:lstStyle/>
-                    <a:p>
-                      <a:pPr algn="l"/>
-                      <a:r>
-                        <a:rPr sz="960">
-                          <a:solidFill>
-                            <a:srgbClr val="1F3864"/>
-                          </a:solidFill>
-                          <a:latin typeface="Calibri"/>
-                        </a:rPr>
-                        <a:t>Free experiments become a paid engagement; an approved-source file</a:t>
-                      </a:r>
-                    </a:p>
-                  </a:txBody>
-                  <a:tcPr>
-                    <a:solidFill>
-                      <a:srgbClr val="FFFFFF"/>
-                    </a:solidFill>
-                  </a:tcPr>
-                </a:tc>
-              </a:tr>
-              <a:tr h="541020">
-                <a:tc>
-                  <a:txBody>
-                    <a:bodyPr/>
-                    <a:lstStyle/>
-                    <a:p>
-                      <a:pPr algn="l"/>
-                      <a:r>
-                        <a:rPr sz="960" b="1">
-                          <a:solidFill>
-                            <a:srgbClr val="1F3864"/>
-                          </a:solidFill>
-                          <a:latin typeface="Calibri"/>
-                        </a:rPr>
-                        <a:t>2 · Master agreement, no volume commitment</a:t>
-                      </a:r>
-                    </a:p>
-                  </a:txBody>
-                  <a:tcPr>
-                    <a:solidFill>
-                      <a:srgbClr val="FFFFFF"/>
-                    </a:solidFill>
-                  </a:tcPr>
-                </a:tc>
-                <a:tc>
-                  <a:txBody>
-                    <a:bodyPr/>
-                    <a:lstStyle/>
-                    <a:p>
-                      <a:pPr algn="ctr"/>
-                      <a:r>
-                        <a:rPr sz="960">
-                          <a:solidFill>
-                            <a:srgbClr val="1F3864"/>
-                          </a:solidFill>
-                          <a:latin typeface="Calibri"/>
-                        </a:rPr>
-                        <a:t>Price ($3.50, resin-indexed), spec, lead time, quality and change terms; 12–24 months; zero minimum — if PCI accepts</a:t>
-                      </a:r>
-                    </a:p>
-                  </a:txBody>
-                  <a:tcPr>
-                    <a:solidFill>
-                      <a:srgbClr val="FFFFFF"/>
-                    </a:solidFill>
-                  </a:tcPr>
-                </a:tc>
-                <a:tc>
-                  <a:txBody>
-                    <a:bodyPr/>
-                    <a:lstStyle/>
-                    <a:p>
-                      <a:pPr algn="ctr"/>
-                      <a:r>
-                        <a:rPr sz="960">
-                          <a:solidFill>
-                            <a:srgbClr val="1F3864"/>
-                          </a:solidFill>
-                          <a:latin typeface="Calibri"/>
-                        </a:rPr>
-                        <a:t>Legal time</a:t>
-                      </a:r>
-                    </a:p>
-                  </a:txBody>
-                  <a:tcPr>
-                    <a:solidFill>
-                      <a:srgbClr val="FFFFFF"/>
-                    </a:solidFill>
-                  </a:tcPr>
-                </a:tc>
-                <a:tc>
-                  <a:txBody>
-                    <a:bodyPr/>
-                    <a:lstStyle/>
-                    <a:p>
-                      <a:pPr algn="l"/>
-                      <a:r>
-                        <a:rPr sz="960">
-                          <a:solidFill>
-                            <a:srgbClr val="1F3864"/>
-                          </a:solidFill>
-                          <a:latin typeface="Calibri"/>
-                        </a:rPr>
-                        <a:t>Formal approved-second-source status; a callable option at a known price</a:t>
-                      </a:r>
-                    </a:p>
-                  </a:txBody>
-                  <a:tcPr>
-                    <a:solidFill>
-                      <a:srgbClr val="FFFFFF"/>
-                    </a:solidFill>
-                  </a:tcPr>
-                </a:tc>
-              </a:tr>
-              <a:tr h="541020">
-                <a:tc>
-                  <a:txBody>
-                    <a:bodyPr/>
-                    <a:lstStyle/>
-                    <a:p>
-                      <a:pPr algn="l"/>
-                      <a:r>
-                        <a:rPr sz="960" b="1">
-                          <a:solidFill>
-                            <a:srgbClr val="1F3864"/>
-                          </a:solidFill>
-                          <a:latin typeface="Calibri"/>
-                        </a:rPr>
-                        <a:t>3 · One production-scale order (Option 3, step one)</a:t>
-                      </a:r>
-                    </a:p>
-                  </a:txBody>
-                  <a:tcPr>
-                    <a:solidFill>
-                      <a:srgbClr val="FFFFFF"/>
-                    </a:solidFill>
-                  </a:tcPr>
-                </a:tc>
-                <a:tc>
-                  <a:txBody>
-                    <a:bodyPr/>
-                    <a:lstStyle/>
-                    <a:p>
-                      <a:pPr algn="ctr"/>
-                      <a:r>
-                        <a:rPr sz="960">
-                          <a:solidFill>
-                            <a:srgbClr val="1F3864"/>
-                          </a:solidFill>
-                          <a:latin typeface="Calibri"/>
-                        </a:rPr>
-                        <a:t>One paid 5-drum batch: proves production scale, completes the file; ramp stays a written commitment to obtain</a:t>
-                      </a:r>
-                    </a:p>
-                  </a:txBody>
-                  <a:tcPr>
-                    <a:solidFill>
-                      <a:srgbClr val="E2EFDA"/>
-                    </a:solidFill>
-                  </a:tcPr>
-                </a:tc>
-                <a:tc>
-                  <a:txBody>
-                    <a:bodyPr/>
-                    <a:lstStyle/>
-                    <a:p>
-                      <a:pPr algn="ctr"/>
-                      <a:r>
-                        <a:rPr sz="960">
-                          <a:solidFill>
-                            <a:srgbClr val="1F3864"/>
-                          </a:solidFill>
-                          <a:latin typeface="Calibri"/>
-                        </a:rPr>
-                        <a:t>$7.9k gross (~$6.2k over SNP)</a:t>
-                      </a:r>
-                    </a:p>
-                  </a:txBody>
-                  <a:tcPr>
-                    <a:solidFill>
-                      <a:srgbClr val="E2EFDA"/>
-                    </a:solidFill>
-                  </a:tcPr>
-                </a:tc>
-                <a:tc>
-                  <a:txBody>
-                    <a:bodyPr/>
-                    <a:lstStyle/>
-                    <a:p>
-                      <a:pPr algn="l"/>
-                      <a:r>
-                        <a:rPr sz="960">
-                          <a:solidFill>
-                            <a:srgbClr val="1F3864"/>
-                          </a:solidFill>
-                          <a:latin typeface="Calibri"/>
-                        </a:rPr>
-                        <a:t>Strongest form — they have shipped to us</a:t>
-                      </a:r>
-                    </a:p>
-                  </a:txBody>
-                  <a:tcPr>
-                    <a:solidFill>
-                      <a:srgbClr val="E2EFDA"/>
-                    </a:solidFill>
-                  </a:tcPr>
-                </a:tc>
-              </a:tr>
-              <a:tr h="541020">
-                <a:tc>
-                  <a:txBody>
-                    <a:bodyPr/>
-                    <a:lstStyle/>
-                    <a:p>
-                      <a:pPr algn="l"/>
-                      <a:r>
-                        <a:rPr sz="960" b="1">
-                          <a:solidFill>
-                            <a:srgbClr val="1F3864"/>
-                          </a:solidFill>
-                          <a:latin typeface="Calibri"/>
-                        </a:rPr>
-                        <a:t>4 · Readiness / capacity-reservation fee</a:t>
-                      </a:r>
-                    </a:p>
-                  </a:txBody>
-                  <a:tcPr>
-                    <a:solidFill>
-                      <a:srgbClr val="FFFFFF"/>
-                    </a:solidFill>
-                  </a:tcPr>
-                </a:tc>
-                <a:tc>
-                  <a:txBody>
-                    <a:bodyPr/>
-                    <a:lstStyle/>
-                    <a:p>
-                      <a:pPr algn="ctr"/>
-                      <a:r>
-                        <a:rPr sz="960">
-                          <a:solidFill>
-                            <a:srgbClr val="1F3864"/>
-                          </a:solidFill>
-                          <a:latin typeface="Calibri"/>
-                        </a:rPr>
-                        <a:t>A fee for the right to call volume at a set price with a committed ramp (pharma: ~20% of batch value; multi-million minimums)</a:t>
-                      </a:r>
-                    </a:p>
-                  </a:txBody>
-                  <a:tcPr>
-                    <a:solidFill>
-                      <a:srgbClr val="FFFFFF"/>
-                    </a:solidFill>
-                  </a:tcPr>
-                </a:tc>
-                <a:tc>
-                  <a:txBody>
-                    <a:bodyPr/>
-                    <a:lstStyle/>
-                    <a:p>
-                      <a:pPr algn="ctr"/>
-                      <a:r>
-                        <a:rPr sz="960">
-                          <a:solidFill>
-                            <a:srgbClr val="1F3864"/>
-                          </a:solidFill>
-                          <a:latin typeface="Calibri"/>
-                        </a:rPr>
-                        <a:t>Token retainer at most</a:t>
-                      </a:r>
-                    </a:p>
-                  </a:txBody>
-                  <a:tcPr>
-                    <a:solidFill>
-                      <a:srgbClr val="FFFFFF"/>
-                    </a:solidFill>
-                  </a:tcPr>
-                </a:tc>
-                <a:tc>
-                  <a:txBody>
-                    <a:bodyPr/>
-                    <a:lstStyle/>
-                    <a:p>
-                      <a:pPr algn="l"/>
-                      <a:r>
-                        <a:rPr sz="960">
-                          <a:solidFill>
-                            <a:srgbClr val="1F3864"/>
-                          </a:solidFill>
-                          <a:latin typeface="Calibri"/>
-                        </a:rPr>
-                        <a:t>Rarely worth it at our scale</a:t>
-                      </a:r>
-                    </a:p>
-                  </a:txBody>
-                  <a:tcPr>
-                    <a:solidFill>
-                      <a:srgbClr val="FFFFFF"/>
-                    </a:solidFill>
-                  </a:tcPr>
-                </a:tc>
-              </a:tr>
-              <a:tr h="541020">
-                <a:tc>
-                  <a:txBody>
-                    <a:bodyPr/>
-                    <a:lstStyle/>
-                    <a:p>
-                      <a:pPr algn="l"/>
-                      <a:r>
-                        <a:rPr sz="960" b="1">
-                          <a:solidFill>
-                            <a:srgbClr val="1F3864"/>
-                          </a:solidFill>
-                          <a:latin typeface="Calibri"/>
-                        </a:rPr>
-                        <a:t>5 · Planned re-check (Option 3's cadence)</a:t>
-                      </a:r>
-                    </a:p>
-                  </a:txBody>
-                  <a:tcPr>
-                    <a:solidFill>
-                      <a:srgbClr val="FFFFFF"/>
-                    </a:solidFill>
-                  </a:tcPr>
-                </a:tc>
-                <a:tc>
-                  <a:txBody>
-                    <a:bodyPr/>
-                    <a:lstStyle/>
-                    <a:p>
-                      <a:pPr algn="ctr"/>
-                      <a:r>
-                        <a:rPr sz="960">
-                          <a:solidFill>
-                            <a:srgbClr val="1F3864"/>
-                          </a:solidFill>
-                          <a:latin typeface="Calibri"/>
-                        </a:rPr>
-                        <a:t>Idle suppliers go stale: Production Part Approval Process (PPAP) re-approval after 12 months idle; ~18 months = 'new supplier'; ISO 13485 §7.4.1</a:t>
-                      </a:r>
-                    </a:p>
-                  </a:txBody>
-                  <a:tcPr>
-                    <a:solidFill>
-                      <a:srgbClr val="E2EFDA"/>
-                    </a:solidFill>
-                  </a:tcPr>
-                </a:tc>
-                <a:tc>
-                  <a:txBody>
-                    <a:bodyPr/>
-                    <a:lstStyle/>
-                    <a:p>
-                      <a:pPr algn="ctr"/>
-                      <a:r>
-                        <a:rPr sz="960">
-                          <a:solidFill>
-                            <a:srgbClr val="1F3864"/>
-                          </a:solidFill>
-                          <a:latin typeface="Calibri"/>
-                        </a:rPr>
-                        <a:t>1–2 batches/yr ≈ $7.9–15.8k gross — if PCI accepts</a:t>
-                      </a:r>
-                    </a:p>
-                  </a:txBody>
-                  <a:tcPr>
-                    <a:solidFill>
-                      <a:srgbClr val="E2EFDA"/>
-                    </a:solidFill>
-                  </a:tcPr>
-                </a:tc>
-                <a:tc>
-                  <a:txBody>
-                    <a:bodyPr/>
-                    <a:lstStyle/>
-                    <a:p>
-                      <a:pPr algn="l"/>
-                      <a:r>
-                        <a:rPr sz="960">
-                          <a:solidFill>
-                            <a:srgbClr val="1F3864"/>
-                          </a:solidFill>
-                          <a:latin typeface="Calibri"/>
-                        </a:rPr>
-                        <a:t>Keeps the option honest and the supplier practiced</a:t>
-                      </a:r>
-                    </a:p>
-                  </a:txBody>
-                  <a:tcPr>
-                    <a:solidFill>
-                      <a:srgbClr val="E2EFDA"/>
-                    </a:solidFill>
-                  </a:tcPr>
-                </a:tc>
-              </a:tr>
-            </a:tbl>
-          </a:graphicData>
-        </a:graphic>
-      </p:graphicFrame>
+              <a:t>A supplier stays ready without steady volume if it gets a real order now and then, signed terms, and payment for its work. Routine in medical devices, pharma and aerospace; what spoils the relationship is not the 'no' — it is silence and unpaid work.</a:t>
+            </a:r>
+          </a:p>
+        </p:txBody>
+      </p:sp>
+      <p:sp>
+        <p:nvSpPr>
+          <p:cNvPr id="6" name="Rectangle 5"/>
+          <p:cNvSpPr/>
+          <p:nvPr/>
+        </p:nvSpPr>
+        <p:spPr>
+          <a:xfrm>
+            <a:off x="548640" y="1828800"/>
+            <a:ext cx="4114800" cy="3383280"/>
+          </a:xfrm>
+          <a:prstGeom prst="rect">
+            <a:avLst/>
+          </a:prstGeom>
+          <a:solidFill>
+            <a:srgbClr val="DCE8F6"/>
+          </a:solidFill>
+          <a:ln>
+            <a:noFill/>
+          </a:ln>
+          <a:effectLst/>
+        </p:spPr>
+        <p:style>
+          <a:lnRef idx="1">
+            <a:schemeClr val="accent1"/>
+          </a:lnRef>
+          <a:fillRef idx="3">
+            <a:schemeClr val="accent1"/>
+          </a:fillRef>
+          <a:effectRef idx="2">
+            <a:schemeClr val="accent1"/>
+          </a:effectRef>
+          <a:fontRef idx="minor">
+            <a:schemeClr val="lt1"/>
+          </a:fontRef>
+        </p:style>
+        <p:txBody>
+          <a:bodyPr rtlCol="0" anchor="ctr"/>
+          <a:lstStyle/>
+          <a:p>
+            <a:pPr algn="ctr"/>
+          </a:p>
+        </p:txBody>
+      </p:sp>
       <p:sp>
         <p:nvSpPr>
           <p:cNvPr id="7" name="Rectangle 6"/>
@@ -13096,8 +12548,562 @@
         </p:nvSpPr>
         <p:spPr>
           <a:xfrm>
-            <a:off x="548640" y="5029200"/>
-            <a:ext cx="11064240" cy="868680"/>
+            <a:off x="548640" y="1828800"/>
+            <a:ext cx="4114800" cy="82296"/>
+          </a:xfrm>
+          <a:prstGeom prst="rect">
+            <a:avLst/>
+          </a:prstGeom>
+          <a:solidFill>
+            <a:srgbClr val="2F6DB5"/>
+          </a:solidFill>
+          <a:ln>
+            <a:noFill/>
+          </a:ln>
+          <a:effectLst/>
+        </p:spPr>
+        <p:style>
+          <a:lnRef idx="1">
+            <a:schemeClr val="accent1"/>
+          </a:lnRef>
+          <a:fillRef idx="3">
+            <a:schemeClr val="accent1"/>
+          </a:fillRef>
+          <a:effectRef idx="2">
+            <a:schemeClr val="accent1"/>
+          </a:effectRef>
+          <a:fontRef idx="minor">
+            <a:schemeClr val="lt1"/>
+          </a:fontRef>
+        </p:style>
+        <p:txBody>
+          <a:bodyPr rtlCol="0" anchor="ctr"/>
+          <a:lstStyle/>
+          <a:p>
+            <a:pPr algn="ctr"/>
+          </a:p>
+        </p:txBody>
+      </p:sp>
+      <p:sp>
+        <p:nvSpPr>
+          <p:cNvPr id="8" name="TextBox 7"/>
+          <p:cNvSpPr txBox="1"/>
+          <p:nvPr/>
+        </p:nvSpPr>
+        <p:spPr>
+          <a:xfrm>
+            <a:off x="685800" y="1993392"/>
+            <a:ext cx="548640" cy="640080"/>
+          </a:xfrm>
+          <a:prstGeom prst="rect">
+            <a:avLst/>
+          </a:prstGeom>
+          <a:noFill/>
+        </p:spPr>
+        <p:txBody>
+          <a:bodyPr wrap="square">
+            <a:spAutoFit/>
+          </a:bodyPr>
+          <a:lstStyle/>
+          <a:p>
+            <a:pPr algn="l">
+              <a:spcAft>
+                <a:spcPts val="0"/>
+              </a:spcAft>
+            </a:pPr>
+            <a:r>
+              <a:rPr sz="2600" b="1" i="0">
+                <a:solidFill>
+                  <a:srgbClr val="2F6DB5"/>
+                </a:solidFill>
+                <a:latin typeface="Calibri"/>
+              </a:rPr>
+              <a:t>1</a:t>
+            </a:r>
+          </a:p>
+        </p:txBody>
+      </p:sp>
+      <p:sp>
+        <p:nvSpPr>
+          <p:cNvPr id="9" name="TextBox 8"/>
+          <p:cNvSpPr txBox="1"/>
+          <p:nvPr/>
+        </p:nvSpPr>
+        <p:spPr>
+          <a:xfrm>
+            <a:off x="1188719" y="2011680"/>
+            <a:ext cx="3337560" cy="320040"/>
+          </a:xfrm>
+          <a:prstGeom prst="rect">
+            <a:avLst/>
+          </a:prstGeom>
+          <a:noFill/>
+        </p:spPr>
+        <p:txBody>
+          <a:bodyPr wrap="square">
+            <a:spAutoFit/>
+          </a:bodyPr>
+          <a:lstStyle/>
+          <a:p>
+            <a:pPr algn="l">
+              <a:spcAft>
+                <a:spcPts val="0"/>
+              </a:spcAft>
+            </a:pPr>
+            <a:r>
+              <a:rPr sz="950" b="1" i="0">
+                <a:solidFill>
+                  <a:srgbClr val="2F6DB5"/>
+                </a:solidFill>
+                <a:latin typeface="Calibri"/>
+              </a:rPr>
+              <a:t>ESSENTIAL — this is Option 3</a:t>
+            </a:r>
+          </a:p>
+        </p:txBody>
+      </p:sp>
+      <p:sp>
+        <p:nvSpPr>
+          <p:cNvPr id="10" name="TextBox 9"/>
+          <p:cNvSpPr txBox="1"/>
+          <p:nvPr/>
+        </p:nvSpPr>
+        <p:spPr>
+          <a:xfrm>
+            <a:off x="1188719" y="2286000"/>
+            <a:ext cx="3337560" cy="640080"/>
+          </a:xfrm>
+          <a:prstGeom prst="rect">
+            <a:avLst/>
+          </a:prstGeom>
+          <a:noFill/>
+        </p:spPr>
+        <p:txBody>
+          <a:bodyPr wrap="square">
+            <a:spAutoFit/>
+          </a:bodyPr>
+          <a:lstStyle/>
+          <a:p>
+            <a:pPr algn="l">
+              <a:spcAft>
+                <a:spcPts val="0"/>
+              </a:spcAft>
+            </a:pPr>
+            <a:r>
+              <a:rPr sz="1400" b="1" i="0">
+                <a:solidFill>
+                  <a:srgbClr val="1F3864"/>
+                </a:solidFill>
+                <a:latin typeface="Calibri"/>
+              </a:rPr>
+              <a:t>Place a real order</a:t>
+            </a:r>
+          </a:p>
+        </p:txBody>
+      </p:sp>
+      <p:sp>
+        <p:nvSpPr>
+          <p:cNvPr id="11" name="TextBox 10"/>
+          <p:cNvSpPr txBox="1"/>
+          <p:nvPr/>
+        </p:nvSpPr>
+        <p:spPr>
+          <a:xfrm>
+            <a:off x="685800" y="2971800"/>
+            <a:ext cx="3840480" cy="1371600"/>
+          </a:xfrm>
+          <a:prstGeom prst="rect">
+            <a:avLst/>
+          </a:prstGeom>
+          <a:noFill/>
+        </p:spPr>
+        <p:txBody>
+          <a:bodyPr wrap="square">
+            <a:spAutoFit/>
+          </a:bodyPr>
+          <a:lstStyle/>
+          <a:p>
+            <a:pPr algn="l">
+              <a:spcAft>
+                <a:spcPts val="0"/>
+              </a:spcAft>
+            </a:pPr>
+            <a:r>
+              <a:rPr sz="1050" b="0" i="0">
+                <a:solidFill>
+                  <a:srgbClr val="595959"/>
+                </a:solidFill>
+                <a:latin typeface="Calibri"/>
+              </a:rPr>
+              <a:t>One 5-drum batch, repeated 1–3 times a year. The only instrument that pays PCI with revenue and proves production scale; without it the other two are paperwork.</a:t>
+            </a:r>
+          </a:p>
+        </p:txBody>
+      </p:sp>
+      <p:sp>
+        <p:nvSpPr>
+          <p:cNvPr id="12" name="TextBox 11"/>
+          <p:cNvSpPr txBox="1"/>
+          <p:nvPr/>
+        </p:nvSpPr>
+        <p:spPr>
+          <a:xfrm>
+            <a:off x="685800" y="4434840"/>
+            <a:ext cx="3840480" cy="731520"/>
+          </a:xfrm>
+          <a:prstGeom prst="rect">
+            <a:avLst/>
+          </a:prstGeom>
+          <a:noFill/>
+        </p:spPr>
+        <p:txBody>
+          <a:bodyPr wrap="square">
+            <a:spAutoFit/>
+          </a:bodyPr>
+          <a:lstStyle/>
+          <a:p>
+            <a:pPr algn="l">
+              <a:spcAft>
+                <a:spcPts val="300"/>
+              </a:spcAft>
+            </a:pPr>
+            <a:r>
+              <a:rPr sz="1000" b="1" i="0">
+                <a:solidFill>
+                  <a:srgbClr val="1F3864"/>
+                </a:solidFill>
+                <a:latin typeface="Calibri"/>
+              </a:rPr>
+              <a:t>Our cost: $7.9k per batch</a:t>
+            </a:r>
+          </a:p>
+          <a:p>
+            <a:pPr algn="l">
+              <a:spcAft>
+                <a:spcPts val="0"/>
+              </a:spcAft>
+            </a:pPr>
+            <a:r>
+              <a:rPr sz="1000" b="0" i="0">
+                <a:solidFill>
+                  <a:srgbClr val="595959"/>
+                </a:solidFill>
+                <a:latin typeface="Calibri"/>
+              </a:rPr>
+              <a:t>PCI gets: A customer, not an experiment</a:t>
+            </a:r>
+          </a:p>
+        </p:txBody>
+      </p:sp>
+      <p:sp>
+        <p:nvSpPr>
+          <p:cNvPr id="13" name="Rectangle 12"/>
+          <p:cNvSpPr/>
+          <p:nvPr/>
+        </p:nvSpPr>
+        <p:spPr>
+          <a:xfrm>
+            <a:off x="4800600" y="1828800"/>
+            <a:ext cx="3657600" cy="3383280"/>
+          </a:xfrm>
+          <a:prstGeom prst="rect">
+            <a:avLst/>
+          </a:prstGeom>
+          <a:solidFill>
+            <a:srgbClr val="DCE8F6"/>
+          </a:solidFill>
+          <a:ln>
+            <a:noFill/>
+          </a:ln>
+          <a:effectLst/>
+        </p:spPr>
+        <p:style>
+          <a:lnRef idx="1">
+            <a:schemeClr val="accent1"/>
+          </a:lnRef>
+          <a:fillRef idx="3">
+            <a:schemeClr val="accent1"/>
+          </a:fillRef>
+          <a:effectRef idx="2">
+            <a:schemeClr val="accent1"/>
+          </a:effectRef>
+          <a:fontRef idx="minor">
+            <a:schemeClr val="lt1"/>
+          </a:fontRef>
+        </p:style>
+        <p:txBody>
+          <a:bodyPr rtlCol="0" anchor="ctr"/>
+          <a:lstStyle/>
+          <a:p>
+            <a:pPr algn="ctr"/>
+          </a:p>
+        </p:txBody>
+      </p:sp>
+      <p:sp>
+        <p:nvSpPr>
+          <p:cNvPr id="14" name="Rectangle 13"/>
+          <p:cNvSpPr/>
+          <p:nvPr/>
+        </p:nvSpPr>
+        <p:spPr>
+          <a:xfrm>
+            <a:off x="4800600" y="1828800"/>
+            <a:ext cx="3657600" cy="82296"/>
+          </a:xfrm>
+          <a:prstGeom prst="rect">
+            <a:avLst/>
+          </a:prstGeom>
+          <a:solidFill>
+            <a:srgbClr val="2F6DB5"/>
+          </a:solidFill>
+          <a:ln>
+            <a:noFill/>
+          </a:ln>
+          <a:effectLst/>
+        </p:spPr>
+        <p:style>
+          <a:lnRef idx="1">
+            <a:schemeClr val="accent1"/>
+          </a:lnRef>
+          <a:fillRef idx="3">
+            <a:schemeClr val="accent1"/>
+          </a:fillRef>
+          <a:effectRef idx="2">
+            <a:schemeClr val="accent1"/>
+          </a:effectRef>
+          <a:fontRef idx="minor">
+            <a:schemeClr val="lt1"/>
+          </a:fontRef>
+        </p:style>
+        <p:txBody>
+          <a:bodyPr rtlCol="0" anchor="ctr"/>
+          <a:lstStyle/>
+          <a:p>
+            <a:pPr algn="ctr"/>
+          </a:p>
+        </p:txBody>
+      </p:sp>
+      <p:sp>
+        <p:nvSpPr>
+          <p:cNvPr id="15" name="TextBox 14"/>
+          <p:cNvSpPr txBox="1"/>
+          <p:nvPr/>
+        </p:nvSpPr>
+        <p:spPr>
+          <a:xfrm>
+            <a:off x="4937760" y="1993392"/>
+            <a:ext cx="548640" cy="640080"/>
+          </a:xfrm>
+          <a:prstGeom prst="rect">
+            <a:avLst/>
+          </a:prstGeom>
+          <a:noFill/>
+        </p:spPr>
+        <p:txBody>
+          <a:bodyPr wrap="square">
+            <a:spAutoFit/>
+          </a:bodyPr>
+          <a:lstStyle/>
+          <a:p>
+            <a:pPr algn="l">
+              <a:spcAft>
+                <a:spcPts val="0"/>
+              </a:spcAft>
+            </a:pPr>
+            <a:r>
+              <a:rPr sz="2600" b="1" i="0">
+                <a:solidFill>
+                  <a:srgbClr val="2F6DB5"/>
+                </a:solidFill>
+                <a:latin typeface="Calibri"/>
+              </a:rPr>
+              <a:t>2</a:t>
+            </a:r>
+          </a:p>
+        </p:txBody>
+      </p:sp>
+      <p:sp>
+        <p:nvSpPr>
+          <p:cNvPr id="16" name="TextBox 15"/>
+          <p:cNvSpPr txBox="1"/>
+          <p:nvPr/>
+        </p:nvSpPr>
+        <p:spPr>
+          <a:xfrm>
+            <a:off x="5440680" y="2011680"/>
+            <a:ext cx="2880360" cy="320040"/>
+          </a:xfrm>
+          <a:prstGeom prst="rect">
+            <a:avLst/>
+          </a:prstGeom>
+          <a:noFill/>
+        </p:spPr>
+        <p:txBody>
+          <a:bodyPr wrap="square">
+            <a:spAutoFit/>
+          </a:bodyPr>
+          <a:lstStyle/>
+          <a:p>
+            <a:pPr algn="l">
+              <a:spcAft>
+                <a:spcPts val="0"/>
+              </a:spcAft>
+            </a:pPr>
+            <a:r>
+              <a:rPr sz="950" b="1" i="0">
+                <a:solidFill>
+                  <a:srgbClr val="2F6DB5"/>
+                </a:solidFill>
+                <a:latin typeface="Calibri"/>
+              </a:rPr>
+              <a:t>ESSENTIAL — costs almost nothing</a:t>
+            </a:r>
+          </a:p>
+        </p:txBody>
+      </p:sp>
+      <p:sp>
+        <p:nvSpPr>
+          <p:cNvPr id="17" name="TextBox 16"/>
+          <p:cNvSpPr txBox="1"/>
+          <p:nvPr/>
+        </p:nvSpPr>
+        <p:spPr>
+          <a:xfrm>
+            <a:off x="5440680" y="2286000"/>
+            <a:ext cx="2880360" cy="640080"/>
+          </a:xfrm>
+          <a:prstGeom prst="rect">
+            <a:avLst/>
+          </a:prstGeom>
+          <a:noFill/>
+        </p:spPr>
+        <p:txBody>
+          <a:bodyPr wrap="square">
+            <a:spAutoFit/>
+          </a:bodyPr>
+          <a:lstStyle/>
+          <a:p>
+            <a:pPr algn="l">
+              <a:spcAft>
+                <a:spcPts val="0"/>
+              </a:spcAft>
+            </a:pPr>
+            <a:r>
+              <a:rPr sz="1400" b="1" i="0">
+                <a:solidFill>
+                  <a:srgbClr val="1F3864"/>
+                </a:solidFill>
+                <a:latin typeface="Calibri"/>
+              </a:rPr>
+              <a:t>Sign terms with no volume commitment</a:t>
+            </a:r>
+          </a:p>
+        </p:txBody>
+      </p:sp>
+      <p:sp>
+        <p:nvSpPr>
+          <p:cNvPr id="18" name="TextBox 17"/>
+          <p:cNvSpPr txBox="1"/>
+          <p:nvPr/>
+        </p:nvSpPr>
+        <p:spPr>
+          <a:xfrm>
+            <a:off x="4937760" y="2971800"/>
+            <a:ext cx="3383280" cy="1371600"/>
+          </a:xfrm>
+          <a:prstGeom prst="rect">
+            <a:avLst/>
+          </a:prstGeom>
+          <a:noFill/>
+        </p:spPr>
+        <p:txBody>
+          <a:bodyPr wrap="square">
+            <a:spAutoFit/>
+          </a:bodyPr>
+          <a:lstStyle/>
+          <a:p>
+            <a:pPr algn="l">
+              <a:spcAft>
+                <a:spcPts val="0"/>
+              </a:spcAft>
+            </a:pPr>
+            <a:r>
+              <a:rPr sz="1050" b="0" i="0">
+                <a:solidFill>
+                  <a:srgbClr val="595959"/>
+                </a:solidFill>
+                <a:latin typeface="Calibri"/>
+              </a:rPr>
+              <a:t>$3.50/lb, spec, lead time, quality and change-notification terms, valid 12–24 months, zero minimum. Locks the economic core of Option 3 in writing: the batch price with no volume string.</a:t>
+            </a:r>
+          </a:p>
+        </p:txBody>
+      </p:sp>
+      <p:sp>
+        <p:nvSpPr>
+          <p:cNvPr id="19" name="TextBox 18"/>
+          <p:cNvSpPr txBox="1"/>
+          <p:nvPr/>
+        </p:nvSpPr>
+        <p:spPr>
+          <a:xfrm>
+            <a:off x="4937760" y="4434840"/>
+            <a:ext cx="3383280" cy="731520"/>
+          </a:xfrm>
+          <a:prstGeom prst="rect">
+            <a:avLst/>
+          </a:prstGeom>
+          <a:noFill/>
+        </p:spPr>
+        <p:txBody>
+          <a:bodyPr wrap="square">
+            <a:spAutoFit/>
+          </a:bodyPr>
+          <a:lstStyle/>
+          <a:p>
+            <a:pPr algn="l">
+              <a:spcAft>
+                <a:spcPts val="300"/>
+              </a:spcAft>
+            </a:pPr>
+            <a:r>
+              <a:rPr sz="1000" b="1" i="0">
+                <a:solidFill>
+                  <a:srgbClr val="1F3864"/>
+                </a:solidFill>
+                <a:latin typeface="Calibri"/>
+              </a:rPr>
+              <a:t>Our cost: Legal time</a:t>
+            </a:r>
+          </a:p>
+          <a:p>
+            <a:pPr algn="l">
+              <a:spcAft>
+                <a:spcPts val="0"/>
+              </a:spcAft>
+            </a:pPr>
+            <a:r>
+              <a:rPr sz="1000" b="0" i="0">
+                <a:solidFill>
+                  <a:srgbClr val="595959"/>
+                </a:solidFill>
+                <a:latin typeface="Calibri"/>
+              </a:rPr>
+              <a:t>PCI gets: 'Approved second source' status they can show</a:t>
+            </a:r>
+          </a:p>
+        </p:txBody>
+      </p:sp>
+      <p:sp>
+        <p:nvSpPr>
+          <p:cNvPr id="20" name="Rectangle 19"/>
+          <p:cNvSpPr/>
+          <p:nvPr/>
+        </p:nvSpPr>
+        <p:spPr>
+          <a:xfrm>
+            <a:off x="8595360" y="1828800"/>
+            <a:ext cx="3017520" cy="3383280"/>
           </a:xfrm>
           <a:prstGeom prst="rect">
             <a:avLst/>
@@ -13134,14 +13140,58 @@
       </p:sp>
       <p:sp>
         <p:nvSpPr>
-          <p:cNvPr id="8" name="TextBox 7"/>
+          <p:cNvPr id="21" name="Rectangle 20"/>
+          <p:cNvSpPr/>
+          <p:nvPr/>
+        </p:nvSpPr>
+        <p:spPr>
+          <a:xfrm>
+            <a:off x="8595360" y="1828800"/>
+            <a:ext cx="3017520" cy="82296"/>
+          </a:xfrm>
+          <a:prstGeom prst="rect">
+            <a:avLst/>
+          </a:prstGeom>
+          <a:solidFill>
+            <a:srgbClr val="8E9BA7"/>
+          </a:solidFill>
+          <a:ln>
+            <a:noFill/>
+          </a:ln>
+          <a:effectLst/>
+        </p:spPr>
+        <p:style>
+          <a:lnRef idx="1">
+            <a:schemeClr val="accent1"/>
+          </a:lnRef>
+          <a:fillRef idx="3">
+            <a:schemeClr val="accent1"/>
+          </a:fillRef>
+          <a:effectRef idx="2">
+            <a:schemeClr val="accent1"/>
+          </a:effectRef>
+          <a:fontRef idx="minor">
+            <a:schemeClr val="lt1"/>
+          </a:fontRef>
+        </p:style>
+        <p:txBody>
+          <a:bodyPr rtlCol="0" anchor="ctr"/>
+          <a:lstStyle/>
+          <a:p>
+            <a:pPr algn="ctr"/>
+          </a:p>
+        </p:txBody>
+      </p:sp>
+      <p:sp>
+        <p:nvSpPr>
+          <p:cNvPr id="22" name="TextBox 21"/>
           <p:cNvSpPr txBox="1"/>
           <p:nvPr/>
         </p:nvSpPr>
         <p:spPr>
           <a:xfrm>
-            <a:off x="731520" y="5148072"/>
-            <a:ext cx="10698480" cy="630936"/>
+            <a:off x="8732520" y="1993392"/>
+            <a:ext cx="548640" cy="640080"/>
           </a:xfrm>
           <a:prstGeom prst="rect">
             <a:avLst/>
@@ -13156,6 +13206,261 @@
           <a:p>
             <a:pPr algn="l">
               <a:spcAft>
+                <a:spcPts val="0"/>
+              </a:spcAft>
+            </a:pPr>
+            <a:r>
+              <a:rPr sz="2600" b="1" i="0">
+                <a:solidFill>
+                  <a:srgbClr val="8E9BA7"/>
+                </a:solidFill>
+                <a:latin typeface="Calibri"/>
+              </a:rPr>
+              <a:t>3</a:t>
+            </a:r>
+          </a:p>
+        </p:txBody>
+      </p:sp>
+      <p:sp>
+        <p:nvSpPr>
+          <p:cNvPr id="23" name="TextBox 22"/>
+          <p:cNvSpPr txBox="1"/>
+          <p:nvPr/>
+        </p:nvSpPr>
+        <p:spPr>
+          <a:xfrm>
+            <a:off x="9235440" y="2011680"/>
+            <a:ext cx="2240279" cy="320040"/>
+          </a:xfrm>
+          <a:prstGeom prst="rect">
+            <a:avLst/>
+          </a:prstGeom>
+          <a:noFill/>
+        </p:spPr>
+        <p:txBody>
+          <a:bodyPr wrap="square">
+            <a:spAutoFit/>
+          </a:bodyPr>
+          <a:lstStyle/>
+          <a:p>
+            <a:pPr algn="l">
+              <a:spcAft>
+                <a:spcPts val="0"/>
+              </a:spcAft>
+            </a:pPr>
+            <a:r>
+              <a:rPr sz="950" b="1" i="0">
+                <a:solidFill>
+                  <a:srgbClr val="8E9BA7"/>
+                </a:solidFill>
+                <a:latin typeface="Calibri"/>
+              </a:rPr>
+              <a:t>ONLY UNDER OPTION 2</a:t>
+            </a:r>
+          </a:p>
+        </p:txBody>
+      </p:sp>
+      <p:sp>
+        <p:nvSpPr>
+          <p:cNvPr id="24" name="TextBox 23"/>
+          <p:cNvSpPr txBox="1"/>
+          <p:nvPr/>
+        </p:nvSpPr>
+        <p:spPr>
+          <a:xfrm>
+            <a:off x="9235440" y="2286000"/>
+            <a:ext cx="2240279" cy="640080"/>
+          </a:xfrm>
+          <a:prstGeom prst="rect">
+            <a:avLst/>
+          </a:prstGeom>
+          <a:noFill/>
+        </p:spPr>
+        <p:txBody>
+          <a:bodyPr wrap="square">
+            <a:spAutoFit/>
+          </a:bodyPr>
+          <a:lstStyle/>
+          <a:p>
+            <a:pPr algn="l">
+              <a:spcAft>
+                <a:spcPts val="0"/>
+              </a:spcAft>
+            </a:pPr>
+            <a:r>
+              <a:rPr sz="1400" b="1" i="0">
+                <a:solidFill>
+                  <a:srgbClr val="1F3864"/>
+                </a:solidFill>
+                <a:latin typeface="Calibri"/>
+              </a:rPr>
+              <a:t>Pay for the work already done</a:t>
+            </a:r>
+          </a:p>
+        </p:txBody>
+      </p:sp>
+      <p:sp>
+        <p:nvSpPr>
+          <p:cNvPr id="25" name="TextBox 24"/>
+          <p:cNvSpPr txBox="1"/>
+          <p:nvPr/>
+        </p:nvSpPr>
+        <p:spPr>
+          <a:xfrm>
+            <a:off x="8732520" y="2971800"/>
+            <a:ext cx="2743200" cy="1371600"/>
+          </a:xfrm>
+          <a:prstGeom prst="rect">
+            <a:avLst/>
+          </a:prstGeom>
+          <a:noFill/>
+        </p:spPr>
+        <p:txBody>
+          <a:bodyPr wrap="square">
+            <a:spAutoFit/>
+          </a:bodyPr>
+          <a:lstStyle/>
+          <a:p>
+            <a:pPr algn="l">
+              <a:spcAft>
+                <a:spcPts val="0"/>
+              </a:spcAft>
+            </a:pPr>
+            <a:r>
+              <a:rPr sz="1050" b="0" i="0">
+                <a:solidFill>
+                  <a:srgbClr val="595959"/>
+                </a:solidFill>
+                <a:latin typeface="Calibri"/>
+              </a:rPr>
+              <a:t>A development fee for the lab batches, studies and paperwork PCI did for free. Repairs the goodwill if we place no order. Under Option 3 the first batch is the payment, so this drops away.</a:t>
+            </a:r>
+          </a:p>
+        </p:txBody>
+      </p:sp>
+      <p:sp>
+        <p:nvSpPr>
+          <p:cNvPr id="26" name="TextBox 25"/>
+          <p:cNvSpPr txBox="1"/>
+          <p:nvPr/>
+        </p:nvSpPr>
+        <p:spPr>
+          <a:xfrm>
+            <a:off x="8732520" y="4434840"/>
+            <a:ext cx="2743200" cy="731520"/>
+          </a:xfrm>
+          <a:prstGeom prst="rect">
+            <a:avLst/>
+          </a:prstGeom>
+          <a:noFill/>
+        </p:spPr>
+        <p:txBody>
+          <a:bodyPr wrap="square">
+            <a:spAutoFit/>
+          </a:bodyPr>
+          <a:lstStyle/>
+          <a:p>
+            <a:pPr algn="l">
+              <a:spcAft>
+                <a:spcPts val="300"/>
+              </a:spcAft>
+            </a:pPr>
+            <a:r>
+              <a:rPr sz="1000" b="1" i="0">
+                <a:solidFill>
+                  <a:srgbClr val="1F3864"/>
+                </a:solidFill>
+                <a:latin typeface="Calibri"/>
+              </a:rPr>
+              <a:t>Our cost: ~$5–10k once, if at all</a:t>
+            </a:r>
+          </a:p>
+          <a:p>
+            <a:pPr algn="l">
+              <a:spcAft>
+                <a:spcPts val="0"/>
+              </a:spcAft>
+            </a:pPr>
+            <a:r>
+              <a:rPr sz="1000" b="0" i="0">
+                <a:solidFill>
+                  <a:srgbClr val="595959"/>
+                </a:solidFill>
+                <a:latin typeface="Calibri"/>
+              </a:rPr>
+              <a:t>PCI gets: Paid for its effort</a:t>
+            </a:r>
+          </a:p>
+        </p:txBody>
+      </p:sp>
+      <p:sp>
+        <p:nvSpPr>
+          <p:cNvPr id="27" name="Rectangle 26"/>
+          <p:cNvSpPr/>
+          <p:nvPr/>
+        </p:nvSpPr>
+        <p:spPr>
+          <a:xfrm>
+            <a:off x="548640" y="5349240"/>
+            <a:ext cx="11064240" cy="566928"/>
+          </a:xfrm>
+          <a:prstGeom prst="rect">
+            <a:avLst/>
+          </a:prstGeom>
+          <a:solidFill>
+            <a:srgbClr val="F6F8FB"/>
+          </a:solidFill>
+          <a:ln>
+            <a:noFill/>
+          </a:ln>
+          <a:effectLst/>
+        </p:spPr>
+        <p:style>
+          <a:lnRef idx="1">
+            <a:schemeClr val="accent1"/>
+          </a:lnRef>
+          <a:fillRef idx="3">
+            <a:schemeClr val="accent1"/>
+          </a:fillRef>
+          <a:effectRef idx="2">
+            <a:schemeClr val="accent1"/>
+          </a:effectRef>
+          <a:fontRef idx="minor">
+            <a:schemeClr val="lt1"/>
+          </a:fontRef>
+        </p:style>
+        <p:txBody>
+          <a:bodyPr rtlCol="0" anchor="ctr"/>
+          <a:lstStyle/>
+          <a:p>
+            <a:pPr algn="ctr"/>
+          </a:p>
+        </p:txBody>
+      </p:sp>
+      <p:sp>
+        <p:nvSpPr>
+          <p:cNvPr id="28" name="TextBox 27"/>
+          <p:cNvSpPr txBox="1"/>
+          <p:nvPr/>
+        </p:nvSpPr>
+        <p:spPr>
+          <a:xfrm>
+            <a:off x="731520" y="5468112"/>
+            <a:ext cx="10698480" cy="329184"/>
+          </a:xfrm>
+          <a:prstGeom prst="rect">
+            <a:avLst/>
+          </a:prstGeom>
+          <a:noFill/>
+        </p:spPr>
+        <p:txBody>
+          <a:bodyPr wrap="square">
+            <a:spAutoFit/>
+          </a:bodyPr>
+          <a:lstStyle/>
+          <a:p>
+            <a:pPr algn="l">
+              <a:spcAft>
                 <a:spcPts val="600"/>
               </a:spcAft>
             </a:pPr>
@@ -13176,20 +13481,20 @@
               </a:spcAft>
             </a:pPr>
             <a:r>
-              <a:rPr sz="1050" b="0" i="0">
+              <a:rPr sz="950" b="0" i="0">
                 <a:solidFill>
                   <a:srgbClr val="595959"/>
                 </a:solidFill>
                 <a:latin typeface="Calibri"/>
               </a:rPr>
-              <a:t>•  Tell PCI the volume reality and the exact triggers · pay promptly · share the test results · a quarterly touchpoint · a reference. Suppliers allocate goodwill on trust, long-term orientation and growth prospects — not on current volume (Pulles, Schiele et al. 2016).</a:t>
-            </a:r>
-          </a:p>
-        </p:txBody>
-      </p:sp>
-      <p:sp>
-        <p:nvSpPr>
-          <p:cNvPr id="9" name="Rectangle 8"/>
+              <a:t>•  Tell PCI the volume reality and the exact triggers · pay promptly · share the test results · a quarterly touchpoint. Suppliers allocate goodwill on trust and growth prospects, not on current volume (Pulles, Schiele et al. 2016).</a:t>
+            </a:r>
+          </a:p>
+        </p:txBody>
+      </p:sp>
+      <p:sp>
+        <p:nvSpPr>
+          <p:cNvPr id="29" name="Rectangle 28"/>
           <p:cNvSpPr/>
           <p:nvPr/>
         </p:nvSpPr>
@@ -13233,7 +13538,7 @@
       </p:sp>
       <p:sp>
         <p:nvSpPr>
-          <p:cNvPr id="10" name="TextBox 9"/>
+          <p:cNvPr id="30" name="TextBox 29"/>
           <p:cNvSpPr txBox="1"/>
           <p:nvPr/>
         </p:nvSpPr>
@@ -13265,7 +13570,7 @@
                 </a:solidFill>
                 <a:latin typeface="Calibri"/>
               </a:rPr>
-              <a:t>Barely using a qualified supplier is normal. Pay for the work, sign the terms, state the triggers, order a batch or two a year — and the door stays open.</a:t>
+              <a:t>Order a batch or two a year and put the terms in writing — that is what keeps the door open. A fee for the work done is the fallback if we order nothing.</a:t>
             </a:r>
           </a:p>
         </p:txBody>

</xml_diff>

<commit_message>
Remove ISO 13485 / QMSR / GHTF references (not our regulatory basis); conduct panel fits
Co-Authored-By: Claude Fable 5.1 <noreply@anthropic.com>
Claude-Session: https://claude.ai/code/session_01LkE2ZRYs3PLyj8XHTsU3i4
</commit_message>
<xml_diff>
--- a/PVA second supplier initiative/PVA_Second_Supplier_Leadership_Deck.pptx
+++ b/PVA second supplier initiative/PVA_Second_Supplier_Leadership_Deck.pptx
@@ -1071,7 +1071,7 @@
           <a:lstStyle/>
           <a:p>
             <a:r>
-              <a:t>Why decide now. Our next conversation with SNP is where the strategy becomes real - continuity terms, forecast sharing, resin consignment, capacity headroom, succession. The posture has to match the decision: we cannot ask for a deeper partnership and, in the same period, plan to move a third of their core line without telling them - announcing it afterwards would undo the partnership conversation. If the answer is Option 1, bring a package, not a cut: a three-year commitment on about a hundred drums a year growing ten percent - back to today's absolute volume by about year five - a level cadence, forecast sharing, a joint hydrogel roadmap; reason given, a quality-system continuity requirement. If it is Option 2 or 3, that is the partnership conversation: our continuity file includes a qualified alternate cooker and, under Option 3, a verification lot or two a year - the supplier is not named and the quote is not shown - the same continuity discipline we are asking SNP to document. Give first, then ask. Decide first; use the conversation to execute, not to discover.</a:t>
+              <a:t>Why decide now. Our next conversation with SNP is where the strategy becomes real - continuity terms, forecast sharing, resin consignment, capacity headroom, succession. The posture has to match the decision: we cannot ask for a deeper partnership and, in the same period, plan to move a third of their core line without telling them - announcing it afterwards would undo the partnership conversation. If the answer is Option 1, bring a package, not a cut: a three-year commitment on about a hundred drums a year growing ten percent - back to today's absolute volume by about year five - a level cadence, forecast sharing, a joint hydrogel roadmap; reason given, a supply-continuity requirement. If it is Option 2 or 3, that is the partnership conversation: our continuity file includes a qualified alternate cooker and, under Option 3, a verification lot or two a year - the supplier is not named and the quote is not shown - the same continuity discipline we are asking SNP to document. Give first, then ask. Decide first; use the conversation to execute, not to discover.</a:t>
             </a:r>
           </a:p>
         </p:txBody>
@@ -5233,7 +5233,7 @@
                 </a:solidFill>
                 <a:latin typeface="Calibri"/>
               </a:rPr>
-              <a:t>Kraljic (HBR 1983), bottleneck items: 'Volume insurance (at cost premium if necessary). Control of vendors. Security of inventories. Backup plans.' Gelderman &amp; van Weele (2003): 'hold' vs 'move'. Simchi-Levi et al. (Interfaces 2015): disruption impact is uncorrelated with spend. Sheffi &amp; Rice (MIT SMR 2005): single sourcing is legitimate only with a deep, managed relationship. Tomlin (2006); Chopra &amp; Sodhi (2014): assuming zero disruption probability is the expensive mistake. Pulles, Schiele et al. (2016): preferential treatment follows attractiveness, not volume. Deloitte Chief Procurement Officer (CPO) Survey 2025: 'active alternative sources' rated most effective (74%). QMSR / ISO 13485 §7.4 / GHTF N17: controls proportionate to risk — no second source required. Six lenses; four refuted claims excluded; memo in the repo.</a:t>
+              <a:t>Kraljic (HBR 1983), bottleneck items: 'Volume insurance (at cost premium if necessary). Control of vendors. Security of inventories. Backup plans.' Gelderman &amp; van Weele (2003): 'hold' vs 'move'. Simchi-Levi et al. (Interfaces 2015): disruption impact is uncorrelated with spend. Sheffi &amp; Rice (MIT SMR 2005): single sourcing is legitimate only with a deep, managed relationship. Tomlin (2006); Chopra &amp; Sodhi (2014): assuming zero disruption probability is the expensive mistake. Pulles, Schiele et al. (2016): preferential treatment follows attractiveness, not volume. Deloitte Chief Procurement Officer (CPO) Survey 2025: 'active alternative sources' rated most effective (74%). No standard or regulation we work under requires a second source; controls are proportionate to risk. Six lenses; four refuted claims excluded; memo in the repo.</a:t>
             </a:r>
           </a:p>
         </p:txBody>
@@ -5788,81 +5788,6 @@
                 <a:latin typeface="Calibri"/>
               </a:rPr>
               <a:t>— Chief Procurement Officer</a:t>
-            </a:r>
-          </a:p>
-          <a:p>
-            <a:pPr>
-              <a:spcAft>
-                <a:spcPts val="100"/>
-              </a:spcAft>
-            </a:pPr>
-            <a:r>
-              <a:rPr b="1" sz="900">
-                <a:solidFill>
-                  <a:srgbClr val="1F3864"/>
-                </a:solidFill>
-                <a:latin typeface="Calibri"/>
-              </a:rPr>
-              <a:t>QMSR  </a:t>
-            </a:r>
-            <a:r>
-              <a:rPr sz="900">
-                <a:solidFill>
-                  <a:srgbClr val="595959"/>
-                </a:solidFill>
-                <a:latin typeface="Calibri"/>
-              </a:rPr>
-              <a:t>— FDA Quality Management System Regulation</a:t>
-            </a:r>
-          </a:p>
-          <a:p>
-            <a:pPr>
-              <a:spcAft>
-                <a:spcPts val="100"/>
-              </a:spcAft>
-            </a:pPr>
-            <a:r>
-              <a:rPr b="1" sz="900">
-                <a:solidFill>
-                  <a:srgbClr val="1F3864"/>
-                </a:solidFill>
-                <a:latin typeface="Calibri"/>
-              </a:rPr>
-              <a:t>ISO  </a:t>
-            </a:r>
-            <a:r>
-              <a:rPr sz="900">
-                <a:solidFill>
-                  <a:srgbClr val="595959"/>
-                </a:solidFill>
-                <a:latin typeface="Calibri"/>
-              </a:rPr>
-              <a:t>— International Organization for Standardization</a:t>
-            </a:r>
-          </a:p>
-          <a:p>
-            <a:pPr>
-              <a:spcAft>
-                <a:spcPts val="100"/>
-              </a:spcAft>
-            </a:pPr>
-            <a:r>
-              <a:rPr b="1" sz="900">
-                <a:solidFill>
-                  <a:srgbClr val="1F3864"/>
-                </a:solidFill>
-                <a:latin typeface="Calibri"/>
-              </a:rPr>
-              <a:t>GHTF  </a:t>
-            </a:r>
-            <a:r>
-              <a:rPr sz="900">
-                <a:solidFill>
-                  <a:srgbClr val="595959"/>
-                </a:solidFill>
-                <a:latin typeface="Calibri"/>
-              </a:rPr>
-              <a:t>— Global Harmonization Task Force</a:t>
             </a:r>
           </a:p>
           <a:p>
@@ -12505,7 +12430,7 @@
         <p:spPr>
           <a:xfrm>
             <a:off x="548640" y="1828800"/>
-            <a:ext cx="4114800" cy="3383280"/>
+            <a:ext cx="4114800" cy="3154680"/>
           </a:xfrm>
           <a:prstGeom prst="rect">
             <a:avLst/>
@@ -12748,7 +12673,7 @@
         </p:nvSpPr>
         <p:spPr>
           <a:xfrm>
-            <a:off x="685800" y="4434840"/>
+            <a:off x="685800" y="4206240"/>
             <a:ext cx="3840480" cy="731520"/>
           </a:xfrm>
           <a:prstGeom prst="rect">
@@ -12804,7 +12729,7 @@
         <p:spPr>
           <a:xfrm>
             <a:off x="4800600" y="1828800"/>
-            <a:ext cx="3657600" cy="3383280"/>
+            <a:ext cx="3657600" cy="3154680"/>
           </a:xfrm>
           <a:prstGeom prst="rect">
             <a:avLst/>
@@ -13047,7 +12972,7 @@
         </p:nvSpPr>
         <p:spPr>
           <a:xfrm>
-            <a:off x="4937760" y="4434840"/>
+            <a:off x="4937760" y="4206240"/>
             <a:ext cx="3383280" cy="731520"/>
           </a:xfrm>
           <a:prstGeom prst="rect">
@@ -13103,7 +13028,7 @@
         <p:spPr>
           <a:xfrm>
             <a:off x="8595360" y="1828800"/>
-            <a:ext cx="3017520" cy="3383280"/>
+            <a:ext cx="3017520" cy="3154680"/>
           </a:xfrm>
           <a:prstGeom prst="rect">
             <a:avLst/>
@@ -13346,7 +13271,7 @@
         </p:nvSpPr>
         <p:spPr>
           <a:xfrm>
-            <a:off x="8732520" y="4434840"/>
+            <a:off x="8732520" y="4206240"/>
             <a:ext cx="2743200" cy="731520"/>
           </a:xfrm>
           <a:prstGeom prst="rect">
@@ -13401,8 +13326,8 @@
         </p:nvSpPr>
         <p:spPr>
           <a:xfrm>
-            <a:off x="548640" y="5349240"/>
-            <a:ext cx="11064240" cy="566928"/>
+            <a:off x="548640" y="5120640"/>
+            <a:ext cx="11064240" cy="777240"/>
           </a:xfrm>
           <a:prstGeom prst="rect">
             <a:avLst/>
@@ -13445,8 +13370,8 @@
         </p:nvSpPr>
         <p:spPr>
           <a:xfrm>
-            <a:off x="731520" y="5468112"/>
-            <a:ext cx="10698480" cy="329184"/>
+            <a:off x="731520" y="5239512"/>
+            <a:ext cx="10698480" cy="539496"/>
           </a:xfrm>
           <a:prstGeom prst="rect">
             <a:avLst/>
@@ -13808,7 +13733,7 @@
                 </a:solidFill>
                 <a:latin typeface="Calibri"/>
               </a:rPr>
-              <a:t>bring a package, not a cut — a 3-year commitment on ~100 drums/yr growing 10%/yr, a level cadence, forecast sharing, a joint hydrogel roadmap. Reason given: a quality-system continuity requirement.</a:t>
+              <a:t>bring a package, not a cut — a 3-year commitment on ~100 drums/yr growing 10%/yr, a level cadence, forecast sharing, a joint hydrogel roadmap. Reason given: a supply-continuity requirement.</a:t>
             </a:r>
           </a:p>
           <a:p>
@@ -13833,7 +13758,7 @@
                 </a:solidFill>
                 <a:latin typeface="Calibri"/>
               </a:rPr>
-              <a:t>that is the partnership conversation. Our continuity file (ISO 13485 clause 7.4 / GHTF N17) includes a qualified alternate cooker and, under Option 3, a verification lot or two a year. The supplier is not named; the quote is not shown.</a:t>
+              <a:t>that is the partnership conversation. Our supply-continuity file includes a qualified alternate cooker and, under Option 3, a verification lot or two a year. The supplier is not named; the quote is not shown.</a:t>
             </a:r>
           </a:p>
         </p:txBody>

</xml_diff>

<commit_message>
Appendix: Option 3 at 1-3 batches, APV estimate row, restart-time row, acronyms pruned to those used
Co-Authored-By: Claude Fable 5.1 <noreply@anthropic.com>
Claude-Session: https://claude.ai/code/session_01LkE2ZRYs3PLyj8XHTsU3i4
</commit_message>
<xml_diff>
--- a/PVA second supplier initiative/PVA_Second_Supplier_Leadership_Deck.pptx
+++ b/PVA second supplier initiative/PVA_Second_Supplier_Leadership_Deck.pptx
@@ -12556,7 +12556,7 @@
         </p:nvGraphicFramePr>
         <p:xfrm>
           <a:off x="548640" y="1051560"/>
-          <a:ext cx="6309360" cy="2743200"/>
+          <a:ext cx="6309360" cy="2926080"/>
         </p:xfrm>
         <a:graphic>
           <a:graphicData uri="http://schemas.openxmlformats.org/drawingml/2006/table">
@@ -12569,7 +12569,7 @@
                 <a:gridCol w="2743200"/>
                 <a:gridCol w="2011680"/>
               </a:tblGrid>
-              <a:tr h="274320">
+              <a:tr h="266007">
                 <a:tc>
                   <a:txBody>
                     <a:bodyPr/>
@@ -12640,7 +12640,7 @@
                   </a:tcPr>
                 </a:tc>
               </a:tr>
-              <a:tr h="274320">
+              <a:tr h="266007">
                 <a:tc>
                   <a:txBody>
                     <a:bodyPr/>
@@ -12711,7 +12711,7 @@
                   </a:tcPr>
                 </a:tc>
               </a:tr>
-              <a:tr h="274320">
+              <a:tr h="266007">
                 <a:tc>
                   <a:txBody>
                     <a:bodyPr/>
@@ -12782,7 +12782,7 @@
                   </a:tcPr>
                 </a:tc>
               </a:tr>
-              <a:tr h="274320">
+              <a:tr h="266007">
                 <a:tc>
                   <a:txBody>
                     <a:bodyPr/>
@@ -12853,7 +12853,7 @@
                   </a:tcPr>
                 </a:tc>
               </a:tr>
-              <a:tr h="274320">
+              <a:tr h="266007">
                 <a:tc>
                   <a:txBody>
                     <a:bodyPr/>
@@ -12924,7 +12924,7 @@
                   </a:tcPr>
                 </a:tc>
               </a:tr>
-              <a:tr h="274320">
+              <a:tr h="266007">
                 <a:tc>
                   <a:txBody>
                     <a:bodyPr/>
@@ -12961,7 +12961,7 @@
                           </a:solidFill>
                           <a:latin typeface="Calibri"/>
                         </a:rPr>
-                        <a:t>1–2 batches/yr = 5–10 drums = 3–7% of demand; +$6.2–12.4k/yr</a:t>
+                        <a:t>1–3 batches/yr = 5–15 drums = 3–10% of demand; +$6.2–18.6k/yr</a:t>
                       </a:r>
                     </a:p>
                   </a:txBody>
@@ -12984,7 +12984,7 @@
                           </a:solidFill>
                           <a:latin typeface="Calibri"/>
                         </a:rPr>
-                        <a:t>$7.9k gross per batch ($3.50/lb × 2,250 lb)</a:t>
+                        <a:t>$7.9k per batch ($3.50/lb × 2,250 lb); no volume term on the price so far</a:t>
                       </a:r>
                     </a:p>
                   </a:txBody>
@@ -12995,7 +12995,7 @@
                   </a:tcPr>
                 </a:tc>
               </a:tr>
-              <a:tr h="274320">
+              <a:tr h="266007">
                 <a:tc>
                   <a:txBody>
                     <a:bodyPr/>
@@ -13066,7 +13066,7 @@
                   </a:tcPr>
                 </a:tc>
               </a:tr>
-              <a:tr h="274320">
+              <a:tr h="266007">
                 <a:tc>
                   <a:txBody>
                     <a:bodyPr/>
@@ -13137,7 +13137,78 @@
                   </a:tcPr>
                 </a:tc>
               </a:tr>
-              <a:tr h="274320">
+              <a:tr h="266007">
+                <a:tc>
+                  <a:txBody>
+                    <a:bodyPr/>
+                    <a:lstStyle/>
+                    <a:p>
+                      <a:pPr algn="l"/>
+                      <a:r>
+                        <a:rPr sz="800" b="1">
+                          <a:solidFill>
+                            <a:srgbClr val="1F3864"/>
+                          </a:solidFill>
+                          <a:latin typeface="Calibri"/>
+                        </a:rPr>
+                        <a:t>APV estimate</a:t>
+                      </a:r>
+                    </a:p>
+                  </a:txBody>
+                  <a:tcPr>
+                    <a:solidFill>
+                      <a:srgbClr val="FFFFFF"/>
+                    </a:solidFill>
+                  </a:tcPr>
+                </a:tc>
+                <a:tc>
+                  <a:txBody>
+                    <a:bodyPr/>
+                    <a:lstStyle/>
+                    <a:p>
+                      <a:pPr algn="ctr"/>
+                      <a:r>
+                        <a:rPr sz="800">
+                          <a:solidFill>
+                            <a:srgbClr val="1F3864"/>
+                          </a:solidFill>
+                          <a:latin typeface="Calibri"/>
+                        </a:rPr>
+                        <a:t>≥ $3.00/lb — never confirmed</a:t>
+                      </a:r>
+                    </a:p>
+                  </a:txBody>
+                  <a:tcPr>
+                    <a:solidFill>
+                      <a:srgbClr val="FFFFFF"/>
+                    </a:solidFill>
+                  </a:tcPr>
+                </a:tc>
+                <a:tc>
+                  <a:txBody>
+                    <a:bodyPr/>
+                    <a:lstStyle/>
+                    <a:p>
+                      <a:pPr algn="ctr"/>
+                      <a:r>
+                        <a:rPr sz="800">
+                          <a:solidFill>
+                            <a:srgbClr val="1F3864"/>
+                          </a:solidFill>
+                          <a:latin typeface="Calibri"/>
+                        </a:rPr>
+                        <a:t>Called $1.50/lb too cheap for our volume on our call</a:t>
+                      </a:r>
+                    </a:p>
+                  </a:txBody>
+                  <a:tcPr>
+                    <a:solidFill>
+                      <a:srgbClr val="FFFFFF"/>
+                    </a:solidFill>
+                  </a:tcPr>
+                </a:tc>
+              </a:tr>
+              <a:tr h="266007">
                 <a:tc>
                   <a:txBody>
                     <a:bodyPr/>
@@ -13174,7 +13245,7 @@
                           </a:solidFill>
                           <a:latin typeface="Calibri"/>
                         </a:rPr>
-                        <a:t>~$15k to date (sunk); ~$15–40k to production release; PCI fee ~$5–10k</a:t>
+                        <a:t>~$15k of internal hours to date (sunk); ~$15–40k more to production release</a:t>
                       </a:r>
                     </a:p>
                   </a:txBody>
@@ -13197,7 +13268,7 @@
                           </a:solidFill>
                           <a:latin typeface="Calibri"/>
                         </a:rPr>
-                        <a:t>Memo §2.3; placeholders</a:t>
+                        <a:t>Placeholders; not in the purchase totals</a:t>
                       </a:r>
                     </a:p>
                   </a:txBody>
@@ -13208,7 +13279,7 @@
                   </a:tcPr>
                 </a:tc>
               </a:tr>
-              <a:tr h="274320">
+              <a:tr h="266010">
                 <a:tc>
                   <a:txBody>
                     <a:bodyPr/>
@@ -13222,7 +13293,7 @@
                           </a:solidFill>
                           <a:latin typeface="Calibri"/>
                         </a:rPr>
-                        <a:t>Outage risk / avoided loss</a:t>
+                        <a:t>Restart time if SNP fails</a:t>
                       </a:r>
                     </a:p>
                   </a:txBody>
@@ -13245,7 +13316,7 @@
                           </a:solidFill>
                           <a:latin typeface="Calibri"/>
                         </a:rPr>
-                        <a:t>2–5%/yr planning band (10% upper case); avoided loss not estimated</a:t>
+                        <a:t>Option 1 weeks (if ramp confirmed); Option 3 weeks to months; Option 2 ~3–6 months</a:t>
                       </a:r>
                     </a:p>
                   </a:txBody>
@@ -13268,7 +13339,7 @@
                           </a:solidFill>
                           <a:latin typeface="Calibri"/>
                         </a:rPr>
-                        <a:t>Memo §5.2; NEEDED from Finance</a:t>
+                        <a:t>Estimates; a cold start decays after ~12 months idle</a:t>
                       </a:r>
                     </a:p>
                   </a:txBody>
@@ -13291,8 +13362,8 @@
         </p:nvSpPr>
         <p:spPr>
           <a:xfrm>
-            <a:off x="548640" y="4572000"/>
-            <a:ext cx="6309360" cy="1645920"/>
+            <a:off x="548640" y="4663440"/>
+            <a:ext cx="6309360" cy="1554480"/>
           </a:xfrm>
           <a:prstGeom prst="rect">
             <a:avLst/>
@@ -13728,7 +13799,7 @@
                 </a:solidFill>
                 <a:latin typeface="Calibri"/>
               </a:rPr>
-              <a:t>CoA  </a:t>
+              <a:t>SQA  </a:t>
             </a:r>
             <a:r>
               <a:rPr sz="900">
@@ -13737,7 +13808,7 @@
                 </a:solidFill>
                 <a:latin typeface="Calibri"/>
               </a:rPr>
-              <a:t>— Certificate of Analysis</a:t>
+              <a:t>— Supplier Quality Agreement</a:t>
             </a:r>
           </a:p>
           <a:p>
@@ -13753,7 +13824,7 @@
                 </a:solidFill>
                 <a:latin typeface="Calibri"/>
               </a:rPr>
-              <a:t>SQA  </a:t>
+              <a:t>NDA  </a:t>
             </a:r>
             <a:r>
               <a:rPr sz="900">
@@ -13762,7 +13833,7 @@
                 </a:solidFill>
                 <a:latin typeface="Calibri"/>
               </a:rPr>
-              <a:t>— Supplier Quality Agreement</a:t>
+              <a:t>— non-disclosure agreement</a:t>
             </a:r>
           </a:p>
           <a:p>
@@ -13778,7 +13849,7 @@
                 </a:solidFill>
                 <a:latin typeface="Calibri"/>
               </a:rPr>
-              <a:t>NRE  </a:t>
+              <a:t>CPO  </a:t>
             </a:r>
             <a:r>
               <a:rPr sz="900">
@@ -13787,107 +13858,7 @@
                 </a:solidFill>
                 <a:latin typeface="Calibri"/>
               </a:rPr>
-              <a:t>— non-recurring engineering</a:t>
-            </a:r>
-          </a:p>
-          <a:p>
-            <a:pPr>
-              <a:spcAft>
-                <a:spcPts val="100"/>
-              </a:spcAft>
-            </a:pPr>
-            <a:r>
-              <a:rPr b="1" sz="900">
-                <a:solidFill>
-                  <a:srgbClr val="1F3864"/>
-                </a:solidFill>
-                <a:latin typeface="Calibri"/>
-              </a:rPr>
-              <a:t>NDA  </a:t>
-            </a:r>
-            <a:r>
-              <a:rPr sz="900">
-                <a:solidFill>
-                  <a:srgbClr val="595959"/>
-                </a:solidFill>
-                <a:latin typeface="Calibri"/>
-              </a:rPr>
-              <a:t>— non-disclosure agreement</a:t>
-            </a:r>
-          </a:p>
-          <a:p>
-            <a:pPr>
-              <a:spcAft>
-                <a:spcPts val="100"/>
-              </a:spcAft>
-            </a:pPr>
-            <a:r>
-              <a:rPr b="1" sz="900">
-                <a:solidFill>
-                  <a:srgbClr val="1F3864"/>
-                </a:solidFill>
-                <a:latin typeface="Calibri"/>
-              </a:rPr>
-              <a:t>PPAP  </a:t>
-            </a:r>
-            <a:r>
-              <a:rPr sz="900">
-                <a:solidFill>
-                  <a:srgbClr val="595959"/>
-                </a:solidFill>
-                <a:latin typeface="Calibri"/>
-              </a:rPr>
-              <a:t>— Production Part Approval Process</a:t>
-            </a:r>
-          </a:p>
-          <a:p>
-            <a:pPr>
-              <a:spcAft>
-                <a:spcPts val="100"/>
-              </a:spcAft>
-            </a:pPr>
-            <a:r>
-              <a:rPr b="1" sz="900">
-                <a:solidFill>
-                  <a:srgbClr val="1F3864"/>
-                </a:solidFill>
-                <a:latin typeface="Calibri"/>
-              </a:rPr>
-              <a:t>SKU  </a:t>
-            </a:r>
-            <a:r>
-              <a:rPr sz="900">
-                <a:solidFill>
-                  <a:srgbClr val="595959"/>
-                </a:solidFill>
-                <a:latin typeface="Calibri"/>
-              </a:rPr>
-              <a:t>— stock-keeping unit</a:t>
-            </a:r>
-          </a:p>
-          <a:p>
-            <a:pPr>
-              <a:spcAft>
-                <a:spcPts val="100"/>
-              </a:spcAft>
-            </a:pPr>
-            <a:r>
-              <a:rPr b="1" sz="900">
-                <a:solidFill>
-                  <a:srgbClr val="1F3864"/>
-                </a:solidFill>
-                <a:latin typeface="Calibri"/>
-              </a:rPr>
-              <a:t>CPO  </a:t>
-            </a:r>
-            <a:r>
-              <a:rPr sz="900">
-                <a:solidFill>
-                  <a:srgbClr val="595959"/>
-                </a:solidFill>
-                <a:latin typeface="Calibri"/>
-              </a:rPr>
-              <a:t>— Chief Procurement Officer</a:t>
+              <a:t>— Chief Procurement Officer (Deloitte survey)</a:t>
             </a:r>
           </a:p>
           <a:p>

</xml_diff>

<commit_message>
Appendix: frameworks block moved below the table
Co-Authored-By: Claude Fable 5.1 <noreply@anthropic.com>
Claude-Session: https://claude.ai/code/session_01LkE2ZRYs3PLyj8XHTsU3i4
</commit_message>
<xml_diff>
--- a/PVA second supplier initiative/PVA_Second_Supplier_Leadership_Deck.pptx
+++ b/PVA second supplier initiative/PVA_Second_Supplier_Leadership_Deck.pptx
@@ -13362,8 +13362,8 @@
         </p:nvSpPr>
         <p:spPr>
           <a:xfrm>
-            <a:off x="548640" y="4663440"/>
-            <a:ext cx="6309360" cy="1554480"/>
+            <a:off x="548640" y="4846320"/>
+            <a:ext cx="6309360" cy="1417320"/>
           </a:xfrm>
           <a:prstGeom prst="rect">
             <a:avLst/>
@@ -13398,7 +13398,7 @@
               </a:spcAft>
             </a:pPr>
             <a:r>
-              <a:rPr sz="760" b="0" i="0">
+              <a:rPr sz="730" b="0" i="0">
                 <a:solidFill>
                   <a:srgbClr val="595959"/>
                 </a:solidFill>

</xml_diff>

<commit_message>
Chronology: ~15-20 screened, funnel + three findings; Why-decide-now replaced by the SNP conversation outline with pre-meeting decisions (for review)
Co-Authored-By: Claude Fable 5.1 <noreply@anthropic.com>
Claude-Session: https://claude.ai/code/session_01LkE2ZRYs3PLyj8XHTsU3i4
</commit_message>
<xml_diff>
--- a/PVA second supplier initiative/PVA_Second_Supplier_Leadership_Deck.pptx
+++ b/PVA second supplier initiative/PVA_Second_Supplier_Leadership_Deck.pptx
@@ -720,7 +720,7 @@
           <a:lstStyle/>
           <a:p>
             <a:r>
-              <a:t>How we got here, as a series of events. November last year: Brenntag, a distributor, tried our formula - the viscosity came out above range, unreadable on their viscometer; they stalled and we never received a quote; in March they sent us a resin sample instead. March to April: we screened about 94 US suppliers and reached out to ArroChem, Piedmont and ILC Dover with one hard gate - hold 90 to 95 degrees. May: ArroChem - the right kind of company - could not get past 90 degrees, and ILC Dover could not reach it either. June 26: CJB cleared it and became the front-runner; APV confirmed heat but, on our call, called a dollar fifty a pound too cheap for our volume - so we estimate APV at three dollars or more, never confirmed; we confirmed demand at about three drums a week - 150 a year. July: Columbus Chemical, also the right kind of company, reached out to us and then told us directly they cannot hold the temperature - eliminated, never quoted. August 4: CJB's quote came in at 8 to 8.50 a pound for toll processing alone - eleven times SNP - and their trial would have cost 6,400 dollars; we declined, so we never corroborated whether they could actually make it. August to September: PCI Manufacturing ran two-plus lab batches and a dilution study, unpaid. September 22: PCI's test results - the viscosity was brought on target within the test by adjusting solids and water - and the spec was agreed. September 28: spec met, and a real quote of 3.50 a pound per five-drum batch. What it is worth: a cold start is now months, not a year. What it cost: PCI's unpaid engineering, and about 15 thousand of our own hours, sunk. Using it costs 62 thousand a year plus a permanent discipline; walking away costs goodwill; the middle is one or two batches a year.</a:t>
+              <a:t>How we got here, as a series of events. November last year: Brenntag, a distributor, tried our formula - the viscosity came out above range, unreadable on their viscometer; they stalled and we never received a quote; in March they sent us a resin sample instead. March to April: we screened fifteen to twenty serious candidates and reached out to ArroChem, Piedmont and ILC Dover with one hard gate - hold 90 to 95 degrees. May: ArroChem - the right kind of company - could not get past 90 degrees, and ILC Dover could not reach it either. June 26: CJB cleared it and became the front-runner; APV confirmed heat but, on our call, called a dollar fifty a pound too cheap for our volume - so we estimate APV at three dollars or more, never confirmed; we confirmed demand at about three drums a week - 150 a year. July: Columbus Chemical, also the right kind of company, reached out to us and then told us directly they cannot hold the temperature - eliminated, never quoted. August 4: CJB's quote came in at 8 to 8.50 a pound for toll processing alone - eleven times SNP - and their trial would have cost 6,400 dollars; we declined, so we never corroborated whether they could actually make it. August to September: PCI Manufacturing ran two-plus lab batches and a dilution study, unpaid. September 22: PCI's test results - the viscosity was brought on target within the test by adjusting solids and water - and the spec was agreed. September 28: spec met, and a real quote of 3.50 a pound per five-drum batch. What it is worth: a cold start is now months, not a year. What it cost: PCI's unpaid engineering, and about 15 thousand of our own hours, sunk. Using it costs 62 thousand a year plus a permanent discipline; walking away costs goodwill; the middle is one or two batches a year.</a:t>
             </a:r>
           </a:p>
         </p:txBody>
@@ -1000,7 +1000,7 @@
           <a:lstStyle/>
           <a:p>
             <a:r>
-              <a:t>Why decide now. Our next conversation with SNP is where the strategy becomes real - continuity terms, forecast sharing, resin consignment, capacity headroom, succession. The posture has to match the decision: we cannot ask for a deeper partnership and, in the same period, plan to move a third of their core line without telling them - announcing it afterwards would undo the partnership conversation. If the answer is Option 1, bring a package, not a cut: a three-year commitment on about a hundred drums a year growing ten percent - back to today's absolute volume by about year five - a level cadence, forecast sharing, a joint hydrogel roadmap; reason given, a supply-continuity requirement. If it is Option 2 or 3, that is the partnership conversation: our continuity file includes a qualified alternate cooker and, under Option 3, a verification lot or two a year - the supplier is not named and the quote is not shown - the same continuity discipline we are asking SNP to document. Give first, then ask. Decide first; use the conversation to execute, not to discover.</a:t>
+              <a:t>The SNP conversation, in order. One: why we are here - growth, a sole source we depend on, and the intent to run it as a partnership; they should hear investment, not audit. Two: our business, shown - volume history, the forecast of 150 drums this year growing ten percent a year, our delivery record, what the product does for our mission. Three: what we bring - a rolling twelve-month forecast refreshed monthly, a level weekly cadence through a blanket order, and the hydrogel program as a written joint roadmap. Four: growing together - their other hydrogel lines, sodium alginate and guar gum, for our other projects, if R&amp;D has a use. Five: running it as partners - resin supply and a consignment buffer, capacity for year-five volume, cover for the people who run the PVA cook, advance notice of changes, a shelf-life study together; continuity agreed as a shared discipline. Six: a resin-indexed price formula instead of ad hoc increases. Seven: close with a quarterly business review, named contacts and an updated quality agreement. Before we walk in we decide five things: the strategy, which sets the posture - under Option 3 we say a continuity verification lot runs once a year and we do not name the supplier; how much forecast we share and whether a multi-year commitment is on the table; the give - blanket order and payment terms; which projects could use the other hydrogels; and whether we fund the resin buffer and the shelf-life study.</a:t>
             </a:r>
           </a:p>
         </p:txBody>
@@ -5727,7 +5727,7 @@
                 </a:solidFill>
                 <a:latin typeface="Calibri"/>
               </a:rPr>
-              <a:t>~94 US suppliers screened</a:t>
+              <a:t>~15–20 serious candidates screened</a:t>
             </a:r>
           </a:p>
         </p:txBody>
@@ -6759,8 +6759,496 @@
         </p:nvSpPr>
         <p:spPr>
           <a:xfrm>
-            <a:off x="548640" y="3246120"/>
-            <a:ext cx="3611880" cy="2606040"/>
+            <a:off x="585216" y="3246120"/>
+            <a:ext cx="2139696" cy="868680"/>
+          </a:xfrm>
+          <a:prstGeom prst="rect">
+            <a:avLst/>
+          </a:prstGeom>
+          <a:solidFill>
+            <a:srgbClr val="EEF2F7"/>
+          </a:solidFill>
+          <a:ln>
+            <a:noFill/>
+          </a:ln>
+          <a:effectLst/>
+        </p:spPr>
+        <p:style>
+          <a:lnRef idx="1">
+            <a:schemeClr val="accent1"/>
+          </a:lnRef>
+          <a:fillRef idx="3">
+            <a:schemeClr val="accent1"/>
+          </a:fillRef>
+          <a:effectRef idx="2">
+            <a:schemeClr val="accent1"/>
+          </a:effectRef>
+          <a:fontRef idx="minor">
+            <a:schemeClr val="lt1"/>
+          </a:fontRef>
+        </p:style>
+        <p:txBody>
+          <a:bodyPr rtlCol="0" anchor="ctr"/>
+          <a:lstStyle/>
+          <a:p>
+            <a:pPr algn="ctr"/>
+          </a:p>
+        </p:txBody>
+      </p:sp>
+      <p:sp>
+        <p:nvSpPr>
+          <p:cNvPr id="34" name="TextBox 33"/>
+          <p:cNvSpPr txBox="1"/>
+          <p:nvPr/>
+        </p:nvSpPr>
+        <p:spPr>
+          <a:xfrm>
+            <a:off x="621792" y="3264408"/>
+            <a:ext cx="777240" cy="832103"/>
+          </a:xfrm>
+          <a:prstGeom prst="rect">
+            <a:avLst/>
+          </a:prstGeom>
+          <a:noFill/>
+        </p:spPr>
+        <p:txBody>
+          <a:bodyPr wrap="square" anchor="ctr">
+            <a:spAutoFit/>
+          </a:bodyPr>
+          <a:lstStyle/>
+          <a:p>
+            <a:pPr algn="ctr">
+              <a:spcAft>
+                <a:spcPts val="0"/>
+              </a:spcAft>
+            </a:pPr>
+            <a:r>
+              <a:rPr sz="1800" b="1" i="0">
+                <a:solidFill>
+                  <a:srgbClr val="1F3864"/>
+                </a:solidFill>
+                <a:latin typeface="Calibri"/>
+              </a:rPr>
+              <a:t>~15–20</a:t>
+            </a:r>
+          </a:p>
+        </p:txBody>
+      </p:sp>
+      <p:sp>
+        <p:nvSpPr>
+          <p:cNvPr id="35" name="TextBox 34"/>
+          <p:cNvSpPr txBox="1"/>
+          <p:nvPr/>
+        </p:nvSpPr>
+        <p:spPr>
+          <a:xfrm>
+            <a:off x="1371600" y="3264408"/>
+            <a:ext cx="1298448" cy="832103"/>
+          </a:xfrm>
+          <a:prstGeom prst="rect">
+            <a:avLst/>
+          </a:prstGeom>
+          <a:noFill/>
+        </p:spPr>
+        <p:txBody>
+          <a:bodyPr wrap="square" anchor="ctr">
+            <a:spAutoFit/>
+          </a:bodyPr>
+          <a:lstStyle/>
+          <a:p>
+            <a:pPr algn="l">
+              <a:spcAft>
+                <a:spcPts val="0"/>
+              </a:spcAft>
+            </a:pPr>
+            <a:r>
+              <a:rPr sz="900" b="0" i="0">
+                <a:solidFill>
+                  <a:srgbClr val="1F3864"/>
+                </a:solidFill>
+                <a:latin typeface="Calibri"/>
+              </a:rPr>
+              <a:t>serious candidates screened</a:t>
+            </a:r>
+          </a:p>
+        </p:txBody>
+      </p:sp>
+      <p:sp>
+        <p:nvSpPr>
+          <p:cNvPr id="36" name="Rectangle 35"/>
+          <p:cNvSpPr/>
+          <p:nvPr/>
+        </p:nvSpPr>
+        <p:spPr>
+          <a:xfrm>
+            <a:off x="2798064" y="3282696"/>
+            <a:ext cx="2139696" cy="795528"/>
+          </a:xfrm>
+          <a:prstGeom prst="rect">
+            <a:avLst/>
+          </a:prstGeom>
+          <a:solidFill>
+            <a:srgbClr val="EEF2F7"/>
+          </a:solidFill>
+          <a:ln>
+            <a:noFill/>
+          </a:ln>
+          <a:effectLst/>
+        </p:spPr>
+        <p:style>
+          <a:lnRef idx="1">
+            <a:schemeClr val="accent1"/>
+          </a:lnRef>
+          <a:fillRef idx="3">
+            <a:schemeClr val="accent1"/>
+          </a:fillRef>
+          <a:effectRef idx="2">
+            <a:schemeClr val="accent1"/>
+          </a:effectRef>
+          <a:fontRef idx="minor">
+            <a:schemeClr val="lt1"/>
+          </a:fontRef>
+        </p:style>
+        <p:txBody>
+          <a:bodyPr rtlCol="0" anchor="ctr"/>
+          <a:lstStyle/>
+          <a:p>
+            <a:pPr algn="ctr"/>
+          </a:p>
+        </p:txBody>
+      </p:sp>
+      <p:sp>
+        <p:nvSpPr>
+          <p:cNvPr id="37" name="TextBox 36"/>
+          <p:cNvSpPr txBox="1"/>
+          <p:nvPr/>
+        </p:nvSpPr>
+        <p:spPr>
+          <a:xfrm>
+            <a:off x="2834640" y="3300984"/>
+            <a:ext cx="777240" cy="758952"/>
+          </a:xfrm>
+          <a:prstGeom prst="rect">
+            <a:avLst/>
+          </a:prstGeom>
+          <a:noFill/>
+        </p:spPr>
+        <p:txBody>
+          <a:bodyPr wrap="square" anchor="ctr">
+            <a:spAutoFit/>
+          </a:bodyPr>
+          <a:lstStyle/>
+          <a:p>
+            <a:pPr algn="ctr">
+              <a:spcAft>
+                <a:spcPts val="0"/>
+              </a:spcAft>
+            </a:pPr>
+            <a:r>
+              <a:rPr sz="1800" b="1" i="0">
+                <a:solidFill>
+                  <a:srgbClr val="1F3864"/>
+                </a:solidFill>
+                <a:latin typeface="Calibri"/>
+              </a:rPr>
+              <a:t>7</a:t>
+            </a:r>
+          </a:p>
+        </p:txBody>
+      </p:sp>
+      <p:sp>
+        <p:nvSpPr>
+          <p:cNvPr id="38" name="TextBox 37"/>
+          <p:cNvSpPr txBox="1"/>
+          <p:nvPr/>
+        </p:nvSpPr>
+        <p:spPr>
+          <a:xfrm>
+            <a:off x="3584448" y="3300984"/>
+            <a:ext cx="1298448" cy="758952"/>
+          </a:xfrm>
+          <a:prstGeom prst="rect">
+            <a:avLst/>
+          </a:prstGeom>
+          <a:noFill/>
+        </p:spPr>
+        <p:txBody>
+          <a:bodyPr wrap="square" anchor="ctr">
+            <a:spAutoFit/>
+          </a:bodyPr>
+          <a:lstStyle/>
+          <a:p>
+            <a:pPr algn="l">
+              <a:spcAft>
+                <a:spcPts val="0"/>
+              </a:spcAft>
+            </a:pPr>
+            <a:r>
+              <a:rPr sz="900" b="0" i="0">
+                <a:solidFill>
+                  <a:srgbClr val="1F3864"/>
+                </a:solidFill>
+                <a:latin typeface="Calibri"/>
+              </a:rPr>
+              <a:t>engaged in tests or calls</a:t>
+            </a:r>
+          </a:p>
+        </p:txBody>
+      </p:sp>
+      <p:sp>
+        <p:nvSpPr>
+          <p:cNvPr id="39" name="Rectangle 38"/>
+          <p:cNvSpPr/>
+          <p:nvPr/>
+        </p:nvSpPr>
+        <p:spPr>
+          <a:xfrm>
+            <a:off x="5010912" y="3319272"/>
+            <a:ext cx="2139696" cy="722375"/>
+          </a:xfrm>
+          <a:prstGeom prst="rect">
+            <a:avLst/>
+          </a:prstGeom>
+          <a:solidFill>
+            <a:srgbClr val="FCE4D6"/>
+          </a:solidFill>
+          <a:ln>
+            <a:noFill/>
+          </a:ln>
+          <a:effectLst/>
+        </p:spPr>
+        <p:style>
+          <a:lnRef idx="1">
+            <a:schemeClr val="accent1"/>
+          </a:lnRef>
+          <a:fillRef idx="3">
+            <a:schemeClr val="accent1"/>
+          </a:fillRef>
+          <a:effectRef idx="2">
+            <a:schemeClr val="accent1"/>
+          </a:effectRef>
+          <a:fontRef idx="minor">
+            <a:schemeClr val="lt1"/>
+          </a:fontRef>
+        </p:style>
+        <p:txBody>
+          <a:bodyPr rtlCol="0" anchor="ctr"/>
+          <a:lstStyle/>
+          <a:p>
+            <a:pPr algn="ctr"/>
+          </a:p>
+        </p:txBody>
+      </p:sp>
+      <p:sp>
+        <p:nvSpPr>
+          <p:cNvPr id="40" name="TextBox 39"/>
+          <p:cNvSpPr txBox="1"/>
+          <p:nvPr/>
+        </p:nvSpPr>
+        <p:spPr>
+          <a:xfrm>
+            <a:off x="5047488" y="3337560"/>
+            <a:ext cx="777240" cy="685799"/>
+          </a:xfrm>
+          <a:prstGeom prst="rect">
+            <a:avLst/>
+          </a:prstGeom>
+          <a:noFill/>
+        </p:spPr>
+        <p:txBody>
+          <a:bodyPr wrap="square" anchor="ctr">
+            <a:spAutoFit/>
+          </a:bodyPr>
+          <a:lstStyle/>
+          <a:p>
+            <a:pPr algn="ctr">
+              <a:spcAft>
+                <a:spcPts val="0"/>
+              </a:spcAft>
+            </a:pPr>
+            <a:r>
+              <a:rPr sz="1800" b="1" i="0">
+                <a:solidFill>
+                  <a:srgbClr val="B23A2E"/>
+                </a:solidFill>
+                <a:latin typeface="Calibri"/>
+              </a:rPr>
+              <a:t>4</a:t>
+            </a:r>
+          </a:p>
+        </p:txBody>
+      </p:sp>
+      <p:sp>
+        <p:nvSpPr>
+          <p:cNvPr id="41" name="TextBox 40"/>
+          <p:cNvSpPr txBox="1"/>
+          <p:nvPr/>
+        </p:nvSpPr>
+        <p:spPr>
+          <a:xfrm>
+            <a:off x="5797296" y="3337560"/>
+            <a:ext cx="1298448" cy="685799"/>
+          </a:xfrm>
+          <a:prstGeom prst="rect">
+            <a:avLst/>
+          </a:prstGeom>
+          <a:noFill/>
+        </p:spPr>
+        <p:txBody>
+          <a:bodyPr wrap="square" anchor="ctr">
+            <a:spAutoFit/>
+          </a:bodyPr>
+          <a:lstStyle/>
+          <a:p>
+            <a:pPr algn="l">
+              <a:spcAft>
+                <a:spcPts val="0"/>
+              </a:spcAft>
+            </a:pPr>
+            <a:r>
+              <a:rPr sz="900" b="0" i="0">
+                <a:solidFill>
+                  <a:srgbClr val="1F3864"/>
+                </a:solidFill>
+                <a:latin typeface="Calibri"/>
+              </a:rPr>
+              <a:t>could not make it — heat or viscosity (Brenntag, ArroChem, ILC Dover, Columbus)</a:t>
+            </a:r>
+          </a:p>
+        </p:txBody>
+      </p:sp>
+      <p:sp>
+        <p:nvSpPr>
+          <p:cNvPr id="42" name="Rectangle 41"/>
+          <p:cNvSpPr/>
+          <p:nvPr/>
+        </p:nvSpPr>
+        <p:spPr>
+          <a:xfrm>
+            <a:off x="7223759" y="3355848"/>
+            <a:ext cx="2139696" cy="649224"/>
+          </a:xfrm>
+          <a:prstGeom prst="rect">
+            <a:avLst/>
+          </a:prstGeom>
+          <a:solidFill>
+            <a:srgbClr val="FFF2CC"/>
+          </a:solidFill>
+          <a:ln>
+            <a:noFill/>
+          </a:ln>
+          <a:effectLst/>
+        </p:spPr>
+        <p:style>
+          <a:lnRef idx="1">
+            <a:schemeClr val="accent1"/>
+          </a:lnRef>
+          <a:fillRef idx="3">
+            <a:schemeClr val="accent1"/>
+          </a:fillRef>
+          <a:effectRef idx="2">
+            <a:schemeClr val="accent1"/>
+          </a:effectRef>
+          <a:fontRef idx="minor">
+            <a:schemeClr val="lt1"/>
+          </a:fontRef>
+        </p:style>
+        <p:txBody>
+          <a:bodyPr rtlCol="0" anchor="ctr"/>
+          <a:lstStyle/>
+          <a:p>
+            <a:pPr algn="ctr"/>
+          </a:p>
+        </p:txBody>
+      </p:sp>
+      <p:sp>
+        <p:nvSpPr>
+          <p:cNvPr id="43" name="TextBox 42"/>
+          <p:cNvSpPr txBox="1"/>
+          <p:nvPr/>
+        </p:nvSpPr>
+        <p:spPr>
+          <a:xfrm>
+            <a:off x="7260336" y="3374136"/>
+            <a:ext cx="777240" cy="612647"/>
+          </a:xfrm>
+          <a:prstGeom prst="rect">
+            <a:avLst/>
+          </a:prstGeom>
+          <a:noFill/>
+        </p:spPr>
+        <p:txBody>
+          <a:bodyPr wrap="square" anchor="ctr">
+            <a:spAutoFit/>
+          </a:bodyPr>
+          <a:lstStyle/>
+          <a:p>
+            <a:pPr algn="ctr">
+              <a:spcAft>
+                <a:spcPts val="0"/>
+              </a:spcAft>
+            </a:pPr>
+            <a:r>
+              <a:rPr sz="1800" b="1" i="0">
+                <a:solidFill>
+                  <a:srgbClr val="9C5A0C"/>
+                </a:solidFill>
+                <a:latin typeface="Calibri"/>
+              </a:rPr>
+              <a:t>2</a:t>
+            </a:r>
+          </a:p>
+        </p:txBody>
+      </p:sp>
+      <p:sp>
+        <p:nvSpPr>
+          <p:cNvPr id="44" name="TextBox 43"/>
+          <p:cNvSpPr txBox="1"/>
+          <p:nvPr/>
+        </p:nvSpPr>
+        <p:spPr>
+          <a:xfrm>
+            <a:off x="8010144" y="3374136"/>
+            <a:ext cx="1298448" cy="612647"/>
+          </a:xfrm>
+          <a:prstGeom prst="rect">
+            <a:avLst/>
+          </a:prstGeom>
+          <a:noFill/>
+        </p:spPr>
+        <p:txBody>
+          <a:bodyPr wrap="square" anchor="ctr">
+            <a:spAutoFit/>
+          </a:bodyPr>
+          <a:lstStyle/>
+          <a:p>
+            <a:pPr algn="l">
+              <a:spcAft>
+                <a:spcPts val="0"/>
+              </a:spcAft>
+            </a:pPr>
+            <a:r>
+              <a:rPr sz="900" b="0" i="0">
+                <a:solidFill>
+                  <a:srgbClr val="1F3864"/>
+                </a:solidFill>
+                <a:latin typeface="Calibri"/>
+              </a:rPr>
+              <a:t>could, but priced out or never quoted (CJB $8.42; APV ≥$3, est.)</a:t>
+            </a:r>
+          </a:p>
+        </p:txBody>
+      </p:sp>
+      <p:sp>
+        <p:nvSpPr>
+          <p:cNvPr id="45" name="Rectangle 44"/>
+          <p:cNvSpPr/>
+          <p:nvPr/>
+        </p:nvSpPr>
+        <p:spPr>
+          <a:xfrm>
+            <a:off x="9436607" y="3392424"/>
+            <a:ext cx="2139696" cy="576071"/>
           </a:xfrm>
           <a:prstGeom prst="rect">
             <a:avLst/>
@@ -6797,14 +7285,136 @@
       </p:sp>
       <p:sp>
         <p:nvSpPr>
-          <p:cNvPr id="34" name="TextBox 33"/>
+          <p:cNvPr id="46" name="TextBox 45"/>
           <p:cNvSpPr txBox="1"/>
           <p:nvPr/>
         </p:nvSpPr>
         <p:spPr>
           <a:xfrm>
-            <a:off x="731520" y="3364991"/>
-            <a:ext cx="3246120" cy="2368296"/>
+            <a:off x="9473184" y="3410712"/>
+            <a:ext cx="777240" cy="539495"/>
+          </a:xfrm>
+          <a:prstGeom prst="rect">
+            <a:avLst/>
+          </a:prstGeom>
+          <a:noFill/>
+        </p:spPr>
+        <p:txBody>
+          <a:bodyPr wrap="square" anchor="ctr">
+            <a:spAutoFit/>
+          </a:bodyPr>
+          <a:lstStyle/>
+          <a:p>
+            <a:pPr algn="ctr">
+              <a:spcAft>
+                <a:spcPts val="0"/>
+              </a:spcAft>
+            </a:pPr>
+            <a:r>
+              <a:rPr sz="1800" b="1" i="0">
+                <a:solidFill>
+                  <a:srgbClr val="2E7D46"/>
+                </a:solidFill>
+                <a:latin typeface="Calibri"/>
+              </a:rPr>
+              <a:t>1</a:t>
+            </a:r>
+          </a:p>
+        </p:txBody>
+      </p:sp>
+      <p:sp>
+        <p:nvSpPr>
+          <p:cNvPr id="47" name="TextBox 46"/>
+          <p:cNvSpPr txBox="1"/>
+          <p:nvPr/>
+        </p:nvSpPr>
+        <p:spPr>
+          <a:xfrm>
+            <a:off x="10222992" y="3410712"/>
+            <a:ext cx="1298448" cy="539495"/>
+          </a:xfrm>
+          <a:prstGeom prst="rect">
+            <a:avLst/>
+          </a:prstGeom>
+          <a:noFill/>
+        </p:spPr>
+        <p:txBody>
+          <a:bodyPr wrap="square" anchor="ctr">
+            <a:spAutoFit/>
+          </a:bodyPr>
+          <a:lstStyle/>
+          <a:p>
+            <a:pPr algn="l">
+              <a:spcAft>
+                <a:spcPts val="0"/>
+              </a:spcAft>
+            </a:pPr>
+            <a:r>
+              <a:rPr sz="900" b="1" i="0">
+                <a:solidFill>
+                  <a:srgbClr val="1F3864"/>
+                </a:solidFill>
+                <a:latin typeface="Calibri"/>
+              </a:rPr>
+              <a:t>can make it: PCI Manufacturing, $3.50/lb</a:t>
+            </a:r>
+          </a:p>
+        </p:txBody>
+      </p:sp>
+      <p:sp>
+        <p:nvSpPr>
+          <p:cNvPr id="48" name="Rectangle 47"/>
+          <p:cNvSpPr/>
+          <p:nvPr/>
+        </p:nvSpPr>
+        <p:spPr>
+          <a:xfrm>
+            <a:off x="548640" y="4251960"/>
+            <a:ext cx="3611880" cy="1600200"/>
+          </a:xfrm>
+          <a:prstGeom prst="rect">
+            <a:avLst/>
+          </a:prstGeom>
+          <a:solidFill>
+            <a:srgbClr val="EEF2F7"/>
+          </a:solidFill>
+          <a:ln>
+            <a:noFill/>
+          </a:ln>
+          <a:effectLst/>
+        </p:spPr>
+        <p:style>
+          <a:lnRef idx="1">
+            <a:schemeClr val="accent1"/>
+          </a:lnRef>
+          <a:fillRef idx="3">
+            <a:schemeClr val="accent1"/>
+          </a:fillRef>
+          <a:effectRef idx="2">
+            <a:schemeClr val="accent1"/>
+          </a:effectRef>
+          <a:fontRef idx="minor">
+            <a:schemeClr val="lt1"/>
+          </a:fontRef>
+        </p:style>
+        <p:txBody>
+          <a:bodyPr rtlCol="0" anchor="ctr"/>
+          <a:lstStyle/>
+          <a:p>
+            <a:pPr algn="ctr"/>
+          </a:p>
+        </p:txBody>
+      </p:sp>
+      <p:sp>
+        <p:nvSpPr>
+          <p:cNvPr id="49" name="TextBox 48"/>
+          <p:cNvSpPr txBox="1"/>
+          <p:nvPr/>
+        </p:nvSpPr>
+        <p:spPr>
+          <a:xfrm>
+            <a:off x="731520" y="4370832"/>
+            <a:ext cx="3246120" cy="1362456"/>
           </a:xfrm>
           <a:prstGeom prst="rect">
             <a:avLst/>
@@ -6825,11 +7435,11 @@
             <a:r>
               <a:rPr sz="1350" b="1" i="0">
                 <a:solidFill>
-                  <a:srgbClr val="2E7D46"/>
-                </a:solidFill>
-                <a:latin typeface="Calibri"/>
-              </a:rPr>
-              <a:t>Proven — and worth</a:t>
+                  <a:srgbClr val="1F3864"/>
+                </a:solidFill>
+                <a:latin typeface="Calibri"/>
+              </a:rPr>
+              <a:t>Capability is rare</a:t>
             </a:r>
           </a:p>
           <a:p>
@@ -6839,59 +7449,27 @@
               </a:spcAft>
             </a:pPr>
             <a:r>
-              <a:rPr sz="1050" b="0" i="0">
+              <a:rPr sz="1000" b="0" i="0">
                 <a:solidFill>
                   <a:srgbClr val="595959"/>
                 </a:solidFill>
                 <a:latin typeface="Calibri"/>
               </a:rPr>
-              <a:t>•  The cook, the viscosity brought on target within the test, the spec — met on PCI's instrument</a:t>
-            </a:r>
-          </a:p>
-          <a:p>
-            <a:pPr algn="l">
-              <a:spcAft>
-                <a:spcPts val="500"/>
-              </a:spcAft>
-            </a:pPr>
-            <a:r>
-              <a:rPr sz="1050" b="0" i="0">
-                <a:solidFill>
-                  <a:srgbClr val="595959"/>
-                </a:solidFill>
-                <a:latin typeface="Calibri"/>
-              </a:rPr>
-              <a:t>•  A qualified-capable, quoted alternative exists: cold start 6–12 months → ~3–6 (2–3 if re-checked yearly)</a:t>
-            </a:r>
-          </a:p>
-          <a:p>
-            <a:pPr algn="l">
-              <a:spcAft>
-                <a:spcPts val="500"/>
-              </a:spcAft>
-            </a:pPr>
-            <a:r>
-              <a:rPr sz="1050" b="0" i="0">
-                <a:solidFill>
-                  <a:srgbClr val="595959"/>
-                </a:solidFill>
-                <a:latin typeface="Calibri"/>
-              </a:rPr>
-              <a:t>•  Not yet proven at scale: production rate; hydrogel performance on 100% PCI material</a:t>
-            </a:r>
-          </a:p>
-        </p:txBody>
-      </p:sp>
-      <p:sp>
-        <p:nvSpPr>
-          <p:cNvPr id="35" name="Rectangle 34"/>
+              <a:t>•  The 90–95 °C dissolution cook at 55-gallon scale eliminated most of the market. One shop passed in ten months; the rest failed on heat, on viscosity, or on price</a:t>
+            </a:r>
+          </a:p>
+        </p:txBody>
+      </p:sp>
+      <p:sp>
+        <p:nvSpPr>
+          <p:cNvPr id="50" name="Rectangle 49"/>
           <p:cNvSpPr/>
           <p:nvPr/>
         </p:nvSpPr>
         <p:spPr>
           <a:xfrm>
-            <a:off x="4297680" y="3246120"/>
-            <a:ext cx="3611880" cy="2606040"/>
+            <a:off x="4297680" y="4251960"/>
+            <a:ext cx="3611880" cy="1600200"/>
           </a:xfrm>
           <a:prstGeom prst="rect">
             <a:avLst/>
@@ -6928,14 +7506,14 @@
       </p:sp>
       <p:sp>
         <p:nvSpPr>
-          <p:cNvPr id="36" name="TextBox 35"/>
+          <p:cNvPr id="51" name="TextBox 50"/>
           <p:cNvSpPr txBox="1"/>
           <p:nvPr/>
         </p:nvSpPr>
         <p:spPr>
           <a:xfrm>
-            <a:off x="4480560" y="3364991"/>
-            <a:ext cx="3246120" cy="2368296"/>
+            <a:off x="4480560" y="4370832"/>
+            <a:ext cx="3246120" cy="1362456"/>
           </a:xfrm>
           <a:prstGeom prst="rect">
             <a:avLst/>
@@ -6960,7 +7538,7 @@
                 </a:solidFill>
                 <a:latin typeface="Calibri"/>
               </a:rPr>
-              <a:t>What it cost — who paid</a:t>
+              <a:t>Capability is expensive</a:t>
             </a:r>
           </a:p>
           <a:p>
@@ -6970,65 +7548,33 @@
               </a:spcAft>
             </a:pPr>
             <a:r>
-              <a:rPr sz="1050" b="0" i="0">
+              <a:rPr sz="1000" b="0" i="0">
                 <a:solidFill>
                   <a:srgbClr val="595959"/>
                 </a:solidFill>
                 <a:latin typeface="Calibri"/>
               </a:rPr>
-              <a:t>•  PCI: months of unpaid engineering for an account worth ~$79k/yr to them at one-third</a:t>
-            </a:r>
-          </a:p>
-          <a:p>
-            <a:pPr algn="l">
-              <a:spcAft>
-                <a:spcPts val="500"/>
-              </a:spcAft>
-            </a:pPr>
-            <a:r>
-              <a:rPr sz="1050" b="0" i="0">
-                <a:solidFill>
-                  <a:srgbClr val="595959"/>
-                </a:solidFill>
-                <a:latin typeface="Calibri"/>
-              </a:rPr>
-              <a:t>•  Us: ~10 months since Brenntag — ~$15k of internal hours, sunk, excluded from the options</a:t>
-            </a:r>
-          </a:p>
-          <a:p>
-            <a:pPr algn="l">
-              <a:spcAft>
-                <a:spcPts val="500"/>
-              </a:spcAft>
-            </a:pPr>
-            <a:r>
-              <a:rPr sz="1050" b="0" i="0">
-                <a:solidFill>
-                  <a:srgbClr val="595959"/>
-                </a:solidFill>
-                <a:latin typeface="Calibri"/>
-              </a:rPr>
-              <a:t>•  Still queued at PCI's expense: the shelf-life study and the hydrogel comparison</a:t>
-            </a:r>
-          </a:p>
-        </p:txBody>
-      </p:sp>
-      <p:sp>
-        <p:nvSpPr>
-          <p:cNvPr id="37" name="Rectangle 36"/>
+              <a:t>•  Everyone who can do it charges 4× to 11× SNP: PCI $3.50, APV ≥$3 (est.), CJB $8.42 — against $0.75. Small batches, drum freight and risk are priced in</a:t>
+            </a:r>
+          </a:p>
+        </p:txBody>
+      </p:sp>
+      <p:sp>
+        <p:nvSpPr>
+          <p:cNvPr id="52" name="Rectangle 51"/>
           <p:cNvSpPr/>
           <p:nvPr/>
         </p:nvSpPr>
         <p:spPr>
           <a:xfrm>
-            <a:off x="8046720" y="3246120"/>
-            <a:ext cx="3566160" cy="2606040"/>
+            <a:off x="8046720" y="4251960"/>
+            <a:ext cx="3566160" cy="1600200"/>
           </a:xfrm>
           <a:prstGeom prst="rect">
             <a:avLst/>
           </a:prstGeom>
           <a:solidFill>
-            <a:srgbClr val="EEF2F7"/>
+            <a:srgbClr val="E2EFDA"/>
           </a:solidFill>
           <a:ln>
             <a:noFill/>
@@ -7059,14 +7605,14 @@
       </p:sp>
       <p:sp>
         <p:nvSpPr>
-          <p:cNvPr id="38" name="TextBox 37"/>
+          <p:cNvPr id="53" name="TextBox 52"/>
           <p:cNvSpPr txBox="1"/>
           <p:nvPr/>
         </p:nvSpPr>
         <p:spPr>
           <a:xfrm>
-            <a:off x="8229600" y="3364991"/>
-            <a:ext cx="3200400" cy="2368296"/>
+            <a:off x="8229600" y="4370832"/>
+            <a:ext cx="3200400" cy="1362456"/>
           </a:xfrm>
           <a:prstGeom prst="rect">
             <a:avLst/>
@@ -7087,11 +7633,11 @@
             <a:r>
               <a:rPr sz="1350" b="1" i="0">
                 <a:solidFill>
-                  <a:srgbClr val="1F3864"/>
-                </a:solidFill>
-                <a:latin typeface="Calibri"/>
-              </a:rPr>
-              <a:t>Use it · walk away · the middle</a:t>
+                  <a:srgbClr val="2E7D46"/>
+                </a:solidFill>
+                <a:latin typeface="Calibri"/>
+              </a:rPr>
+              <a:t>SNP Inc. is an outlier, not a benchmark</a:t>
             </a:r>
           </a:p>
           <a:p>
@@ -7101,52 +7647,20 @@
               </a:spcAft>
             </a:pPr>
             <a:r>
-              <a:rPr sz="1050" b="0" i="0">
+              <a:rPr sz="1000" b="0" i="0">
                 <a:solidFill>
                   <a:srgbClr val="595959"/>
                 </a:solidFill>
                 <a:latin typeface="Calibri"/>
               </a:rPr>
-              <a:t>•  Use it: +$62k/yr at one-third, a permanent two-stream discipline, and the signal to SNP Inc.</a:t>
-            </a:r>
-          </a:p>
-          <a:p>
-            <a:pPr algn="l">
-              <a:spcAft>
-                <a:spcPts val="500"/>
-              </a:spcAft>
-            </a:pPr>
-            <a:r>
-              <a:rPr sz="1050" b="0" i="0">
-                <a:solidFill>
-                  <a:srgbClr val="595959"/>
-                </a:solidFill>
-                <a:latin typeface="Calibri"/>
-              </a:rPr>
-              <a:t>•  Walk away: goodwill — cost = extra months of a cold start × outage cost × probability</a:t>
-            </a:r>
-          </a:p>
-          <a:p>
-            <a:pPr algn="l">
-              <a:spcAft>
-                <a:spcPts val="500"/>
-              </a:spcAft>
-            </a:pPr>
-            <a:r>
-              <a:rPr sz="1050" b="0" i="0">
-                <a:solidFill>
-                  <a:srgbClr val="595959"/>
-                </a:solidFill>
-                <a:latin typeface="Calibri"/>
-              </a:rPr>
-              <a:t>•  The middle (Option 3): 1–3 batches of 5 drums a year, $7.9k each — a paid, practiced supplier</a:t>
-            </a:r>
-          </a:p>
-        </p:txBody>
-      </p:sp>
-      <p:sp>
-        <p:nvSpPr>
-          <p:cNvPr id="39" name="Rectangle 38"/>
+              <a:t>•  A specialist, close by, right-sized tanks, PVA as its core line, and a price below the whole US market. We cannot replicate that price; we can only protect it</a:t>
+            </a:r>
+          </a:p>
+        </p:txBody>
+      </p:sp>
+      <p:sp>
+        <p:nvSpPr>
+          <p:cNvPr id="54" name="Rectangle 53"/>
           <p:cNvSpPr/>
           <p:nvPr/>
         </p:nvSpPr>
@@ -7190,7 +7704,7 @@
       </p:sp>
       <p:sp>
         <p:nvSpPr>
-          <p:cNvPr id="40" name="TextBox 39"/>
+          <p:cNvPr id="55" name="TextBox 54"/>
           <p:cNvSpPr txBox="1"/>
           <p:nvPr/>
         </p:nvSpPr>
@@ -7222,7 +7736,7 @@
                 </a:solidFill>
                 <a:latin typeface="Calibri"/>
               </a:rPr>
-              <a:t>Ten months, nine suppliers, one shop that can make it — and now a real price. Whether we buy is a separate decision, with a real price on both sides.</a:t>
+              <a:t>Ten months, seven suppliers engaged, one shop that can make it — at 4.7× SNP's price. SNP Inc. is an outlier we cannot replicate, only protect.</a:t>
             </a:r>
           </a:p>
         </p:txBody>
@@ -12014,7 +12528,7 @@
                 </a:solidFill>
                 <a:latin typeface="Calibri"/>
               </a:rPr>
-              <a:t>Why decide now</a:t>
+              <a:t>The SNP Inc. conversation — outline, and what we decide before it</a:t>
             </a:r>
           </a:p>
         </p:txBody>
@@ -12066,8 +12580,8 @@
         </p:nvSpPr>
         <p:spPr>
           <a:xfrm>
-            <a:off x="548640" y="1097280"/>
-            <a:ext cx="6035040" cy="4663440"/>
+            <a:off x="548640" y="1005840"/>
+            <a:ext cx="6949440" cy="320040"/>
           </a:xfrm>
           <a:prstGeom prst="rect">
             <a:avLst/>
@@ -12080,6 +12594,45 @@
           </a:bodyPr>
           <a:lstStyle/>
           <a:p>
+            <a:pPr algn="l">
+              <a:spcAft>
+                <a:spcPts val="0"/>
+              </a:spcAft>
+            </a:pPr>
+            <a:r>
+              <a:rPr sz="1200" b="1" i="0">
+                <a:solidFill>
+                  <a:srgbClr val="1F3864"/>
+                </a:solidFill>
+                <a:latin typeface="Calibri"/>
+              </a:rPr>
+              <a:t>The meeting, in order — what we say, and what we want out of each part</a:t>
+            </a:r>
+          </a:p>
+        </p:txBody>
+      </p:sp>
+      <p:sp>
+        <p:nvSpPr>
+          <p:cNvPr id="6" name="TextBox 5"/>
+          <p:cNvSpPr txBox="1"/>
+          <p:nvPr/>
+        </p:nvSpPr>
+        <p:spPr>
+          <a:xfrm>
+            <a:off x="548640" y="1325880"/>
+            <a:ext cx="6949440" cy="4572000"/>
+          </a:xfrm>
+          <a:prstGeom prst="rect">
+            <a:avLst/>
+          </a:prstGeom>
+          <a:noFill/>
+        </p:spPr>
+        <p:txBody>
+          <a:bodyPr wrap="square">
+            <a:spAutoFit/>
+          </a:bodyPr>
+          <a:lstStyle/>
+          <a:p>
             <a:pPr>
               <a:spcAft>
                 <a:spcPts val="900"/>
@@ -12092,16 +12645,25 @@
                 </a:solidFill>
                 <a:latin typeface="Calibri"/>
               </a:rPr>
-              <a:t>•  Our next conversation with SNP Inc. is where the strategy becomes real. </a:t>
-            </a:r>
-            <a:r>
-              <a:rPr sz="1200">
+              <a:t>1  Why we are here   </a:t>
+            </a:r>
+            <a:r>
+              <a:rPr sz="1100">
                 <a:solidFill>
                   <a:srgbClr val="595959"/>
                 </a:solidFill>
                 <a:latin typeface="Calibri"/>
               </a:rPr>
-              <a:t>Continuity terms, forecast sharing, resin consignment, a resin-indexed price, capacity headroom, succession — settled in conversation, not by email.</a:t>
+              <a:t>Years of growth, a sole source we depend on, and the intent to run it as a partnership.  </a:t>
+            </a:r>
+            <a:r>
+              <a:rPr sz="1100" b="1">
+                <a:solidFill>
+                  <a:srgbClr val="2E7D46"/>
+                </a:solidFill>
+                <a:latin typeface="Calibri"/>
+              </a:rPr>
+              <a:t>→ They hear investment, not audit</a:t>
             </a:r>
           </a:p>
           <a:p>
@@ -12117,16 +12679,25 @@
                 </a:solidFill>
                 <a:latin typeface="Calibri"/>
               </a:rPr>
-              <a:t>•  The posture has to match the decision. </a:t>
-            </a:r>
-            <a:r>
-              <a:rPr sz="1200">
+              <a:t>2  Our business, shown   </a:t>
+            </a:r>
+            <a:r>
+              <a:rPr sz="1100">
                 <a:solidFill>
                   <a:srgbClr val="595959"/>
                 </a:solidFill>
                 <a:latin typeface="Calibri"/>
               </a:rPr>
-              <a:t>We cannot ask for a deeper partnership and, in the same period, plan to move a third of their core line without telling them. Announcing it afterwards would undo the partnership conversation.</a:t>
+              <a:t>Volume history, the forecast (150 drums this year, +10%/yr), our delivery record, what the product does for our mission.  </a:t>
+            </a:r>
+            <a:r>
+              <a:rPr sz="1100" b="1">
+                <a:solidFill>
+                  <a:srgbClr val="2E7D46"/>
+                </a:solidFill>
+                <a:latin typeface="Calibri"/>
+              </a:rPr>
+              <a:t>→ A growing account worth planning for</a:t>
             </a:r>
           </a:p>
           <a:p>
@@ -12142,16 +12713,25 @@
                 </a:solidFill>
                 <a:latin typeface="Calibri"/>
               </a:rPr>
-              <a:t>•  If Option 1: </a:t>
-            </a:r>
-            <a:r>
-              <a:rPr sz="1200">
+              <a:t>3  What we bring   </a:t>
+            </a:r>
+            <a:r>
+              <a:rPr sz="1100">
                 <a:solidFill>
                   <a:srgbClr val="595959"/>
                 </a:solidFill>
                 <a:latin typeface="Calibri"/>
               </a:rPr>
-              <a:t>bring a package, not a cut — a 3-year commitment on ~100 drums/yr growing 10%/yr, a level cadence, forecast sharing, a joint hydrogel roadmap. Reason given: a supply-continuity requirement.</a:t>
+              <a:t>Rolling 12-month forecast refreshed monthly; a level weekly cadence through a blanket order; the hydrogel program as a written joint roadmap.  </a:t>
+            </a:r>
+            <a:r>
+              <a:rPr sz="1100" b="1">
+                <a:solidFill>
+                  <a:srgbClr val="2E7D46"/>
+                </a:solidFill>
+                <a:latin typeface="Calibri"/>
+              </a:rPr>
+              <a:t>→ Predictability for their kettle and resin buys</a:t>
             </a:r>
           </a:p>
           <a:p>
@@ -12167,30 +12747,141 @@
                 </a:solidFill>
                 <a:latin typeface="Calibri"/>
               </a:rPr>
-              <a:t>•  If Option 2 or 3: </a:t>
-            </a:r>
-            <a:r>
-              <a:rPr sz="1200">
+              <a:t>4  Growing together   </a:t>
+            </a:r>
+            <a:r>
+              <a:rPr sz="1100">
                 <a:solidFill>
                   <a:srgbClr val="595959"/>
                 </a:solidFill>
                 <a:latin typeface="Calibri"/>
               </a:rPr>
-              <a:t>that is the partnership conversation. Our supply-continuity file includes a qualified alternate cooker and, under Option 3, a verification lot or two a year. The supplier is not named; the quote is not shown.</a:t>
-            </a:r>
-          </a:p>
-        </p:txBody>
-      </p:sp>
-      <p:sp>
-        <p:nvSpPr>
-          <p:cNvPr id="6" name="Rectangle 5"/>
+              <a:t>Their other hydrogel lines — sodium alginate, guar gum — for our other projects.  </a:t>
+            </a:r>
+            <a:r>
+              <a:rPr sz="1100" b="1">
+                <a:solidFill>
+                  <a:srgbClr val="2E7D46"/>
+                </a:solidFill>
+                <a:latin typeface="Calibri"/>
+              </a:rPr>
+              <a:t>→ A second and third line, if R&amp;D has a use</a:t>
+            </a:r>
+          </a:p>
+          <a:p>
+            <a:pPr>
+              <a:spcAft>
+                <a:spcPts val="900"/>
+              </a:spcAft>
+            </a:pPr>
+            <a:r>
+              <a:rPr b="1" sz="1200">
+                <a:solidFill>
+                  <a:srgbClr val="1F3864"/>
+                </a:solidFill>
+                <a:latin typeface="Calibri"/>
+              </a:rPr>
+              <a:t>5  Running it as partners   </a:t>
+            </a:r>
+            <a:r>
+              <a:rPr sz="1100">
+                <a:solidFill>
+                  <a:srgbClr val="595959"/>
+                </a:solidFill>
+                <a:latin typeface="Calibri"/>
+              </a:rPr>
+              <a:t>Resin supply and a consignment buffer; capacity for Year-5 volume; cover for the people who run the PVA cook; advance notice of changes; a shelf-life study together.  </a:t>
+            </a:r>
+            <a:r>
+              <a:rPr sz="1100" b="1">
+                <a:solidFill>
+                  <a:srgbClr val="2E7D46"/>
+                </a:solidFill>
+                <a:latin typeface="Calibri"/>
+              </a:rPr>
+              <a:t>→ Continuity agreed as a shared discipline, not a demand</a:t>
+            </a:r>
+          </a:p>
+          <a:p>
+            <a:pPr>
+              <a:spcAft>
+                <a:spcPts val="900"/>
+              </a:spcAft>
+            </a:pPr>
+            <a:r>
+              <a:rPr b="1" sz="1200">
+                <a:solidFill>
+                  <a:srgbClr val="1F3864"/>
+                </a:solidFill>
+                <a:latin typeface="Calibri"/>
+              </a:rPr>
+              <a:t>6  Price   </a:t>
+            </a:r>
+            <a:r>
+              <a:rPr sz="1100">
+                <a:solidFill>
+                  <a:srgbClr val="595959"/>
+                </a:solidFill>
+                <a:latin typeface="Calibri"/>
+              </a:rPr>
+              <a:t>A resin-indexed formula in place of ad hoc increases.  </a:t>
+            </a:r>
+            <a:r>
+              <a:rPr sz="1100" b="1">
+                <a:solidFill>
+                  <a:srgbClr val="2E7D46"/>
+                </a:solidFill>
+                <a:latin typeface="Calibri"/>
+              </a:rPr>
+              <a:t>→ Predictability for both sides</a:t>
+            </a:r>
+          </a:p>
+          <a:p>
+            <a:pPr>
+              <a:spcAft>
+                <a:spcPts val="900"/>
+              </a:spcAft>
+            </a:pPr>
+            <a:r>
+              <a:rPr b="1" sz="1200">
+                <a:solidFill>
+                  <a:srgbClr val="1F3864"/>
+                </a:solidFill>
+                <a:latin typeface="Calibri"/>
+              </a:rPr>
+              <a:t>7  Close   </a:t>
+            </a:r>
+            <a:r>
+              <a:rPr sz="1100">
+                <a:solidFill>
+                  <a:srgbClr val="595959"/>
+                </a:solidFill>
+                <a:latin typeface="Calibri"/>
+              </a:rPr>
+              <a:t>Quarterly business review, named contacts, an updated Supplier Quality Agreement (SQA).  </a:t>
+            </a:r>
+            <a:r>
+              <a:rPr sz="1100" b="1">
+                <a:solidFill>
+                  <a:srgbClr val="2E7D46"/>
+                </a:solidFill>
+                <a:latin typeface="Calibri"/>
+              </a:rPr>
+              <a:t>→ A cadence that keeps it alive</a:t>
+            </a:r>
+          </a:p>
+        </p:txBody>
+      </p:sp>
+      <p:sp>
+        <p:nvSpPr>
+          <p:cNvPr id="7" name="Rectangle 6"/>
           <p:cNvSpPr/>
           <p:nvPr/>
         </p:nvSpPr>
         <p:spPr>
           <a:xfrm>
-            <a:off x="6858000" y="1097280"/>
-            <a:ext cx="4754880" cy="4663440"/>
+            <a:off x="7726679" y="1005840"/>
+            <a:ext cx="3886200" cy="4846320"/>
           </a:xfrm>
           <a:prstGeom prst="rect">
             <a:avLst/>
@@ -12229,14 +12920,14 @@
       </p:sp>
       <p:sp>
         <p:nvSpPr>
-          <p:cNvPr id="7" name="TextBox 6"/>
+          <p:cNvPr id="8" name="TextBox 7"/>
           <p:cNvSpPr txBox="1"/>
           <p:nvPr/>
         </p:nvSpPr>
         <p:spPr>
           <a:xfrm>
-            <a:off x="7040880" y="1188720"/>
-            <a:ext cx="4389120" cy="4526280"/>
+            <a:off x="7863840" y="1097280"/>
+            <a:ext cx="3611880" cy="4663440"/>
           </a:xfrm>
           <a:prstGeom prst="rect">
             <a:avLst/>
@@ -12251,7 +12942,7 @@
           <a:p>
             <a:pPr algn="l">
               <a:spcAft>
-                <a:spcPts val="500"/>
+                <a:spcPts val="600"/>
               </a:spcAft>
             </a:pPr>
             <a:r>
@@ -12261,110 +12952,139 @@
                 </a:solidFill>
                 <a:latin typeface="Calibri"/>
               </a:rPr>
-              <a:t>To settle with SNP Inc. under Option 2 / 3</a:t>
-            </a:r>
-          </a:p>
-          <a:p>
-            <a:pPr algn="l">
-              <a:spcAft>
-                <a:spcPts val="500"/>
-              </a:spcAft>
-            </a:pPr>
-            <a:r>
-              <a:rPr sz="1050" b="0" i="0">
+              <a:t>Decide before we walk in</a:t>
+            </a:r>
+          </a:p>
+          <a:p>
+            <a:pPr>
+              <a:spcAft>
+                <a:spcPts val="700"/>
+              </a:spcAft>
+            </a:pPr>
+            <a:r>
+              <a:rPr b="1" sz="1050">
+                <a:solidFill>
+                  <a:srgbClr val="1F3864"/>
+                </a:solidFill>
+                <a:latin typeface="Calibri"/>
+              </a:rPr>
+              <a:t>The strategy — Option 1, 2 or 3  </a:t>
+            </a:r>
+            <a:r>
+              <a:rPr sz="1000">
                 <a:solidFill>
                   <a:srgbClr val="595959"/>
                 </a:solidFill>
                 <a:latin typeface="Calibri"/>
               </a:rPr>
-              <a:t>•  Give first: rolling 12-month forecast, refreshed monthly; the hydrogel program as a written joint roadmap; a multi-year commitment</a:t>
-            </a:r>
-          </a:p>
-          <a:p>
-            <a:pPr algn="l">
-              <a:spcAft>
-                <a:spcPts val="500"/>
-              </a:spcAft>
-            </a:pPr>
-            <a:r>
-              <a:rPr sz="1050" b="0" i="0">
+              <a:t>— sets the whole posture. Under Option 3 we say a continuity verification lot runs once a year; the supplier is not named. (Leadership)</a:t>
+            </a:r>
+          </a:p>
+          <a:p>
+            <a:pPr>
+              <a:spcAft>
+                <a:spcPts val="700"/>
+              </a:spcAft>
+            </a:pPr>
+            <a:r>
+              <a:rPr b="1" sz="1050">
+                <a:solidFill>
+                  <a:srgbClr val="1F3864"/>
+                </a:solidFill>
+                <a:latin typeface="Calibri"/>
+              </a:rPr>
+              <a:t>How much forecast, what commitment  </a:t>
+            </a:r>
+            <a:r>
+              <a:rPr sz="1000">
                 <a:solidFill>
                   <a:srgbClr val="595959"/>
                 </a:solidFill>
                 <a:latin typeface="Calibri"/>
               </a:rPr>
-              <a:t>•  Then ask, as Supplier Quality Agreement (SQA) clauses: second line/site plan, key-person cover, advance change notice, right to audit</a:t>
-            </a:r>
-          </a:p>
-          <a:p>
-            <a:pPr algn="l">
-              <a:spcAft>
-                <a:spcPts val="500"/>
-              </a:spcAft>
-            </a:pPr>
-            <a:r>
-              <a:rPr sz="1050" b="0" i="0">
+              <a:t>— 12-month rolling and a 3-year outlook; whether a multi-year commitment or letter of intent is on the table. (Leadership, Legal)</a:t>
+            </a:r>
+          </a:p>
+          <a:p>
+            <a:pPr>
+              <a:spcAft>
+                <a:spcPts val="700"/>
+              </a:spcAft>
+            </a:pPr>
+            <a:r>
+              <a:rPr b="1" sz="1050">
+                <a:solidFill>
+                  <a:srgbClr val="1F3864"/>
+                </a:solidFill>
+                <a:latin typeface="Calibri"/>
+              </a:rPr>
+              <a:t>The give  </a:t>
+            </a:r>
+            <a:r>
+              <a:rPr sz="1000">
                 <a:solidFill>
                   <a:srgbClr val="595959"/>
                 </a:solidFill>
                 <a:latin typeface="Calibri"/>
               </a:rPr>
-              <a:t>•  12–26 weeks of dry PVA resin on consignment (shelf-stable; ~$2–6k tied up)</a:t>
-            </a:r>
-          </a:p>
-          <a:p>
-            <a:pPr algn="l">
-              <a:spcAft>
-                <a:spcPts val="500"/>
-              </a:spcAft>
-            </a:pPr>
-            <a:r>
-              <a:rPr sz="1050" b="0" i="0">
+              <a:t>— blanket order — yes or no; payment terms as a lever — yes or no. (Finance, Supply Chain)</a:t>
+            </a:r>
+          </a:p>
+          <a:p>
+            <a:pPr>
+              <a:spcAft>
+                <a:spcPts val="700"/>
+              </a:spcAft>
+            </a:pPr>
+            <a:r>
+              <a:rPr b="1" sz="1050">
+                <a:solidFill>
+                  <a:srgbClr val="1F3864"/>
+                </a:solidFill>
+                <a:latin typeface="Calibri"/>
+              </a:rPr>
+              <a:t>The other hydrogels  </a:t>
+            </a:r>
+            <a:r>
+              <a:rPr sz="1000">
                 <a:solidFill>
                   <a:srgbClr val="595959"/>
                 </a:solidFill>
                 <a:latin typeface="Calibri"/>
               </a:rPr>
-              <a:t>•  Capacity headroom at Year-5 volume (~99k lb/yr, ~1,900 lb/week)</a:t>
-            </a:r>
-          </a:p>
-          <a:p>
-            <a:pPr algn="l">
-              <a:spcAft>
-                <a:spcPts val="500"/>
-              </a:spcAft>
-            </a:pPr>
-            <a:r>
-              <a:rPr sz="1050" b="0" i="0">
+              <a:t>— which projects could use alginate or guar, at what solids. (R&amp;D, before the meeting)</a:t>
+            </a:r>
+          </a:p>
+          <a:p>
+            <a:pPr>
+              <a:spcAft>
+                <a:spcPts val="700"/>
+              </a:spcAft>
+            </a:pPr>
+            <a:r>
+              <a:rPr b="1" sz="1050">
+                <a:solidFill>
+                  <a:srgbClr val="1F3864"/>
+                </a:solidFill>
+                <a:latin typeface="Calibri"/>
+              </a:rPr>
+              <a:t>Continuity money  </a:t>
+            </a:r>
+            <a:r>
+              <a:rPr sz="1000">
                 <a:solidFill>
                   <a:srgbClr val="595959"/>
                 </a:solidFill>
                 <a:latin typeface="Calibri"/>
               </a:rPr>
-              <a:t>•  Business continuity: ownership, financial resilience — under mutual non-disclosure agreement (NDA)</a:t>
-            </a:r>
-          </a:p>
-          <a:p>
-            <a:pPr algn="l">
-              <a:spcAft>
-                <a:spcPts val="500"/>
-              </a:spcAft>
-            </a:pPr>
-            <a:r>
-              <a:rPr sz="1050" b="0" i="0">
-                <a:solidFill>
-                  <a:srgbClr val="595959"/>
-                </a:solidFill>
-                <a:latin typeface="Calibri"/>
-              </a:rPr>
-              <a:t>•  A shelf-life study: cheap if the limiter is viscosity build; a formulation change if it is microbial — unknown today</a:t>
-            </a:r>
-          </a:p>
-        </p:txBody>
-      </p:sp>
-      <p:sp>
-        <p:nvSpPr>
-          <p:cNvPr id="8" name="Rectangle 7"/>
+              <a:t>— fund the resin buffer (~$2–6k tied up) and the shelf-life study — or not. (Supply Chain)</a:t>
+            </a:r>
+          </a:p>
+        </p:txBody>
+      </p:sp>
+      <p:sp>
+        <p:nvSpPr>
+          <p:cNvPr id="9" name="Rectangle 8"/>
           <p:cNvSpPr/>
           <p:nvPr/>
         </p:nvSpPr>
@@ -12408,7 +13128,7 @@
       </p:sp>
       <p:sp>
         <p:nvSpPr>
-          <p:cNvPr id="9" name="TextBox 8"/>
+          <p:cNvPr id="10" name="TextBox 9"/>
           <p:cNvSpPr txBox="1"/>
           <p:nvPr/>
         </p:nvSpPr>
@@ -12440,7 +13160,7 @@
                 </a:solidFill>
                 <a:latin typeface="Calibri"/>
               </a:rPr>
-              <a:t>Decide the strategy first; then use the SNP Inc. conversation to execute it — not to discover it.</a:t>
+              <a:t>Decide the strategy and the give before the meeting; the meeting is where we execute the partnership, not where we discover it.</a:t>
             </a:r>
           </a:p>
         </p:txBody>

</xml_diff>

<commit_message>
Pricing chart as a market band beyond US data; options slide with larger bold figures
Co-Authored-By: Claude Fable 5.1 <noreply@anthropic.com>
Claude-Session: https://claude.ai/code/session_01LkE2ZRYs3PLyj8XHTsU3i4
</commit_message>
<xml_diff>
--- a/PVA second supplier initiative/PVA_Second_Supplier_Leadership_Deck.pptx
+++ b/PVA second supplier initiative/PVA_Second_Supplier_Leadership_Deck.pptx
@@ -721,7 +721,7 @@
           <a:lstStyle/>
           <a:p>
             <a:r>
-              <a:t>Price per pound against quantity per order. The grey points are the verified market prices of pre-mixed PVA solution at every pack size we found - one-gallon jugs, cases, pails, a twenty-gallon lot, and ton-scale offers offshore before freight. The navy line is the curve fitted through them: price falls about eighteen percent every time the lot doubles. That is the normal behaviour of this market - small lots carry packaging, handling and margin. SNP, green, sells us about three drums a week at 75 cents - on or below the curve, even though the market points are neither delivered nor medical-grade. The green dashed line is the same slope drawn through SNP's price: it is what to expect if we ever bought smaller lots from them - about a dollar at one drum, about two dollars at five gallons. It is a regression from the market's behaviour, not a quote from SNP. PCI, in amber, sits four to six times above the curve at its quantities - the batch-fixed cost and drum freight of a non-specialist. CJB is off the curve entirely; APV's three dollars is an estimate from our call, never confirmed. The message: price follows lot size everywhere in this market, except at SNP.</a:t>
+              <a:t>Price per pound against quantity per order. The grey points are the verified market prices of pre-mixed PVA solution at every pack size we found - one-gallon jugs, cases, pails, a twenty-gallon lot, and ton-scale offers offshore before freight. The navy line is the curve fitted through them: price falls about eighteen percent every time the lot doubles where we have US data, up to twenty gallons. Beyond that no US vendor publishes a price, so the market is drawn as a band: the fitted trend at the bottom, the flattening seen in vendors' own volume ladders at the top - roughly a dollar to two dollars at a drum. SNP, green, sells us about three drums a week at 75 cents - at or below the bottom of that band, even though the market points are neither delivered nor medical-grade. The green dashed line is the same slope drawn through SNP's price: it is what to expect if we ever bought smaller lots from them - about a dollar at one drum, about two dollars at five gallons. It is a regression from the market's behaviour, not a quote from SNP. PCI, in amber, sits above the top of the band at its quantities - the batch-fixed cost and drum freight of a non-specialist. CJB is off the curve entirely; APV's three dollars is an estimate from our call, never confirmed. The message: price follows lot size everywhere in this market, except at SNP.</a:t>
             </a:r>
           </a:p>
         </p:txBody>
@@ -6622,7 +6622,7 @@
                 </a:solidFill>
                 <a:latin typeface="Calibri"/>
               </a:rPr>
-              <a:t>— verified market prices of pre-mixed PVA solution at each pack size (composites-grade in the US; ton-scale offers offshore, before freight)</a:t>
+              <a:t>— verified market prices of pre-mixed PVA solution at each pack size (composites-grade in the US up to 20 gal; ton-scale offers offshore, before freight)</a:t>
             </a:r>
           </a:p>
           <a:p>
@@ -6638,7 +6638,7 @@
                 </a:solidFill>
                 <a:latin typeface="Calibri"/>
               </a:rPr>
-              <a:t>Navy line  </a:t>
+              <a:t>Navy line and band  </a:t>
             </a:r>
             <a:r>
               <a:rPr sz="950">
@@ -6647,7 +6647,7 @@
                 </a:solidFill>
                 <a:latin typeface="Calibri"/>
               </a:rPr>
-              <a:t>— the market curve fitted through them: price falls ~18% for every doubling of the lot. At SNP's lot size the market would charge ~$0.99; at a 5-drum batch ~$0.85</a:t>
+              <a:t>— solid where US data exists: price falls ~18% per doubling of the lot. Beyond 20 gal no US vendor publishes a price, so the market is a band: from that trend (low edge) up to the flattening seen in vendors' own volume ladders (high edge). At one drum $1.37–2.06; at SNP's lot $0.99–1.81; at a 5-drum batch $0.85–1.70</a:t>
             </a:r>
           </a:p>
           <a:p>
@@ -6672,7 +6672,7 @@
                 </a:solidFill>
                 <a:latin typeface="Calibri"/>
               </a:rPr>
-              <a:t>— $0.75 at ~3 drums a week — on or below the curve even though the market points are not delivered and not medical-grade</a:t>
+              <a:t>— $0.75 at ~3 drums a week — at or below the bottom of the band, delivered and to our spec</a:t>
             </a:r>
           </a:p>
           <a:p>
@@ -6722,7 +6722,7 @@
                 </a:solidFill>
                 <a:latin typeface="Calibri"/>
               </a:rPr>
-              <a:t>— $3.50 at a 5-drum batch and $6.00 below it — 4× and 6× the curve at those quantities: batch-fixed cost and drum freight priced in</a:t>
+              <a:t>— $3.50 at a 5-drum batch and $6.00 below it — above the top of the band at those quantities: batch-fixed cost and drum freight priced in</a:t>
             </a:r>
           </a:p>
           <a:p>
@@ -9949,8 +9949,8 @@
         </p:nvSpPr>
         <p:spPr>
           <a:xfrm>
-            <a:off x="2926080" y="987552"/>
-            <a:ext cx="5760720" cy="274320"/>
+            <a:off x="2834640" y="987552"/>
+            <a:ext cx="5394960" cy="274320"/>
           </a:xfrm>
           <a:prstGeom prst="rect">
             <a:avLst/>
@@ -9969,7 +9969,7 @@
               </a:spcAft>
             </a:pPr>
             <a:r>
-              <a:rPr sz="950" b="1" i="0">
+              <a:rPr sz="900" b="1" i="0">
                 <a:solidFill>
                   <a:srgbClr val="1F3864"/>
                 </a:solidFill>
@@ -9989,7 +9989,7 @@
         <p:spPr>
           <a:xfrm>
             <a:off x="548640" y="1325880"/>
-            <a:ext cx="2377440" cy="1280160"/>
+            <a:ext cx="2240280" cy="1280160"/>
           </a:xfrm>
           <a:prstGeom prst="rect">
             <a:avLst/>
@@ -10059,8 +10059,8 @@
         </p:nvSpPr>
         <p:spPr>
           <a:xfrm>
-            <a:off x="2926080" y="1490472"/>
-            <a:ext cx="5577840" cy="566928"/>
+            <a:off x="2834640" y="1490472"/>
+            <a:ext cx="5212080" cy="566928"/>
           </a:xfrm>
           <a:prstGeom prst="rect">
             <a:avLst/>
@@ -10103,8 +10103,8 @@
         </p:nvSpPr>
         <p:spPr>
           <a:xfrm>
-            <a:off x="2926080" y="1490472"/>
-            <a:ext cx="184909" cy="566928"/>
+            <a:off x="2834640" y="1490472"/>
+            <a:ext cx="172784" cy="566928"/>
           </a:xfrm>
           <a:prstGeom prst="rect">
             <a:avLst/>
@@ -10147,7 +10147,7 @@
         </p:nvSpPr>
         <p:spPr>
           <a:xfrm>
-            <a:off x="2907792" y="1490472"/>
+            <a:off x="2816352" y="1490472"/>
             <a:ext cx="18288" cy="566928"/>
           </a:xfrm>
           <a:prstGeom prst="rect">
@@ -10191,7 +10191,7 @@
         </p:nvSpPr>
         <p:spPr>
           <a:xfrm>
-            <a:off x="3110989" y="1490472"/>
+            <a:off x="3007424" y="1490472"/>
             <a:ext cx="18288" cy="566928"/>
           </a:xfrm>
           <a:prstGeom prst="rect">
@@ -10235,8 +10235,8 @@
         </p:nvSpPr>
         <p:spPr>
           <a:xfrm>
-            <a:off x="3481266" y="1490472"/>
-            <a:ext cx="184909" cy="566928"/>
+            <a:off x="3353420" y="1490472"/>
+            <a:ext cx="172784" cy="566928"/>
           </a:xfrm>
           <a:prstGeom prst="rect">
             <a:avLst/>
@@ -10279,7 +10279,7 @@
         </p:nvSpPr>
         <p:spPr>
           <a:xfrm>
-            <a:off x="3462978" y="1490472"/>
+            <a:off x="3335132" y="1490472"/>
             <a:ext cx="18288" cy="566928"/>
           </a:xfrm>
           <a:prstGeom prst="rect">
@@ -10323,7 +10323,7 @@
         </p:nvSpPr>
         <p:spPr>
           <a:xfrm>
-            <a:off x="3666175" y="1490472"/>
+            <a:off x="3526204" y="1490472"/>
             <a:ext cx="18288" cy="566928"/>
           </a:xfrm>
           <a:prstGeom prst="rect">
@@ -10367,8 +10367,8 @@
         </p:nvSpPr>
         <p:spPr>
           <a:xfrm>
-            <a:off x="4036452" y="1490472"/>
-            <a:ext cx="184909" cy="566928"/>
+            <a:off x="3872200" y="1490472"/>
+            <a:ext cx="172784" cy="566928"/>
           </a:xfrm>
           <a:prstGeom prst="rect">
             <a:avLst/>
@@ -10411,7 +10411,7 @@
         </p:nvSpPr>
         <p:spPr>
           <a:xfrm>
-            <a:off x="4018164" y="1490472"/>
+            <a:off x="3853912" y="1490472"/>
             <a:ext cx="18288" cy="566928"/>
           </a:xfrm>
           <a:prstGeom prst="rect">
@@ -10455,7 +10455,7 @@
         </p:nvSpPr>
         <p:spPr>
           <a:xfrm>
-            <a:off x="4221361" y="1490472"/>
+            <a:off x="4044984" y="1490472"/>
             <a:ext cx="18288" cy="566928"/>
           </a:xfrm>
           <a:prstGeom prst="rect">
@@ -10499,8 +10499,8 @@
         </p:nvSpPr>
         <p:spPr>
           <a:xfrm>
-            <a:off x="4591638" y="1490472"/>
-            <a:ext cx="184909" cy="566928"/>
+            <a:off x="4390981" y="1490472"/>
+            <a:ext cx="172784" cy="566928"/>
           </a:xfrm>
           <a:prstGeom prst="rect">
             <a:avLst/>
@@ -10543,7 +10543,7 @@
         </p:nvSpPr>
         <p:spPr>
           <a:xfrm>
-            <a:off x="4573350" y="1490472"/>
+            <a:off x="4372693" y="1490472"/>
             <a:ext cx="18288" cy="566928"/>
           </a:xfrm>
           <a:prstGeom prst="rect">
@@ -10587,7 +10587,7 @@
         </p:nvSpPr>
         <p:spPr>
           <a:xfrm>
-            <a:off x="4776547" y="1490472"/>
+            <a:off x="4563765" y="1490472"/>
             <a:ext cx="18288" cy="566928"/>
           </a:xfrm>
           <a:prstGeom prst="rect">
@@ -10631,8 +10631,8 @@
         </p:nvSpPr>
         <p:spPr>
           <a:xfrm>
-            <a:off x="5146824" y="1490472"/>
-            <a:ext cx="184909" cy="566928"/>
+            <a:off x="4909761" y="1490472"/>
+            <a:ext cx="172784" cy="566928"/>
           </a:xfrm>
           <a:prstGeom prst="rect">
             <a:avLst/>
@@ -10675,7 +10675,7 @@
         </p:nvSpPr>
         <p:spPr>
           <a:xfrm>
-            <a:off x="5128536" y="1490472"/>
+            <a:off x="4891473" y="1490472"/>
             <a:ext cx="18288" cy="566928"/>
           </a:xfrm>
           <a:prstGeom prst="rect">
@@ -10719,7 +10719,7 @@
         </p:nvSpPr>
         <p:spPr>
           <a:xfrm>
-            <a:off x="5331733" y="1490472"/>
+            <a:off x="5082545" y="1490472"/>
             <a:ext cx="18288" cy="566928"/>
           </a:xfrm>
           <a:prstGeom prst="rect">
@@ -10763,8 +10763,8 @@
         </p:nvSpPr>
         <p:spPr>
           <a:xfrm>
-            <a:off x="5702010" y="1490472"/>
-            <a:ext cx="184909" cy="566928"/>
+            <a:off x="5428542" y="1490472"/>
+            <a:ext cx="172784" cy="566928"/>
           </a:xfrm>
           <a:prstGeom prst="rect">
             <a:avLst/>
@@ -10807,7 +10807,7 @@
         </p:nvSpPr>
         <p:spPr>
           <a:xfrm>
-            <a:off x="5683722" y="1490472"/>
+            <a:off x="5410254" y="1490472"/>
             <a:ext cx="18288" cy="566928"/>
           </a:xfrm>
           <a:prstGeom prst="rect">
@@ -10851,7 +10851,7 @@
         </p:nvSpPr>
         <p:spPr>
           <a:xfrm>
-            <a:off x="5886919" y="1490472"/>
+            <a:off x="5601326" y="1490472"/>
             <a:ext cx="18288" cy="566928"/>
           </a:xfrm>
           <a:prstGeom prst="rect">
@@ -10895,8 +10895,8 @@
         </p:nvSpPr>
         <p:spPr>
           <a:xfrm>
-            <a:off x="6257196" y="1490472"/>
-            <a:ext cx="184909" cy="566928"/>
+            <a:off x="5947322" y="1490472"/>
+            <a:ext cx="172784" cy="566928"/>
           </a:xfrm>
           <a:prstGeom prst="rect">
             <a:avLst/>
@@ -10939,7 +10939,7 @@
         </p:nvSpPr>
         <p:spPr>
           <a:xfrm>
-            <a:off x="6238908" y="1490472"/>
+            <a:off x="5929034" y="1490472"/>
             <a:ext cx="18288" cy="566928"/>
           </a:xfrm>
           <a:prstGeom prst="rect">
@@ -10983,7 +10983,7 @@
         </p:nvSpPr>
         <p:spPr>
           <a:xfrm>
-            <a:off x="6442105" y="1490472"/>
+            <a:off x="6120106" y="1490472"/>
             <a:ext cx="18288" cy="566928"/>
           </a:xfrm>
           <a:prstGeom prst="rect">
@@ -11027,8 +11027,8 @@
         </p:nvSpPr>
         <p:spPr>
           <a:xfrm>
-            <a:off x="6812382" y="1490472"/>
-            <a:ext cx="184909" cy="566928"/>
+            <a:off x="6466103" y="1490472"/>
+            <a:ext cx="172784" cy="566928"/>
           </a:xfrm>
           <a:prstGeom prst="rect">
             <a:avLst/>
@@ -11071,7 +11071,7 @@
         </p:nvSpPr>
         <p:spPr>
           <a:xfrm>
-            <a:off x="6794094" y="1490472"/>
+            <a:off x="6447815" y="1490472"/>
             <a:ext cx="18288" cy="566928"/>
           </a:xfrm>
           <a:prstGeom prst="rect">
@@ -11115,7 +11115,7 @@
         </p:nvSpPr>
         <p:spPr>
           <a:xfrm>
-            <a:off x="6997291" y="1490472"/>
+            <a:off x="6638887" y="1490472"/>
             <a:ext cx="18288" cy="566928"/>
           </a:xfrm>
           <a:prstGeom prst="rect">
@@ -11159,8 +11159,8 @@
         </p:nvSpPr>
         <p:spPr>
           <a:xfrm>
-            <a:off x="7367568" y="1490472"/>
-            <a:ext cx="184909" cy="566928"/>
+            <a:off x="6984883" y="1490472"/>
+            <a:ext cx="172784" cy="566928"/>
           </a:xfrm>
           <a:prstGeom prst="rect">
             <a:avLst/>
@@ -11203,7 +11203,7 @@
         </p:nvSpPr>
         <p:spPr>
           <a:xfrm>
-            <a:off x="7349280" y="1490472"/>
+            <a:off x="6966595" y="1490472"/>
             <a:ext cx="18288" cy="566928"/>
           </a:xfrm>
           <a:prstGeom prst="rect">
@@ -11247,7 +11247,7 @@
         </p:nvSpPr>
         <p:spPr>
           <a:xfrm>
-            <a:off x="7552478" y="1490472"/>
+            <a:off x="7157667" y="1490472"/>
             <a:ext cx="18288" cy="566928"/>
           </a:xfrm>
           <a:prstGeom prst="rect">
@@ -11291,8 +11291,8 @@
         </p:nvSpPr>
         <p:spPr>
           <a:xfrm>
-            <a:off x="7922754" y="1490472"/>
-            <a:ext cx="184909" cy="566928"/>
+            <a:off x="7503664" y="1490472"/>
+            <a:ext cx="172784" cy="566928"/>
           </a:xfrm>
           <a:prstGeom prst="rect">
             <a:avLst/>
@@ -11335,7 +11335,7 @@
         </p:nvSpPr>
         <p:spPr>
           <a:xfrm>
-            <a:off x="7904466" y="1490472"/>
+            <a:off x="7485376" y="1490472"/>
             <a:ext cx="18288" cy="566928"/>
           </a:xfrm>
           <a:prstGeom prst="rect">
@@ -11379,7 +11379,7 @@
         </p:nvSpPr>
         <p:spPr>
           <a:xfrm>
-            <a:off x="8107664" y="1490472"/>
+            <a:off x="7676448" y="1490472"/>
             <a:ext cx="18288" cy="566928"/>
           </a:xfrm>
           <a:prstGeom prst="rect">
@@ -11423,8 +11423,8 @@
         </p:nvSpPr>
         <p:spPr>
           <a:xfrm>
-            <a:off x="8641080" y="1280160"/>
-            <a:ext cx="3017520" cy="1417320"/>
+            <a:off x="8229600" y="1252728"/>
+            <a:ext cx="3429000" cy="1463040"/>
           </a:xfrm>
           <a:prstGeom prst="rect">
             <a:avLst/>
@@ -11439,11 +11439,11 @@
           <a:p>
             <a:pPr>
               <a:spcAft>
-                <a:spcPts val="100"/>
-              </a:spcAft>
-            </a:pPr>
-            <a:r>
-              <a:rPr sz="800">
+                <a:spcPts val="200"/>
+              </a:spcAft>
+            </a:pPr>
+            <a:r>
+              <a:rPr sz="850">
                 <a:solidFill>
                   <a:srgbClr val="595959"/>
                 </a:solidFill>
@@ -11452,7 +11452,7 @@
               <a:t>Drums a year  </a:t>
             </a:r>
             <a:r>
-              <a:rPr sz="850" b="1">
+              <a:rPr sz="1100" b="1">
                 <a:solidFill>
                   <a:srgbClr val="1F3864"/>
                 </a:solidFill>
@@ -11464,11 +11464,11 @@
           <a:p>
             <a:pPr>
               <a:spcAft>
-                <a:spcPts val="100"/>
-              </a:spcAft>
-            </a:pPr>
-            <a:r>
-              <a:rPr sz="800">
+                <a:spcPts val="200"/>
+              </a:spcAft>
+            </a:pPr>
+            <a:r>
+              <a:rPr sz="850">
                 <a:solidFill>
                   <a:srgbClr val="595959"/>
                 </a:solidFill>
@@ -11477,7 +11477,7 @@
               <a:t>Money a year  </a:t>
             </a:r>
             <a:r>
-              <a:rPr sz="850" b="1">
+              <a:rPr sz="1100" b="1">
                 <a:solidFill>
                   <a:srgbClr val="1F3864"/>
                 </a:solidFill>
@@ -11489,11 +11489,11 @@
           <a:p>
             <a:pPr>
               <a:spcAft>
-                <a:spcPts val="100"/>
-              </a:spcAft>
-            </a:pPr>
-            <a:r>
-              <a:rPr sz="800">
+                <a:spcPts val="200"/>
+              </a:spcAft>
+            </a:pPr>
+            <a:r>
+              <a:rPr sz="850">
                 <a:solidFill>
                   <a:srgbClr val="595959"/>
                 </a:solidFill>
@@ -11502,7 +11502,7 @@
               <a:t>SNP Inc. sees  </a:t>
             </a:r>
             <a:r>
-              <a:rPr sz="850" b="0">
+              <a:rPr sz="900" b="0">
                 <a:solidFill>
                   <a:srgbClr val="1F3864"/>
                 </a:solidFill>
@@ -11514,11 +11514,11 @@
           <a:p>
             <a:pPr>
               <a:spcAft>
-                <a:spcPts val="100"/>
-              </a:spcAft>
-            </a:pPr>
-            <a:r>
-              <a:rPr sz="800">
+                <a:spcPts val="200"/>
+              </a:spcAft>
+            </a:pPr>
+            <a:r>
+              <a:rPr sz="850">
                 <a:solidFill>
                   <a:srgbClr val="595959"/>
                 </a:solidFill>
@@ -11527,7 +11527,7 @@
               <a:t>If SNP fails, restart in  </a:t>
             </a:r>
             <a:r>
-              <a:rPr sz="850" b="0">
+              <a:rPr sz="900" b="0">
                 <a:solidFill>
                   <a:srgbClr val="1F3864"/>
                 </a:solidFill>
@@ -11547,7 +11547,7 @@
         <p:spPr>
           <a:xfrm>
             <a:off x="548640" y="2788920"/>
-            <a:ext cx="2377440" cy="1280160"/>
+            <a:ext cx="2240280" cy="1280160"/>
           </a:xfrm>
           <a:prstGeom prst="rect">
             <a:avLst/>
@@ -11617,8 +11617,8 @@
         </p:nvSpPr>
         <p:spPr>
           <a:xfrm>
-            <a:off x="2926080" y="2953512"/>
-            <a:ext cx="5577840" cy="566928"/>
+            <a:off x="2834640" y="2953512"/>
+            <a:ext cx="5212080" cy="566928"/>
           </a:xfrm>
           <a:prstGeom prst="rect">
             <a:avLst/>
@@ -11661,8 +11661,8 @@
         </p:nvSpPr>
         <p:spPr>
           <a:xfrm>
-            <a:off x="4072211" y="2953512"/>
-            <a:ext cx="184909" cy="566928"/>
+            <a:off x="3905615" y="2953512"/>
+            <a:ext cx="172784" cy="566928"/>
           </a:xfrm>
           <a:prstGeom prst="rect">
             <a:avLst/>
@@ -11705,7 +11705,7 @@
         </p:nvSpPr>
         <p:spPr>
           <a:xfrm>
-            <a:off x="4053923" y="2953512"/>
+            <a:off x="3887327" y="2953512"/>
             <a:ext cx="18288" cy="566928"/>
           </a:xfrm>
           <a:prstGeom prst="rect">
@@ -11749,7 +11749,7 @@
         </p:nvSpPr>
         <p:spPr>
           <a:xfrm>
-            <a:off x="4257120" y="2953512"/>
+            <a:off x="4078399" y="2953512"/>
             <a:ext cx="18288" cy="566928"/>
           </a:xfrm>
           <a:prstGeom prst="rect">
@@ -11793,8 +11793,8 @@
         </p:nvSpPr>
         <p:spPr>
           <a:xfrm>
-            <a:off x="5829613" y="2953512"/>
-            <a:ext cx="184909" cy="566928"/>
+            <a:off x="5547777" y="2953512"/>
+            <a:ext cx="172784" cy="566928"/>
           </a:xfrm>
           <a:prstGeom prst="rect">
             <a:avLst/>
@@ -11837,7 +11837,7 @@
         </p:nvSpPr>
         <p:spPr>
           <a:xfrm>
-            <a:off x="5811325" y="2953512"/>
+            <a:off x="5529489" y="2953512"/>
             <a:ext cx="18288" cy="566928"/>
           </a:xfrm>
           <a:prstGeom prst="rect">
@@ -11881,7 +11881,7 @@
         </p:nvSpPr>
         <p:spPr>
           <a:xfrm>
-            <a:off x="6014522" y="2953512"/>
+            <a:off x="5720561" y="2953512"/>
             <a:ext cx="18288" cy="566928"/>
           </a:xfrm>
           <a:prstGeom prst="rect">
@@ -11925,8 +11925,8 @@
         </p:nvSpPr>
         <p:spPr>
           <a:xfrm>
-            <a:off x="7587014" y="2953512"/>
-            <a:ext cx="184909" cy="566928"/>
+            <a:off x="7189939" y="2953512"/>
+            <a:ext cx="172784" cy="566928"/>
           </a:xfrm>
           <a:prstGeom prst="rect">
             <a:avLst/>
@@ -11969,7 +11969,7 @@
         </p:nvSpPr>
         <p:spPr>
           <a:xfrm>
-            <a:off x="7568726" y="2953512"/>
+            <a:off x="7171651" y="2953512"/>
             <a:ext cx="18288" cy="566928"/>
           </a:xfrm>
           <a:prstGeom prst="rect">
@@ -12013,7 +12013,7 @@
         </p:nvSpPr>
         <p:spPr>
           <a:xfrm>
-            <a:off x="7771924" y="2953512"/>
+            <a:off x="7362723" y="2953512"/>
             <a:ext cx="18288" cy="566928"/>
           </a:xfrm>
           <a:prstGeom prst="rect">
@@ -12057,8 +12057,8 @@
         </p:nvSpPr>
         <p:spPr>
           <a:xfrm>
-            <a:off x="8641080" y="2743200"/>
-            <a:ext cx="3017520" cy="1417320"/>
+            <a:off x="8229600" y="2715768"/>
+            <a:ext cx="3429000" cy="1463040"/>
           </a:xfrm>
           <a:prstGeom prst="rect">
             <a:avLst/>
@@ -12073,11 +12073,11 @@
           <a:p>
             <a:pPr>
               <a:spcAft>
-                <a:spcPts val="100"/>
-              </a:spcAft>
-            </a:pPr>
-            <a:r>
-              <a:rPr sz="800">
+                <a:spcPts val="200"/>
+              </a:spcAft>
+            </a:pPr>
+            <a:r>
+              <a:rPr sz="850">
                 <a:solidFill>
                   <a:srgbClr val="595959"/>
                 </a:solidFill>
@@ -12086,23 +12086,23 @@
               <a:t>Drums a year  </a:t>
             </a:r>
             <a:r>
-              <a:rPr sz="850" b="1">
+              <a:rPr sz="1100" b="1">
                 <a:solidFill>
                   <a:srgbClr val="1F3864"/>
                 </a:solidFill>
                 <a:latin typeface="Calibri"/>
               </a:rPr>
-              <a:t>150 = SNP 145/140/135 + PCI 5/10/15 (1/2/3 batches)</a:t>
+              <a:t>150 = SNP 145 / 140 / 135 + PCI 5 / 10 / 15</a:t>
             </a:r>
           </a:p>
           <a:p>
             <a:pPr>
               <a:spcAft>
-                <a:spcPts val="100"/>
-              </a:spcAft>
-            </a:pPr>
-            <a:r>
-              <a:rPr sz="800">
+                <a:spcPts val="200"/>
+              </a:spcAft>
+            </a:pPr>
+            <a:r>
+              <a:rPr sz="850">
                 <a:solidFill>
                   <a:srgbClr val="595959"/>
                 </a:solidFill>
@@ -12111,23 +12111,23 @@
               <a:t>Money a year  </a:t>
             </a:r>
             <a:r>
-              <a:rPr sz="850" b="1">
+              <a:rPr sz="1100" b="1">
                 <a:solidFill>
                   <a:srgbClr val="1F3864"/>
                 </a:solidFill>
                 <a:latin typeface="Calibri"/>
               </a:rPr>
-              <a:t>$56.9k / $63.1k / $69.3k = SNP $49.0k/$47.3k/$45.6k + PCI $7.9k/$15.8k/$23.6k</a:t>
+              <a:t>$56.9k / $63.1k / $69.3k (PCI $7.9k / $15.8k / $23.6k)</a:t>
             </a:r>
           </a:p>
           <a:p>
             <a:pPr>
               <a:spcAft>
-                <a:spcPts val="100"/>
-              </a:spcAft>
-            </a:pPr>
-            <a:r>
-              <a:rPr sz="800">
+                <a:spcPts val="200"/>
+              </a:spcAft>
+            </a:pPr>
+            <a:r>
+              <a:rPr sz="850">
                 <a:solidFill>
                   <a:srgbClr val="595959"/>
                 </a:solidFill>
@@ -12136,7 +12136,7 @@
               <a:t>SNP Inc. sees  </a:t>
             </a:r>
             <a:r>
-              <a:rPr sz="850" b="0">
+              <a:rPr sz="900" b="0">
                 <a:solidFill>
                   <a:srgbClr val="1F3864"/>
                 </a:solidFill>
@@ -12148,11 +12148,11 @@
           <a:p>
             <a:pPr>
               <a:spcAft>
-                <a:spcPts val="100"/>
-              </a:spcAft>
-            </a:pPr>
-            <a:r>
-              <a:rPr sz="800">
+                <a:spcPts val="200"/>
+              </a:spcAft>
+            </a:pPr>
+            <a:r>
+              <a:rPr sz="850">
                 <a:solidFill>
                   <a:srgbClr val="595959"/>
                 </a:solidFill>
@@ -12161,7 +12161,7 @@
               <a:t>If SNP fails, restart in  </a:t>
             </a:r>
             <a:r>
-              <a:rPr sz="850" b="0">
+              <a:rPr sz="900" b="0">
                 <a:solidFill>
                   <a:srgbClr val="1F3864"/>
                 </a:solidFill>
@@ -12181,7 +12181,7 @@
         <p:spPr>
           <a:xfrm>
             <a:off x="548640" y="4251960"/>
-            <a:ext cx="2377440" cy="1280160"/>
+            <a:ext cx="2240280" cy="1280160"/>
           </a:xfrm>
           <a:prstGeom prst="rect">
             <a:avLst/>
@@ -12251,8 +12251,8 @@
         </p:nvSpPr>
         <p:spPr>
           <a:xfrm>
-            <a:off x="2926080" y="4416552"/>
-            <a:ext cx="5577840" cy="566928"/>
+            <a:off x="2834640" y="4416552"/>
+            <a:ext cx="5212080" cy="566928"/>
           </a:xfrm>
           <a:prstGeom prst="rect">
             <a:avLst/>
@@ -12295,7 +12295,7 @@
         </p:nvSpPr>
         <p:spPr>
           <a:xfrm>
-            <a:off x="2651760" y="5001768"/>
+            <a:off x="2560320" y="5001768"/>
             <a:ext cx="548640" cy="228600"/>
           </a:xfrm>
           <a:prstGeom prst="rect">
@@ -12334,7 +12334,7 @@
         </p:nvSpPr>
         <p:spPr>
           <a:xfrm>
-            <a:off x="4042399" y="5001768"/>
+            <a:off x="3859770" y="5001768"/>
             <a:ext cx="548640" cy="228600"/>
           </a:xfrm>
           <a:prstGeom prst="rect">
@@ -12373,7 +12373,7 @@
         </p:nvSpPr>
         <p:spPr>
           <a:xfrm>
-            <a:off x="5433039" y="5001768"/>
+            <a:off x="5159220" y="5001768"/>
             <a:ext cx="548640" cy="228600"/>
           </a:xfrm>
           <a:prstGeom prst="rect">
@@ -12412,7 +12412,7 @@
         </p:nvSpPr>
         <p:spPr>
           <a:xfrm>
-            <a:off x="6838960" y="5001768"/>
+            <a:off x="6472949" y="5001768"/>
             <a:ext cx="548640" cy="228600"/>
           </a:xfrm>
           <a:prstGeom prst="rect">
@@ -12451,7 +12451,7 @@
         </p:nvSpPr>
         <p:spPr>
           <a:xfrm>
-            <a:off x="8229600" y="5001768"/>
+            <a:off x="7772400" y="5001768"/>
             <a:ext cx="548640" cy="228600"/>
           </a:xfrm>
           <a:prstGeom prst="rect">
@@ -12490,8 +12490,8 @@
         </p:nvSpPr>
         <p:spPr>
           <a:xfrm>
-            <a:off x="8641080" y="4206240"/>
-            <a:ext cx="3017520" cy="1417320"/>
+            <a:off x="8229600" y="4178808"/>
+            <a:ext cx="3429000" cy="1463040"/>
           </a:xfrm>
           <a:prstGeom prst="rect">
             <a:avLst/>
@@ -12506,11 +12506,11 @@
           <a:p>
             <a:pPr>
               <a:spcAft>
-                <a:spcPts val="100"/>
-              </a:spcAft>
-            </a:pPr>
-            <a:r>
-              <a:rPr sz="800">
+                <a:spcPts val="200"/>
+              </a:spcAft>
+            </a:pPr>
+            <a:r>
+              <a:rPr sz="850">
                 <a:solidFill>
                   <a:srgbClr val="595959"/>
                 </a:solidFill>
@@ -12519,7 +12519,7 @@
               <a:t>Drums a year  </a:t>
             </a:r>
             <a:r>
-              <a:rPr sz="850" b="1">
+              <a:rPr sz="1100" b="1">
                 <a:solidFill>
                   <a:srgbClr val="1F3864"/>
                 </a:solidFill>
@@ -12531,11 +12531,11 @@
           <a:p>
             <a:pPr>
               <a:spcAft>
-                <a:spcPts val="100"/>
-              </a:spcAft>
-            </a:pPr>
-            <a:r>
-              <a:rPr sz="800">
+                <a:spcPts val="200"/>
+              </a:spcAft>
+            </a:pPr>
+            <a:r>
+              <a:rPr sz="850">
                 <a:solidFill>
                   <a:srgbClr val="595959"/>
                 </a:solidFill>
@@ -12544,7 +12544,7 @@
               <a:t>Money a year  </a:t>
             </a:r>
             <a:r>
-              <a:rPr sz="850" b="1">
+              <a:rPr sz="1100" b="1">
                 <a:solidFill>
                   <a:srgbClr val="1F3864"/>
                 </a:solidFill>
@@ -12556,11 +12556,11 @@
           <a:p>
             <a:pPr>
               <a:spcAft>
-                <a:spcPts val="100"/>
-              </a:spcAft>
-            </a:pPr>
-            <a:r>
-              <a:rPr sz="800">
+                <a:spcPts val="200"/>
+              </a:spcAft>
+            </a:pPr>
+            <a:r>
+              <a:rPr sz="850">
                 <a:solidFill>
                   <a:srgbClr val="595959"/>
                 </a:solidFill>
@@ -12569,7 +12569,7 @@
               <a:t>SNP Inc. sees  </a:t>
             </a:r>
             <a:r>
-              <a:rPr sz="850" b="0">
+              <a:rPr sz="900" b="0">
                 <a:solidFill>
                   <a:srgbClr val="1F3864"/>
                 </a:solidFill>
@@ -12581,11 +12581,11 @@
           <a:p>
             <a:pPr>
               <a:spcAft>
-                <a:spcPts val="100"/>
-              </a:spcAft>
-            </a:pPr>
-            <a:r>
-              <a:rPr sz="800">
+                <a:spcPts val="200"/>
+              </a:spcAft>
+            </a:pPr>
+            <a:r>
+              <a:rPr sz="850">
                 <a:solidFill>
                   <a:srgbClr val="595959"/>
                 </a:solidFill>
@@ -12594,7 +12594,7 @@
               <a:t>If SNP fails, restart in  </a:t>
             </a:r>
             <a:r>
-              <a:rPr sz="850" b="0">
+              <a:rPr sz="900" b="0">
                 <a:solidFill>
                   <a:srgbClr val="1F3864"/>
                 </a:solidFill>

</xml_diff>

<commit_message>
Pricing slide: legend below the plot, sidebar fits
Co-Authored-By: Claude Fable 5.1 <noreply@anthropic.com>
Claude-Session: https://claude.ai/code/session_01LkE2ZRYs3PLyj8XHTsU3i4
</commit_message>
<xml_diff>
--- a/PVA second supplier initiative/PVA_Second_Supplier_Leadership_Deck.pptx
+++ b/PVA second supplier initiative/PVA_Second_Supplier_Leadership_Deck.pptx
@@ -6484,8 +6484,8 @@
         </p:blipFill>
         <p:spPr>
           <a:xfrm>
-            <a:off x="548640" y="1051560"/>
-            <a:ext cx="7406640" cy="4787219"/>
+            <a:off x="548640" y="1024128"/>
+            <a:ext cx="6799106" cy="4892040"/>
           </a:xfrm>
           <a:prstGeom prst="rect">
             <a:avLst/>
@@ -6597,7 +6597,7 @@
                 </a:solidFill>
                 <a:latin typeface="Calibri"/>
               </a:rPr>
-              <a:t>— quantity per order, from a 1-gallon jug to 150 drums, on a log scale</a:t>
+              <a:t>— quantity per order, 1-gallon jug to 150 drums, log scale</a:t>
             </a:r>
           </a:p>
           <a:p>
@@ -6622,7 +6622,7 @@
                 </a:solidFill>
                 <a:latin typeface="Calibri"/>
               </a:rPr>
-              <a:t>— verified market prices of pre-mixed PVA solution at each pack size (composites-grade in the US up to 20 gal; ton-scale offers offshore, before freight)</a:t>
+              <a:t>— verified prices of pre-mixed PVA solution by pack size: US composites grade up to 20 gal; ton-scale offshore offers before freight</a:t>
             </a:r>
           </a:p>
           <a:p>
@@ -6647,7 +6647,7 @@
                 </a:solidFill>
                 <a:latin typeface="Calibri"/>
               </a:rPr>
-              <a:t>— solid where US data exists: price falls ~18% per doubling of the lot. Beyond 20 gal no US vendor publishes a price, so the market is a band: from that trend (low edge) up to the flattening seen in vendors' own volume ladders (high edge). At one drum $1.37–2.06; at SNP's lot $0.99–1.81; at a 5-drum batch $0.85–1.70</a:t>
+              <a:t>— solid where US data exists: ~18% lower per doubling of the lot. Beyond 20 gal no US vendor publishes a price, so the market is a band from that trend up to the flattening in vendors' own ladders: one drum $1.37–2.06, SNP's lot $0.99–1.81, a 5-drum batch $0.85–1.70</a:t>
             </a:r>
           </a:p>
           <a:p>
@@ -6722,7 +6722,7 @@
                 </a:solidFill>
                 <a:latin typeface="Calibri"/>
               </a:rPr>
-              <a:t>— $3.50 at a 5-drum batch and $6.00 below it — above the top of the band at those quantities: batch-fixed cost and drum freight priced in</a:t>
+              <a:t>— $3.50 at a 5-drum batch, $6.00 below it — above the band: batch-fixed cost and drum freight priced in</a:t>
             </a:r>
           </a:p>
           <a:p>
@@ -6747,7 +6747,7 @@
                 </a:solidFill>
                 <a:latin typeface="Calibri"/>
               </a:rPr>
-              <a:t>— $8.42 at a 40-gallon minimum, off the curve entirely; APV ≥$3 is an estimate from our call, never confirmed</a:t>
+              <a:t>— $8.42 at a 40-gal minimum, off the chart's logic; APV ≥$3 is an estimate from our call, never confirmed</a:t>
             </a:r>
           </a:p>
         </p:txBody>

</xml_diff>

<commit_message>
Pricing chart: short, readable legend inside the plot
Co-Authored-By: Claude Fable 5.1 <noreply@anthropic.com>
Claude-Session: https://claude.ai/code/session_01LkE2ZRYs3PLyj8XHTsU3i4
</commit_message>
<xml_diff>
--- a/PVA second supplier initiative/PVA_Second_Supplier_Leadership_Deck.pptx
+++ b/PVA second supplier initiative/PVA_Second_Supplier_Leadership_Deck.pptx
@@ -6484,8 +6484,8 @@
         </p:blipFill>
         <p:spPr>
           <a:xfrm>
-            <a:off x="548640" y="1024128"/>
-            <a:ext cx="6799106" cy="4892040"/>
+            <a:off x="548640" y="1051560"/>
+            <a:ext cx="7406640" cy="4787219"/>
           </a:xfrm>
           <a:prstGeom prst="rect">
             <a:avLst/>

</xml_diff>

<commit_message>
Pricing chart: market band = 10th-90th percentile spread of the verified points around the trend
Co-Authored-By: Claude Fable 5.1 <noreply@anthropic.com>
Claude-Session: https://claude.ai/code/session_01LkE2ZRYs3PLyj8XHTsU3i4
</commit_message>
<xml_diff>
--- a/PVA second supplier initiative/PVA_Second_Supplier_Leadership_Deck.pptx
+++ b/PVA second supplier initiative/PVA_Second_Supplier_Leadership_Deck.pptx
@@ -721,7 +721,7 @@
           <a:lstStyle/>
           <a:p>
             <a:r>
-              <a:t>Price per pound against quantity per order. The grey points are the verified market prices of pre-mixed PVA solution at every pack size we found - one-gallon jugs, cases, pails, a twenty-gallon lot, and ton-scale offers offshore before freight. The navy line is the curve fitted through them: price falls about eighteen percent every time the lot doubles where we have US data, up to twenty gallons. Beyond that no US vendor publishes a price, so the market is drawn as a band: the fitted trend at the bottom, the flattening seen in vendors' own volume ladders at the top - roughly a dollar to two dollars at a drum. SNP, green, sells us about three drums a week at 75 cents - at or below the bottom of that band, even though the market points are neither delivered nor medical-grade. The green dashed line is the same slope drawn through SNP's price: it is what to expect if we ever bought smaller lots from them - about a dollar at one drum, about two dollars at five gallons. It is a regression from the market's behaviour, not a quote from SNP. PCI, in amber, sits above the top of the band at its quantities - the batch-fixed cost and drum freight of a non-specialist. CJB is off the curve entirely; APV's three dollars is an estimate from our call, never confirmed. The message: price follows lot size everywhere in this market, except at SNP.</a:t>
+              <a:t>Price per pound against quantity per order. The grey points are the verified market prices of pre-mixed PVA solution at every pack size we found - one-gallon jugs, cases, pails, a twenty-gallon lot, and ton-scale offers offshore before freight. The navy line is the curve fitted through them: price falls about eighteen percent every time the lot doubles where we have US data, up to twenty gallons. The band is where eighty percent of the verified points fall around that trend; beyond twenty gallons, where no US vendor publishes a price, its top follows the flattening seen in vendors' own volume ladders. SNP, green, sells us about three drums a week at 75 cents - at or below the bottom of that band, even though the market points are neither delivered nor medical-grade. The green dashed line is the same slope drawn through SNP's price: it is what to expect if we ever bought smaller lots from them - about a dollar at one drum, about two dollars at five gallons. It is a regression from the market's behaviour, not a quote from SNP. PCI, in amber, sits above the top of the band at its quantities - the batch-fixed cost and drum freight of a non-specialist. CJB is off the curve entirely; APV's three dollars is an estimate from our call, never confirmed. The message: price follows lot size everywhere in this market, except at SNP.</a:t>
             </a:r>
           </a:p>
         </p:txBody>
@@ -6647,7 +6647,7 @@
                 </a:solidFill>
                 <a:latin typeface="Calibri"/>
               </a:rPr>
-              <a:t>— solid where US data exists: ~18% lower per doubling of the lot. Beyond 20 gal no US vendor publishes a price, so the market is a band from that trend up to the flattening in vendors' own ladders: one drum $1.37–2.06, SNP's lot $0.99–1.81, a 5-drum batch $0.85–1.70</a:t>
+              <a:t>— the trend: ~18% lower per doubling of the lot. The band is where 80% of the verified points fall around it; beyond 20 gal, where no US vendor publishes a price, its top follows the flattening in vendors' own ladders. One drum $0.83–3.53; SNP's lot $0.60–3.09; a 5-drum batch $0.51–2.91</a:t>
             </a:r>
           </a:p>
           <a:p>

</xml_diff>

<commit_message>
Pricing slide: sidebar and takeaway aligned with the wider band
Co-Authored-By: Claude Fable 5.1 <noreply@anthropic.com>
Claude-Session: https://claude.ai/code/session_01LkE2ZRYs3PLyj8XHTsU3i4
</commit_message>
<xml_diff>
--- a/PVA second supplier initiative/PVA_Second_Supplier_Leadership_Deck.pptx
+++ b/PVA second supplier initiative/PVA_Second_Supplier_Leadership_Deck.pptx
@@ -721,7 +721,7 @@
           <a:lstStyle/>
           <a:p>
             <a:r>
-              <a:t>Price per pound against quantity per order. The grey points are the verified market prices of pre-mixed PVA solution at every pack size we found - one-gallon jugs, cases, pails, a twenty-gallon lot, and ton-scale offers offshore before freight. The navy line is the curve fitted through them: price falls about eighteen percent every time the lot doubles where we have US data, up to twenty gallons. The band is where eighty percent of the verified points fall around that trend; beyond twenty gallons, where no US vendor publishes a price, its top follows the flattening seen in vendors' own volume ladders. SNP, green, sells us about three drums a week at 75 cents - at or below the bottom of that band, even though the market points are neither delivered nor medical-grade. The green dashed line is the same slope drawn through SNP's price: it is what to expect if we ever bought smaller lots from them - about a dollar at one drum, about two dollars at five gallons. It is a regression from the market's behaviour, not a quote from SNP. PCI, in amber, sits above the top of the band at its quantities - the batch-fixed cost and drum freight of a non-specialist. CJB is off the curve entirely; APV's three dollars is an estimate from our call, never confirmed. The message: price follows lot size everywhere in this market, except at SNP.</a:t>
+              <a:t>Price per pound against quantity per order. The grey points are the verified market prices of pre-mixed PVA solution at every pack size we found - one-gallon jugs, cases, pails, a twenty-gallon lot, and ton-scale offers offshore before freight. The navy line is the curve fitted through them: price falls about eighteen percent every time the lot doubles where we have US data, up to twenty gallons. The band is where eighty percent of the verified points fall around that trend; beyond twenty gallons, where no US vendor publishes a price, its top follows the flattening seen in vendors' own volume ladders. SNP, green, sells us about three drums a week at 75 cents - in the bottom of that band, and delivered, to our spec, even though the market points are neither delivered nor medical-grade. The green dashed line is the same slope drawn through SNP's price: it is what to expect if we ever bought smaller lots from them - about a dollar at one drum, about two dollars at five gallons. It is a regression from the market's behaviour, not a quote from SNP. PCI, in amber, sits above the top of the band at its quantities - the batch-fixed cost and drum freight of a non-specialist. CJB is off the curve entirely; APV's three dollars is an estimate from our call, never confirmed. The message: price follows lot size everywhere in this market, except at SNP.</a:t>
             </a:r>
           </a:p>
         </p:txBody>
@@ -6672,7 +6672,7 @@
                 </a:solidFill>
                 <a:latin typeface="Calibri"/>
               </a:rPr>
-              <a:t>— $0.75 at ~3 drums a week — at or below the bottom of the band, delivered and to our spec</a:t>
+              <a:t>— $0.75 at ~3 drums a week — in the bottom of the band, and delivered, to our spec, medical-grade controls: the cheapest end of the market for a better product</a:t>
             </a:r>
           </a:p>
           <a:p>
@@ -6747,7 +6747,7 @@
                 </a:solidFill>
                 <a:latin typeface="Calibri"/>
               </a:rPr>
-              <a:t>— $8.42 at a 40-gal minimum, off the chart's logic; APV ≥$3 is an estimate from our call, never confirmed</a:t>
+              <a:t>— CJB $8.42 at a 40-gal minimum sits far above the band; APV ≥$3 (estimate from our call, never confirmed) sits at the band's top</a:t>
             </a:r>
           </a:p>
         </p:txBody>
@@ -6830,7 +6830,7 @@
                 </a:solidFill>
                 <a:latin typeface="Calibri"/>
               </a:rPr>
-              <a:t>Price follows lot size everywhere in this market — except at SNP Inc., who sells us drum lots at a bulk price. Every other supplier charges what its lot size implies, or more.</a:t>
+              <a:t>Price follows lot size across this market. SNP Inc. sells us drum lots at the bottom of the band, delivered to our spec; every other supplier that can make it charges the top of the band, or more.</a:t>
             </a:r>
           </a:p>
         </p:txBody>

</xml_diff>

<commit_message>
Pricing chart: market band floored at SNP's $0.75 (no US-delivered lot observed cheaper)
Co-Authored-By: Claude Fable 5.1 <noreply@anthropic.com>
Claude-Session: https://claude.ai/code/session_01LkE2ZRYs3PLyj8XHTsU3i4
</commit_message>
<xml_diff>
--- a/PVA second supplier initiative/PVA_Second_Supplier_Leadership_Deck.pptx
+++ b/PVA second supplier initiative/PVA_Second_Supplier_Leadership_Deck.pptx
@@ -721,7 +721,7 @@
           <a:lstStyle/>
           <a:p>
             <a:r>
-              <a:t>Price per pound against quantity per order. The grey points are the verified market prices of pre-mixed PVA solution at every pack size we found - one-gallon jugs, cases, pails, a twenty-gallon lot, and ton-scale offers offshore before freight. The navy line is the curve fitted through them: price falls about eighteen percent every time the lot doubles where we have US data, up to twenty gallons. The band is where eighty percent of the verified points fall around that trend; beyond twenty gallons, where no US vendor publishes a price, its top follows the flattening seen in vendors' own volume ladders. SNP, green, sells us about three drums a week at 75 cents - in the bottom of that band, and delivered, to our spec, even though the market points are neither delivered nor medical-grade. The green dashed line is the same slope drawn through SNP's price: it is what to expect if we ever bought smaller lots from them - about a dollar at one drum, about two dollars at five gallons. It is a regression from the market's behaviour, not a quote from SNP. PCI, in amber, sits above the top of the band at its quantities - the batch-fixed cost and drum freight of a non-specialist. CJB is off the curve entirely; APV's three dollars is an estimate from our call, never confirmed. The message: price follows lot size everywhere in this market, except at SNP.</a:t>
+              <a:t>Price per pound against quantity per order. The grey points are the verified market prices of pre-mixed PVA solution at every pack size we found - one-gallon jugs, cases, pails, a twenty-gallon lot, and ton-scale offers offshore before freight. The navy line is the curve fitted through them: price falls about eighteen percent every time the lot doubles where we have US data, up to twenty gallons. The band is where eighty percent of the verified points fall around that trend; beyond twenty gallons, where no US vendor publishes a price, its top follows the flattening seen in vendors' own volume ladders, and its floor is SNP's 75 cents - no US-delivered lot has been seen cheaper; the offshore ton offers are before freight and duty. SNP, green, sells us about three drums a week at 75 cents - the floor of that band, and delivered, to our spec, even though the market points are neither delivered nor medical-grade. The green dashed line is the same slope drawn through SNP's price: it is what to expect if we ever bought smaller lots from them - about a dollar at one drum, about two dollars at five gallons. It is a regression from the market's behaviour, not a quote from SNP. PCI, in amber, sits above the top of the band at its quantities - the batch-fixed cost and drum freight of a non-specialist. CJB is off the curve entirely; APV's three dollars is an estimate from our call, never confirmed. The message: price follows lot size everywhere in this market, except at SNP.</a:t>
             </a:r>
           </a:p>
         </p:txBody>
@@ -6647,7 +6647,7 @@
                 </a:solidFill>
                 <a:latin typeface="Calibri"/>
               </a:rPr>
-              <a:t>— the trend: ~18% lower per doubling of the lot. The band is where 80% of the verified points fall around it; beyond 20 gal, where no US vendor publishes a price, its top follows the flattening in vendors' own ladders. One drum $0.83–3.53; SNP's lot $0.60–3.09; a 5-drum batch $0.51–2.91</a:t>
+              <a:t>— the trend: ~18% lower per doubling of the lot. The band is where 80% of the verified points fall around it; beyond 20 gal its top follows the flattening in vendors' ladders, and its floor is SNP's $0.75 — no US-delivered lot has been seen cheaper (offshore ton offers are before freight and duty). One drum $0.83–3.53; SNP's lot $0.75–3.09; a 5-drum batch $0.75–2.91</a:t>
             </a:r>
           </a:p>
           <a:p>
@@ -6672,7 +6672,7 @@
                 </a:solidFill>
                 <a:latin typeface="Calibri"/>
               </a:rPr>
-              <a:t>— $0.75 at ~3 drums a week — in the bottom of the band, and delivered, to our spec, medical-grade controls: the cheapest end of the market for a better product</a:t>
+              <a:t>— $0.75 at ~3 drums a week — the floor of the band, and delivered, to our spec: the cheapest price in the market for a better product</a:t>
             </a:r>
           </a:p>
           <a:p>
@@ -6830,7 +6830,7 @@
                 </a:solidFill>
                 <a:latin typeface="Calibri"/>
               </a:rPr>
-              <a:t>Price follows lot size across this market. SNP Inc. sells us drum lots at the bottom of the band, delivered to our spec; every other supplier that can make it charges the top of the band, or more.</a:t>
+              <a:t>Price follows lot size across this market. SNP Inc. is its floor — drum lots at $0.75, delivered to our spec; every other supplier that can make it charges the top of the band, or more.</a:t>
             </a:r>
           </a:p>
         </p:txBody>

</xml_diff>

<commit_message>
Pricing slide: floor note and sidebar fit
Co-Authored-By: Claude Fable 5.1 <noreply@anthropic.com>
Claude-Session: https://claude.ai/code/session_01LkE2ZRYs3PLyj8XHTsU3i4
</commit_message>
<xml_diff>
--- a/PVA second supplier initiative/PVA_Second_Supplier_Leadership_Deck.pptx
+++ b/PVA second supplier initiative/PVA_Second_Supplier_Leadership_Deck.pptx
@@ -6622,7 +6622,7 @@
                 </a:solidFill>
                 <a:latin typeface="Calibri"/>
               </a:rPr>
-              <a:t>— verified prices of pre-mixed PVA solution by pack size: US composites grade up to 20 gal; ton-scale offshore offers before freight</a:t>
+              <a:t>— verified prices of pre-mixed PVA solution by pack size (US up to 20 gal; offshore ton offers before freight)</a:t>
             </a:r>
           </a:p>
           <a:p>
@@ -6647,7 +6647,7 @@
                 </a:solidFill>
                 <a:latin typeface="Calibri"/>
               </a:rPr>
-              <a:t>— the trend: ~18% lower per doubling of the lot. The band is where 80% of the verified points fall around it; beyond 20 gal its top follows the flattening in vendors' ladders, and its floor is SNP's $0.75 — no US-delivered lot has been seen cheaper (offshore ton offers are before freight and duty). One drum $0.83–3.53; SNP's lot $0.75–3.09; a 5-drum batch $0.75–2.91</a:t>
+              <a:t>— trend ~18% lower per doubling of the lot; the band is where 80% of the points fall. Beyond 20 gal its top follows the flattening in vendors' ladders; its floor is SNP's $0.75 — no US-delivered lot has been seen cheaper. One drum $0.83–3.53; SNP's lot $0.75–3.09; 5-drum batch $0.75–2.91</a:t>
             </a:r>
           </a:p>
           <a:p>
@@ -6672,7 +6672,7 @@
                 </a:solidFill>
                 <a:latin typeface="Calibri"/>
               </a:rPr>
-              <a:t>— $0.75 at ~3 drums a week — the floor of the band, and delivered, to our spec: the cheapest price in the market for a better product</a:t>
+              <a:t>— $0.75 at ~3 drums a week — the floor of the band, delivered and to our spec: the market's cheapest price for a better product</a:t>
             </a:r>
           </a:p>
           <a:p>

</xml_diff>

<commit_message>
SNP conversation: other hydrogels framed as possibilities to explore, not commitments
Co-Authored-By: Claude Fable 5.1 <noreply@anthropic.com>
Claude-Session: https://claude.ai/code/session_01LkE2ZRYs3PLyj8XHTsU3i4
</commit_message>
<xml_diff>
--- a/PVA second supplier initiative/PVA_Second_Supplier_Leadership_Deck.pptx
+++ b/PVA second supplier initiative/PVA_Second_Supplier_Leadership_Deck.pptx
@@ -1141,7 +1141,7 @@
           <a:lstStyle/>
           <a:p>
             <a:r>
-              <a:t>The SNP conversation, in order. One: why we are here - growth, a sole source we depend on, and the intent to run it as a partnership; they should hear investment, not audit. Two: our business, shown - volume history, the forecast of 150 drums this year growing ten percent a year, our delivery record, what the product does for our mission. Three: what we bring - a rolling twelve-month forecast refreshed monthly, a level weekly cadence through a blanket order, and the hydrogel program as a written joint roadmap. Four: growing together - their other hydrogel lines, sodium alginate and guar gum, for our other projects, if R&amp;D has a use. Five: running it as partners - resin supply and a consignment buffer, capacity for year-five volume, cover for the people who run the PVA cook, advance notice of changes, a shelf-life study together; continuity agreed as a shared discipline. Six: a resin-indexed price formula instead of ad hoc increases. Seven: close with a quarterly business review, named contacts and an updated quality agreement. Before we walk in we decide five things: the strategy, which sets the posture - under Option 3 we say a continuity verification lot runs once a year and we do not name the supplier; how much forecast we share and whether a multi-year commitment is on the table; the give - blanket order and payment terms; which projects could use the other hydrogels; and whether we fund the resin buffer and the shelf-life study.</a:t>
+              <a:t>The SNP conversation, in order. One: why we are here - growth, a sole source we depend on, and the intent to run it as a partnership; they should hear investment, not audit. Two: our business, shown - volume history, the forecast of 150 drums this year growing ten percent a year, our delivery record, what the product does for our mission. Three: what we bring - a rolling twelve-month forecast refreshed monthly, a level weekly cadence through a blanket order, and the hydrogel program as a written joint roadmap. Four: growing together, as an exploration and not a commitment - their other hydrogel lines, sodium alginate and guar gum, as possibilities for future projects; we learn what else they can make and promise nothing either way. Five: running it as partners - resin supply and a consignment buffer, capacity for year-five volume, cover for the people who run the PVA cook, advance notice of changes, a shelf-life study together; continuity agreed as a shared discipline. Six: a resin-indexed price formula instead of ad hoc increases. Seven: close with a quarterly business review, named contacts and an updated quality agreement. Before we walk in we decide five things: the strategy, which sets the posture - under Option 3 we say a continuity verification lot runs once a year and we do not name the supplier; how much forecast we share and whether a multi-year commitment is on the table; the give - blanket order and payment terms; whether to raise the other hydrogels at all, as possibilities only; and whether we fund the resin buffer and the shelf-life study.</a:t>
             </a:r>
           </a:p>
         </p:txBody>
@@ -14816,7 +14816,7 @@
                 </a:solidFill>
                 <a:latin typeface="Calibri"/>
               </a:rPr>
-              <a:t>Their other hydrogel lines — sodium alginate, guar gum — for our other projects.  </a:t>
+              <a:t>Explore, not commit: their other hydrogel lines — sodium alginate, guar gum — as possibilities for future projects.  </a:t>
             </a:r>
             <a:r>
               <a:rPr sz="1100" b="1">
@@ -14825,7 +14825,7 @@
                 </a:solidFill>
                 <a:latin typeface="Calibri"/>
               </a:rPr>
-              <a:t>→ A second and third line, if R&amp;D has a use</a:t>
+              <a:t>→ We learn what else they can make; no promise either way</a:t>
             </a:r>
           </a:p>
           <a:p>
@@ -15112,7 +15112,7 @@
                 </a:solidFill>
                 <a:latin typeface="Calibri"/>
               </a:rPr>
-              <a:t>— which projects could use alginate or guar, at what solids. (R&amp;D, before the meeting)</a:t>
+              <a:t>— whether to ask about alginate and guar at all, as possibilities only — no project named, no commitment. (R&amp;D, before the meeting)</a:t>
             </a:r>
           </a:p>
           <a:p>

</xml_diff>

<commit_message>
Pricing slide: sidebar trimmed to fit
Co-Authored-By: Claude Fable 5.1 <noreply@anthropic.com>
Claude-Session: https://claude.ai/code/session_01LkE2ZRYs3PLyj8XHTsU3i4
</commit_message>
<xml_diff>
--- a/PVA second supplier initiative/PVA_Second_Supplier_Leadership_Deck.pptx
+++ b/PVA second supplier initiative/PVA_Second_Supplier_Leadership_Deck.pptx
@@ -6672,7 +6672,7 @@
                 </a:solidFill>
                 <a:latin typeface="Calibri"/>
               </a:rPr>
-              <a:t>— $0.75 at ~3 drums a week — the floor of the band, delivered and to our spec: the market's cheapest price for a better product</a:t>
+              <a:t>— $0.75 at ~3 drums a week — the floor of the band, delivered and to our spec</a:t>
             </a:r>
           </a:p>
           <a:p>
@@ -6747,7 +6747,7 @@
                 </a:solidFill>
                 <a:latin typeface="Calibri"/>
               </a:rPr>
-              <a:t>— CJB $8.42 at a 40-gal minimum sits far above the band; APV ≥$3 (estimate from our call, never confirmed) sits at the band's top</a:t>
+              <a:t>— CJB $8.42 far above the band; APV ≥$3 (estimate, never confirmed) at its top</a:t>
             </a:r>
           </a:p>
         </p:txBody>

</xml_diff>

<commit_message>
Build script matches Oscar's Final deck (title slide, chronology wording)
Co-Authored-By: Claude Fable 5.1 <noreply@anthropic.com>
Claude-Session: https://claude.ai/code/session_01LkE2ZRYs3PLyj8XHTsU3i4
</commit_message>
<xml_diff>
--- a/PVA second supplier initiative/PVA_Second_Supplier_Leadership_Deck.pptx
+++ b/PVA second supplier initiative/PVA_Second_Supplier_Leadership_Deck.pptx
@@ -4286,61 +4286,6 @@
                 <a:latin typeface="Calibri"/>
               </a:rPr>
               <a:t>Update: PCI Manufacturing has proven it can make our product — and told us what it costs</a:t>
-            </a:r>
-          </a:p>
-        </p:txBody>
-      </p:sp>
-      <p:sp>
-        <p:nvSpPr>
-          <p:cNvPr id="5" name="TextBox 4"/>
-          <p:cNvSpPr txBox="1"/>
-          <p:nvPr/>
-        </p:nvSpPr>
-        <p:spPr>
-          <a:xfrm>
-            <a:off x="731520" y="4663440"/>
-            <a:ext cx="10698480" cy="1463040"/>
-          </a:xfrm>
-          <a:prstGeom prst="rect">
-            <a:avLst/>
-          </a:prstGeom>
-          <a:noFill/>
-        </p:spPr>
-        <p:txBody>
-          <a:bodyPr wrap="square">
-            <a:spAutoFit/>
-          </a:bodyPr>
-          <a:lstStyle/>
-          <a:p>
-            <a:pPr algn="l">
-              <a:spcAft>
-                <a:spcPts val="400"/>
-              </a:spcAft>
-            </a:pPr>
-            <a:r>
-              <a:rPr sz="1350" b="0" i="0">
-                <a:solidFill>
-                  <a:srgbClr val="FFFFFF"/>
-                </a:solidFill>
-                <a:latin typeface="Calibri"/>
-              </a:rPr>
-              <a:t>PVA = polyvinyl alcohol — the liquid we buy in 55-gallon drums (450 lb of PVA each) from SNP Inc. (Durham, NC) to make our hydrogels. Sole-sourced today. Volumes on these slides are in drums and percent of demand.</a:t>
-            </a:r>
-          </a:p>
-          <a:p>
-            <a:pPr algn="l">
-              <a:spcAft>
-                <a:spcPts val="400"/>
-              </a:spcAft>
-            </a:pPr>
-            <a:r>
-              <a:rPr sz="1200" b="0" i="0">
-                <a:solidFill>
-                  <a:srgbClr val="9DC3E6"/>
-                </a:solidFill>
-                <a:latin typeface="Calibri"/>
-              </a:rPr>
-              <a:t>Oscar Penny  ·  Supply Chain  ·  28 September 2026  ·  Decision requested</a:t>
             </a:r>
           </a:p>
         </p:txBody>
@@ -6807,7 +6752,7 @@
                 </a:solidFill>
                 <a:latin typeface="Calibri"/>
               </a:rPr>
-              <a:t>CJB priced out</a:t>
+              <a:t>CJB capable but priced out</a:t>
             </a:r>
           </a:p>
         </p:txBody>
@@ -6986,7 +6931,7 @@
                 </a:solidFill>
                 <a:latin typeface="Calibri"/>
               </a:rPr>
-              <a:t>Two-plus batches, a dilution study, method work — unpaid</a:t>
+              <a:t>Two-plus batch tank (110 gal), a dilution study, method work — unpaid</a:t>
             </a:r>
           </a:p>
         </p:txBody>

</xml_diff>